<commit_message>
Reemplazar el cronograma del Dojo AM por el plan real con avance
Catorce tareas del 07/07 al 06/11/2026 agrupadas en las cuatro fases,
con porcentaje de avance por tarea y línea de estado al 18/09.

Co-Authored-By: Claude Fable 5.1 <noreply@anthropic.com>
Claude-Session: https://claude.ai/code/session_013R5zM6jAzpk9971GWdT5eG
</commit_message>
<xml_diff>
--- a/docs/Dojo_AM_Unidad_Pintura.pptx
+++ b/docs/Dojo_AM_Unidad_Pintura.pptx
@@ -868,7 +868,7 @@
           <a:p>
             <a:r>
               <a:rPr lang="en-US" dirty="0"/>
-              <a:t>Cronograma comprimido de 15 semanas para cerrar antes del receso: diseño en septiembre, construcción de fines de septiembre a inicios de noviembre, piloto de dos semanas en noviembre y despliegue a todos los turnos entre el 23 de noviembre y el 23 de diciembre. Riesgo principal: el plazo de fabricación de las maquetas, que debe arrancar con el layout todavía en cierre.</a:t>
+              <a:t>Cronograma con avance real al 18 de septiembre. Fase 1 de diseño cerrada salvo las evaluaciones teóricas al 70%. Fase 2 en curso: falta completar la recopilación de herramientas, la identificación de elementos y el prototipo de stands y pasaporte. Piloto en Overview del 7 al 18 de octubre, implementación del 15 al 29 de octubre, validación con Gerencia, Calidad y Producción el 22 y seguimiento hasta el 6 de noviembre.</a:t>
             </a:r>
             <a:endParaRPr lang="en-US" dirty="0"/>
           </a:p>
@@ -5579,7 +5579,7 @@
                 <a:ea typeface="Arial" pitchFamily="34" charset="-122"/>
                 <a:cs typeface="Arial" pitchFamily="34" charset="-120"/>
               </a:rPr>
-              <a:t>Cronograma: todo listo para fines de diciembre</a:t>
+              <a:t>Cronograma del proyecto</a:t>
             </a:r>
             <a:endParaRPr lang="en-US" sz="2800" dirty="0"/>
           </a:p>
@@ -5626,14 +5626,53 @@
       </p:sp>
       <p:sp>
         <p:nvSpPr>
-          <p:cNvPr id="4" name="Shape 2"/>
+          <p:cNvPr id="4" name="Text 2"/>
+          <p:cNvSpPr txBox="1"/>
+          <p:nvPr/>
+        </p:nvSpPr>
+        <p:spPr>
+          <a:xfrm>
+            <a:off x="548640" y="1024128"/>
+            <a:ext cx="7315200" cy="274320"/>
+          </a:xfrm>
+          <a:prstGeom prst="rect">
+            <a:avLst/>
+          </a:prstGeom>
+          <a:noFill/>
+          <a:ln/>
+        </p:spPr>
+        <p:txBody>
+          <a:bodyPr wrap="square" lIns="0" tIns="0" rIns="0" bIns="0" rtlCol="0" anchor="ctr"/>
+          <a:lstStyle/>
+          <a:p>
+            <a:pPr indent="0" marL="0">
+              <a:buNone/>
+            </a:pPr>
+            <a:r>
+              <a:rPr lang="en-US" sz="1100" dirty="0">
+                <a:solidFill>
+                  <a:srgbClr val="6B7280"/>
+                </a:solidFill>
+                <a:latin typeface="Arial" pitchFamily="34" charset="0"/>
+                <a:ea typeface="Arial" pitchFamily="34" charset="-122"/>
+                <a:cs typeface="Arial" pitchFamily="34" charset="-120"/>
+              </a:rPr>
+              <a:t>Avance al 18/09/2026. Las tareas se agrupan en las 4 fases del plan.</a:t>
+            </a:r>
+            <a:endParaRPr lang="en-US" sz="1100" dirty="0"/>
+          </a:p>
+        </p:txBody>
+      </p:sp>
+      <p:sp>
+        <p:nvSpPr>
+          <p:cNvPr id="5" name="Shape 3"/>
           <p:cNvSpPr/>
           <p:nvPr/>
         </p:nvSpPr>
         <p:spPr>
           <a:xfrm>
             <a:off x="3977640" y="1399032"/>
-            <a:ext cx="1252552" cy="329184"/>
+            <a:ext cx="1521562" cy="329184"/>
           </a:xfrm>
           <a:prstGeom prst="rect">
             <a:avLst/>
@@ -5651,14 +5690,14 @@
       </p:sp>
       <p:sp>
         <p:nvSpPr>
-          <p:cNvPr id="5" name="Text 3"/>
+          <p:cNvPr id="6" name="Text 4"/>
           <p:cNvSpPr txBox="1"/>
           <p:nvPr/>
         </p:nvSpPr>
         <p:spPr>
           <a:xfrm>
             <a:off x="3977640" y="1399032"/>
-            <a:ext cx="1252552" cy="329184"/>
+            <a:ext cx="1521562" cy="329184"/>
           </a:xfrm>
           <a:prstGeom prst="rect">
             <a:avLst/>
@@ -5682,7 +5721,7 @@
                 <a:ea typeface="Arial" pitchFamily="34" charset="-122"/>
                 <a:cs typeface="Arial" pitchFamily="34" charset="-120"/>
               </a:rPr>
-              <a:t>Septiembre</a:t>
+              <a:t>Julio</a:t>
             </a:r>
             <a:endParaRPr lang="en-US" sz="1000" dirty="0"/>
           </a:p>
@@ -5690,7 +5729,7 @@
       </p:sp>
       <p:sp>
         <p:nvSpPr>
-          <p:cNvPr id="6" name="Shape 4"/>
+          <p:cNvPr id="7" name="Shape 5"/>
           <p:cNvSpPr/>
           <p:nvPr/>
         </p:nvSpPr>
@@ -5713,14 +5752,14 @@
       </p:sp>
       <p:sp>
         <p:nvSpPr>
-          <p:cNvPr id="7" name="Shape 5"/>
+          <p:cNvPr id="8" name="Shape 6"/>
           <p:cNvSpPr/>
           <p:nvPr/>
         </p:nvSpPr>
         <p:spPr>
           <a:xfrm>
-            <a:off x="5230192" y="1399032"/>
-            <a:ext cx="2284066" cy="329184"/>
+            <a:off x="5499202" y="1399032"/>
+            <a:ext cx="1814170" cy="329184"/>
           </a:xfrm>
           <a:prstGeom prst="rect">
             <a:avLst/>
@@ -5738,14 +5777,14 @@
       </p:sp>
       <p:sp>
         <p:nvSpPr>
-          <p:cNvPr id="8" name="Text 6"/>
-          <p:cNvSpPr txBox="1"/>
-          <p:nvPr/>
-        </p:nvSpPr>
-        <p:spPr>
-          <a:xfrm>
-            <a:off x="5230192" y="1399032"/>
-            <a:ext cx="2284066" cy="329184"/>
+          <p:cNvPr id="9" name="Text 7"/>
+          <p:cNvSpPr txBox="1"/>
+          <p:nvPr/>
+        </p:nvSpPr>
+        <p:spPr>
+          <a:xfrm>
+            <a:off x="5499202" y="1399032"/>
+            <a:ext cx="1814170" cy="329184"/>
           </a:xfrm>
           <a:prstGeom prst="rect">
             <a:avLst/>
@@ -5769,7 +5808,7 @@
                 <a:ea typeface="Arial" pitchFamily="34" charset="-122"/>
                 <a:cs typeface="Arial" pitchFamily="34" charset="-120"/>
               </a:rPr>
-              <a:t>Octubre</a:t>
+              <a:t>Agosto</a:t>
             </a:r>
             <a:endParaRPr lang="en-US" sz="1000" dirty="0"/>
           </a:p>
@@ -5777,13 +5816,13 @@
       </p:sp>
       <p:sp>
         <p:nvSpPr>
-          <p:cNvPr id="9" name="Shape 7"/>
+          <p:cNvPr id="10" name="Shape 8"/>
           <p:cNvSpPr/>
           <p:nvPr/>
         </p:nvSpPr>
         <p:spPr>
           <a:xfrm>
-            <a:off x="5230192" y="1783080"/>
+            <a:off x="5499202" y="1783080"/>
             <a:ext cx="0" cy="4197096"/>
           </a:xfrm>
           <a:prstGeom prst="line">
@@ -5800,14 +5839,14 @@
       </p:sp>
       <p:sp>
         <p:nvSpPr>
-          <p:cNvPr id="10" name="Shape 8"/>
+          <p:cNvPr id="11" name="Shape 9"/>
           <p:cNvSpPr/>
           <p:nvPr/>
         </p:nvSpPr>
         <p:spPr>
           <a:xfrm>
-            <a:off x="7514258" y="1399032"/>
-            <a:ext cx="2210386" cy="329184"/>
+            <a:off x="7313371" y="1399032"/>
+            <a:ext cx="1755648" cy="329184"/>
           </a:xfrm>
           <a:prstGeom prst="rect">
             <a:avLst/>
@@ -5825,14 +5864,14 @@
       </p:sp>
       <p:sp>
         <p:nvSpPr>
-          <p:cNvPr id="11" name="Text 9"/>
-          <p:cNvSpPr txBox="1"/>
-          <p:nvPr/>
-        </p:nvSpPr>
-        <p:spPr>
-          <a:xfrm>
-            <a:off x="7514258" y="1399032"/>
-            <a:ext cx="2210386" cy="329184"/>
+          <p:cNvPr id="12" name="Text 10"/>
+          <p:cNvSpPr txBox="1"/>
+          <p:nvPr/>
+        </p:nvSpPr>
+        <p:spPr>
+          <a:xfrm>
+            <a:off x="7313371" y="1399032"/>
+            <a:ext cx="1755648" cy="329184"/>
           </a:xfrm>
           <a:prstGeom prst="rect">
             <a:avLst/>
@@ -5856,7 +5895,7 @@
                 <a:ea typeface="Arial" pitchFamily="34" charset="-122"/>
                 <a:cs typeface="Arial" pitchFamily="34" charset="-120"/>
               </a:rPr>
-              <a:t>Noviembre</a:t>
+              <a:t>Septiembre</a:t>
             </a:r>
             <a:endParaRPr lang="en-US" sz="1000" dirty="0"/>
           </a:p>
@@ -5864,13 +5903,13 @@
       </p:sp>
       <p:sp>
         <p:nvSpPr>
-          <p:cNvPr id="12" name="Shape 10"/>
+          <p:cNvPr id="13" name="Shape 11"/>
           <p:cNvSpPr/>
           <p:nvPr/>
         </p:nvSpPr>
         <p:spPr>
           <a:xfrm>
-            <a:off x="7514258" y="1783080"/>
+            <a:off x="7313371" y="1783080"/>
             <a:ext cx="0" cy="4197096"/>
           </a:xfrm>
           <a:prstGeom prst="line">
@@ -5887,14 +5926,14 @@
       </p:sp>
       <p:sp>
         <p:nvSpPr>
-          <p:cNvPr id="13" name="Shape 11"/>
+          <p:cNvPr id="14" name="Shape 12"/>
           <p:cNvSpPr/>
           <p:nvPr/>
         </p:nvSpPr>
         <p:spPr>
           <a:xfrm>
-            <a:off x="9724644" y="1399032"/>
-            <a:ext cx="1915668" cy="329184"/>
+            <a:off x="9069019" y="1399032"/>
+            <a:ext cx="1814170" cy="329184"/>
           </a:xfrm>
           <a:prstGeom prst="rect">
             <a:avLst/>
@@ -5912,14 +5951,14 @@
       </p:sp>
       <p:sp>
         <p:nvSpPr>
-          <p:cNvPr id="14" name="Text 12"/>
-          <p:cNvSpPr txBox="1"/>
-          <p:nvPr/>
-        </p:nvSpPr>
-        <p:spPr>
-          <a:xfrm>
-            <a:off x="9724644" y="1399032"/>
-            <a:ext cx="1915668" cy="329184"/>
+          <p:cNvPr id="15" name="Text 13"/>
+          <p:cNvSpPr txBox="1"/>
+          <p:nvPr/>
+        </p:nvSpPr>
+        <p:spPr>
+          <a:xfrm>
+            <a:off x="9069019" y="1399032"/>
+            <a:ext cx="1814170" cy="329184"/>
           </a:xfrm>
           <a:prstGeom prst="rect">
             <a:avLst/>
@@ -5943,7 +5982,7 @@
                 <a:ea typeface="Arial" pitchFamily="34" charset="-122"/>
                 <a:cs typeface="Arial" pitchFamily="34" charset="-120"/>
               </a:rPr>
-              <a:t>Diciembre</a:t>
+              <a:t>Octubre</a:t>
             </a:r>
             <a:endParaRPr lang="en-US" sz="1000" dirty="0"/>
           </a:p>
@@ -5951,13 +5990,13 @@
       </p:sp>
       <p:sp>
         <p:nvSpPr>
-          <p:cNvPr id="15" name="Shape 13"/>
+          <p:cNvPr id="16" name="Shape 14"/>
           <p:cNvSpPr/>
           <p:nvPr/>
         </p:nvSpPr>
         <p:spPr>
           <a:xfrm>
-            <a:off x="9724644" y="1783080"/>
+            <a:off x="9069019" y="1783080"/>
             <a:ext cx="0" cy="4197096"/>
           </a:xfrm>
           <a:prstGeom prst="line">
@@ -5974,7 +6013,94 @@
       </p:sp>
       <p:sp>
         <p:nvSpPr>
-          <p:cNvPr id="16" name="Shape 14"/>
+          <p:cNvPr id="17" name="Shape 15"/>
+          <p:cNvSpPr/>
+          <p:nvPr/>
+        </p:nvSpPr>
+        <p:spPr>
+          <a:xfrm>
+            <a:off x="10883189" y="1399032"/>
+            <a:ext cx="409651" cy="329184"/>
+          </a:xfrm>
+          <a:prstGeom prst="rect">
+            <a:avLst/>
+          </a:prstGeom>
+          <a:solidFill>
+            <a:srgbClr val="F3F5F8"/>
+          </a:solidFill>
+          <a:ln w="12700">
+            <a:solidFill>
+              <a:srgbClr val="FFFFFF"/>
+            </a:solidFill>
+            <a:prstDash val="solid"/>
+          </a:ln>
+        </p:spPr>
+      </p:sp>
+      <p:sp>
+        <p:nvSpPr>
+          <p:cNvPr id="18" name="Text 16"/>
+          <p:cNvSpPr txBox="1"/>
+          <p:nvPr/>
+        </p:nvSpPr>
+        <p:spPr>
+          <a:xfrm>
+            <a:off x="10883189" y="1399032"/>
+            <a:ext cx="409651" cy="329184"/>
+          </a:xfrm>
+          <a:prstGeom prst="rect">
+            <a:avLst/>
+          </a:prstGeom>
+          <a:noFill/>
+          <a:ln/>
+        </p:spPr>
+        <p:txBody>
+          <a:bodyPr wrap="square" lIns="0" tIns="0" rIns="0" bIns="0" rtlCol="0" anchor="ctr"/>
+          <a:lstStyle/>
+          <a:p>
+            <a:pPr algn="ctr" indent="0" marL="0">
+              <a:buNone/>
+            </a:pPr>
+            <a:r>
+              <a:rPr lang="en-US" sz="1000" b="1" dirty="0">
+                <a:solidFill>
+                  <a:srgbClr val="022A5B"/>
+                </a:solidFill>
+                <a:latin typeface="Arial" pitchFamily="34" charset="0"/>
+                <a:ea typeface="Arial" pitchFamily="34" charset="-122"/>
+                <a:cs typeface="Arial" pitchFamily="34" charset="-120"/>
+              </a:rPr>
+              <a:t>Nov</a:t>
+            </a:r>
+            <a:endParaRPr lang="en-US" sz="1000" dirty="0"/>
+          </a:p>
+        </p:txBody>
+      </p:sp>
+      <p:sp>
+        <p:nvSpPr>
+          <p:cNvPr id="19" name="Shape 17"/>
+          <p:cNvSpPr/>
+          <p:nvPr/>
+        </p:nvSpPr>
+        <p:spPr>
+          <a:xfrm>
+            <a:off x="10883189" y="1783080"/>
+            <a:ext cx="0" cy="4197096"/>
+          </a:xfrm>
+          <a:prstGeom prst="line">
+            <a:avLst/>
+          </a:prstGeom>
+          <a:noFill/>
+          <a:ln w="9525">
+            <a:solidFill>
+              <a:srgbClr val="D9E0EA"/>
+            </a:solidFill>
+            <a:prstDash val="solid"/>
+          </a:ln>
+        </p:spPr>
+      </p:sp>
+      <p:sp>
+        <p:nvSpPr>
+          <p:cNvPr id="20" name="Shape 18"/>
           <p:cNvSpPr/>
           <p:nvPr/>
         </p:nvSpPr>
@@ -5997,13 +6123,13 @@
       </p:sp>
       <p:sp>
         <p:nvSpPr>
-          <p:cNvPr id="17" name="Shape 15"/>
+          <p:cNvPr id="21" name="Shape 19"/>
           <p:cNvSpPr/>
           <p:nvPr/>
         </p:nvSpPr>
         <p:spPr>
           <a:xfrm>
-            <a:off x="4493397" y="1783080"/>
+            <a:off x="4387291" y="1783080"/>
             <a:ext cx="0" cy="4197096"/>
           </a:xfrm>
           <a:prstGeom prst="line">
@@ -6020,13 +6146,13 @@
       </p:sp>
       <p:sp>
         <p:nvSpPr>
-          <p:cNvPr id="18" name="Shape 16"/>
+          <p:cNvPr id="22" name="Shape 20"/>
           <p:cNvSpPr/>
           <p:nvPr/>
         </p:nvSpPr>
         <p:spPr>
           <a:xfrm>
-            <a:off x="5009154" y="1783080"/>
+            <a:off x="4796942" y="1783080"/>
             <a:ext cx="0" cy="4197096"/>
           </a:xfrm>
           <a:prstGeom prst="line">
@@ -6043,13 +6169,13 @@
       </p:sp>
       <p:sp>
         <p:nvSpPr>
-          <p:cNvPr id="19" name="Shape 17"/>
+          <p:cNvPr id="23" name="Shape 21"/>
           <p:cNvSpPr/>
           <p:nvPr/>
         </p:nvSpPr>
         <p:spPr>
           <a:xfrm>
-            <a:off x="5524910" y="1783080"/>
+            <a:off x="5206594" y="1783080"/>
             <a:ext cx="0" cy="4197096"/>
           </a:xfrm>
           <a:prstGeom prst="line">
@@ -6066,13 +6192,13 @@
       </p:sp>
       <p:sp>
         <p:nvSpPr>
-          <p:cNvPr id="20" name="Shape 18"/>
+          <p:cNvPr id="24" name="Shape 22"/>
           <p:cNvSpPr/>
           <p:nvPr/>
         </p:nvSpPr>
         <p:spPr>
           <a:xfrm>
-            <a:off x="6040667" y="1783080"/>
+            <a:off x="5616245" y="1783080"/>
             <a:ext cx="0" cy="4197096"/>
           </a:xfrm>
           <a:prstGeom prst="line">
@@ -6089,13 +6215,13 @@
       </p:sp>
       <p:sp>
         <p:nvSpPr>
-          <p:cNvPr id="21" name="Shape 19"/>
+          <p:cNvPr id="25" name="Shape 23"/>
           <p:cNvSpPr/>
           <p:nvPr/>
         </p:nvSpPr>
         <p:spPr>
           <a:xfrm>
-            <a:off x="6556424" y="1783080"/>
+            <a:off x="6025896" y="1783080"/>
             <a:ext cx="0" cy="4197096"/>
           </a:xfrm>
           <a:prstGeom prst="line">
@@ -6112,13 +6238,13 @@
       </p:sp>
       <p:sp>
         <p:nvSpPr>
-          <p:cNvPr id="22" name="Shape 20"/>
+          <p:cNvPr id="26" name="Shape 24"/>
           <p:cNvSpPr/>
           <p:nvPr/>
         </p:nvSpPr>
         <p:spPr>
           <a:xfrm>
-            <a:off x="7072181" y="1783080"/>
+            <a:off x="6435547" y="1783080"/>
             <a:ext cx="0" cy="4197096"/>
           </a:xfrm>
           <a:prstGeom prst="line">
@@ -6135,13 +6261,13 @@
       </p:sp>
       <p:sp>
         <p:nvSpPr>
-          <p:cNvPr id="23" name="Shape 21"/>
+          <p:cNvPr id="27" name="Shape 25"/>
           <p:cNvSpPr/>
           <p:nvPr/>
         </p:nvSpPr>
         <p:spPr>
           <a:xfrm>
-            <a:off x="7587937" y="1783080"/>
+            <a:off x="6845198" y="1783080"/>
             <a:ext cx="0" cy="4197096"/>
           </a:xfrm>
           <a:prstGeom prst="line">
@@ -6158,13 +6284,13 @@
       </p:sp>
       <p:sp>
         <p:nvSpPr>
-          <p:cNvPr id="24" name="Shape 22"/>
+          <p:cNvPr id="28" name="Shape 26"/>
           <p:cNvSpPr/>
           <p:nvPr/>
         </p:nvSpPr>
         <p:spPr>
           <a:xfrm>
-            <a:off x="8103694" y="1783080"/>
+            <a:off x="7254850" y="1783080"/>
             <a:ext cx="0" cy="4197096"/>
           </a:xfrm>
           <a:prstGeom prst="line">
@@ -6181,13 +6307,13 @@
       </p:sp>
       <p:sp>
         <p:nvSpPr>
-          <p:cNvPr id="25" name="Shape 23"/>
+          <p:cNvPr id="29" name="Shape 27"/>
           <p:cNvSpPr/>
           <p:nvPr/>
         </p:nvSpPr>
         <p:spPr>
           <a:xfrm>
-            <a:off x="8619451" y="1783080"/>
+            <a:off x="7664501" y="1783080"/>
             <a:ext cx="0" cy="4197096"/>
           </a:xfrm>
           <a:prstGeom prst="line">
@@ -6204,13 +6330,13 @@
       </p:sp>
       <p:sp>
         <p:nvSpPr>
-          <p:cNvPr id="26" name="Shape 24"/>
+          <p:cNvPr id="30" name="Shape 28"/>
           <p:cNvSpPr/>
           <p:nvPr/>
         </p:nvSpPr>
         <p:spPr>
           <a:xfrm>
-            <a:off x="9135208" y="1783080"/>
+            <a:off x="8074152" y="1783080"/>
             <a:ext cx="0" cy="4197096"/>
           </a:xfrm>
           <a:prstGeom prst="line">
@@ -6227,13 +6353,13 @@
       </p:sp>
       <p:sp>
         <p:nvSpPr>
-          <p:cNvPr id="27" name="Shape 25"/>
+          <p:cNvPr id="31" name="Shape 29"/>
           <p:cNvSpPr/>
           <p:nvPr/>
         </p:nvSpPr>
         <p:spPr>
           <a:xfrm>
-            <a:off x="9650964" y="1783080"/>
+            <a:off x="8483803" y="1783080"/>
             <a:ext cx="0" cy="4197096"/>
           </a:xfrm>
           <a:prstGeom prst="line">
@@ -6250,13 +6376,13 @@
       </p:sp>
       <p:sp>
         <p:nvSpPr>
-          <p:cNvPr id="28" name="Shape 26"/>
+          <p:cNvPr id="32" name="Shape 30"/>
           <p:cNvSpPr/>
           <p:nvPr/>
         </p:nvSpPr>
         <p:spPr>
           <a:xfrm>
-            <a:off x="10166721" y="1783080"/>
+            <a:off x="8893454" y="1783080"/>
             <a:ext cx="0" cy="4197096"/>
           </a:xfrm>
           <a:prstGeom prst="line">
@@ -6273,13 +6399,13 @@
       </p:sp>
       <p:sp>
         <p:nvSpPr>
-          <p:cNvPr id="29" name="Shape 27"/>
+          <p:cNvPr id="33" name="Shape 31"/>
           <p:cNvSpPr/>
           <p:nvPr/>
         </p:nvSpPr>
         <p:spPr>
           <a:xfrm>
-            <a:off x="10682478" y="1783080"/>
+            <a:off x="9303106" y="1783080"/>
             <a:ext cx="0" cy="4197096"/>
           </a:xfrm>
           <a:prstGeom prst="line">
@@ -6296,13 +6422,13 @@
       </p:sp>
       <p:sp>
         <p:nvSpPr>
-          <p:cNvPr id="30" name="Shape 28"/>
+          <p:cNvPr id="34" name="Shape 32"/>
           <p:cNvSpPr/>
           <p:nvPr/>
         </p:nvSpPr>
         <p:spPr>
           <a:xfrm>
-            <a:off x="11198235" y="1783080"/>
+            <a:off x="9712757" y="1783080"/>
             <a:ext cx="0" cy="4197096"/>
           </a:xfrm>
           <a:prstGeom prst="line">
@@ -6319,14 +6445,122 @@
       </p:sp>
       <p:sp>
         <p:nvSpPr>
-          <p:cNvPr id="31" name="Shape 29"/>
+          <p:cNvPr id="35" name="Shape 33"/>
           <p:cNvSpPr/>
           <p:nvPr/>
         </p:nvSpPr>
         <p:spPr>
           <a:xfrm>
+            <a:off x="10122408" y="1783080"/>
+            <a:ext cx="0" cy="4197096"/>
+          </a:xfrm>
+          <a:prstGeom prst="line">
+            <a:avLst/>
+          </a:prstGeom>
+          <a:noFill/>
+          <a:ln w="6350">
+            <a:solidFill>
+              <a:srgbClr val="EEF1F5"/>
+            </a:solidFill>
+            <a:prstDash val="solid"/>
+          </a:ln>
+        </p:spPr>
+      </p:sp>
+      <p:sp>
+        <p:nvSpPr>
+          <p:cNvPr id="36" name="Shape 34"/>
+          <p:cNvSpPr/>
+          <p:nvPr/>
+        </p:nvSpPr>
+        <p:spPr>
+          <a:xfrm>
+            <a:off x="10532059" y="1783080"/>
+            <a:ext cx="0" cy="4197096"/>
+          </a:xfrm>
+          <a:prstGeom prst="line">
+            <a:avLst/>
+          </a:prstGeom>
+          <a:noFill/>
+          <a:ln w="6350">
+            <a:solidFill>
+              <a:srgbClr val="EEF1F5"/>
+            </a:solidFill>
+            <a:prstDash val="solid"/>
+          </a:ln>
+        </p:spPr>
+      </p:sp>
+      <p:sp>
+        <p:nvSpPr>
+          <p:cNvPr id="37" name="Shape 35"/>
+          <p:cNvSpPr/>
+          <p:nvPr/>
+        </p:nvSpPr>
+        <p:spPr>
+          <a:xfrm>
+            <a:off x="10941710" y="1783080"/>
+            <a:ext cx="0" cy="4197096"/>
+          </a:xfrm>
+          <a:prstGeom prst="line">
+            <a:avLst/>
+          </a:prstGeom>
+          <a:noFill/>
+          <a:ln w="6350">
+            <a:solidFill>
+              <a:srgbClr val="EEF1F5"/>
+            </a:solidFill>
+            <a:prstDash val="solid"/>
+          </a:ln>
+        </p:spPr>
+      </p:sp>
+      <p:sp>
+        <p:nvSpPr>
+          <p:cNvPr id="38" name="Text 36"/>
+          <p:cNvSpPr txBox="1"/>
+          <p:nvPr/>
+        </p:nvSpPr>
+        <p:spPr>
+          <a:xfrm>
+            <a:off x="11311128" y="1399032"/>
+            <a:ext cx="329184" cy="329184"/>
+          </a:xfrm>
+          <a:prstGeom prst="rect">
+            <a:avLst/>
+          </a:prstGeom>
+          <a:noFill/>
+          <a:ln/>
+        </p:spPr>
+        <p:txBody>
+          <a:bodyPr wrap="square" lIns="0" tIns="0" rIns="0" bIns="0" rtlCol="0" anchor="ctr"/>
+          <a:lstStyle/>
+          <a:p>
+            <a:pPr algn="ctr" indent="0" marL="0">
+              <a:buNone/>
+            </a:pPr>
+            <a:r>
+              <a:rPr lang="en-US" sz="900" b="1" dirty="0">
+                <a:solidFill>
+                  <a:srgbClr val="6B7280"/>
+                </a:solidFill>
+                <a:latin typeface="Arial" pitchFamily="34" charset="0"/>
+                <a:ea typeface="Arial" pitchFamily="34" charset="-122"/>
+                <a:cs typeface="Arial" pitchFamily="34" charset="-120"/>
+              </a:rPr>
+              <a:t>%</a:t>
+            </a:r>
+            <a:endParaRPr lang="en-US" sz="900" dirty="0"/>
+          </a:p>
+        </p:txBody>
+      </p:sp>
+      <p:sp>
+        <p:nvSpPr>
+          <p:cNvPr id="39" name="Shape 37"/>
+          <p:cNvSpPr/>
+          <p:nvPr/>
+        </p:nvSpPr>
+        <p:spPr>
+          <a:xfrm>
             <a:off x="548640" y="1783080"/>
-            <a:ext cx="11091672" cy="246888"/>
+            <a:ext cx="11091672" cy="233172"/>
           </a:xfrm>
           <a:prstGeom prst="rect">
             <a:avLst/>
@@ -6344,14 +6578,14 @@
       </p:sp>
       <p:sp>
         <p:nvSpPr>
-          <p:cNvPr id="32" name="Text 30"/>
+          <p:cNvPr id="40" name="Text 38"/>
           <p:cNvSpPr txBox="1"/>
           <p:nvPr/>
         </p:nvSpPr>
         <p:spPr>
           <a:xfrm>
             <a:off x="640080" y="1783080"/>
-            <a:ext cx="3017520" cy="246888"/>
+            <a:ext cx="2240280" cy="233172"/>
           </a:xfrm>
           <a:prstGeom prst="rect">
             <a:avLst/>
@@ -6383,14 +6617,53 @@
       </p:sp>
       <p:sp>
         <p:nvSpPr>
-          <p:cNvPr id="33" name="Shape 31"/>
+          <p:cNvPr id="41" name="Text 39"/>
+          <p:cNvSpPr txBox="1"/>
+          <p:nvPr/>
+        </p:nvSpPr>
+        <p:spPr>
+          <a:xfrm>
+            <a:off x="3017520" y="1783080"/>
+            <a:ext cx="914400" cy="233172"/>
+          </a:xfrm>
+          <a:prstGeom prst="rect">
+            <a:avLst/>
+          </a:prstGeom>
+          <a:noFill/>
+          <a:ln/>
+        </p:spPr>
+        <p:txBody>
+          <a:bodyPr wrap="square" lIns="0" tIns="0" rIns="0" bIns="0" rtlCol="0" anchor="ctr"/>
+          <a:lstStyle/>
+          <a:p>
+            <a:pPr algn="r" indent="0" marL="0">
+              <a:buNone/>
+            </a:pPr>
+            <a:r>
+              <a:rPr lang="en-US" sz="750" dirty="0">
+                <a:solidFill>
+                  <a:srgbClr val="6B7280"/>
+                </a:solidFill>
+                <a:latin typeface="Arial" pitchFamily="34" charset="0"/>
+                <a:ea typeface="Arial" pitchFamily="34" charset="-122"/>
+                <a:cs typeface="Arial" pitchFamily="34" charset="-120"/>
+              </a:rPr>
+              <a:t>07/07 – 27/08</a:t>
+            </a:r>
+            <a:endParaRPr lang="en-US" sz="750" dirty="0"/>
+          </a:p>
+        </p:txBody>
+      </p:sp>
+      <p:sp>
+        <p:nvSpPr>
+          <p:cNvPr id="42" name="Shape 40"/>
           <p:cNvSpPr/>
           <p:nvPr/>
         </p:nvSpPr>
         <p:spPr>
           <a:xfrm>
-            <a:off x="3977640" y="1847088"/>
-            <a:ext cx="1326232" cy="118872"/>
+            <a:off x="4036162" y="1847088"/>
+            <a:ext cx="2984602" cy="105156"/>
           </a:xfrm>
           <a:prstGeom prst="rect">
             <a:avLst/>
@@ -6408,14 +6681,14 @@
       </p:sp>
       <p:sp>
         <p:nvSpPr>
-          <p:cNvPr id="34" name="Text 32"/>
-          <p:cNvSpPr txBox="1"/>
-          <p:nvPr/>
-        </p:nvSpPr>
-        <p:spPr>
-          <a:xfrm>
-            <a:off x="3063240" y="1783080"/>
-            <a:ext cx="868680" cy="246888"/>
+          <p:cNvPr id="43" name="Text 41"/>
+          <p:cNvSpPr txBox="1"/>
+          <p:nvPr/>
+        </p:nvSpPr>
+        <p:spPr>
+          <a:xfrm>
+            <a:off x="868680" y="2016252"/>
+            <a:ext cx="2240280" cy="233172"/>
           </a:xfrm>
           <a:prstGeom prst="rect">
             <a:avLst/>
@@ -6427,6 +6700,45 @@
           <a:bodyPr wrap="square" lIns="0" tIns="0" rIns="0" bIns="0" rtlCol="0" anchor="ctr"/>
           <a:lstStyle/>
           <a:p>
+            <a:pPr indent="0" marL="0">
+              <a:buNone/>
+            </a:pPr>
+            <a:r>
+              <a:rPr lang="en-US" sz="850" dirty="0">
+                <a:solidFill>
+                  <a:srgbClr val="1F2937"/>
+                </a:solidFill>
+                <a:latin typeface="Arial" pitchFamily="34" charset="0"/>
+                <a:ea typeface="Arial" pitchFamily="34" charset="-122"/>
+                <a:cs typeface="Arial" pitchFamily="34" charset="-120"/>
+              </a:rPr>
+              <a:t>Definición del Dojo</a:t>
+            </a:r>
+            <a:endParaRPr lang="en-US" sz="850" dirty="0"/>
+          </a:p>
+        </p:txBody>
+      </p:sp>
+      <p:sp>
+        <p:nvSpPr>
+          <p:cNvPr id="44" name="Text 42"/>
+          <p:cNvSpPr txBox="1"/>
+          <p:nvPr/>
+        </p:nvSpPr>
+        <p:spPr>
+          <a:xfrm>
+            <a:off x="3017520" y="2016252"/>
+            <a:ext cx="914400" cy="233172"/>
+          </a:xfrm>
+          <a:prstGeom prst="rect">
+            <a:avLst/>
+          </a:prstGeom>
+          <a:noFill/>
+          <a:ln/>
+        </p:spPr>
+        <p:txBody>
+          <a:bodyPr wrap="square" lIns="0" tIns="0" rIns="0" bIns="0" rtlCol="0" anchor="ctr"/>
+          <a:lstStyle/>
+          <a:p>
             <a:pPr algn="r" indent="0" marL="0">
               <a:buNone/>
             </a:pPr>
@@ -6439,7 +6751,7 @@
                 <a:ea typeface="Arial" pitchFamily="34" charset="-122"/>
                 <a:cs typeface="Arial" pitchFamily="34" charset="-120"/>
               </a:rPr>
-              <a:t>14/09 – 02/10</a:t>
+              <a:t>07/07 – 07/07</a:t>
             </a:r>
             <a:endParaRPr lang="en-US" sz="750" dirty="0"/>
           </a:p>
@@ -6447,62 +6759,23 @@
       </p:sp>
       <p:sp>
         <p:nvSpPr>
-          <p:cNvPr id="35" name="Text 33"/>
-          <p:cNvSpPr txBox="1"/>
-          <p:nvPr/>
-        </p:nvSpPr>
-        <p:spPr>
-          <a:xfrm>
-            <a:off x="868680" y="2029968"/>
-            <a:ext cx="3017520" cy="246888"/>
-          </a:xfrm>
-          <a:prstGeom prst="rect">
-            <a:avLst/>
-          </a:prstGeom>
-          <a:noFill/>
-          <a:ln/>
-        </p:spPr>
-        <p:txBody>
-          <a:bodyPr wrap="square" lIns="0" tIns="0" rIns="0" bIns="0" rtlCol="0" anchor="ctr"/>
-          <a:lstStyle/>
-          <a:p>
-            <a:pPr indent="0" marL="0">
-              <a:buNone/>
-            </a:pPr>
-            <a:r>
-              <a:rPr lang="en-US" sz="900" dirty="0">
-                <a:solidFill>
-                  <a:srgbClr val="1F2937"/>
-                </a:solidFill>
-                <a:latin typeface="Arial" pitchFamily="34" charset="0"/>
-                <a:ea typeface="Arial" pitchFamily="34" charset="-122"/>
-                <a:cs typeface="Arial" pitchFamily="34" charset="-120"/>
-              </a:rPr>
-              <a:t>Definir el espacio físico y el layout</a:t>
-            </a:r>
-            <a:endParaRPr lang="en-US" sz="900" dirty="0"/>
-          </a:p>
-        </p:txBody>
-      </p:sp>
-      <p:sp>
-        <p:nvSpPr>
-          <p:cNvPr id="36" name="Shape 34"/>
+          <p:cNvPr id="45" name="Shape 43"/>
           <p:cNvSpPr/>
           <p:nvPr/>
         </p:nvSpPr>
         <p:spPr>
           <a:xfrm>
-            <a:off x="3977640" y="2075688"/>
-            <a:ext cx="663116" cy="155448"/>
+            <a:off x="4036162" y="2061972"/>
+            <a:ext cx="73152" cy="141732"/>
           </a:xfrm>
           <a:prstGeom prst="roundRect">
             <a:avLst>
-              <a:gd name="adj" fmla="val 29412"/>
+              <a:gd name="adj" fmla="val 62500"/>
             </a:avLst>
           </a:prstGeom>
           <a:solidFill>
             <a:srgbClr val="022A5B">
-              <a:alpha val="55000"/>
+              <a:alpha val="30000"/>
             </a:srgbClr>
           </a:solidFill>
           <a:ln w="9525">
@@ -6515,101 +6788,167 @@
       </p:sp>
       <p:sp>
         <p:nvSpPr>
-          <p:cNvPr id="37" name="Text 35"/>
-          <p:cNvSpPr txBox="1"/>
-          <p:nvPr/>
-        </p:nvSpPr>
-        <p:spPr>
-          <a:xfrm>
-            <a:off x="3063240" y="2029968"/>
-            <a:ext cx="868680" cy="246888"/>
-          </a:xfrm>
-          <a:prstGeom prst="rect">
-            <a:avLst/>
-          </a:prstGeom>
-          <a:noFill/>
-          <a:ln/>
-        </p:spPr>
-        <p:txBody>
-          <a:bodyPr wrap="square" lIns="0" tIns="0" rIns="0" bIns="0" rtlCol="0" anchor="ctr"/>
-          <a:lstStyle/>
-          <a:p>
-            <a:pPr algn="r" indent="0" marL="0">
-              <a:buNone/>
-            </a:pPr>
-            <a:r>
-              <a:rPr lang="en-US" sz="750" dirty="0">
-                <a:solidFill>
-                  <a:srgbClr val="6B7280"/>
-                </a:solidFill>
-                <a:latin typeface="Arial" pitchFamily="34" charset="0"/>
-                <a:ea typeface="Arial" pitchFamily="34" charset="-122"/>
-                <a:cs typeface="Arial" pitchFamily="34" charset="-120"/>
-              </a:rPr>
-              <a:t>14/09 – 23/09</a:t>
-            </a:r>
-            <a:endParaRPr lang="en-US" sz="750" dirty="0"/>
-          </a:p>
-        </p:txBody>
-      </p:sp>
-      <p:sp>
-        <p:nvSpPr>
-          <p:cNvPr id="38" name="Text 36"/>
-          <p:cNvSpPr txBox="1"/>
-          <p:nvPr/>
-        </p:nvSpPr>
-        <p:spPr>
-          <a:xfrm>
-            <a:off x="868680" y="2276856"/>
-            <a:ext cx="3017520" cy="246888"/>
-          </a:xfrm>
-          <a:prstGeom prst="rect">
-            <a:avLst/>
-          </a:prstGeom>
-          <a:noFill/>
-          <a:ln/>
-        </p:spPr>
-        <p:txBody>
-          <a:bodyPr wrap="square" lIns="0" tIns="0" rIns="0" bIns="0" rtlCol="0" anchor="ctr"/>
-          <a:lstStyle/>
-          <a:p>
-            <a:pPr indent="0" marL="0">
-              <a:buNone/>
-            </a:pPr>
-            <a:r>
-              <a:rPr lang="en-US" sz="900" dirty="0">
-                <a:solidFill>
-                  <a:srgbClr val="1F2937"/>
-                </a:solidFill>
-                <a:latin typeface="Arial" pitchFamily="34" charset="0"/>
-                <a:ea typeface="Arial" pitchFamily="34" charset="-122"/>
-                <a:cs typeface="Arial" pitchFamily="34" charset="-120"/>
-              </a:rPr>
-              <a:t>Priorizar problemas con Mantenimiento</a:t>
-            </a:r>
-            <a:endParaRPr lang="en-US" sz="900" dirty="0"/>
-          </a:p>
-        </p:txBody>
-      </p:sp>
-      <p:sp>
-        <p:nvSpPr>
-          <p:cNvPr id="39" name="Shape 37"/>
+          <p:cNvPr id="46" name="Shape 44"/>
           <p:cNvSpPr/>
           <p:nvPr/>
         </p:nvSpPr>
         <p:spPr>
           <a:xfrm>
-            <a:off x="3977640" y="2322576"/>
-            <a:ext cx="810475" cy="155448"/>
+            <a:off x="4036162" y="2061972"/>
+            <a:ext cx="73152" cy="141732"/>
           </a:xfrm>
           <a:prstGeom prst="roundRect">
             <a:avLst>
-              <a:gd name="adj" fmla="val 29412"/>
+              <a:gd name="adj" fmla="val 62500"/>
+            </a:avLst>
+          </a:prstGeom>
+          <a:solidFill>
+            <a:srgbClr val="022A5B"/>
+          </a:solidFill>
+          <a:ln w="9525">
+            <a:solidFill>
+              <a:srgbClr val="022A5B"/>
+            </a:solidFill>
+            <a:prstDash val="solid"/>
+          </a:ln>
+        </p:spPr>
+      </p:sp>
+      <p:sp>
+        <p:nvSpPr>
+          <p:cNvPr id="47" name="Text 45"/>
+          <p:cNvSpPr txBox="1"/>
+          <p:nvPr/>
+        </p:nvSpPr>
+        <p:spPr>
+          <a:xfrm>
+            <a:off x="11311128" y="2016252"/>
+            <a:ext cx="329184" cy="233172"/>
+          </a:xfrm>
+          <a:prstGeom prst="rect">
+            <a:avLst/>
+          </a:prstGeom>
+          <a:noFill/>
+          <a:ln/>
+        </p:spPr>
+        <p:txBody>
+          <a:bodyPr wrap="square" lIns="0" tIns="0" rIns="0" bIns="0" rtlCol="0" anchor="ctr"/>
+          <a:lstStyle/>
+          <a:p>
+            <a:pPr algn="ctr" indent="0" marL="0">
+              <a:buNone/>
+            </a:pPr>
+            <a:r>
+              <a:rPr lang="en-US" sz="800" b="1" dirty="0">
+                <a:solidFill>
+                  <a:srgbClr val="2E7D32"/>
+                </a:solidFill>
+                <a:latin typeface="Arial" pitchFamily="34" charset="0"/>
+                <a:ea typeface="Arial" pitchFamily="34" charset="-122"/>
+                <a:cs typeface="Arial" pitchFamily="34" charset="-120"/>
+              </a:rPr>
+              <a:t>100%</a:t>
+            </a:r>
+            <a:endParaRPr lang="en-US" sz="800" dirty="0"/>
+          </a:p>
+        </p:txBody>
+      </p:sp>
+      <p:sp>
+        <p:nvSpPr>
+          <p:cNvPr id="48" name="Text 46"/>
+          <p:cNvSpPr txBox="1"/>
+          <p:nvPr/>
+        </p:nvSpPr>
+        <p:spPr>
+          <a:xfrm>
+            <a:off x="868680" y="2249424"/>
+            <a:ext cx="2240280" cy="233172"/>
+          </a:xfrm>
+          <a:prstGeom prst="rect">
+            <a:avLst/>
+          </a:prstGeom>
+          <a:noFill/>
+          <a:ln/>
+        </p:spPr>
+        <p:txBody>
+          <a:bodyPr wrap="square" lIns="0" tIns="0" rIns="0" bIns="0" rtlCol="0" anchor="ctr"/>
+          <a:lstStyle/>
+          <a:p>
+            <a:pPr indent="0" marL="0">
+              <a:buNone/>
+            </a:pPr>
+            <a:r>
+              <a:rPr lang="en-US" sz="850" dirty="0">
+                <a:solidFill>
+                  <a:srgbClr val="1F2937"/>
+                </a:solidFill>
+                <a:latin typeface="Arial" pitchFamily="34" charset="0"/>
+                <a:ea typeface="Arial" pitchFamily="34" charset="-122"/>
+                <a:cs typeface="Arial" pitchFamily="34" charset="-120"/>
+              </a:rPr>
+              <a:t>Diseño teórico</a:t>
+            </a:r>
+            <a:endParaRPr lang="en-US" sz="850" dirty="0"/>
+          </a:p>
+        </p:txBody>
+      </p:sp>
+      <p:sp>
+        <p:nvSpPr>
+          <p:cNvPr id="49" name="Text 47"/>
+          <p:cNvSpPr txBox="1"/>
+          <p:nvPr/>
+        </p:nvSpPr>
+        <p:spPr>
+          <a:xfrm>
+            <a:off x="3017520" y="2249424"/>
+            <a:ext cx="914400" cy="233172"/>
+          </a:xfrm>
+          <a:prstGeom prst="rect">
+            <a:avLst/>
+          </a:prstGeom>
+          <a:noFill/>
+          <a:ln/>
+        </p:spPr>
+        <p:txBody>
+          <a:bodyPr wrap="square" lIns="0" tIns="0" rIns="0" bIns="0" rtlCol="0" anchor="ctr"/>
+          <a:lstStyle/>
+          <a:p>
+            <a:pPr algn="r" indent="0" marL="0">
+              <a:buNone/>
+            </a:pPr>
+            <a:r>
+              <a:rPr lang="en-US" sz="750" dirty="0">
+                <a:solidFill>
+                  <a:srgbClr val="6B7280"/>
+                </a:solidFill>
+                <a:latin typeface="Arial" pitchFamily="34" charset="0"/>
+                <a:ea typeface="Arial" pitchFamily="34" charset="-122"/>
+                <a:cs typeface="Arial" pitchFamily="34" charset="-120"/>
+              </a:rPr>
+              <a:t>13/07 – 25/07</a:t>
+            </a:r>
+            <a:endParaRPr lang="en-US" sz="750" dirty="0"/>
+          </a:p>
+        </p:txBody>
+      </p:sp>
+      <p:sp>
+        <p:nvSpPr>
+          <p:cNvPr id="50" name="Shape 48"/>
+          <p:cNvSpPr/>
+          <p:nvPr/>
+        </p:nvSpPr>
+        <p:spPr>
+          <a:xfrm>
+            <a:off x="4387291" y="2295144"/>
+            <a:ext cx="702259" cy="141732"/>
+          </a:xfrm>
+          <a:prstGeom prst="roundRect">
+            <a:avLst>
+              <a:gd name="adj" fmla="val 32258"/>
             </a:avLst>
           </a:prstGeom>
           <a:solidFill>
             <a:srgbClr val="022A5B">
-              <a:alpha val="55000"/>
+              <a:alpha val="30000"/>
             </a:srgbClr>
           </a:solidFill>
           <a:ln w="9525">
@@ -6622,101 +6961,167 @@
       </p:sp>
       <p:sp>
         <p:nvSpPr>
-          <p:cNvPr id="40" name="Text 38"/>
-          <p:cNvSpPr txBox="1"/>
-          <p:nvPr/>
-        </p:nvSpPr>
-        <p:spPr>
-          <a:xfrm>
-            <a:off x="3063240" y="2276856"/>
-            <a:ext cx="868680" cy="246888"/>
-          </a:xfrm>
-          <a:prstGeom prst="rect">
-            <a:avLst/>
-          </a:prstGeom>
-          <a:noFill/>
-          <a:ln/>
-        </p:spPr>
-        <p:txBody>
-          <a:bodyPr wrap="square" lIns="0" tIns="0" rIns="0" bIns="0" rtlCol="0" anchor="ctr"/>
-          <a:lstStyle/>
-          <a:p>
-            <a:pPr algn="r" indent="0" marL="0">
-              <a:buNone/>
-            </a:pPr>
-            <a:r>
-              <a:rPr lang="en-US" sz="750" dirty="0">
-                <a:solidFill>
-                  <a:srgbClr val="6B7280"/>
-                </a:solidFill>
-                <a:latin typeface="Arial" pitchFamily="34" charset="0"/>
-                <a:ea typeface="Arial" pitchFamily="34" charset="-122"/>
-                <a:cs typeface="Arial" pitchFamily="34" charset="-120"/>
-              </a:rPr>
-              <a:t>14/09 – 25/09</a:t>
-            </a:r>
-            <a:endParaRPr lang="en-US" sz="750" dirty="0"/>
-          </a:p>
-        </p:txBody>
-      </p:sp>
-      <p:sp>
-        <p:nvSpPr>
-          <p:cNvPr id="41" name="Text 39"/>
-          <p:cNvSpPr txBox="1"/>
-          <p:nvPr/>
-        </p:nvSpPr>
-        <p:spPr>
-          <a:xfrm>
-            <a:off x="868680" y="2523744"/>
-            <a:ext cx="3017520" cy="246888"/>
-          </a:xfrm>
-          <a:prstGeom prst="rect">
-            <a:avLst/>
-          </a:prstGeom>
-          <a:noFill/>
-          <a:ln/>
-        </p:spPr>
-        <p:txBody>
-          <a:bodyPr wrap="square" lIns="0" tIns="0" rIns="0" bIns="0" rtlCol="0" anchor="ctr"/>
-          <a:lstStyle/>
-          <a:p>
-            <a:pPr indent="0" marL="0">
-              <a:buNone/>
-            </a:pPr>
-            <a:r>
-              <a:rPr lang="en-US" sz="900" dirty="0">
-                <a:solidFill>
-                  <a:srgbClr val="1F2937"/>
-                </a:solidFill>
-                <a:latin typeface="Arial" pitchFamily="34" charset="0"/>
-                <a:ea typeface="Arial" pitchFamily="34" charset="-122"/>
-                <a:cs typeface="Arial" pitchFamily="34" charset="-120"/>
-              </a:rPr>
-              <a:t>Formar a los multiplicadores</a:t>
-            </a:r>
-            <a:endParaRPr lang="en-US" sz="900" dirty="0"/>
-          </a:p>
-        </p:txBody>
-      </p:sp>
-      <p:sp>
-        <p:nvSpPr>
-          <p:cNvPr id="42" name="Shape 40"/>
+          <p:cNvPr id="51" name="Shape 49"/>
           <p:cNvSpPr/>
           <p:nvPr/>
         </p:nvSpPr>
         <p:spPr>
           <a:xfrm>
-            <a:off x="4493397" y="2569464"/>
-            <a:ext cx="1326232" cy="155448"/>
+            <a:off x="4387291" y="2295144"/>
+            <a:ext cx="702259" cy="141732"/>
           </a:xfrm>
           <a:prstGeom prst="roundRect">
             <a:avLst>
-              <a:gd name="adj" fmla="val 29412"/>
+              <a:gd name="adj" fmla="val 32258"/>
+            </a:avLst>
+          </a:prstGeom>
+          <a:solidFill>
+            <a:srgbClr val="022A5B"/>
+          </a:solidFill>
+          <a:ln w="9525">
+            <a:solidFill>
+              <a:srgbClr val="022A5B"/>
+            </a:solidFill>
+            <a:prstDash val="solid"/>
+          </a:ln>
+        </p:spPr>
+      </p:sp>
+      <p:sp>
+        <p:nvSpPr>
+          <p:cNvPr id="52" name="Text 50"/>
+          <p:cNvSpPr txBox="1"/>
+          <p:nvPr/>
+        </p:nvSpPr>
+        <p:spPr>
+          <a:xfrm>
+            <a:off x="11311128" y="2249424"/>
+            <a:ext cx="329184" cy="233172"/>
+          </a:xfrm>
+          <a:prstGeom prst="rect">
+            <a:avLst/>
+          </a:prstGeom>
+          <a:noFill/>
+          <a:ln/>
+        </p:spPr>
+        <p:txBody>
+          <a:bodyPr wrap="square" lIns="0" tIns="0" rIns="0" bIns="0" rtlCol="0" anchor="ctr"/>
+          <a:lstStyle/>
+          <a:p>
+            <a:pPr algn="ctr" indent="0" marL="0">
+              <a:buNone/>
+            </a:pPr>
+            <a:r>
+              <a:rPr lang="en-US" sz="800" b="1" dirty="0">
+                <a:solidFill>
+                  <a:srgbClr val="2E7D32"/>
+                </a:solidFill>
+                <a:latin typeface="Arial" pitchFamily="34" charset="0"/>
+                <a:ea typeface="Arial" pitchFamily="34" charset="-122"/>
+                <a:cs typeface="Arial" pitchFamily="34" charset="-120"/>
+              </a:rPr>
+              <a:t>100%</a:t>
+            </a:r>
+            <a:endParaRPr lang="en-US" sz="800" dirty="0"/>
+          </a:p>
+        </p:txBody>
+      </p:sp>
+      <p:sp>
+        <p:nvSpPr>
+          <p:cNvPr id="53" name="Text 51"/>
+          <p:cNvSpPr txBox="1"/>
+          <p:nvPr/>
+        </p:nvSpPr>
+        <p:spPr>
+          <a:xfrm>
+            <a:off x="868680" y="2482596"/>
+            <a:ext cx="2240280" cy="233172"/>
+          </a:xfrm>
+          <a:prstGeom prst="rect">
+            <a:avLst/>
+          </a:prstGeom>
+          <a:noFill/>
+          <a:ln/>
+        </p:spPr>
+        <p:txBody>
+          <a:bodyPr wrap="square" lIns="0" tIns="0" rIns="0" bIns="0" rtlCol="0" anchor="ctr"/>
+          <a:lstStyle/>
+          <a:p>
+            <a:pPr indent="0" marL="0">
+              <a:buNone/>
+            </a:pPr>
+            <a:r>
+              <a:rPr lang="en-US" sz="850" dirty="0">
+                <a:solidFill>
+                  <a:srgbClr val="1F2937"/>
+                </a:solidFill>
+                <a:latin typeface="Arial" pitchFamily="34" charset="0"/>
+                <a:ea typeface="Arial" pitchFamily="34" charset="-122"/>
+                <a:cs typeface="Arial" pitchFamily="34" charset="-120"/>
+              </a:rPr>
+              <a:t>Corroboración técnica y elementos por gestión</a:t>
+            </a:r>
+            <a:endParaRPr lang="en-US" sz="850" dirty="0"/>
+          </a:p>
+        </p:txBody>
+      </p:sp>
+      <p:sp>
+        <p:nvSpPr>
+          <p:cNvPr id="54" name="Text 52"/>
+          <p:cNvSpPr txBox="1"/>
+          <p:nvPr/>
+        </p:nvSpPr>
+        <p:spPr>
+          <a:xfrm>
+            <a:off x="3017520" y="2482596"/>
+            <a:ext cx="914400" cy="233172"/>
+          </a:xfrm>
+          <a:prstGeom prst="rect">
+            <a:avLst/>
+          </a:prstGeom>
+          <a:noFill/>
+          <a:ln/>
+        </p:spPr>
+        <p:txBody>
+          <a:bodyPr wrap="square" lIns="0" tIns="0" rIns="0" bIns="0" rtlCol="0" anchor="ctr"/>
+          <a:lstStyle/>
+          <a:p>
+            <a:pPr algn="r" indent="0" marL="0">
+              <a:buNone/>
+            </a:pPr>
+            <a:r>
+              <a:rPr lang="en-US" sz="750" dirty="0">
+                <a:solidFill>
+                  <a:srgbClr val="6B7280"/>
+                </a:solidFill>
+                <a:latin typeface="Arial" pitchFamily="34" charset="0"/>
+                <a:ea typeface="Arial" pitchFamily="34" charset="-122"/>
+                <a:cs typeface="Arial" pitchFamily="34" charset="-120"/>
+              </a:rPr>
+              <a:t>22/07 – 05/08</a:t>
+            </a:r>
+            <a:endParaRPr lang="en-US" sz="750" dirty="0"/>
+          </a:p>
+        </p:txBody>
+      </p:sp>
+      <p:sp>
+        <p:nvSpPr>
+          <p:cNvPr id="55" name="Shape 53"/>
+          <p:cNvSpPr/>
+          <p:nvPr/>
+        </p:nvSpPr>
+        <p:spPr>
+          <a:xfrm>
+            <a:off x="4913986" y="2528316"/>
+            <a:ext cx="819302" cy="141732"/>
+          </a:xfrm>
+          <a:prstGeom prst="roundRect">
+            <a:avLst>
+              <a:gd name="adj" fmla="val 32258"/>
             </a:avLst>
           </a:prstGeom>
           <a:solidFill>
             <a:srgbClr val="022A5B">
-              <a:alpha val="55000"/>
+              <a:alpha val="30000"/>
             </a:srgbClr>
           </a:solidFill>
           <a:ln w="9525">
@@ -6729,14 +7134,41 @@
       </p:sp>
       <p:sp>
         <p:nvSpPr>
-          <p:cNvPr id="43" name="Text 41"/>
-          <p:cNvSpPr txBox="1"/>
-          <p:nvPr/>
-        </p:nvSpPr>
-        <p:spPr>
-          <a:xfrm>
-            <a:off x="3063240" y="2523744"/>
-            <a:ext cx="868680" cy="246888"/>
+          <p:cNvPr id="56" name="Shape 54"/>
+          <p:cNvSpPr/>
+          <p:nvPr/>
+        </p:nvSpPr>
+        <p:spPr>
+          <a:xfrm>
+            <a:off x="4913986" y="2528316"/>
+            <a:ext cx="819302" cy="141732"/>
+          </a:xfrm>
+          <a:prstGeom prst="roundRect">
+            <a:avLst>
+              <a:gd name="adj" fmla="val 32258"/>
+            </a:avLst>
+          </a:prstGeom>
+          <a:solidFill>
+            <a:srgbClr val="022A5B"/>
+          </a:solidFill>
+          <a:ln w="9525">
+            <a:solidFill>
+              <a:srgbClr val="022A5B"/>
+            </a:solidFill>
+            <a:prstDash val="solid"/>
+          </a:ln>
+        </p:spPr>
+      </p:sp>
+      <p:sp>
+        <p:nvSpPr>
+          <p:cNvPr id="57" name="Text 55"/>
+          <p:cNvSpPr txBox="1"/>
+          <p:nvPr/>
+        </p:nvSpPr>
+        <p:spPr>
+          <a:xfrm>
+            <a:off x="11311128" y="2482596"/>
+            <a:ext cx="329184" cy="233172"/>
           </a:xfrm>
           <a:prstGeom prst="rect">
             <a:avLst/>
@@ -6748,6 +7180,84 @@
           <a:bodyPr wrap="square" lIns="0" tIns="0" rIns="0" bIns="0" rtlCol="0" anchor="ctr"/>
           <a:lstStyle/>
           <a:p>
+            <a:pPr algn="ctr" indent="0" marL="0">
+              <a:buNone/>
+            </a:pPr>
+            <a:r>
+              <a:rPr lang="en-US" sz="800" b="1" dirty="0">
+                <a:solidFill>
+                  <a:srgbClr val="2E7D32"/>
+                </a:solidFill>
+                <a:latin typeface="Arial" pitchFamily="34" charset="0"/>
+                <a:ea typeface="Arial" pitchFamily="34" charset="-122"/>
+                <a:cs typeface="Arial" pitchFamily="34" charset="-120"/>
+              </a:rPr>
+              <a:t>100%</a:t>
+            </a:r>
+            <a:endParaRPr lang="en-US" sz="800" dirty="0"/>
+          </a:p>
+        </p:txBody>
+      </p:sp>
+      <p:sp>
+        <p:nvSpPr>
+          <p:cNvPr id="58" name="Text 56"/>
+          <p:cNvSpPr txBox="1"/>
+          <p:nvPr/>
+        </p:nvSpPr>
+        <p:spPr>
+          <a:xfrm>
+            <a:off x="868680" y="2715768"/>
+            <a:ext cx="2240280" cy="233172"/>
+          </a:xfrm>
+          <a:prstGeom prst="rect">
+            <a:avLst/>
+          </a:prstGeom>
+          <a:noFill/>
+          <a:ln/>
+        </p:spPr>
+        <p:txBody>
+          <a:bodyPr wrap="square" lIns="0" tIns="0" rIns="0" bIns="0" rtlCol="0" anchor="ctr"/>
+          <a:lstStyle/>
+          <a:p>
+            <a:pPr indent="0" marL="0">
+              <a:buNone/>
+            </a:pPr>
+            <a:r>
+              <a:rPr lang="en-US" sz="850" dirty="0">
+                <a:solidFill>
+                  <a:srgbClr val="1F2937"/>
+                </a:solidFill>
+                <a:latin typeface="Arial" pitchFamily="34" charset="0"/>
+                <a:ea typeface="Arial" pitchFamily="34" charset="-122"/>
+                <a:cs typeface="Arial" pitchFamily="34" charset="-120"/>
+              </a:rPr>
+              <a:t>Conformación de evaluaciones teóricas</a:t>
+            </a:r>
+            <a:endParaRPr lang="en-US" sz="850" dirty="0"/>
+          </a:p>
+        </p:txBody>
+      </p:sp>
+      <p:sp>
+        <p:nvSpPr>
+          <p:cNvPr id="59" name="Text 57"/>
+          <p:cNvSpPr txBox="1"/>
+          <p:nvPr/>
+        </p:nvSpPr>
+        <p:spPr>
+          <a:xfrm>
+            <a:off x="3017520" y="2715768"/>
+            <a:ext cx="914400" cy="233172"/>
+          </a:xfrm>
+          <a:prstGeom prst="rect">
+            <a:avLst/>
+          </a:prstGeom>
+          <a:noFill/>
+          <a:ln/>
+        </p:spPr>
+        <p:txBody>
+          <a:bodyPr wrap="square" lIns="0" tIns="0" rIns="0" bIns="0" rtlCol="0" anchor="ctr"/>
+          <a:lstStyle/>
+          <a:p>
             <a:pPr algn="r" indent="0" marL="0">
               <a:buNone/>
             </a:pPr>
@@ -6760,7 +7270,7 @@
                 <a:ea typeface="Arial" pitchFamily="34" charset="-122"/>
                 <a:cs typeface="Arial" pitchFamily="34" charset="-120"/>
               </a:rPr>
-              <a:t>21/09 – 09/10</a:t>
+              <a:t>02/08 – 16/08</a:t>
             </a:r>
             <a:endParaRPr lang="en-US" sz="750" dirty="0"/>
           </a:p>
@@ -6768,14 +7278,282 @@
       </p:sp>
       <p:sp>
         <p:nvSpPr>
-          <p:cNvPr id="44" name="Shape 42"/>
+          <p:cNvPr id="60" name="Shape 58"/>
           <p:cNvSpPr/>
           <p:nvPr/>
         </p:nvSpPr>
         <p:spPr>
           <a:xfrm>
-            <a:off x="548640" y="2770632"/>
-            <a:ext cx="11091672" cy="246888"/>
+            <a:off x="5557723" y="2761488"/>
+            <a:ext cx="819302" cy="141732"/>
+          </a:xfrm>
+          <a:prstGeom prst="roundRect">
+            <a:avLst>
+              <a:gd name="adj" fmla="val 32258"/>
+            </a:avLst>
+          </a:prstGeom>
+          <a:solidFill>
+            <a:srgbClr val="022A5B">
+              <a:alpha val="30000"/>
+            </a:srgbClr>
+          </a:solidFill>
+          <a:ln w="9525">
+            <a:solidFill>
+              <a:srgbClr val="022A5B"/>
+            </a:solidFill>
+            <a:prstDash val="solid"/>
+          </a:ln>
+        </p:spPr>
+      </p:sp>
+      <p:sp>
+        <p:nvSpPr>
+          <p:cNvPr id="61" name="Shape 59"/>
+          <p:cNvSpPr/>
+          <p:nvPr/>
+        </p:nvSpPr>
+        <p:spPr>
+          <a:xfrm>
+            <a:off x="5557723" y="2761488"/>
+            <a:ext cx="573512" cy="141732"/>
+          </a:xfrm>
+          <a:prstGeom prst="roundRect">
+            <a:avLst>
+              <a:gd name="adj" fmla="val 32258"/>
+            </a:avLst>
+          </a:prstGeom>
+          <a:solidFill>
+            <a:srgbClr val="022A5B"/>
+          </a:solidFill>
+          <a:ln w="9525">
+            <a:solidFill>
+              <a:srgbClr val="022A5B"/>
+            </a:solidFill>
+            <a:prstDash val="solid"/>
+          </a:ln>
+        </p:spPr>
+      </p:sp>
+      <p:sp>
+        <p:nvSpPr>
+          <p:cNvPr id="62" name="Text 60"/>
+          <p:cNvSpPr txBox="1"/>
+          <p:nvPr/>
+        </p:nvSpPr>
+        <p:spPr>
+          <a:xfrm>
+            <a:off x="11311128" y="2715768"/>
+            <a:ext cx="329184" cy="233172"/>
+          </a:xfrm>
+          <a:prstGeom prst="rect">
+            <a:avLst/>
+          </a:prstGeom>
+          <a:noFill/>
+          <a:ln/>
+        </p:spPr>
+        <p:txBody>
+          <a:bodyPr wrap="square" lIns="0" tIns="0" rIns="0" bIns="0" rtlCol="0" anchor="ctr"/>
+          <a:lstStyle/>
+          <a:p>
+            <a:pPr algn="ctr" indent="0" marL="0">
+              <a:buNone/>
+            </a:pPr>
+            <a:r>
+              <a:rPr lang="en-US" sz="800" b="1" dirty="0">
+                <a:solidFill>
+                  <a:srgbClr val="B8860B"/>
+                </a:solidFill>
+                <a:latin typeface="Arial" pitchFamily="34" charset="0"/>
+                <a:ea typeface="Arial" pitchFamily="34" charset="-122"/>
+                <a:cs typeface="Arial" pitchFamily="34" charset="-120"/>
+              </a:rPr>
+              <a:t>70%</a:t>
+            </a:r>
+            <a:endParaRPr lang="en-US" sz="800" dirty="0"/>
+          </a:p>
+        </p:txBody>
+      </p:sp>
+      <p:sp>
+        <p:nvSpPr>
+          <p:cNvPr id="63" name="Text 61"/>
+          <p:cNvSpPr txBox="1"/>
+          <p:nvPr/>
+        </p:nvSpPr>
+        <p:spPr>
+          <a:xfrm>
+            <a:off x="868680" y="2948940"/>
+            <a:ext cx="2240280" cy="233172"/>
+          </a:xfrm>
+          <a:prstGeom prst="rect">
+            <a:avLst/>
+          </a:prstGeom>
+          <a:noFill/>
+          <a:ln/>
+        </p:spPr>
+        <p:txBody>
+          <a:bodyPr wrap="square" lIns="0" tIns="0" rIns="0" bIns="0" rtlCol="0" anchor="ctr"/>
+          <a:lstStyle/>
+          <a:p>
+            <a:pPr indent="0" marL="0">
+              <a:buNone/>
+            </a:pPr>
+            <a:r>
+              <a:rPr lang="en-US" sz="850" dirty="0">
+                <a:solidFill>
+                  <a:srgbClr val="1F2937"/>
+                </a:solidFill>
+                <a:latin typeface="Arial" pitchFamily="34" charset="0"/>
+                <a:ea typeface="Arial" pitchFamily="34" charset="-122"/>
+                <a:cs typeface="Arial" pitchFamily="34" charset="-120"/>
+              </a:rPr>
+              <a:t>Diseño de juegos por cada Dojo</a:t>
+            </a:r>
+            <a:endParaRPr lang="en-US" sz="850" dirty="0"/>
+          </a:p>
+        </p:txBody>
+      </p:sp>
+      <p:sp>
+        <p:nvSpPr>
+          <p:cNvPr id="64" name="Text 62"/>
+          <p:cNvSpPr txBox="1"/>
+          <p:nvPr/>
+        </p:nvSpPr>
+        <p:spPr>
+          <a:xfrm>
+            <a:off x="3017520" y="2948940"/>
+            <a:ext cx="914400" cy="233172"/>
+          </a:xfrm>
+          <a:prstGeom prst="rect">
+            <a:avLst/>
+          </a:prstGeom>
+          <a:noFill/>
+          <a:ln/>
+        </p:spPr>
+        <p:txBody>
+          <a:bodyPr wrap="square" lIns="0" tIns="0" rIns="0" bIns="0" rtlCol="0" anchor="ctr"/>
+          <a:lstStyle/>
+          <a:p>
+            <a:pPr algn="r" indent="0" marL="0">
+              <a:buNone/>
+            </a:pPr>
+            <a:r>
+              <a:rPr lang="en-US" sz="750" dirty="0">
+                <a:solidFill>
+                  <a:srgbClr val="6B7280"/>
+                </a:solidFill>
+                <a:latin typeface="Arial" pitchFamily="34" charset="0"/>
+                <a:ea typeface="Arial" pitchFamily="34" charset="-122"/>
+                <a:cs typeface="Arial" pitchFamily="34" charset="-120"/>
+              </a:rPr>
+              <a:t>13/08 – 27/08</a:t>
+            </a:r>
+            <a:endParaRPr lang="en-US" sz="750" dirty="0"/>
+          </a:p>
+        </p:txBody>
+      </p:sp>
+      <p:sp>
+        <p:nvSpPr>
+          <p:cNvPr id="65" name="Shape 63"/>
+          <p:cNvSpPr/>
+          <p:nvPr/>
+        </p:nvSpPr>
+        <p:spPr>
+          <a:xfrm>
+            <a:off x="6201461" y="2994660"/>
+            <a:ext cx="819302" cy="141732"/>
+          </a:xfrm>
+          <a:prstGeom prst="roundRect">
+            <a:avLst>
+              <a:gd name="adj" fmla="val 32258"/>
+            </a:avLst>
+          </a:prstGeom>
+          <a:solidFill>
+            <a:srgbClr val="022A5B">
+              <a:alpha val="30000"/>
+            </a:srgbClr>
+          </a:solidFill>
+          <a:ln w="9525">
+            <a:solidFill>
+              <a:srgbClr val="022A5B"/>
+            </a:solidFill>
+            <a:prstDash val="solid"/>
+          </a:ln>
+        </p:spPr>
+      </p:sp>
+      <p:sp>
+        <p:nvSpPr>
+          <p:cNvPr id="66" name="Shape 64"/>
+          <p:cNvSpPr/>
+          <p:nvPr/>
+        </p:nvSpPr>
+        <p:spPr>
+          <a:xfrm>
+            <a:off x="6201461" y="2994660"/>
+            <a:ext cx="819302" cy="141732"/>
+          </a:xfrm>
+          <a:prstGeom prst="roundRect">
+            <a:avLst>
+              <a:gd name="adj" fmla="val 32258"/>
+            </a:avLst>
+          </a:prstGeom>
+          <a:solidFill>
+            <a:srgbClr val="022A5B"/>
+          </a:solidFill>
+          <a:ln w="9525">
+            <a:solidFill>
+              <a:srgbClr val="022A5B"/>
+            </a:solidFill>
+            <a:prstDash val="solid"/>
+          </a:ln>
+        </p:spPr>
+      </p:sp>
+      <p:sp>
+        <p:nvSpPr>
+          <p:cNvPr id="67" name="Text 65"/>
+          <p:cNvSpPr txBox="1"/>
+          <p:nvPr/>
+        </p:nvSpPr>
+        <p:spPr>
+          <a:xfrm>
+            <a:off x="11311128" y="2948940"/>
+            <a:ext cx="329184" cy="233172"/>
+          </a:xfrm>
+          <a:prstGeom prst="rect">
+            <a:avLst/>
+          </a:prstGeom>
+          <a:noFill/>
+          <a:ln/>
+        </p:spPr>
+        <p:txBody>
+          <a:bodyPr wrap="square" lIns="0" tIns="0" rIns="0" bIns="0" rtlCol="0" anchor="ctr"/>
+          <a:lstStyle/>
+          <a:p>
+            <a:pPr algn="ctr" indent="0" marL="0">
+              <a:buNone/>
+            </a:pPr>
+            <a:r>
+              <a:rPr lang="en-US" sz="800" b="1" dirty="0">
+                <a:solidFill>
+                  <a:srgbClr val="2E7D32"/>
+                </a:solidFill>
+                <a:latin typeface="Arial" pitchFamily="34" charset="0"/>
+                <a:ea typeface="Arial" pitchFamily="34" charset="-122"/>
+                <a:cs typeface="Arial" pitchFamily="34" charset="-120"/>
+              </a:rPr>
+              <a:t>100%</a:t>
+            </a:r>
+            <a:endParaRPr lang="en-US" sz="800" dirty="0"/>
+          </a:p>
+        </p:txBody>
+      </p:sp>
+      <p:sp>
+        <p:nvSpPr>
+          <p:cNvPr id="68" name="Shape 66"/>
+          <p:cNvSpPr/>
+          <p:nvPr/>
+        </p:nvSpPr>
+        <p:spPr>
+          <a:xfrm>
+            <a:off x="548640" y="3182112"/>
+            <a:ext cx="11091672" cy="233172"/>
           </a:xfrm>
           <a:prstGeom prst="rect">
             <a:avLst/>
@@ -6793,14 +7571,14 @@
       </p:sp>
       <p:sp>
         <p:nvSpPr>
-          <p:cNvPr id="45" name="Text 43"/>
-          <p:cNvSpPr txBox="1"/>
-          <p:nvPr/>
-        </p:nvSpPr>
-        <p:spPr>
-          <a:xfrm>
-            <a:off x="640080" y="2770632"/>
-            <a:ext cx="3017520" cy="246888"/>
+          <p:cNvPr id="69" name="Text 67"/>
+          <p:cNvSpPr txBox="1"/>
+          <p:nvPr/>
+        </p:nvSpPr>
+        <p:spPr>
+          <a:xfrm>
+            <a:off x="640080" y="3182112"/>
+            <a:ext cx="2240280" cy="233172"/>
           </a:xfrm>
           <a:prstGeom prst="rect">
             <a:avLst/>
@@ -6832,14 +7610,53 @@
       </p:sp>
       <p:sp>
         <p:nvSpPr>
-          <p:cNvPr id="46" name="Shape 44"/>
+          <p:cNvPr id="70" name="Text 68"/>
+          <p:cNvSpPr txBox="1"/>
+          <p:nvPr/>
+        </p:nvSpPr>
+        <p:spPr>
+          <a:xfrm>
+            <a:off x="3017520" y="3182112"/>
+            <a:ext cx="914400" cy="233172"/>
+          </a:xfrm>
+          <a:prstGeom prst="rect">
+            <a:avLst/>
+          </a:prstGeom>
+          <a:noFill/>
+          <a:ln/>
+        </p:spPr>
+        <p:txBody>
+          <a:bodyPr wrap="square" lIns="0" tIns="0" rIns="0" bIns="0" rtlCol="0" anchor="ctr"/>
+          <a:lstStyle/>
+          <a:p>
+            <a:pPr algn="r" indent="0" marL="0">
+              <a:buNone/>
+            </a:pPr>
+            <a:r>
+              <a:rPr lang="en-US" sz="750" dirty="0">
+                <a:solidFill>
+                  <a:srgbClr val="6B7280"/>
+                </a:solidFill>
+                <a:latin typeface="Arial" pitchFamily="34" charset="0"/>
+                <a:ea typeface="Arial" pitchFamily="34" charset="-122"/>
+                <a:cs typeface="Arial" pitchFamily="34" charset="-120"/>
+              </a:rPr>
+              <a:t>24/08 – 10/10</a:t>
+            </a:r>
+            <a:endParaRPr lang="en-US" sz="750" dirty="0"/>
+          </a:p>
+        </p:txBody>
+      </p:sp>
+      <p:sp>
+        <p:nvSpPr>
+          <p:cNvPr id="71" name="Shape 69"/>
           <p:cNvSpPr/>
           <p:nvPr/>
         </p:nvSpPr>
         <p:spPr>
           <a:xfrm>
-            <a:off x="5009154" y="2834640"/>
-            <a:ext cx="2873502" cy="118872"/>
+            <a:off x="6845198" y="3246120"/>
+            <a:ext cx="2750515" cy="105156"/>
           </a:xfrm>
           <a:prstGeom prst="rect">
             <a:avLst/>
@@ -6857,14 +7674,14 @@
       </p:sp>
       <p:sp>
         <p:nvSpPr>
-          <p:cNvPr id="47" name="Text 45"/>
-          <p:cNvSpPr txBox="1"/>
-          <p:nvPr/>
-        </p:nvSpPr>
-        <p:spPr>
-          <a:xfrm>
-            <a:off x="3063240" y="2770632"/>
-            <a:ext cx="868680" cy="246888"/>
+          <p:cNvPr id="72" name="Text 70"/>
+          <p:cNvSpPr txBox="1"/>
+          <p:nvPr/>
+        </p:nvSpPr>
+        <p:spPr>
+          <a:xfrm>
+            <a:off x="868680" y="3415284"/>
+            <a:ext cx="2240280" cy="233172"/>
           </a:xfrm>
           <a:prstGeom prst="rect">
             <a:avLst/>
@@ -6876,6 +7693,45 @@
           <a:bodyPr wrap="square" lIns="0" tIns="0" rIns="0" bIns="0" rtlCol="0" anchor="ctr"/>
           <a:lstStyle/>
           <a:p>
+            <a:pPr indent="0" marL="0">
+              <a:buNone/>
+            </a:pPr>
+            <a:r>
+              <a:rPr lang="en-US" sz="850" dirty="0">
+                <a:solidFill>
+                  <a:srgbClr val="1F2937"/>
+                </a:solidFill>
+                <a:latin typeface="Arial" pitchFamily="34" charset="0"/>
+                <a:ea typeface="Arial" pitchFamily="34" charset="-122"/>
+                <a:cs typeface="Arial" pitchFamily="34" charset="-120"/>
+              </a:rPr>
+              <a:t>Recopilación de herramientas</a:t>
+            </a:r>
+            <a:endParaRPr lang="en-US" sz="850" dirty="0"/>
+          </a:p>
+        </p:txBody>
+      </p:sp>
+      <p:sp>
+        <p:nvSpPr>
+          <p:cNvPr id="73" name="Text 71"/>
+          <p:cNvSpPr txBox="1"/>
+          <p:nvPr/>
+        </p:nvSpPr>
+        <p:spPr>
+          <a:xfrm>
+            <a:off x="3017520" y="3415284"/>
+            <a:ext cx="914400" cy="233172"/>
+          </a:xfrm>
+          <a:prstGeom prst="rect">
+            <a:avLst/>
+          </a:prstGeom>
+          <a:noFill/>
+          <a:ln/>
+        </p:spPr>
+        <p:txBody>
+          <a:bodyPr wrap="square" lIns="0" tIns="0" rIns="0" bIns="0" rtlCol="0" anchor="ctr"/>
+          <a:lstStyle/>
+          <a:p>
             <a:pPr algn="r" indent="0" marL="0">
               <a:buNone/>
             </a:pPr>
@@ -6888,7 +7744,7 @@
                 <a:ea typeface="Arial" pitchFamily="34" charset="-122"/>
                 <a:cs typeface="Arial" pitchFamily="34" charset="-120"/>
               </a:rPr>
-              <a:t>28/09 – 06/11</a:t>
+              <a:t>24/08 – 07/09</a:t>
             </a:r>
             <a:endParaRPr lang="en-US" sz="750" dirty="0"/>
           </a:p>
@@ -6896,62 +7752,23 @@
       </p:sp>
       <p:sp>
         <p:nvSpPr>
-          <p:cNvPr id="48" name="Text 46"/>
-          <p:cNvSpPr txBox="1"/>
-          <p:nvPr/>
-        </p:nvSpPr>
-        <p:spPr>
-          <a:xfrm>
-            <a:off x="868680" y="3017520"/>
-            <a:ext cx="3017520" cy="246888"/>
-          </a:xfrm>
-          <a:prstGeom prst="rect">
-            <a:avLst/>
-          </a:prstGeom>
-          <a:noFill/>
-          <a:ln/>
-        </p:spPr>
-        <p:txBody>
-          <a:bodyPr wrap="square" lIns="0" tIns="0" rIns="0" bIns="0" rtlCol="0" anchor="ctr"/>
-          <a:lstStyle/>
-          <a:p>
-            <a:pPr indent="0" marL="0">
-              <a:buNone/>
-            </a:pPr>
-            <a:r>
-              <a:rPr lang="en-US" sz="900" dirty="0">
-                <a:solidFill>
-                  <a:srgbClr val="1F2937"/>
-                </a:solidFill>
-                <a:latin typeface="Arial" pitchFamily="34" charset="0"/>
-                <a:ea typeface="Arial" pitchFamily="34" charset="-122"/>
-                <a:cs typeface="Arial" pitchFamily="34" charset="-120"/>
-              </a:rPr>
-              <a:t>Fabricar las 4 maquetas</a:t>
-            </a:r>
-            <a:endParaRPr lang="en-US" sz="900" dirty="0"/>
-          </a:p>
-        </p:txBody>
-      </p:sp>
-      <p:sp>
-        <p:nvSpPr>
-          <p:cNvPr id="49" name="Shape 47"/>
+          <p:cNvPr id="74" name="Shape 72"/>
           <p:cNvSpPr/>
           <p:nvPr/>
         </p:nvSpPr>
         <p:spPr>
           <a:xfrm>
-            <a:off x="5009154" y="3063240"/>
-            <a:ext cx="2357745" cy="155448"/>
+            <a:off x="6845198" y="3461004"/>
+            <a:ext cx="819302" cy="141732"/>
           </a:xfrm>
           <a:prstGeom prst="roundRect">
             <a:avLst>
-              <a:gd name="adj" fmla="val 29412"/>
+              <a:gd name="adj" fmla="val 32258"/>
             </a:avLst>
           </a:prstGeom>
           <a:solidFill>
             <a:srgbClr val="0B3A73">
-              <a:alpha val="55000"/>
+              <a:alpha val="30000"/>
             </a:srgbClr>
           </a:solidFill>
           <a:ln w="9525">
@@ -6964,101 +7781,167 @@
       </p:sp>
       <p:sp>
         <p:nvSpPr>
-          <p:cNvPr id="50" name="Text 48"/>
-          <p:cNvSpPr txBox="1"/>
-          <p:nvPr/>
-        </p:nvSpPr>
-        <p:spPr>
-          <a:xfrm>
-            <a:off x="3063240" y="3017520"/>
-            <a:ext cx="868680" cy="246888"/>
-          </a:xfrm>
-          <a:prstGeom prst="rect">
-            <a:avLst/>
-          </a:prstGeom>
-          <a:noFill/>
-          <a:ln/>
-        </p:spPr>
-        <p:txBody>
-          <a:bodyPr wrap="square" lIns="0" tIns="0" rIns="0" bIns="0" rtlCol="0" anchor="ctr"/>
-          <a:lstStyle/>
-          <a:p>
-            <a:pPr algn="r" indent="0" marL="0">
-              <a:buNone/>
-            </a:pPr>
-            <a:r>
-              <a:rPr lang="en-US" sz="750" dirty="0">
-                <a:solidFill>
-                  <a:srgbClr val="6B7280"/>
-                </a:solidFill>
-                <a:latin typeface="Arial" pitchFamily="34" charset="0"/>
-                <a:ea typeface="Arial" pitchFamily="34" charset="-122"/>
-                <a:cs typeface="Arial" pitchFamily="34" charset="-120"/>
-              </a:rPr>
-              <a:t>28/09 – 30/10</a:t>
-            </a:r>
-            <a:endParaRPr lang="en-US" sz="750" dirty="0"/>
-          </a:p>
-        </p:txBody>
-      </p:sp>
-      <p:sp>
-        <p:nvSpPr>
-          <p:cNvPr id="51" name="Text 49"/>
-          <p:cNvSpPr txBox="1"/>
-          <p:nvPr/>
-        </p:nvSpPr>
-        <p:spPr>
-          <a:xfrm>
-            <a:off x="868680" y="3264408"/>
-            <a:ext cx="3017520" cy="246888"/>
-          </a:xfrm>
-          <a:prstGeom prst="rect">
-            <a:avLst/>
-          </a:prstGeom>
-          <a:noFill/>
-          <a:ln/>
-        </p:spPr>
-        <p:txBody>
-          <a:bodyPr wrap="square" lIns="0" tIns="0" rIns="0" bIns="0" rtlCol="0" anchor="ctr"/>
-          <a:lstStyle/>
-          <a:p>
-            <a:pPr indent="0" marL="0">
-              <a:buNone/>
-            </a:pPr>
-            <a:r>
-              <a:rPr lang="en-US" sz="900" dirty="0">
-                <a:solidFill>
-                  <a:srgbClr val="1F2937"/>
-                </a:solidFill>
-                <a:latin typeface="Arial" pitchFamily="34" charset="0"/>
-                <a:ea typeface="Arial" pitchFamily="34" charset="-122"/>
-                <a:cs typeface="Arial" pitchFamily="34" charset="-120"/>
-              </a:rPr>
-              <a:t>Imprimir tótems y señalización del sector</a:t>
-            </a:r>
-            <a:endParaRPr lang="en-US" sz="900" dirty="0"/>
-          </a:p>
-        </p:txBody>
-      </p:sp>
-      <p:sp>
-        <p:nvSpPr>
-          <p:cNvPr id="52" name="Shape 50"/>
+          <p:cNvPr id="75" name="Shape 73"/>
           <p:cNvSpPr/>
           <p:nvPr/>
         </p:nvSpPr>
         <p:spPr>
           <a:xfrm>
-            <a:off x="5524910" y="3310128"/>
-            <a:ext cx="1326232" cy="155448"/>
+            <a:off x="6845198" y="3461004"/>
+            <a:ext cx="409651" cy="141732"/>
           </a:xfrm>
           <a:prstGeom prst="roundRect">
             <a:avLst>
-              <a:gd name="adj" fmla="val 29412"/>
+              <a:gd name="adj" fmla="val 32258"/>
+            </a:avLst>
+          </a:prstGeom>
+          <a:solidFill>
+            <a:srgbClr val="0B3A73"/>
+          </a:solidFill>
+          <a:ln w="9525">
+            <a:solidFill>
+              <a:srgbClr val="0B3A73"/>
+            </a:solidFill>
+            <a:prstDash val="solid"/>
+          </a:ln>
+        </p:spPr>
+      </p:sp>
+      <p:sp>
+        <p:nvSpPr>
+          <p:cNvPr id="76" name="Text 74"/>
+          <p:cNvSpPr txBox="1"/>
+          <p:nvPr/>
+        </p:nvSpPr>
+        <p:spPr>
+          <a:xfrm>
+            <a:off x="11311128" y="3415284"/>
+            <a:ext cx="329184" cy="233172"/>
+          </a:xfrm>
+          <a:prstGeom prst="rect">
+            <a:avLst/>
+          </a:prstGeom>
+          <a:noFill/>
+          <a:ln/>
+        </p:spPr>
+        <p:txBody>
+          <a:bodyPr wrap="square" lIns="0" tIns="0" rIns="0" bIns="0" rtlCol="0" anchor="ctr"/>
+          <a:lstStyle/>
+          <a:p>
+            <a:pPr algn="ctr" indent="0" marL="0">
+              <a:buNone/>
+            </a:pPr>
+            <a:r>
+              <a:rPr lang="en-US" sz="800" b="1" dirty="0">
+                <a:solidFill>
+                  <a:srgbClr val="B8860B"/>
+                </a:solidFill>
+                <a:latin typeface="Arial" pitchFamily="34" charset="0"/>
+                <a:ea typeface="Arial" pitchFamily="34" charset="-122"/>
+                <a:cs typeface="Arial" pitchFamily="34" charset="-120"/>
+              </a:rPr>
+              <a:t>50%</a:t>
+            </a:r>
+            <a:endParaRPr lang="en-US" sz="800" dirty="0"/>
+          </a:p>
+        </p:txBody>
+      </p:sp>
+      <p:sp>
+        <p:nvSpPr>
+          <p:cNvPr id="77" name="Text 75"/>
+          <p:cNvSpPr txBox="1"/>
+          <p:nvPr/>
+        </p:nvSpPr>
+        <p:spPr>
+          <a:xfrm>
+            <a:off x="868680" y="3648456"/>
+            <a:ext cx="2240280" cy="233172"/>
+          </a:xfrm>
+          <a:prstGeom prst="rect">
+            <a:avLst/>
+          </a:prstGeom>
+          <a:noFill/>
+          <a:ln/>
+        </p:spPr>
+        <p:txBody>
+          <a:bodyPr wrap="square" lIns="0" tIns="0" rIns="0" bIns="0" rtlCol="0" anchor="ctr"/>
+          <a:lstStyle/>
+          <a:p>
+            <a:pPr indent="0" marL="0">
+              <a:buNone/>
+            </a:pPr>
+            <a:r>
+              <a:rPr lang="en-US" sz="850" dirty="0">
+                <a:solidFill>
+                  <a:srgbClr val="1F2937"/>
+                </a:solidFill>
+                <a:latin typeface="Arial" pitchFamily="34" charset="0"/>
+                <a:ea typeface="Arial" pitchFamily="34" charset="-122"/>
+                <a:cs typeface="Arial" pitchFamily="34" charset="-120"/>
+              </a:rPr>
+              <a:t>Diseño del espacio</a:t>
+            </a:r>
+            <a:endParaRPr lang="en-US" sz="850" dirty="0"/>
+          </a:p>
+        </p:txBody>
+      </p:sp>
+      <p:sp>
+        <p:nvSpPr>
+          <p:cNvPr id="78" name="Text 76"/>
+          <p:cNvSpPr txBox="1"/>
+          <p:nvPr/>
+        </p:nvSpPr>
+        <p:spPr>
+          <a:xfrm>
+            <a:off x="3017520" y="3648456"/>
+            <a:ext cx="914400" cy="233172"/>
+          </a:xfrm>
+          <a:prstGeom prst="rect">
+            <a:avLst/>
+          </a:prstGeom>
+          <a:noFill/>
+          <a:ln/>
+        </p:spPr>
+        <p:txBody>
+          <a:bodyPr wrap="square" lIns="0" tIns="0" rIns="0" bIns="0" rtlCol="0" anchor="ctr"/>
+          <a:lstStyle/>
+          <a:p>
+            <a:pPr algn="r" indent="0" marL="0">
+              <a:buNone/>
+            </a:pPr>
+            <a:r>
+              <a:rPr lang="en-US" sz="750" dirty="0">
+                <a:solidFill>
+                  <a:srgbClr val="6B7280"/>
+                </a:solidFill>
+                <a:latin typeface="Arial" pitchFamily="34" charset="0"/>
+                <a:ea typeface="Arial" pitchFamily="34" charset="-122"/>
+                <a:cs typeface="Arial" pitchFamily="34" charset="-120"/>
+              </a:rPr>
+              <a:t>04/09 – 18/09</a:t>
+            </a:r>
+            <a:endParaRPr lang="en-US" sz="750" dirty="0"/>
+          </a:p>
+        </p:txBody>
+      </p:sp>
+      <p:sp>
+        <p:nvSpPr>
+          <p:cNvPr id="79" name="Shape 77"/>
+          <p:cNvSpPr/>
+          <p:nvPr/>
+        </p:nvSpPr>
+        <p:spPr>
+          <a:xfrm>
+            <a:off x="7488936" y="3694176"/>
+            <a:ext cx="819302" cy="141732"/>
+          </a:xfrm>
+          <a:prstGeom prst="roundRect">
+            <a:avLst>
+              <a:gd name="adj" fmla="val 32258"/>
             </a:avLst>
           </a:prstGeom>
           <a:solidFill>
             <a:srgbClr val="0B3A73">
-              <a:alpha val="55000"/>
+              <a:alpha val="30000"/>
             </a:srgbClr>
           </a:solidFill>
           <a:ln w="9525">
@@ -7071,101 +7954,167 @@
       </p:sp>
       <p:sp>
         <p:nvSpPr>
-          <p:cNvPr id="53" name="Text 51"/>
-          <p:cNvSpPr txBox="1"/>
-          <p:nvPr/>
-        </p:nvSpPr>
-        <p:spPr>
-          <a:xfrm>
-            <a:off x="3063240" y="3264408"/>
-            <a:ext cx="868680" cy="246888"/>
-          </a:xfrm>
-          <a:prstGeom prst="rect">
-            <a:avLst/>
-          </a:prstGeom>
-          <a:noFill/>
-          <a:ln/>
-        </p:spPr>
-        <p:txBody>
-          <a:bodyPr wrap="square" lIns="0" tIns="0" rIns="0" bIns="0" rtlCol="0" anchor="ctr"/>
-          <a:lstStyle/>
-          <a:p>
-            <a:pPr algn="r" indent="0" marL="0">
-              <a:buNone/>
-            </a:pPr>
-            <a:r>
-              <a:rPr lang="en-US" sz="750" dirty="0">
-                <a:solidFill>
-                  <a:srgbClr val="6B7280"/>
-                </a:solidFill>
-                <a:latin typeface="Arial" pitchFamily="34" charset="0"/>
-                <a:ea typeface="Arial" pitchFamily="34" charset="-122"/>
-                <a:cs typeface="Arial" pitchFamily="34" charset="-120"/>
-              </a:rPr>
-              <a:t>05/10 – 23/10</a:t>
-            </a:r>
-            <a:endParaRPr lang="en-US" sz="750" dirty="0"/>
-          </a:p>
-        </p:txBody>
-      </p:sp>
-      <p:sp>
-        <p:nvSpPr>
-          <p:cNvPr id="54" name="Text 52"/>
-          <p:cNvSpPr txBox="1"/>
-          <p:nvPr/>
-        </p:nvSpPr>
-        <p:spPr>
-          <a:xfrm>
-            <a:off x="868680" y="3511296"/>
-            <a:ext cx="3017520" cy="246888"/>
-          </a:xfrm>
-          <a:prstGeom prst="rect">
-            <a:avLst/>
-          </a:prstGeom>
-          <a:noFill/>
-          <a:ln/>
-        </p:spPr>
-        <p:txBody>
-          <a:bodyPr wrap="square" lIns="0" tIns="0" rIns="0" bIns="0" rtlCol="0" anchor="ctr"/>
-          <a:lstStyle/>
-          <a:p>
-            <a:pPr indent="0" marL="0">
-              <a:buNone/>
-            </a:pPr>
-            <a:r>
-              <a:rPr lang="en-US" sz="900" dirty="0">
-                <a:solidFill>
-                  <a:srgbClr val="1F2937"/>
-                </a:solidFill>
-                <a:latin typeface="Arial" pitchFamily="34" charset="0"/>
-                <a:ea typeface="Arial" pitchFamily="34" charset="-122"/>
-                <a:cs typeface="Arial" pitchFamily="34" charset="-120"/>
-              </a:rPr>
-              <a:t>Crear contenido y estándares LLA</a:t>
-            </a:r>
-            <a:endParaRPr lang="en-US" sz="900" dirty="0"/>
-          </a:p>
-        </p:txBody>
-      </p:sp>
-      <p:sp>
-        <p:nvSpPr>
-          <p:cNvPr id="55" name="Shape 53"/>
+          <p:cNvPr id="80" name="Shape 78"/>
           <p:cNvSpPr/>
           <p:nvPr/>
         </p:nvSpPr>
         <p:spPr>
           <a:xfrm>
-            <a:off x="5524910" y="3557016"/>
-            <a:ext cx="1841988" cy="155448"/>
+            <a:off x="7488936" y="3694176"/>
+            <a:ext cx="819302" cy="141732"/>
           </a:xfrm>
           <a:prstGeom prst="roundRect">
             <a:avLst>
-              <a:gd name="adj" fmla="val 29412"/>
+              <a:gd name="adj" fmla="val 32258"/>
+            </a:avLst>
+          </a:prstGeom>
+          <a:solidFill>
+            <a:srgbClr val="0B3A73"/>
+          </a:solidFill>
+          <a:ln w="9525">
+            <a:solidFill>
+              <a:srgbClr val="0B3A73"/>
+            </a:solidFill>
+            <a:prstDash val="solid"/>
+          </a:ln>
+        </p:spPr>
+      </p:sp>
+      <p:sp>
+        <p:nvSpPr>
+          <p:cNvPr id="81" name="Text 79"/>
+          <p:cNvSpPr txBox="1"/>
+          <p:nvPr/>
+        </p:nvSpPr>
+        <p:spPr>
+          <a:xfrm>
+            <a:off x="11311128" y="3648456"/>
+            <a:ext cx="329184" cy="233172"/>
+          </a:xfrm>
+          <a:prstGeom prst="rect">
+            <a:avLst/>
+          </a:prstGeom>
+          <a:noFill/>
+          <a:ln/>
+        </p:spPr>
+        <p:txBody>
+          <a:bodyPr wrap="square" lIns="0" tIns="0" rIns="0" bIns="0" rtlCol="0" anchor="ctr"/>
+          <a:lstStyle/>
+          <a:p>
+            <a:pPr algn="ctr" indent="0" marL="0">
+              <a:buNone/>
+            </a:pPr>
+            <a:r>
+              <a:rPr lang="en-US" sz="800" b="1" dirty="0">
+                <a:solidFill>
+                  <a:srgbClr val="2E7D32"/>
+                </a:solidFill>
+                <a:latin typeface="Arial" pitchFamily="34" charset="0"/>
+                <a:ea typeface="Arial" pitchFamily="34" charset="-122"/>
+                <a:cs typeface="Arial" pitchFamily="34" charset="-120"/>
+              </a:rPr>
+              <a:t>100%</a:t>
+            </a:r>
+            <a:endParaRPr lang="en-US" sz="800" dirty="0"/>
+          </a:p>
+        </p:txBody>
+      </p:sp>
+      <p:sp>
+        <p:nvSpPr>
+          <p:cNvPr id="82" name="Text 80"/>
+          <p:cNvSpPr txBox="1"/>
+          <p:nvPr/>
+        </p:nvSpPr>
+        <p:spPr>
+          <a:xfrm>
+            <a:off x="868680" y="3881628"/>
+            <a:ext cx="2240280" cy="233172"/>
+          </a:xfrm>
+          <a:prstGeom prst="rect">
+            <a:avLst/>
+          </a:prstGeom>
+          <a:noFill/>
+          <a:ln/>
+        </p:spPr>
+        <p:txBody>
+          <a:bodyPr wrap="square" lIns="0" tIns="0" rIns="0" bIns="0" rtlCol="0" anchor="ctr"/>
+          <a:lstStyle/>
+          <a:p>
+            <a:pPr indent="0" marL="0">
+              <a:buNone/>
+            </a:pPr>
+            <a:r>
+              <a:rPr lang="en-US" sz="850" dirty="0">
+                <a:solidFill>
+                  <a:srgbClr val="1F2937"/>
+                </a:solidFill>
+                <a:latin typeface="Arial" pitchFamily="34" charset="0"/>
+                <a:ea typeface="Arial" pitchFamily="34" charset="-122"/>
+                <a:cs typeface="Arial" pitchFamily="34" charset="-120"/>
+              </a:rPr>
+              <a:t>Identificación de elementos</a:t>
+            </a:r>
+            <a:endParaRPr lang="en-US" sz="850" dirty="0"/>
+          </a:p>
+        </p:txBody>
+      </p:sp>
+      <p:sp>
+        <p:nvSpPr>
+          <p:cNvPr id="83" name="Text 81"/>
+          <p:cNvSpPr txBox="1"/>
+          <p:nvPr/>
+        </p:nvSpPr>
+        <p:spPr>
+          <a:xfrm>
+            <a:off x="3017520" y="3881628"/>
+            <a:ext cx="914400" cy="233172"/>
+          </a:xfrm>
+          <a:prstGeom prst="rect">
+            <a:avLst/>
+          </a:prstGeom>
+          <a:noFill/>
+          <a:ln/>
+        </p:spPr>
+        <p:txBody>
+          <a:bodyPr wrap="square" lIns="0" tIns="0" rIns="0" bIns="0" rtlCol="0" anchor="ctr"/>
+          <a:lstStyle/>
+          <a:p>
+            <a:pPr algn="r" indent="0" marL="0">
+              <a:buNone/>
+            </a:pPr>
+            <a:r>
+              <a:rPr lang="en-US" sz="750" dirty="0">
+                <a:solidFill>
+                  <a:srgbClr val="6B7280"/>
+                </a:solidFill>
+                <a:latin typeface="Arial" pitchFamily="34" charset="0"/>
+                <a:ea typeface="Arial" pitchFamily="34" charset="-122"/>
+                <a:cs typeface="Arial" pitchFamily="34" charset="-120"/>
+              </a:rPr>
+              <a:t>15/09 – 29/09</a:t>
+            </a:r>
+            <a:endParaRPr lang="en-US" sz="750" dirty="0"/>
+          </a:p>
+        </p:txBody>
+      </p:sp>
+      <p:sp>
+        <p:nvSpPr>
+          <p:cNvPr id="84" name="Shape 82"/>
+          <p:cNvSpPr/>
+          <p:nvPr/>
+        </p:nvSpPr>
+        <p:spPr>
+          <a:xfrm>
+            <a:off x="8132674" y="3927348"/>
+            <a:ext cx="819302" cy="141732"/>
+          </a:xfrm>
+          <a:prstGeom prst="roundRect">
+            <a:avLst>
+              <a:gd name="adj" fmla="val 32258"/>
             </a:avLst>
           </a:prstGeom>
           <a:solidFill>
             <a:srgbClr val="0B3A73">
-              <a:alpha val="55000"/>
+              <a:alpha val="30000"/>
             </a:srgbClr>
           </a:solidFill>
           <a:ln w="9525">
@@ -7178,101 +8127,167 @@
       </p:sp>
       <p:sp>
         <p:nvSpPr>
-          <p:cNvPr id="56" name="Text 54"/>
-          <p:cNvSpPr txBox="1"/>
-          <p:nvPr/>
-        </p:nvSpPr>
-        <p:spPr>
-          <a:xfrm>
-            <a:off x="3063240" y="3511296"/>
-            <a:ext cx="868680" cy="246888"/>
-          </a:xfrm>
-          <a:prstGeom prst="rect">
-            <a:avLst/>
-          </a:prstGeom>
-          <a:noFill/>
-          <a:ln/>
-        </p:spPr>
-        <p:txBody>
-          <a:bodyPr wrap="square" lIns="0" tIns="0" rIns="0" bIns="0" rtlCol="0" anchor="ctr"/>
-          <a:lstStyle/>
-          <a:p>
-            <a:pPr algn="r" indent="0" marL="0">
-              <a:buNone/>
-            </a:pPr>
-            <a:r>
-              <a:rPr lang="en-US" sz="750" dirty="0">
-                <a:solidFill>
-                  <a:srgbClr val="6B7280"/>
-                </a:solidFill>
-                <a:latin typeface="Arial" pitchFamily="34" charset="0"/>
-                <a:ea typeface="Arial" pitchFamily="34" charset="-122"/>
-                <a:cs typeface="Arial" pitchFamily="34" charset="-120"/>
-              </a:rPr>
-              <a:t>05/10 – 30/10</a:t>
-            </a:r>
-            <a:endParaRPr lang="en-US" sz="750" dirty="0"/>
-          </a:p>
-        </p:txBody>
-      </p:sp>
-      <p:sp>
-        <p:nvSpPr>
-          <p:cNvPr id="57" name="Text 55"/>
-          <p:cNvSpPr txBox="1"/>
-          <p:nvPr/>
-        </p:nvSpPr>
-        <p:spPr>
-          <a:xfrm>
-            <a:off x="868680" y="3758184"/>
-            <a:ext cx="3017520" cy="246888"/>
-          </a:xfrm>
-          <a:prstGeom prst="rect">
-            <a:avLst/>
-          </a:prstGeom>
-          <a:noFill/>
-          <a:ln/>
-        </p:spPr>
-        <p:txBody>
-          <a:bodyPr wrap="square" lIns="0" tIns="0" rIns="0" bIns="0" rtlCol="0" anchor="ctr"/>
-          <a:lstStyle/>
-          <a:p>
-            <a:pPr indent="0" marL="0">
-              <a:buNone/>
-            </a:pPr>
-            <a:r>
-              <a:rPr lang="en-US" sz="900" dirty="0">
-                <a:solidFill>
-                  <a:srgbClr val="1F2937"/>
-                </a:solidFill>
-                <a:latin typeface="Arial" pitchFamily="34" charset="0"/>
-                <a:ea typeface="Arial" pitchFamily="34" charset="-122"/>
-                <a:cs typeface="Arial" pitchFamily="34" charset="-120"/>
-              </a:rPr>
-              <a:t>Adaptar el AM Game a Pintura</a:t>
-            </a:r>
-            <a:endParaRPr lang="en-US" sz="900" dirty="0"/>
-          </a:p>
-        </p:txBody>
-      </p:sp>
-      <p:sp>
-        <p:nvSpPr>
-          <p:cNvPr id="58" name="Shape 56"/>
+          <p:cNvPr id="85" name="Shape 83"/>
           <p:cNvSpPr/>
           <p:nvPr/>
         </p:nvSpPr>
         <p:spPr>
           <a:xfrm>
-            <a:off x="6040667" y="3803904"/>
-            <a:ext cx="1841988" cy="155448"/>
+            <a:off x="8132674" y="3927348"/>
+            <a:ext cx="163860" cy="141732"/>
           </a:xfrm>
           <a:prstGeom prst="roundRect">
             <a:avLst>
-              <a:gd name="adj" fmla="val 29412"/>
+              <a:gd name="adj" fmla="val 32258"/>
+            </a:avLst>
+          </a:prstGeom>
+          <a:solidFill>
+            <a:srgbClr val="0B3A73"/>
+          </a:solidFill>
+          <a:ln w="9525">
+            <a:solidFill>
+              <a:srgbClr val="0B3A73"/>
+            </a:solidFill>
+            <a:prstDash val="solid"/>
+          </a:ln>
+        </p:spPr>
+      </p:sp>
+      <p:sp>
+        <p:nvSpPr>
+          <p:cNvPr id="86" name="Text 84"/>
+          <p:cNvSpPr txBox="1"/>
+          <p:nvPr/>
+        </p:nvSpPr>
+        <p:spPr>
+          <a:xfrm>
+            <a:off x="11311128" y="3881628"/>
+            <a:ext cx="329184" cy="233172"/>
+          </a:xfrm>
+          <a:prstGeom prst="rect">
+            <a:avLst/>
+          </a:prstGeom>
+          <a:noFill/>
+          <a:ln/>
+        </p:spPr>
+        <p:txBody>
+          <a:bodyPr wrap="square" lIns="0" tIns="0" rIns="0" bIns="0" rtlCol="0" anchor="ctr"/>
+          <a:lstStyle/>
+          <a:p>
+            <a:pPr algn="ctr" indent="0" marL="0">
+              <a:buNone/>
+            </a:pPr>
+            <a:r>
+              <a:rPr lang="en-US" sz="800" b="1" dirty="0">
+                <a:solidFill>
+                  <a:srgbClr val="B8860B"/>
+                </a:solidFill>
+                <a:latin typeface="Arial" pitchFamily="34" charset="0"/>
+                <a:ea typeface="Arial" pitchFamily="34" charset="-122"/>
+                <a:cs typeface="Arial" pitchFamily="34" charset="-120"/>
+              </a:rPr>
+              <a:t>20%</a:t>
+            </a:r>
+            <a:endParaRPr lang="en-US" sz="800" dirty="0"/>
+          </a:p>
+        </p:txBody>
+      </p:sp>
+      <p:sp>
+        <p:nvSpPr>
+          <p:cNvPr id="87" name="Text 85"/>
+          <p:cNvSpPr txBox="1"/>
+          <p:nvPr/>
+        </p:nvSpPr>
+        <p:spPr>
+          <a:xfrm>
+            <a:off x="868680" y="4114800"/>
+            <a:ext cx="2240280" cy="233172"/>
+          </a:xfrm>
+          <a:prstGeom prst="rect">
+            <a:avLst/>
+          </a:prstGeom>
+          <a:noFill/>
+          <a:ln/>
+        </p:spPr>
+        <p:txBody>
+          <a:bodyPr wrap="square" lIns="0" tIns="0" rIns="0" bIns="0" rtlCol="0" anchor="ctr"/>
+          <a:lstStyle/>
+          <a:p>
+            <a:pPr indent="0" marL="0">
+              <a:buNone/>
+            </a:pPr>
+            <a:r>
+              <a:rPr lang="en-US" sz="850" dirty="0">
+                <a:solidFill>
+                  <a:srgbClr val="1F2937"/>
+                </a:solidFill>
+                <a:latin typeface="Arial" pitchFamily="34" charset="0"/>
+                <a:ea typeface="Arial" pitchFamily="34" charset="-122"/>
+                <a:cs typeface="Arial" pitchFamily="34" charset="-120"/>
+              </a:rPr>
+              <a:t>Prototipo de stands y pasaporte</a:t>
+            </a:r>
+            <a:endParaRPr lang="en-US" sz="850" dirty="0"/>
+          </a:p>
+        </p:txBody>
+      </p:sp>
+      <p:sp>
+        <p:nvSpPr>
+          <p:cNvPr id="88" name="Text 86"/>
+          <p:cNvSpPr txBox="1"/>
+          <p:nvPr/>
+        </p:nvSpPr>
+        <p:spPr>
+          <a:xfrm>
+            <a:off x="3017520" y="4114800"/>
+            <a:ext cx="914400" cy="233172"/>
+          </a:xfrm>
+          <a:prstGeom prst="rect">
+            <a:avLst/>
+          </a:prstGeom>
+          <a:noFill/>
+          <a:ln/>
+        </p:spPr>
+        <p:txBody>
+          <a:bodyPr wrap="square" lIns="0" tIns="0" rIns="0" bIns="0" rtlCol="0" anchor="ctr"/>
+          <a:lstStyle/>
+          <a:p>
+            <a:pPr algn="r" indent="0" marL="0">
+              <a:buNone/>
+            </a:pPr>
+            <a:r>
+              <a:rPr lang="en-US" sz="750" dirty="0">
+                <a:solidFill>
+                  <a:srgbClr val="6B7280"/>
+                </a:solidFill>
+                <a:latin typeface="Arial" pitchFamily="34" charset="0"/>
+                <a:ea typeface="Arial" pitchFamily="34" charset="-122"/>
+                <a:cs typeface="Arial" pitchFamily="34" charset="-120"/>
+              </a:rPr>
+              <a:t>26/09 – 10/10</a:t>
+            </a:r>
+            <a:endParaRPr lang="en-US" sz="750" dirty="0"/>
+          </a:p>
+        </p:txBody>
+      </p:sp>
+      <p:sp>
+        <p:nvSpPr>
+          <p:cNvPr id="89" name="Shape 87"/>
+          <p:cNvSpPr/>
+          <p:nvPr/>
+        </p:nvSpPr>
+        <p:spPr>
+          <a:xfrm>
+            <a:off x="8776411" y="4160520"/>
+            <a:ext cx="819302" cy="141732"/>
+          </a:xfrm>
+          <a:prstGeom prst="roundRect">
+            <a:avLst>
+              <a:gd name="adj" fmla="val 32258"/>
             </a:avLst>
           </a:prstGeom>
           <a:solidFill>
             <a:srgbClr val="0B3A73">
-              <a:alpha val="55000"/>
+              <a:alpha val="30000"/>
             </a:srgbClr>
           </a:solidFill>
           <a:ln w="9525">
@@ -7285,14 +8300,41 @@
       </p:sp>
       <p:sp>
         <p:nvSpPr>
-          <p:cNvPr id="59" name="Text 57"/>
-          <p:cNvSpPr txBox="1"/>
-          <p:nvPr/>
-        </p:nvSpPr>
-        <p:spPr>
-          <a:xfrm>
-            <a:off x="3063240" y="3758184"/>
-            <a:ext cx="868680" cy="246888"/>
+          <p:cNvPr id="90" name="Shape 88"/>
+          <p:cNvSpPr/>
+          <p:nvPr/>
+        </p:nvSpPr>
+        <p:spPr>
+          <a:xfrm>
+            <a:off x="8776411" y="4160520"/>
+            <a:ext cx="163860" cy="141732"/>
+          </a:xfrm>
+          <a:prstGeom prst="roundRect">
+            <a:avLst>
+              <a:gd name="adj" fmla="val 32258"/>
+            </a:avLst>
+          </a:prstGeom>
+          <a:solidFill>
+            <a:srgbClr val="0B3A73"/>
+          </a:solidFill>
+          <a:ln w="9525">
+            <a:solidFill>
+              <a:srgbClr val="0B3A73"/>
+            </a:solidFill>
+            <a:prstDash val="solid"/>
+          </a:ln>
+        </p:spPr>
+      </p:sp>
+      <p:sp>
+        <p:nvSpPr>
+          <p:cNvPr id="91" name="Text 89"/>
+          <p:cNvSpPr txBox="1"/>
+          <p:nvPr/>
+        </p:nvSpPr>
+        <p:spPr>
+          <a:xfrm>
+            <a:off x="11311128" y="4114800"/>
+            <a:ext cx="329184" cy="233172"/>
           </a:xfrm>
           <a:prstGeom prst="rect">
             <a:avLst/>
@@ -7304,34 +8346,34 @@
           <a:bodyPr wrap="square" lIns="0" tIns="0" rIns="0" bIns="0" rtlCol="0" anchor="ctr"/>
           <a:lstStyle/>
           <a:p>
-            <a:pPr algn="r" indent="0" marL="0">
-              <a:buNone/>
-            </a:pPr>
-            <a:r>
-              <a:rPr lang="en-US" sz="750" dirty="0">
-                <a:solidFill>
-                  <a:srgbClr val="6B7280"/>
-                </a:solidFill>
-                <a:latin typeface="Arial" pitchFamily="34" charset="0"/>
-                <a:ea typeface="Arial" pitchFamily="34" charset="-122"/>
-                <a:cs typeface="Arial" pitchFamily="34" charset="-120"/>
-              </a:rPr>
-              <a:t>12/10 – 06/11</a:t>
-            </a:r>
-            <a:endParaRPr lang="en-US" sz="750" dirty="0"/>
-          </a:p>
-        </p:txBody>
-      </p:sp>
-      <p:sp>
-        <p:nvSpPr>
-          <p:cNvPr id="60" name="Shape 58"/>
+            <a:pPr algn="ctr" indent="0" marL="0">
+              <a:buNone/>
+            </a:pPr>
+            <a:r>
+              <a:rPr lang="en-US" sz="800" b="1" dirty="0">
+                <a:solidFill>
+                  <a:srgbClr val="B8860B"/>
+                </a:solidFill>
+                <a:latin typeface="Arial" pitchFamily="34" charset="0"/>
+                <a:ea typeface="Arial" pitchFamily="34" charset="-122"/>
+                <a:cs typeface="Arial" pitchFamily="34" charset="-120"/>
+              </a:rPr>
+              <a:t>20%</a:t>
+            </a:r>
+            <a:endParaRPr lang="en-US" sz="800" dirty="0"/>
+          </a:p>
+        </p:txBody>
+      </p:sp>
+      <p:sp>
+        <p:nvSpPr>
+          <p:cNvPr id="92" name="Shape 90"/>
           <p:cNvSpPr/>
           <p:nvPr/>
         </p:nvSpPr>
         <p:spPr>
           <a:xfrm>
-            <a:off x="548640" y="4005072"/>
-            <a:ext cx="11091672" cy="246888"/>
+            <a:off x="548640" y="4347972"/>
+            <a:ext cx="11091672" cy="233172"/>
           </a:xfrm>
           <a:prstGeom prst="rect">
             <a:avLst/>
@@ -7349,14 +8391,14 @@
       </p:sp>
       <p:sp>
         <p:nvSpPr>
-          <p:cNvPr id="61" name="Text 59"/>
-          <p:cNvSpPr txBox="1"/>
-          <p:nvPr/>
-        </p:nvSpPr>
-        <p:spPr>
-          <a:xfrm>
-            <a:off x="640080" y="4005072"/>
-            <a:ext cx="3017520" cy="246888"/>
+          <p:cNvPr id="93" name="Text 91"/>
+          <p:cNvSpPr txBox="1"/>
+          <p:nvPr/>
+        </p:nvSpPr>
+        <p:spPr>
+          <a:xfrm>
+            <a:off x="640080" y="4347972"/>
+            <a:ext cx="2240280" cy="233172"/>
           </a:xfrm>
           <a:prstGeom prst="rect">
             <a:avLst/>
@@ -7388,14 +8430,53 @@
       </p:sp>
       <p:sp>
         <p:nvSpPr>
-          <p:cNvPr id="62" name="Shape 60"/>
+          <p:cNvPr id="94" name="Text 92"/>
+          <p:cNvSpPr txBox="1"/>
+          <p:nvPr/>
+        </p:nvSpPr>
+        <p:spPr>
+          <a:xfrm>
+            <a:off x="3017520" y="4347972"/>
+            <a:ext cx="914400" cy="233172"/>
+          </a:xfrm>
+          <a:prstGeom prst="rect">
+            <a:avLst/>
+          </a:prstGeom>
+          <a:noFill/>
+          <a:ln/>
+        </p:spPr>
+        <p:txBody>
+          <a:bodyPr wrap="square" lIns="0" tIns="0" rIns="0" bIns="0" rtlCol="0" anchor="ctr"/>
+          <a:lstStyle/>
+          <a:p>
+            <a:pPr algn="r" indent="0" marL="0">
+              <a:buNone/>
+            </a:pPr>
+            <a:r>
+              <a:rPr lang="en-US" sz="750" dirty="0">
+                <a:solidFill>
+                  <a:srgbClr val="6B7280"/>
+                </a:solidFill>
+                <a:latin typeface="Arial" pitchFamily="34" charset="0"/>
+                <a:ea typeface="Arial" pitchFamily="34" charset="-122"/>
+                <a:cs typeface="Arial" pitchFamily="34" charset="-120"/>
+              </a:rPr>
+              <a:t>07/10 – 18/10</a:t>
+            </a:r>
+            <a:endParaRPr lang="en-US" sz="750" dirty="0"/>
+          </a:p>
+        </p:txBody>
+      </p:sp>
+      <p:sp>
+        <p:nvSpPr>
+          <p:cNvPr id="95" name="Shape 93"/>
           <p:cNvSpPr/>
           <p:nvPr/>
         </p:nvSpPr>
         <p:spPr>
           <a:xfrm>
-            <a:off x="8103694" y="4069080"/>
-            <a:ext cx="810475" cy="118872"/>
+            <a:off x="9420149" y="4411980"/>
+            <a:ext cx="643738" cy="105156"/>
           </a:xfrm>
           <a:prstGeom prst="rect">
             <a:avLst/>
@@ -7413,14 +8494,14 @@
       </p:sp>
       <p:sp>
         <p:nvSpPr>
-          <p:cNvPr id="63" name="Text 61"/>
-          <p:cNvSpPr txBox="1"/>
-          <p:nvPr/>
-        </p:nvSpPr>
-        <p:spPr>
-          <a:xfrm>
-            <a:off x="3063240" y="4005072"/>
-            <a:ext cx="868680" cy="246888"/>
+          <p:cNvPr id="96" name="Text 94"/>
+          <p:cNvSpPr txBox="1"/>
+          <p:nvPr/>
+        </p:nvSpPr>
+        <p:spPr>
+          <a:xfrm>
+            <a:off x="868680" y="4581144"/>
+            <a:ext cx="2240280" cy="233172"/>
           </a:xfrm>
           <a:prstGeom prst="rect">
             <a:avLst/>
@@ -7432,6 +8513,45 @@
           <a:bodyPr wrap="square" lIns="0" tIns="0" rIns="0" bIns="0" rtlCol="0" anchor="ctr"/>
           <a:lstStyle/>
           <a:p>
+            <a:pPr indent="0" marL="0">
+              <a:buNone/>
+            </a:pPr>
+            <a:r>
+              <a:rPr lang="en-US" sz="850" dirty="0">
+                <a:solidFill>
+                  <a:srgbClr val="1F2937"/>
+                </a:solidFill>
+                <a:latin typeface="Arial" pitchFamily="34" charset="0"/>
+                <a:ea typeface="Arial" pitchFamily="34" charset="-122"/>
+                <a:cs typeface="Arial" pitchFamily="34" charset="-120"/>
+              </a:rPr>
+              <a:t>Montar piloto en Overview + fotos</a:t>
+            </a:r>
+            <a:endParaRPr lang="en-US" sz="850" dirty="0"/>
+          </a:p>
+        </p:txBody>
+      </p:sp>
+      <p:sp>
+        <p:nvSpPr>
+          <p:cNvPr id="97" name="Text 95"/>
+          <p:cNvSpPr txBox="1"/>
+          <p:nvPr/>
+        </p:nvSpPr>
+        <p:spPr>
+          <a:xfrm>
+            <a:off x="3017520" y="4581144"/>
+            <a:ext cx="914400" cy="233172"/>
+          </a:xfrm>
+          <a:prstGeom prst="rect">
+            <a:avLst/>
+          </a:prstGeom>
+          <a:noFill/>
+          <a:ln/>
+        </p:spPr>
+        <p:txBody>
+          <a:bodyPr wrap="square" lIns="0" tIns="0" rIns="0" bIns="0" rtlCol="0" anchor="ctr"/>
+          <a:lstStyle/>
+          <a:p>
             <a:pPr algn="r" indent="0" marL="0">
               <a:buNone/>
             </a:pPr>
@@ -7444,7 +8564,7 @@
                 <a:ea typeface="Arial" pitchFamily="34" charset="-122"/>
                 <a:cs typeface="Arial" pitchFamily="34" charset="-120"/>
               </a:rPr>
-              <a:t>09/11 – 20/11</a:t>
+              <a:t>07/10 – 14/10</a:t>
             </a:r>
             <a:endParaRPr lang="en-US" sz="750" dirty="0"/>
           </a:p>
@@ -7452,62 +8572,23 @@
       </p:sp>
       <p:sp>
         <p:nvSpPr>
-          <p:cNvPr id="64" name="Text 62"/>
-          <p:cNvSpPr txBox="1"/>
-          <p:nvPr/>
-        </p:nvSpPr>
-        <p:spPr>
-          <a:xfrm>
-            <a:off x="868680" y="4251960"/>
-            <a:ext cx="3017520" cy="246888"/>
-          </a:xfrm>
-          <a:prstGeom prst="rect">
-            <a:avLst/>
-          </a:prstGeom>
-          <a:noFill/>
-          <a:ln/>
-        </p:spPr>
-        <p:txBody>
-          <a:bodyPr wrap="square" lIns="0" tIns="0" rIns="0" bIns="0" rtlCol="0" anchor="ctr"/>
-          <a:lstStyle/>
-          <a:p>
-            <a:pPr indent="0" marL="0">
-              <a:buNone/>
-            </a:pPr>
-            <a:r>
-              <a:rPr lang="en-US" sz="900" dirty="0">
-                <a:solidFill>
-                  <a:srgbClr val="1F2937"/>
-                </a:solidFill>
-                <a:latin typeface="Arial" pitchFamily="34" charset="0"/>
-                <a:ea typeface="Arial" pitchFamily="34" charset="-122"/>
-                <a:cs typeface="Arial" pitchFamily="34" charset="-120"/>
-              </a:rPr>
-              <a:t>Sesiones piloto con el primer grupo</a:t>
-            </a:r>
-            <a:endParaRPr lang="en-US" sz="900" dirty="0"/>
-          </a:p>
-        </p:txBody>
-      </p:sp>
-      <p:sp>
-        <p:nvSpPr>
-          <p:cNvPr id="65" name="Shape 63"/>
+          <p:cNvPr id="98" name="Shape 96"/>
           <p:cNvSpPr/>
           <p:nvPr/>
         </p:nvSpPr>
         <p:spPr>
           <a:xfrm>
-            <a:off x="8103694" y="4297680"/>
-            <a:ext cx="294718" cy="155448"/>
+            <a:off x="9420149" y="4626864"/>
+            <a:ext cx="409651" cy="141732"/>
           </a:xfrm>
           <a:prstGeom prst="roundRect">
             <a:avLst>
-              <a:gd name="adj" fmla="val 29412"/>
+              <a:gd name="adj" fmla="val 32258"/>
             </a:avLst>
           </a:prstGeom>
           <a:solidFill>
             <a:srgbClr val="079CCE">
-              <a:alpha val="55000"/>
+              <a:alpha val="30000"/>
             </a:srgbClr>
           </a:solidFill>
           <a:ln w="9525">
@@ -7520,14 +8601,14 @@
       </p:sp>
       <p:sp>
         <p:nvSpPr>
-          <p:cNvPr id="66" name="Text 64"/>
-          <p:cNvSpPr txBox="1"/>
-          <p:nvPr/>
-        </p:nvSpPr>
-        <p:spPr>
-          <a:xfrm>
-            <a:off x="3063240" y="4251960"/>
-            <a:ext cx="868680" cy="246888"/>
+          <p:cNvPr id="99" name="Text 97"/>
+          <p:cNvSpPr txBox="1"/>
+          <p:nvPr/>
+        </p:nvSpPr>
+        <p:spPr>
+          <a:xfrm>
+            <a:off x="11311128" y="4581144"/>
+            <a:ext cx="329184" cy="233172"/>
           </a:xfrm>
           <a:prstGeom prst="rect">
             <a:avLst/>
@@ -7539,6 +8620,84 @@
           <a:bodyPr wrap="square" lIns="0" tIns="0" rIns="0" bIns="0" rtlCol="0" anchor="ctr"/>
           <a:lstStyle/>
           <a:p>
+            <a:pPr algn="ctr" indent="0" marL="0">
+              <a:buNone/>
+            </a:pPr>
+            <a:r>
+              <a:rPr lang="en-US" sz="800" b="1" dirty="0">
+                <a:solidFill>
+                  <a:srgbClr val="6B7280"/>
+                </a:solidFill>
+                <a:latin typeface="Arial" pitchFamily="34" charset="0"/>
+                <a:ea typeface="Arial" pitchFamily="34" charset="-122"/>
+                <a:cs typeface="Arial" pitchFamily="34" charset="-120"/>
+              </a:rPr>
+              <a:t>0%</a:t>
+            </a:r>
+            <a:endParaRPr lang="en-US" sz="800" dirty="0"/>
+          </a:p>
+        </p:txBody>
+      </p:sp>
+      <p:sp>
+        <p:nvSpPr>
+          <p:cNvPr id="100" name="Text 98"/>
+          <p:cNvSpPr txBox="1"/>
+          <p:nvPr/>
+        </p:nvSpPr>
+        <p:spPr>
+          <a:xfrm>
+            <a:off x="868680" y="4814316"/>
+            <a:ext cx="2240280" cy="233172"/>
+          </a:xfrm>
+          <a:prstGeom prst="rect">
+            <a:avLst/>
+          </a:prstGeom>
+          <a:noFill/>
+          <a:ln/>
+        </p:spPr>
+        <p:txBody>
+          <a:bodyPr wrap="square" lIns="0" tIns="0" rIns="0" bIns="0" rtlCol="0" anchor="ctr"/>
+          <a:lstStyle/>
+          <a:p>
+            <a:pPr indent="0" marL="0">
+              <a:buNone/>
+            </a:pPr>
+            <a:r>
+              <a:rPr lang="en-US" sz="850" dirty="0">
+                <a:solidFill>
+                  <a:srgbClr val="1F2937"/>
+                </a:solidFill>
+                <a:latin typeface="Arial" pitchFamily="34" charset="0"/>
+                <a:ea typeface="Arial" pitchFamily="34" charset="-122"/>
+                <a:cs typeface="Arial" pitchFamily="34" charset="-120"/>
+              </a:rPr>
+              <a:t>Prueba piloto</a:t>
+            </a:r>
+            <a:endParaRPr lang="en-US" sz="850" dirty="0"/>
+          </a:p>
+        </p:txBody>
+      </p:sp>
+      <p:sp>
+        <p:nvSpPr>
+          <p:cNvPr id="101" name="Text 99"/>
+          <p:cNvSpPr txBox="1"/>
+          <p:nvPr/>
+        </p:nvSpPr>
+        <p:spPr>
+          <a:xfrm>
+            <a:off x="3017520" y="4814316"/>
+            <a:ext cx="914400" cy="233172"/>
+          </a:xfrm>
+          <a:prstGeom prst="rect">
+            <a:avLst/>
+          </a:prstGeom>
+          <a:noFill/>
+          <a:ln/>
+        </p:spPr>
+        <p:txBody>
+          <a:bodyPr wrap="square" lIns="0" tIns="0" rIns="0" bIns="0" rtlCol="0" anchor="ctr"/>
+          <a:lstStyle/>
+          <a:p>
             <a:pPr algn="r" indent="0" marL="0">
               <a:buNone/>
             </a:pPr>
@@ -7551,7 +8710,7 @@
                 <a:ea typeface="Arial" pitchFamily="34" charset="-122"/>
                 <a:cs typeface="Arial" pitchFamily="34" charset="-120"/>
               </a:rPr>
-              <a:t>09/11 – 13/11</a:t>
+              <a:t>11/10 – 18/10</a:t>
             </a:r>
             <a:endParaRPr lang="en-US" sz="750" dirty="0"/>
           </a:p>
@@ -7559,62 +8718,23 @@
       </p:sp>
       <p:sp>
         <p:nvSpPr>
-          <p:cNvPr id="67" name="Text 65"/>
-          <p:cNvSpPr txBox="1"/>
-          <p:nvPr/>
-        </p:nvSpPr>
-        <p:spPr>
-          <a:xfrm>
-            <a:off x="868680" y="4498848"/>
-            <a:ext cx="3017520" cy="246888"/>
-          </a:xfrm>
-          <a:prstGeom prst="rect">
-            <a:avLst/>
-          </a:prstGeom>
-          <a:noFill/>
-          <a:ln/>
-        </p:spPr>
-        <p:txBody>
-          <a:bodyPr wrap="square" lIns="0" tIns="0" rIns="0" bIns="0" rtlCol="0" anchor="ctr"/>
-          <a:lstStyle/>
-          <a:p>
-            <a:pPr indent="0" marL="0">
-              <a:buNone/>
-            </a:pPr>
-            <a:r>
-              <a:rPr lang="en-US" sz="900" dirty="0">
-                <a:solidFill>
-                  <a:srgbClr val="1F2937"/>
-                </a:solidFill>
-                <a:latin typeface="Arial" pitchFamily="34" charset="0"/>
-                <a:ea typeface="Arial" pitchFamily="34" charset="-122"/>
-                <a:cs typeface="Arial" pitchFamily="34" charset="-120"/>
-              </a:rPr>
-              <a:t>Ajustar tiempos y dificultad de los juegos</a:t>
-            </a:r>
-            <a:endParaRPr lang="en-US" sz="900" dirty="0"/>
-          </a:p>
-        </p:txBody>
-      </p:sp>
-      <p:sp>
-        <p:nvSpPr>
-          <p:cNvPr id="68" name="Shape 66"/>
+          <p:cNvPr id="102" name="Shape 100"/>
           <p:cNvSpPr/>
           <p:nvPr/>
         </p:nvSpPr>
         <p:spPr>
           <a:xfrm>
-            <a:off x="8324733" y="4544568"/>
-            <a:ext cx="442077" cy="155448"/>
+            <a:off x="9654235" y="4860036"/>
+            <a:ext cx="409651" cy="141732"/>
           </a:xfrm>
           <a:prstGeom prst="roundRect">
             <a:avLst>
-              <a:gd name="adj" fmla="val 29412"/>
+              <a:gd name="adj" fmla="val 32258"/>
             </a:avLst>
           </a:prstGeom>
           <a:solidFill>
             <a:srgbClr val="079CCE">
-              <a:alpha val="55000"/>
+              <a:alpha val="30000"/>
             </a:srgbClr>
           </a:solidFill>
           <a:ln w="9525">
@@ -7627,14 +8747,14 @@
       </p:sp>
       <p:sp>
         <p:nvSpPr>
-          <p:cNvPr id="69" name="Text 67"/>
-          <p:cNvSpPr txBox="1"/>
-          <p:nvPr/>
-        </p:nvSpPr>
-        <p:spPr>
-          <a:xfrm>
-            <a:off x="3063240" y="4498848"/>
-            <a:ext cx="868680" cy="246888"/>
+          <p:cNvPr id="103" name="Text 101"/>
+          <p:cNvSpPr txBox="1"/>
+          <p:nvPr/>
+        </p:nvSpPr>
+        <p:spPr>
+          <a:xfrm>
+            <a:off x="11311128" y="4814316"/>
+            <a:ext cx="329184" cy="233172"/>
           </a:xfrm>
           <a:prstGeom prst="rect">
             <a:avLst/>
@@ -7646,11 +8766,11 @@
           <a:bodyPr wrap="square" lIns="0" tIns="0" rIns="0" bIns="0" rtlCol="0" anchor="ctr"/>
           <a:lstStyle/>
           <a:p>
-            <a:pPr algn="r" indent="0" marL="0">
-              <a:buNone/>
-            </a:pPr>
-            <a:r>
-              <a:rPr lang="en-US" sz="750" dirty="0">
+            <a:pPr algn="ctr" indent="0" marL="0">
+              <a:buNone/>
+            </a:pPr>
+            <a:r>
+              <a:rPr lang="en-US" sz="800" b="1" dirty="0">
                 <a:solidFill>
                   <a:srgbClr val="6B7280"/>
                 </a:solidFill>
@@ -7658,129 +8778,22 @@
                 <a:ea typeface="Arial" pitchFamily="34" charset="-122"/>
                 <a:cs typeface="Arial" pitchFamily="34" charset="-120"/>
               </a:rPr>
-              <a:t>12/11 – 18/11</a:t>
-            </a:r>
-            <a:endParaRPr lang="en-US" sz="750" dirty="0"/>
-          </a:p>
-        </p:txBody>
-      </p:sp>
-      <p:sp>
-        <p:nvSpPr>
-          <p:cNvPr id="70" name="Text 68"/>
-          <p:cNvSpPr txBox="1"/>
-          <p:nvPr/>
-        </p:nvSpPr>
-        <p:spPr>
-          <a:xfrm>
-            <a:off x="868680" y="4745736"/>
-            <a:ext cx="3017520" cy="246888"/>
-          </a:xfrm>
-          <a:prstGeom prst="rect">
-            <a:avLst/>
-          </a:prstGeom>
-          <a:noFill/>
-          <a:ln/>
-        </p:spPr>
-        <p:txBody>
-          <a:bodyPr wrap="square" lIns="0" tIns="0" rIns="0" bIns="0" rtlCol="0" anchor="ctr"/>
-          <a:lstStyle/>
-          <a:p>
-            <a:pPr indent="0" marL="0">
-              <a:buNone/>
-            </a:pPr>
-            <a:r>
-              <a:rPr lang="en-US" sz="900" dirty="0">
-                <a:solidFill>
-                  <a:srgbClr val="1F2937"/>
-                </a:solidFill>
-                <a:latin typeface="Arial" pitchFamily="34" charset="0"/>
-                <a:ea typeface="Arial" pitchFamily="34" charset="-122"/>
-                <a:cs typeface="Arial" pitchFamily="34" charset="-120"/>
-              </a:rPr>
-              <a:t>Medir resultados iniciales (línea base)</a:t>
-            </a:r>
-            <a:endParaRPr lang="en-US" sz="900" dirty="0"/>
-          </a:p>
-        </p:txBody>
-      </p:sp>
-      <p:sp>
-        <p:nvSpPr>
-          <p:cNvPr id="71" name="Shape 69"/>
+              <a:t>0%</a:t>
+            </a:r>
+            <a:endParaRPr lang="en-US" sz="800" dirty="0"/>
+          </a:p>
+        </p:txBody>
+      </p:sp>
+      <p:sp>
+        <p:nvSpPr>
+          <p:cNvPr id="104" name="Shape 102"/>
           <p:cNvSpPr/>
           <p:nvPr/>
         </p:nvSpPr>
         <p:spPr>
           <a:xfrm>
-            <a:off x="8619451" y="4791456"/>
-            <a:ext cx="294718" cy="155448"/>
-          </a:xfrm>
-          <a:prstGeom prst="roundRect">
-            <a:avLst>
-              <a:gd name="adj" fmla="val 29412"/>
-            </a:avLst>
-          </a:prstGeom>
-          <a:solidFill>
-            <a:srgbClr val="079CCE">
-              <a:alpha val="55000"/>
-            </a:srgbClr>
-          </a:solidFill>
-          <a:ln w="9525">
-            <a:solidFill>
-              <a:srgbClr val="079CCE"/>
-            </a:solidFill>
-            <a:prstDash val="solid"/>
-          </a:ln>
-        </p:spPr>
-      </p:sp>
-      <p:sp>
-        <p:nvSpPr>
-          <p:cNvPr id="72" name="Text 70"/>
-          <p:cNvSpPr txBox="1"/>
-          <p:nvPr/>
-        </p:nvSpPr>
-        <p:spPr>
-          <a:xfrm>
-            <a:off x="3063240" y="4745736"/>
-            <a:ext cx="868680" cy="246888"/>
-          </a:xfrm>
-          <a:prstGeom prst="rect">
-            <a:avLst/>
-          </a:prstGeom>
-          <a:noFill/>
-          <a:ln/>
-        </p:spPr>
-        <p:txBody>
-          <a:bodyPr wrap="square" lIns="0" tIns="0" rIns="0" bIns="0" rtlCol="0" anchor="ctr"/>
-          <a:lstStyle/>
-          <a:p>
-            <a:pPr algn="r" indent="0" marL="0">
-              <a:buNone/>
-            </a:pPr>
-            <a:r>
-              <a:rPr lang="en-US" sz="750" dirty="0">
-                <a:solidFill>
-                  <a:srgbClr val="6B7280"/>
-                </a:solidFill>
-                <a:latin typeface="Arial" pitchFamily="34" charset="0"/>
-                <a:ea typeface="Arial" pitchFamily="34" charset="-122"/>
-                <a:cs typeface="Arial" pitchFamily="34" charset="-120"/>
-              </a:rPr>
-              <a:t>16/11 – 20/11</a:t>
-            </a:r>
-            <a:endParaRPr lang="en-US" sz="750" dirty="0"/>
-          </a:p>
-        </p:txBody>
-      </p:sp>
-      <p:sp>
-        <p:nvSpPr>
-          <p:cNvPr id="73" name="Shape 71"/>
-          <p:cNvSpPr/>
-          <p:nvPr/>
-        </p:nvSpPr>
-        <p:spPr>
-          <a:xfrm>
-            <a:off x="548640" y="4992624"/>
-            <a:ext cx="11091672" cy="246888"/>
+            <a:off x="548640" y="5047488"/>
+            <a:ext cx="11091672" cy="233172"/>
           </a:xfrm>
           <a:prstGeom prst="rect">
             <a:avLst/>
@@ -7798,14 +8811,14 @@
       </p:sp>
       <p:sp>
         <p:nvSpPr>
-          <p:cNvPr id="74" name="Text 72"/>
-          <p:cNvSpPr txBox="1"/>
-          <p:nvPr/>
-        </p:nvSpPr>
-        <p:spPr>
-          <a:xfrm>
-            <a:off x="640080" y="4992624"/>
-            <a:ext cx="3017520" cy="246888"/>
+          <p:cNvPr id="105" name="Text 103"/>
+          <p:cNvSpPr txBox="1"/>
+          <p:nvPr/>
+        </p:nvSpPr>
+        <p:spPr>
+          <a:xfrm>
+            <a:off x="640080" y="5047488"/>
+            <a:ext cx="2240280" cy="233172"/>
           </a:xfrm>
           <a:prstGeom prst="rect">
             <a:avLst/>
@@ -7837,14 +8850,53 @@
       </p:sp>
       <p:sp>
         <p:nvSpPr>
-          <p:cNvPr id="75" name="Shape 73"/>
+          <p:cNvPr id="106" name="Text 104"/>
+          <p:cNvSpPr txBox="1"/>
+          <p:nvPr/>
+        </p:nvSpPr>
+        <p:spPr>
+          <a:xfrm>
+            <a:off x="3017520" y="5047488"/>
+            <a:ext cx="914400" cy="233172"/>
+          </a:xfrm>
+          <a:prstGeom prst="rect">
+            <a:avLst/>
+          </a:prstGeom>
+          <a:noFill/>
+          <a:ln/>
+        </p:spPr>
+        <p:txBody>
+          <a:bodyPr wrap="square" lIns="0" tIns="0" rIns="0" bIns="0" rtlCol="0" anchor="ctr"/>
+          <a:lstStyle/>
+          <a:p>
+            <a:pPr algn="r" indent="0" marL="0">
+              <a:buNone/>
+            </a:pPr>
+            <a:r>
+              <a:rPr lang="en-US" sz="750" dirty="0">
+                <a:solidFill>
+                  <a:srgbClr val="6B7280"/>
+                </a:solidFill>
+                <a:latin typeface="Arial" pitchFamily="34" charset="0"/>
+                <a:ea typeface="Arial" pitchFamily="34" charset="-122"/>
+                <a:cs typeface="Arial" pitchFamily="34" charset="-120"/>
+              </a:rPr>
+              <a:t>15/10 – 06/11</a:t>
+            </a:r>
+            <a:endParaRPr lang="en-US" sz="750" dirty="0"/>
+          </a:p>
+        </p:txBody>
+      </p:sp>
+      <p:sp>
+        <p:nvSpPr>
+          <p:cNvPr id="107" name="Shape 105"/>
           <p:cNvSpPr/>
           <p:nvPr/>
         </p:nvSpPr>
         <p:spPr>
           <a:xfrm>
-            <a:off x="9135208" y="5056632"/>
-            <a:ext cx="2210386" cy="118872"/>
+            <a:off x="9888322" y="5111496"/>
+            <a:ext cx="1287475" cy="105156"/>
           </a:xfrm>
           <a:prstGeom prst="rect">
             <a:avLst/>
@@ -7862,14 +8914,14 @@
       </p:sp>
       <p:sp>
         <p:nvSpPr>
-          <p:cNvPr id="76" name="Text 74"/>
-          <p:cNvSpPr txBox="1"/>
-          <p:nvPr/>
-        </p:nvSpPr>
-        <p:spPr>
-          <a:xfrm>
-            <a:off x="3063240" y="4992624"/>
-            <a:ext cx="868680" cy="246888"/>
+          <p:cNvPr id="108" name="Text 106"/>
+          <p:cNvSpPr txBox="1"/>
+          <p:nvPr/>
+        </p:nvSpPr>
+        <p:spPr>
+          <a:xfrm>
+            <a:off x="868680" y="5280660"/>
+            <a:ext cx="2240280" cy="233172"/>
           </a:xfrm>
           <a:prstGeom prst="rect">
             <a:avLst/>
@@ -7881,6 +8933,45 @@
           <a:bodyPr wrap="square" lIns="0" tIns="0" rIns="0" bIns="0" rtlCol="0" anchor="ctr"/>
           <a:lstStyle/>
           <a:p>
+            <a:pPr indent="0" marL="0">
+              <a:buNone/>
+            </a:pPr>
+            <a:r>
+              <a:rPr lang="en-US" sz="850" dirty="0">
+                <a:solidFill>
+                  <a:srgbClr val="1F2937"/>
+                </a:solidFill>
+                <a:latin typeface="Arial" pitchFamily="34" charset="0"/>
+                <a:ea typeface="Arial" pitchFamily="34" charset="-122"/>
+                <a:cs typeface="Arial" pitchFamily="34" charset="-120"/>
+              </a:rPr>
+              <a:t>Implementación</a:t>
+            </a:r>
+            <a:endParaRPr lang="en-US" sz="850" dirty="0"/>
+          </a:p>
+        </p:txBody>
+      </p:sp>
+      <p:sp>
+        <p:nvSpPr>
+          <p:cNvPr id="109" name="Text 107"/>
+          <p:cNvSpPr txBox="1"/>
+          <p:nvPr/>
+        </p:nvSpPr>
+        <p:spPr>
+          <a:xfrm>
+            <a:off x="3017520" y="5280660"/>
+            <a:ext cx="914400" cy="233172"/>
+          </a:xfrm>
+          <a:prstGeom prst="rect">
+            <a:avLst/>
+          </a:prstGeom>
+          <a:noFill/>
+          <a:ln/>
+        </p:spPr>
+        <p:txBody>
+          <a:bodyPr wrap="square" lIns="0" tIns="0" rIns="0" bIns="0" rtlCol="0" anchor="ctr"/>
+          <a:lstStyle/>
+          <a:p>
             <a:pPr algn="r" indent="0" marL="0">
               <a:buNone/>
             </a:pPr>
@@ -7893,7 +8984,7 @@
                 <a:ea typeface="Arial" pitchFamily="34" charset="-122"/>
                 <a:cs typeface="Arial" pitchFamily="34" charset="-120"/>
               </a:rPr>
-              <a:t>23/11 – 23/12</a:t>
+              <a:t>15/10 – 29/10</a:t>
             </a:r>
             <a:endParaRPr lang="en-US" sz="750" dirty="0"/>
           </a:p>
@@ -7901,62 +8992,23 @@
       </p:sp>
       <p:sp>
         <p:nvSpPr>
-          <p:cNvPr id="77" name="Text 75"/>
-          <p:cNvSpPr txBox="1"/>
-          <p:nvPr/>
-        </p:nvSpPr>
-        <p:spPr>
-          <a:xfrm>
-            <a:off x="868680" y="5239512"/>
-            <a:ext cx="3017520" cy="246888"/>
-          </a:xfrm>
-          <a:prstGeom prst="rect">
-            <a:avLst/>
-          </a:prstGeom>
-          <a:noFill/>
-          <a:ln/>
-        </p:spPr>
-        <p:txBody>
-          <a:bodyPr wrap="square" lIns="0" tIns="0" rIns="0" bIns="0" rtlCol="0" anchor="ctr"/>
-          <a:lstStyle/>
-          <a:p>
-            <a:pPr indent="0" marL="0">
-              <a:buNone/>
-            </a:pPr>
-            <a:r>
-              <a:rPr lang="en-US" sz="900" dirty="0">
-                <a:solidFill>
-                  <a:srgbClr val="1F2937"/>
-                </a:solidFill>
-                <a:latin typeface="Arial" pitchFamily="34" charset="0"/>
-                <a:ea typeface="Arial" pitchFamily="34" charset="-122"/>
-                <a:cs typeface="Arial" pitchFamily="34" charset="-120"/>
-              </a:rPr>
-              <a:t>Sesiones para todos los turnos y líneas</a:t>
-            </a:r>
-            <a:endParaRPr lang="en-US" sz="900" dirty="0"/>
-          </a:p>
-        </p:txBody>
-      </p:sp>
-      <p:sp>
-        <p:nvSpPr>
-          <p:cNvPr id="78" name="Shape 76"/>
+          <p:cNvPr id="110" name="Shape 108"/>
           <p:cNvSpPr/>
           <p:nvPr/>
         </p:nvSpPr>
         <p:spPr>
           <a:xfrm>
-            <a:off x="9135208" y="5285232"/>
-            <a:ext cx="1841988" cy="155448"/>
+            <a:off x="9888322" y="5326380"/>
+            <a:ext cx="819302" cy="141732"/>
           </a:xfrm>
           <a:prstGeom prst="roundRect">
             <a:avLst>
-              <a:gd name="adj" fmla="val 29412"/>
+              <a:gd name="adj" fmla="val 32258"/>
             </a:avLst>
           </a:prstGeom>
           <a:solidFill>
             <a:srgbClr val="FFA403">
-              <a:alpha val="55000"/>
+              <a:alpha val="30000"/>
             </a:srgbClr>
           </a:solidFill>
           <a:ln w="9525">
@@ -7969,14 +9021,14 @@
       </p:sp>
       <p:sp>
         <p:nvSpPr>
-          <p:cNvPr id="79" name="Text 77"/>
-          <p:cNvSpPr txBox="1"/>
-          <p:nvPr/>
-        </p:nvSpPr>
-        <p:spPr>
-          <a:xfrm>
-            <a:off x="3063240" y="5239512"/>
-            <a:ext cx="868680" cy="246888"/>
+          <p:cNvPr id="111" name="Text 109"/>
+          <p:cNvSpPr txBox="1"/>
+          <p:nvPr/>
+        </p:nvSpPr>
+        <p:spPr>
+          <a:xfrm>
+            <a:off x="11311128" y="5280660"/>
+            <a:ext cx="329184" cy="233172"/>
           </a:xfrm>
           <a:prstGeom prst="rect">
             <a:avLst/>
@@ -7988,6 +9040,84 @@
           <a:bodyPr wrap="square" lIns="0" tIns="0" rIns="0" bIns="0" rtlCol="0" anchor="ctr"/>
           <a:lstStyle/>
           <a:p>
+            <a:pPr algn="ctr" indent="0" marL="0">
+              <a:buNone/>
+            </a:pPr>
+            <a:r>
+              <a:rPr lang="en-US" sz="800" b="1" dirty="0">
+                <a:solidFill>
+                  <a:srgbClr val="6B7280"/>
+                </a:solidFill>
+                <a:latin typeface="Arial" pitchFamily="34" charset="0"/>
+                <a:ea typeface="Arial" pitchFamily="34" charset="-122"/>
+                <a:cs typeface="Arial" pitchFamily="34" charset="-120"/>
+              </a:rPr>
+              <a:t>0%</a:t>
+            </a:r>
+            <a:endParaRPr lang="en-US" sz="800" dirty="0"/>
+          </a:p>
+        </p:txBody>
+      </p:sp>
+      <p:sp>
+        <p:nvSpPr>
+          <p:cNvPr id="112" name="Text 110"/>
+          <p:cNvSpPr txBox="1"/>
+          <p:nvPr/>
+        </p:nvSpPr>
+        <p:spPr>
+          <a:xfrm>
+            <a:off x="868680" y="5513832"/>
+            <a:ext cx="2240280" cy="233172"/>
+          </a:xfrm>
+          <a:prstGeom prst="rect">
+            <a:avLst/>
+          </a:prstGeom>
+          <a:noFill/>
+          <a:ln/>
+        </p:spPr>
+        <p:txBody>
+          <a:bodyPr wrap="square" lIns="0" tIns="0" rIns="0" bIns="0" rtlCol="0" anchor="ctr"/>
+          <a:lstStyle/>
+          <a:p>
+            <a:pPr indent="0" marL="0">
+              <a:buNone/>
+            </a:pPr>
+            <a:r>
+              <a:rPr lang="en-US" sz="850" dirty="0">
+                <a:solidFill>
+                  <a:srgbClr val="1F2937"/>
+                </a:solidFill>
+                <a:latin typeface="Arial" pitchFamily="34" charset="0"/>
+                <a:ea typeface="Arial" pitchFamily="34" charset="-122"/>
+                <a:cs typeface="Arial" pitchFamily="34" charset="-120"/>
+              </a:rPr>
+              <a:t>Validación Gerencia / Calidad / Producción</a:t>
+            </a:r>
+            <a:endParaRPr lang="en-US" sz="850" dirty="0"/>
+          </a:p>
+        </p:txBody>
+      </p:sp>
+      <p:sp>
+        <p:nvSpPr>
+          <p:cNvPr id="113" name="Text 111"/>
+          <p:cNvSpPr txBox="1"/>
+          <p:nvPr/>
+        </p:nvSpPr>
+        <p:spPr>
+          <a:xfrm>
+            <a:off x="3017520" y="5513832"/>
+            <a:ext cx="914400" cy="233172"/>
+          </a:xfrm>
+          <a:prstGeom prst="rect">
+            <a:avLst/>
+          </a:prstGeom>
+          <a:noFill/>
+          <a:ln/>
+        </p:spPr>
+        <p:txBody>
+          <a:bodyPr wrap="square" lIns="0" tIns="0" rIns="0" bIns="0" rtlCol="0" anchor="ctr"/>
+          <a:lstStyle/>
+          <a:p>
             <a:pPr algn="r" indent="0" marL="0">
               <a:buNone/>
             </a:pPr>
@@ -8000,7 +9130,7 @@
                 <a:ea typeface="Arial" pitchFamily="34" charset="-122"/>
                 <a:cs typeface="Arial" pitchFamily="34" charset="-120"/>
               </a:rPr>
-              <a:t>23/11 – 18/12</a:t>
+              <a:t>19/10 – 22/10</a:t>
             </a:r>
             <a:endParaRPr lang="en-US" sz="750" dirty="0"/>
           </a:p>
@@ -8008,62 +9138,23 @@
       </p:sp>
       <p:sp>
         <p:nvSpPr>
-          <p:cNvPr id="80" name="Text 78"/>
-          <p:cNvSpPr txBox="1"/>
-          <p:nvPr/>
-        </p:nvSpPr>
-        <p:spPr>
-          <a:xfrm>
-            <a:off x="868680" y="5486400"/>
-            <a:ext cx="3017520" cy="246888"/>
-          </a:xfrm>
-          <a:prstGeom prst="rect">
-            <a:avLst/>
-          </a:prstGeom>
-          <a:noFill/>
-          <a:ln/>
-        </p:spPr>
-        <p:txBody>
-          <a:bodyPr wrap="square" lIns="0" tIns="0" rIns="0" bIns="0" rtlCol="0" anchor="ctr"/>
-          <a:lstStyle/>
-          <a:p>
-            <a:pPr indent="0" marL="0">
-              <a:buNone/>
-            </a:pPr>
-            <a:r>
-              <a:rPr lang="en-US" sz="900" dirty="0">
-                <a:solidFill>
-                  <a:srgbClr val="1F2937"/>
-                </a:solidFill>
-                <a:latin typeface="Arial" pitchFamily="34" charset="0"/>
-                <a:ea typeface="Arial" pitchFamily="34" charset="-122"/>
-                <a:cs typeface="Arial" pitchFamily="34" charset="-120"/>
-              </a:rPr>
-              <a:t>Ranking y reconocimiento</a:t>
-            </a:r>
-            <a:endParaRPr lang="en-US" sz="900" dirty="0"/>
-          </a:p>
-        </p:txBody>
-      </p:sp>
-      <p:sp>
-        <p:nvSpPr>
-          <p:cNvPr id="81" name="Shape 79"/>
+          <p:cNvPr id="114" name="Shape 112"/>
           <p:cNvSpPr/>
           <p:nvPr/>
         </p:nvSpPr>
         <p:spPr>
           <a:xfrm>
-            <a:off x="10166721" y="5532120"/>
-            <a:ext cx="1178873" cy="155448"/>
+            <a:off x="10122408" y="5559552"/>
+            <a:ext cx="175565" cy="141732"/>
           </a:xfrm>
           <a:prstGeom prst="roundRect">
             <a:avLst>
-              <a:gd name="adj" fmla="val 29412"/>
+              <a:gd name="adj" fmla="val 32258"/>
             </a:avLst>
           </a:prstGeom>
           <a:solidFill>
             <a:srgbClr val="FFA403">
-              <a:alpha val="55000"/>
+              <a:alpha val="30000"/>
             </a:srgbClr>
           </a:solidFill>
           <a:ln w="9525">
@@ -8076,14 +9167,14 @@
       </p:sp>
       <p:sp>
         <p:nvSpPr>
-          <p:cNvPr id="82" name="Text 80"/>
-          <p:cNvSpPr txBox="1"/>
-          <p:nvPr/>
-        </p:nvSpPr>
-        <p:spPr>
-          <a:xfrm>
-            <a:off x="3063240" y="5486400"/>
-            <a:ext cx="868680" cy="246888"/>
+          <p:cNvPr id="115" name="Text 113"/>
+          <p:cNvSpPr txBox="1"/>
+          <p:nvPr/>
+        </p:nvSpPr>
+        <p:spPr>
+          <a:xfrm>
+            <a:off x="11311128" y="5513832"/>
+            <a:ext cx="329184" cy="233172"/>
           </a:xfrm>
           <a:prstGeom prst="rect">
             <a:avLst/>
@@ -8095,6 +9186,84 @@
           <a:bodyPr wrap="square" lIns="0" tIns="0" rIns="0" bIns="0" rtlCol="0" anchor="ctr"/>
           <a:lstStyle/>
           <a:p>
+            <a:pPr algn="ctr" indent="0" marL="0">
+              <a:buNone/>
+            </a:pPr>
+            <a:r>
+              <a:rPr lang="en-US" sz="800" b="1" dirty="0">
+                <a:solidFill>
+                  <a:srgbClr val="6B7280"/>
+                </a:solidFill>
+                <a:latin typeface="Arial" pitchFamily="34" charset="0"/>
+                <a:ea typeface="Arial" pitchFamily="34" charset="-122"/>
+                <a:cs typeface="Arial" pitchFamily="34" charset="-120"/>
+              </a:rPr>
+              <a:t>0%</a:t>
+            </a:r>
+            <a:endParaRPr lang="en-US" sz="800" dirty="0"/>
+          </a:p>
+        </p:txBody>
+      </p:sp>
+      <p:sp>
+        <p:nvSpPr>
+          <p:cNvPr id="116" name="Text 114"/>
+          <p:cNvSpPr txBox="1"/>
+          <p:nvPr/>
+        </p:nvSpPr>
+        <p:spPr>
+          <a:xfrm>
+            <a:off x="868680" y="5747004"/>
+            <a:ext cx="2240280" cy="233172"/>
+          </a:xfrm>
+          <a:prstGeom prst="rect">
+            <a:avLst/>
+          </a:prstGeom>
+          <a:noFill/>
+          <a:ln/>
+        </p:spPr>
+        <p:txBody>
+          <a:bodyPr wrap="square" lIns="0" tIns="0" rIns="0" bIns="0" rtlCol="0" anchor="ctr"/>
+          <a:lstStyle/>
+          <a:p>
+            <a:pPr indent="0" marL="0">
+              <a:buNone/>
+            </a:pPr>
+            <a:r>
+              <a:rPr lang="en-US" sz="850" dirty="0">
+                <a:solidFill>
+                  <a:srgbClr val="1F2937"/>
+                </a:solidFill>
+                <a:latin typeface="Arial" pitchFamily="34" charset="0"/>
+                <a:ea typeface="Arial" pitchFamily="34" charset="-122"/>
+                <a:cs typeface="Arial" pitchFamily="34" charset="-120"/>
+              </a:rPr>
+              <a:t>Seguimiento y ajustes post implementación</a:t>
+            </a:r>
+            <a:endParaRPr lang="en-US" sz="850" dirty="0"/>
+          </a:p>
+        </p:txBody>
+      </p:sp>
+      <p:sp>
+        <p:nvSpPr>
+          <p:cNvPr id="117" name="Text 115"/>
+          <p:cNvSpPr txBox="1"/>
+          <p:nvPr/>
+        </p:nvSpPr>
+        <p:spPr>
+          <a:xfrm>
+            <a:off x="3017520" y="5747004"/>
+            <a:ext cx="914400" cy="233172"/>
+          </a:xfrm>
+          <a:prstGeom prst="rect">
+            <a:avLst/>
+          </a:prstGeom>
+          <a:noFill/>
+          <a:ln/>
+        </p:spPr>
+        <p:txBody>
+          <a:bodyPr wrap="square" lIns="0" tIns="0" rIns="0" bIns="0" rtlCol="0" anchor="ctr"/>
+          <a:lstStyle/>
+          <a:p>
             <a:pPr algn="r" indent="0" marL="0">
               <a:buNone/>
             </a:pPr>
@@ -8107,7 +9276,7 @@
                 <a:ea typeface="Arial" pitchFamily="34" charset="-122"/>
                 <a:cs typeface="Arial" pitchFamily="34" charset="-120"/>
               </a:rPr>
-              <a:t>07/12 – 23/12</a:t>
+              <a:t>30/10 – 06/11</a:t>
             </a:r>
             <a:endParaRPr lang="en-US" sz="750" dirty="0"/>
           </a:p>
@@ -8115,62 +9284,23 @@
       </p:sp>
       <p:sp>
         <p:nvSpPr>
-          <p:cNvPr id="83" name="Text 81"/>
-          <p:cNvSpPr txBox="1"/>
-          <p:nvPr/>
-        </p:nvSpPr>
-        <p:spPr>
-          <a:xfrm>
-            <a:off x="868680" y="5733288"/>
-            <a:ext cx="3017520" cy="246888"/>
-          </a:xfrm>
-          <a:prstGeom prst="rect">
-            <a:avLst/>
-          </a:prstGeom>
-          <a:noFill/>
-          <a:ln/>
-        </p:spPr>
-        <p:txBody>
-          <a:bodyPr wrap="square" lIns="0" tIns="0" rIns="0" bIns="0" rtlCol="0" anchor="ctr"/>
-          <a:lstStyle/>
-          <a:p>
-            <a:pPr indent="0" marL="0">
-              <a:buNone/>
-            </a:pPr>
-            <a:r>
-              <a:rPr lang="en-US" sz="900" dirty="0">
-                <a:solidFill>
-                  <a:srgbClr val="1F2937"/>
-                </a:solidFill>
-                <a:latin typeface="Arial" pitchFamily="34" charset="0"/>
-                <a:ea typeface="Arial" pitchFamily="34" charset="-122"/>
-                <a:cs typeface="Arial" pitchFamily="34" charset="-120"/>
-              </a:rPr>
-              <a:t>Cierre y primera medición de indicadores</a:t>
-            </a:r>
-            <a:endParaRPr lang="en-US" sz="900" dirty="0"/>
-          </a:p>
-        </p:txBody>
-      </p:sp>
-      <p:sp>
-        <p:nvSpPr>
-          <p:cNvPr id="84" name="Shape 82"/>
+          <p:cNvPr id="118" name="Shape 116"/>
           <p:cNvSpPr/>
           <p:nvPr/>
         </p:nvSpPr>
         <p:spPr>
           <a:xfrm>
-            <a:off x="10682478" y="5779008"/>
-            <a:ext cx="663116" cy="155448"/>
+            <a:off x="10766146" y="5792724"/>
+            <a:ext cx="409651" cy="141732"/>
           </a:xfrm>
           <a:prstGeom prst="roundRect">
             <a:avLst>
-              <a:gd name="adj" fmla="val 29412"/>
+              <a:gd name="adj" fmla="val 32258"/>
             </a:avLst>
           </a:prstGeom>
           <a:solidFill>
             <a:srgbClr val="FFA403">
-              <a:alpha val="55000"/>
+              <a:alpha val="30000"/>
             </a:srgbClr>
           </a:solidFill>
           <a:ln w="9525">
@@ -8183,14 +9313,14 @@
       </p:sp>
       <p:sp>
         <p:nvSpPr>
-          <p:cNvPr id="85" name="Text 83"/>
-          <p:cNvSpPr txBox="1"/>
-          <p:nvPr/>
-        </p:nvSpPr>
-        <p:spPr>
-          <a:xfrm>
-            <a:off x="3063240" y="5733288"/>
-            <a:ext cx="868680" cy="246888"/>
+          <p:cNvPr id="119" name="Text 117"/>
+          <p:cNvSpPr txBox="1"/>
+          <p:nvPr/>
+        </p:nvSpPr>
+        <p:spPr>
+          <a:xfrm>
+            <a:off x="11311128" y="5747004"/>
+            <a:ext cx="329184" cy="233172"/>
           </a:xfrm>
           <a:prstGeom prst="rect">
             <a:avLst/>
@@ -8202,11 +9332,11 @@
           <a:bodyPr wrap="square" lIns="0" tIns="0" rIns="0" bIns="0" rtlCol="0" anchor="ctr"/>
           <a:lstStyle/>
           <a:p>
-            <a:pPr algn="r" indent="0" marL="0">
-              <a:buNone/>
-            </a:pPr>
-            <a:r>
-              <a:rPr lang="en-US" sz="750" dirty="0">
+            <a:pPr algn="ctr" indent="0" marL="0">
+              <a:buNone/>
+            </a:pPr>
+            <a:r>
+              <a:rPr lang="en-US" sz="800" b="1" dirty="0">
                 <a:solidFill>
                   <a:srgbClr val="6B7280"/>
                 </a:solidFill>
@@ -8214,22 +9344,111 @@
                 <a:ea typeface="Arial" pitchFamily="34" charset="-122"/>
                 <a:cs typeface="Arial" pitchFamily="34" charset="-120"/>
               </a:rPr>
-              <a:t>14/12 – 23/12</a:t>
-            </a:r>
-            <a:endParaRPr lang="en-US" sz="750" dirty="0"/>
-          </a:p>
-        </p:txBody>
-      </p:sp>
-      <p:sp>
-        <p:nvSpPr>
-          <p:cNvPr id="86" name="Shape 84"/>
+              <a:t>0%</a:t>
+            </a:r>
+            <a:endParaRPr lang="en-US" sz="800" dirty="0"/>
+          </a:p>
+        </p:txBody>
+      </p:sp>
+      <p:sp>
+        <p:nvSpPr>
+          <p:cNvPr id="120" name="Shape 118"/>
           <p:cNvSpPr/>
           <p:nvPr/>
         </p:nvSpPr>
         <p:spPr>
           <a:xfrm>
-            <a:off x="5203288" y="1805940"/>
-            <a:ext cx="201168" cy="201168"/>
+            <a:off x="8308238" y="1728216"/>
+            <a:ext cx="0" cy="4251960"/>
+          </a:xfrm>
+          <a:prstGeom prst="line">
+            <a:avLst/>
+          </a:prstGeom>
+          <a:noFill/>
+          <a:ln w="19050">
+            <a:solidFill>
+              <a:srgbClr val="E42312"/>
+            </a:solidFill>
+            <a:prstDash val="dash"/>
+          </a:ln>
+        </p:spPr>
+      </p:sp>
+      <p:sp>
+        <p:nvSpPr>
+          <p:cNvPr id="121" name="Shape 119"/>
+          <p:cNvSpPr/>
+          <p:nvPr/>
+        </p:nvSpPr>
+        <p:spPr>
+          <a:xfrm>
+            <a:off x="8015630" y="1179576"/>
+            <a:ext cx="585216" cy="201168"/>
+          </a:xfrm>
+          <a:prstGeom prst="roundRect">
+            <a:avLst>
+              <a:gd name="adj" fmla="val 22727"/>
+            </a:avLst>
+          </a:prstGeom>
+          <a:solidFill>
+            <a:srgbClr val="E42312"/>
+          </a:solidFill>
+          <a:ln w="12700">
+            <a:solidFill>
+              <a:srgbClr val="E42312"/>
+            </a:solidFill>
+            <a:prstDash val="solid"/>
+          </a:ln>
+        </p:spPr>
+      </p:sp>
+      <p:sp>
+        <p:nvSpPr>
+          <p:cNvPr id="122" name="Text 120"/>
+          <p:cNvSpPr txBox="1"/>
+          <p:nvPr/>
+        </p:nvSpPr>
+        <p:spPr>
+          <a:xfrm>
+            <a:off x="8015630" y="1179576"/>
+            <a:ext cx="585216" cy="201168"/>
+          </a:xfrm>
+          <a:prstGeom prst="rect">
+            <a:avLst/>
+          </a:prstGeom>
+          <a:noFill/>
+          <a:ln/>
+        </p:spPr>
+        <p:txBody>
+          <a:bodyPr wrap="square" lIns="0" tIns="0" rIns="0" bIns="0" rtlCol="0" anchor="ctr"/>
+          <a:lstStyle/>
+          <a:p>
+            <a:pPr algn="ctr" indent="0" marL="0">
+              <a:buNone/>
+            </a:pPr>
+            <a:r>
+              <a:rPr lang="en-US" sz="700" b="1" dirty="0">
+                <a:solidFill>
+                  <a:srgbClr val="FFFFFF"/>
+                </a:solidFill>
+                <a:latin typeface="Arial" pitchFamily="34" charset="0"/>
+                <a:ea typeface="Arial" pitchFamily="34" charset="-122"/>
+                <a:cs typeface="Arial" pitchFamily="34" charset="-120"/>
+              </a:rPr>
+              <a:t>HOY 18/09</a:t>
+            </a:r>
+            <a:endParaRPr lang="en-US" sz="700" dirty="0"/>
+          </a:p>
+        </p:txBody>
+      </p:sp>
+      <p:sp>
+        <p:nvSpPr>
+          <p:cNvPr id="123" name="Shape 121"/>
+          <p:cNvSpPr/>
+          <p:nvPr/>
+        </p:nvSpPr>
+        <p:spPr>
+          <a:xfrm>
+            <a:off x="9972446" y="4373118"/>
+            <a:ext cx="182880" cy="182880"/>
           </a:xfrm>
           <a:prstGeom prst="diamond">
             <a:avLst/>
@@ -8247,14 +9466,14 @@
       </p:sp>
       <p:sp>
         <p:nvSpPr>
-          <p:cNvPr id="87" name="Shape 85"/>
+          <p:cNvPr id="124" name="Shape 122"/>
           <p:cNvSpPr/>
           <p:nvPr/>
         </p:nvSpPr>
         <p:spPr>
           <a:xfrm>
-            <a:off x="7782072" y="2793492"/>
-            <a:ext cx="201168" cy="201168"/>
+            <a:off x="10206533" y="5072634"/>
+            <a:ext cx="182880" cy="182880"/>
           </a:xfrm>
           <a:prstGeom prst="diamond">
             <a:avLst/>
@@ -8272,14 +9491,14 @@
       </p:sp>
       <p:sp>
         <p:nvSpPr>
-          <p:cNvPr id="88" name="Shape 86"/>
+          <p:cNvPr id="125" name="Shape 123"/>
           <p:cNvSpPr/>
           <p:nvPr/>
         </p:nvSpPr>
         <p:spPr>
           <a:xfrm>
-            <a:off x="8813585" y="4027932"/>
-            <a:ext cx="201168" cy="201168"/>
+            <a:off x="11084357" y="5072634"/>
+            <a:ext cx="182880" cy="182880"/>
           </a:xfrm>
           <a:prstGeom prst="diamond">
             <a:avLst/>
@@ -8297,14 +9516,109 @@
       </p:sp>
       <p:sp>
         <p:nvSpPr>
-          <p:cNvPr id="89" name="Shape 87"/>
+          <p:cNvPr id="126" name="Shape 124"/>
           <p:cNvSpPr/>
           <p:nvPr/>
         </p:nvSpPr>
         <p:spPr>
           <a:xfrm>
-            <a:off x="11245010" y="5015484"/>
-            <a:ext cx="201168" cy="201168"/>
+            <a:off x="640080" y="6135624"/>
+            <a:ext cx="365760" cy="146304"/>
+          </a:xfrm>
+          <a:prstGeom prst="roundRect">
+            <a:avLst>
+              <a:gd name="adj" fmla="val 25000"/>
+            </a:avLst>
+          </a:prstGeom>
+          <a:solidFill>
+            <a:srgbClr val="0B3A73">
+              <a:alpha val="30000"/>
+            </a:srgbClr>
+          </a:solidFill>
+          <a:ln w="9525">
+            <a:solidFill>
+              <a:srgbClr val="0B3A73"/>
+            </a:solidFill>
+            <a:prstDash val="solid"/>
+          </a:ln>
+        </p:spPr>
+      </p:sp>
+      <p:sp>
+        <p:nvSpPr>
+          <p:cNvPr id="127" name="Shape 125"/>
+          <p:cNvSpPr/>
+          <p:nvPr/>
+        </p:nvSpPr>
+        <p:spPr>
+          <a:xfrm>
+            <a:off x="640080" y="6135624"/>
+            <a:ext cx="182880" cy="146304"/>
+          </a:xfrm>
+          <a:prstGeom prst="roundRect">
+            <a:avLst>
+              <a:gd name="adj" fmla="val 25000"/>
+            </a:avLst>
+          </a:prstGeom>
+          <a:solidFill>
+            <a:srgbClr val="0B3A73"/>
+          </a:solidFill>
+          <a:ln w="9525">
+            <a:solidFill>
+              <a:srgbClr val="0B3A73"/>
+            </a:solidFill>
+            <a:prstDash val="solid"/>
+          </a:ln>
+        </p:spPr>
+      </p:sp>
+      <p:sp>
+        <p:nvSpPr>
+          <p:cNvPr id="128" name="Text 126"/>
+          <p:cNvSpPr txBox="1"/>
+          <p:nvPr/>
+        </p:nvSpPr>
+        <p:spPr>
+          <a:xfrm>
+            <a:off x="1097280" y="6089904"/>
+            <a:ext cx="2926080" cy="237744"/>
+          </a:xfrm>
+          <a:prstGeom prst="rect">
+            <a:avLst/>
+          </a:prstGeom>
+          <a:noFill/>
+          <a:ln/>
+        </p:spPr>
+        <p:txBody>
+          <a:bodyPr wrap="square" lIns="0" tIns="0" rIns="0" bIns="0" rtlCol="0" anchor="ctr"/>
+          <a:lstStyle/>
+          <a:p>
+            <a:pPr indent="0" marL="0">
+              <a:buNone/>
+            </a:pPr>
+            <a:r>
+              <a:rPr lang="en-US" sz="850" dirty="0">
+                <a:solidFill>
+                  <a:srgbClr val="1F2937"/>
+                </a:solidFill>
+                <a:latin typeface="Arial" pitchFamily="34" charset="0"/>
+                <a:ea typeface="Arial" pitchFamily="34" charset="-122"/>
+                <a:cs typeface="Arial" pitchFamily="34" charset="-120"/>
+              </a:rPr>
+              <a:t>Parte oscura de la barra = avance real</a:t>
+            </a:r>
+            <a:endParaRPr lang="en-US" sz="850" dirty="0"/>
+          </a:p>
+        </p:txBody>
+      </p:sp>
+      <p:sp>
+        <p:nvSpPr>
+          <p:cNvPr id="129" name="Shape 127"/>
+          <p:cNvSpPr/>
+          <p:nvPr/>
+        </p:nvSpPr>
+        <p:spPr>
+          <a:xfrm>
+            <a:off x="4114800" y="6126480"/>
+            <a:ext cx="164592" cy="164592"/>
           </a:xfrm>
           <a:prstGeom prst="diamond">
             <a:avLst/>
@@ -8322,39 +9636,14 @@
       </p:sp>
       <p:sp>
         <p:nvSpPr>
-          <p:cNvPr id="90" name="Shape 88"/>
-          <p:cNvSpPr/>
-          <p:nvPr/>
-        </p:nvSpPr>
-        <p:spPr>
-          <a:xfrm>
-            <a:off x="640080" y="6309360"/>
-            <a:ext cx="164592" cy="164592"/>
-          </a:xfrm>
-          <a:prstGeom prst="diamond">
-            <a:avLst/>
-          </a:prstGeom>
-          <a:solidFill>
-            <a:srgbClr val="E42312"/>
-          </a:solidFill>
-          <a:ln w="12700">
-            <a:solidFill>
-              <a:srgbClr val="FFFFFF"/>
-            </a:solidFill>
-            <a:prstDash val="solid"/>
-          </a:ln>
-        </p:spPr>
-      </p:sp>
-      <p:sp>
-        <p:nvSpPr>
-          <p:cNvPr id="91" name="Text 89"/>
-          <p:cNvSpPr txBox="1"/>
-          <p:nvPr/>
-        </p:nvSpPr>
-        <p:spPr>
-          <a:xfrm>
-            <a:off x="914400" y="6272784"/>
-            <a:ext cx="10698480" cy="237744"/>
+          <p:cNvPr id="130" name="Text 128"/>
+          <p:cNvSpPr txBox="1"/>
+          <p:nvPr/>
+        </p:nvSpPr>
+        <p:spPr>
+          <a:xfrm>
+            <a:off x="4389120" y="6089904"/>
+            <a:ext cx="7223760" cy="237744"/>
           </a:xfrm>
           <a:prstGeom prst="rect">
             <a:avLst/>
@@ -8370,7 +9659,7 @@
               <a:buNone/>
             </a:pPr>
             <a:r>
-              <a:rPr lang="en-US" sz="900" dirty="0">
+              <a:rPr lang="en-US" sz="850" dirty="0">
                 <a:solidFill>
                   <a:srgbClr val="1F2937"/>
                 </a:solidFill>
@@ -8378,22 +9667,22 @@
                 <a:ea typeface="Arial" pitchFamily="34" charset="-122"/>
                 <a:cs typeface="Arial" pitchFamily="34" charset="-120"/>
               </a:rPr>
-              <a:t>Hitos: 02/10 layout y presupuesto aprobados · 06/11 maquetas y tótems listos · 20/11 go/no-go del despliegue · 23/12 100% de los turnos certificados</a:t>
-            </a:r>
-            <a:endParaRPr lang="en-US" sz="900" dirty="0"/>
-          </a:p>
-        </p:txBody>
-      </p:sp>
-      <p:sp>
-        <p:nvSpPr>
-          <p:cNvPr id="92" name="Text 90"/>
-          <p:cNvSpPr txBox="1"/>
-          <p:nvPr/>
-        </p:nvSpPr>
-        <p:spPr>
-          <a:xfrm>
-            <a:off x="640080" y="6547104"/>
-            <a:ext cx="10972800" cy="237744"/>
+              <a:t>Hitos: 18/10 prueba piloto · 22/10 validación con Gerencia, Calidad y Producción · 06/11 cierre del seguimiento inicial</a:t>
+            </a:r>
+            <a:endParaRPr lang="en-US" sz="850" dirty="0"/>
+          </a:p>
+        </p:txBody>
+      </p:sp>
+      <p:sp>
+        <p:nvSpPr>
+          <p:cNvPr id="131" name="Text 129"/>
+          <p:cNvSpPr txBox="1"/>
+          <p:nvPr/>
+        </p:nvSpPr>
+        <p:spPr>
+          <a:xfrm>
+            <a:off x="640080" y="6345936"/>
+            <a:ext cx="10972800" cy="256032"/>
           </a:xfrm>
           <a:prstGeom prst="rect">
             <a:avLst/>
@@ -8409,7 +9698,7 @@
               <a:buNone/>
             </a:pPr>
             <a:r>
-              <a:rPr lang="en-US" sz="900" i="1" dirty="0">
+              <a:rPr lang="en-US" sz="850" i="1" dirty="0">
                 <a:solidFill>
                   <a:srgbClr val="6B7280"/>
                 </a:solidFill>
@@ -8417,15 +9706,15 @@
                 <a:ea typeface="Arial" pitchFamily="34" charset="-122"/>
                 <a:cs typeface="Arial" pitchFamily="34" charset="-120"/>
               </a:rPr>
-              <a:t>Duración total: 15 semanas (14/09 a 23/12/2026). Para llegar a diciembre las fases se solapan: la construcción arranca antes de cerrar el diseño y el despliegue sigue al piloto sin pausa.</a:t>
-            </a:r>
-            <a:endParaRPr lang="en-US" sz="900" dirty="0"/>
-          </a:p>
-        </p:txBody>
-      </p:sp>
-      <p:sp>
-        <p:nvSpPr>
-          <p:cNvPr id="93" name="Text 91"/>
+              <a:t>Estado al 18/09: 7 de 14 tareas terminadas, 4 en curso (evaluaciones teóricas 70%, herramientas 50%, identificación de elementos 20%, prototipo de stands 20%) y 2 vencidas sin cerrar: evaluaciones teóricas y recopilación de herramientas.</a:t>
+            </a:r>
+            <a:endParaRPr lang="en-US" sz="850" dirty="0"/>
+          </a:p>
+        </p:txBody>
+      </p:sp>
+      <p:sp>
+        <p:nvSpPr>
+          <p:cNvPr id="132" name="Text 130"/>
           <p:cNvSpPr txBox="1"/>
           <p:nvPr/>
         </p:nvSpPr>

</xml_diff>

<commit_message>
Cronograma del Dojo AM con columnas por semana calendario
Encabezado por número de semana ISO (S28 a S45) en lugar de meses.

Co-Authored-By: Claude Fable 5.1 <noreply@anthropic.com>
Claude-Session: https://claude.ai/code/session_013R5zM6jAzpk9971GWdT5eG
</commit_message>
<xml_diff>
--- a/docs/Dojo_AM_Unidad_Pintura.pptx
+++ b/docs/Dojo_AM_Unidad_Pintura.pptx
@@ -5657,7 +5657,7 @@
                 <a:ea typeface="Arial" pitchFamily="34" charset="-122"/>
                 <a:cs typeface="Arial" pitchFamily="34" charset="-120"/>
               </a:rPr>
-              <a:t>Avance al 18/09/2026. Las tareas se agrupan en las 4 fases del plan.</a:t>
+              <a:t>Avance al 18/09/2026 (semana 38). Columnas por semana calendario, de la S28 a la S45.</a:t>
             </a:r>
             <a:endParaRPr lang="en-US" sz="1100" dirty="0"/>
           </a:p>
@@ -5672,7 +5672,94 @@
         <p:spPr>
           <a:xfrm>
             <a:off x="3977640" y="1399032"/>
-            <a:ext cx="1521562" cy="329184"/>
+            <a:ext cx="409651" cy="329184"/>
+          </a:xfrm>
+          <a:prstGeom prst="rect">
+            <a:avLst/>
+          </a:prstGeom>
+          <a:solidFill>
+            <a:srgbClr val="E8EDF4"/>
+          </a:solidFill>
+          <a:ln w="12700">
+            <a:solidFill>
+              <a:srgbClr val="FFFFFF"/>
+            </a:solidFill>
+            <a:prstDash val="solid"/>
+          </a:ln>
+        </p:spPr>
+      </p:sp>
+      <p:sp>
+        <p:nvSpPr>
+          <p:cNvPr id="6" name="Text 4"/>
+          <p:cNvSpPr txBox="1"/>
+          <p:nvPr/>
+        </p:nvSpPr>
+        <p:spPr>
+          <a:xfrm>
+            <a:off x="3977640" y="1399032"/>
+            <a:ext cx="409651" cy="329184"/>
+          </a:xfrm>
+          <a:prstGeom prst="rect">
+            <a:avLst/>
+          </a:prstGeom>
+          <a:noFill/>
+          <a:ln/>
+        </p:spPr>
+        <p:txBody>
+          <a:bodyPr wrap="square" lIns="0" tIns="0" rIns="0" bIns="0" rtlCol="0" anchor="ctr"/>
+          <a:lstStyle/>
+          <a:p>
+            <a:pPr algn="ctr" indent="0" marL="0">
+              <a:buNone/>
+            </a:pPr>
+            <a:r>
+              <a:rPr lang="en-US" sz="850" b="1" dirty="0">
+                <a:solidFill>
+                  <a:srgbClr val="022A5B"/>
+                </a:solidFill>
+                <a:latin typeface="Arial" pitchFamily="34" charset="0"/>
+                <a:ea typeface="Arial" pitchFamily="34" charset="-122"/>
+                <a:cs typeface="Arial" pitchFamily="34" charset="-120"/>
+              </a:rPr>
+              <a:t>S28</a:t>
+            </a:r>
+            <a:endParaRPr lang="en-US" sz="850" dirty="0"/>
+          </a:p>
+        </p:txBody>
+      </p:sp>
+      <p:sp>
+        <p:nvSpPr>
+          <p:cNvPr id="7" name="Shape 5"/>
+          <p:cNvSpPr/>
+          <p:nvPr/>
+        </p:nvSpPr>
+        <p:spPr>
+          <a:xfrm>
+            <a:off x="3977640" y="1783080"/>
+            <a:ext cx="0" cy="4197096"/>
+          </a:xfrm>
+          <a:prstGeom prst="line">
+            <a:avLst/>
+          </a:prstGeom>
+          <a:noFill/>
+          <a:ln w="6350">
+            <a:solidFill>
+              <a:srgbClr val="E3E8EF"/>
+            </a:solidFill>
+            <a:prstDash val="solid"/>
+          </a:ln>
+        </p:spPr>
+      </p:sp>
+      <p:sp>
+        <p:nvSpPr>
+          <p:cNvPr id="8" name="Shape 6"/>
+          <p:cNvSpPr/>
+          <p:nvPr/>
+        </p:nvSpPr>
+        <p:spPr>
+          <a:xfrm>
+            <a:off x="4387291" y="1399032"/>
+            <a:ext cx="409651" cy="329184"/>
           </a:xfrm>
           <a:prstGeom prst="rect">
             <a:avLst/>
@@ -5690,14 +5777,14 @@
       </p:sp>
       <p:sp>
         <p:nvSpPr>
-          <p:cNvPr id="6" name="Text 4"/>
-          <p:cNvSpPr txBox="1"/>
-          <p:nvPr/>
-        </p:nvSpPr>
-        <p:spPr>
-          <a:xfrm>
-            <a:off x="3977640" y="1399032"/>
-            <a:ext cx="1521562" cy="329184"/>
+          <p:cNvPr id="9" name="Text 7"/>
+          <p:cNvSpPr txBox="1"/>
+          <p:nvPr/>
+        </p:nvSpPr>
+        <p:spPr>
+          <a:xfrm>
+            <a:off x="4387291" y="1399032"/>
+            <a:ext cx="409651" cy="329184"/>
           </a:xfrm>
           <a:prstGeom prst="rect">
             <a:avLst/>
@@ -5713,7 +5800,7 @@
               <a:buNone/>
             </a:pPr>
             <a:r>
-              <a:rPr lang="en-US" sz="1000" b="1" dirty="0">
+              <a:rPr lang="en-US" sz="850" b="1" dirty="0">
                 <a:solidFill>
                   <a:srgbClr val="022A5B"/>
                 </a:solidFill>
@@ -5721,30 +5808,30 @@
                 <a:ea typeface="Arial" pitchFamily="34" charset="-122"/>
                 <a:cs typeface="Arial" pitchFamily="34" charset="-120"/>
               </a:rPr>
-              <a:t>Julio</a:t>
-            </a:r>
-            <a:endParaRPr lang="en-US" sz="1000" dirty="0"/>
-          </a:p>
-        </p:txBody>
-      </p:sp>
-      <p:sp>
-        <p:nvSpPr>
-          <p:cNvPr id="7" name="Shape 5"/>
+              <a:t>S29</a:t>
+            </a:r>
+            <a:endParaRPr lang="en-US" sz="850" dirty="0"/>
+          </a:p>
+        </p:txBody>
+      </p:sp>
+      <p:sp>
+        <p:nvSpPr>
+          <p:cNvPr id="10" name="Shape 8"/>
           <p:cNvSpPr/>
           <p:nvPr/>
         </p:nvSpPr>
         <p:spPr>
           <a:xfrm>
-            <a:off x="3977640" y="1783080"/>
+            <a:off x="4387291" y="1783080"/>
             <a:ext cx="0" cy="4197096"/>
           </a:xfrm>
           <a:prstGeom prst="line">
             <a:avLst/>
           </a:prstGeom>
           <a:noFill/>
-          <a:ln w="9525">
+          <a:ln w="6350">
             <a:solidFill>
-              <a:srgbClr val="D9E0EA"/>
+              <a:srgbClr val="E3E8EF"/>
             </a:solidFill>
             <a:prstDash val="solid"/>
           </a:ln>
@@ -5752,14 +5839,101 @@
       </p:sp>
       <p:sp>
         <p:nvSpPr>
-          <p:cNvPr id="8" name="Shape 6"/>
+          <p:cNvPr id="11" name="Shape 9"/>
           <p:cNvSpPr/>
           <p:nvPr/>
         </p:nvSpPr>
         <p:spPr>
           <a:xfrm>
-            <a:off x="5499202" y="1399032"/>
-            <a:ext cx="1814170" cy="329184"/>
+            <a:off x="4796942" y="1399032"/>
+            <a:ext cx="409651" cy="329184"/>
+          </a:xfrm>
+          <a:prstGeom prst="rect">
+            <a:avLst/>
+          </a:prstGeom>
+          <a:solidFill>
+            <a:srgbClr val="E8EDF4"/>
+          </a:solidFill>
+          <a:ln w="12700">
+            <a:solidFill>
+              <a:srgbClr val="FFFFFF"/>
+            </a:solidFill>
+            <a:prstDash val="solid"/>
+          </a:ln>
+        </p:spPr>
+      </p:sp>
+      <p:sp>
+        <p:nvSpPr>
+          <p:cNvPr id="12" name="Text 10"/>
+          <p:cNvSpPr txBox="1"/>
+          <p:nvPr/>
+        </p:nvSpPr>
+        <p:spPr>
+          <a:xfrm>
+            <a:off x="4796942" y="1399032"/>
+            <a:ext cx="409651" cy="329184"/>
+          </a:xfrm>
+          <a:prstGeom prst="rect">
+            <a:avLst/>
+          </a:prstGeom>
+          <a:noFill/>
+          <a:ln/>
+        </p:spPr>
+        <p:txBody>
+          <a:bodyPr wrap="square" lIns="0" tIns="0" rIns="0" bIns="0" rtlCol="0" anchor="ctr"/>
+          <a:lstStyle/>
+          <a:p>
+            <a:pPr algn="ctr" indent="0" marL="0">
+              <a:buNone/>
+            </a:pPr>
+            <a:r>
+              <a:rPr lang="en-US" sz="850" b="1" dirty="0">
+                <a:solidFill>
+                  <a:srgbClr val="022A5B"/>
+                </a:solidFill>
+                <a:latin typeface="Arial" pitchFamily="34" charset="0"/>
+                <a:ea typeface="Arial" pitchFamily="34" charset="-122"/>
+                <a:cs typeface="Arial" pitchFamily="34" charset="-120"/>
+              </a:rPr>
+              <a:t>S30</a:t>
+            </a:r>
+            <a:endParaRPr lang="en-US" sz="850" dirty="0"/>
+          </a:p>
+        </p:txBody>
+      </p:sp>
+      <p:sp>
+        <p:nvSpPr>
+          <p:cNvPr id="13" name="Shape 11"/>
+          <p:cNvSpPr/>
+          <p:nvPr/>
+        </p:nvSpPr>
+        <p:spPr>
+          <a:xfrm>
+            <a:off x="4796942" y="1783080"/>
+            <a:ext cx="0" cy="4197096"/>
+          </a:xfrm>
+          <a:prstGeom prst="line">
+            <a:avLst/>
+          </a:prstGeom>
+          <a:noFill/>
+          <a:ln w="6350">
+            <a:solidFill>
+              <a:srgbClr val="E3E8EF"/>
+            </a:solidFill>
+            <a:prstDash val="solid"/>
+          </a:ln>
+        </p:spPr>
+      </p:sp>
+      <p:sp>
+        <p:nvSpPr>
+          <p:cNvPr id="14" name="Shape 12"/>
+          <p:cNvSpPr/>
+          <p:nvPr/>
+        </p:nvSpPr>
+        <p:spPr>
+          <a:xfrm>
+            <a:off x="5206594" y="1399032"/>
+            <a:ext cx="409651" cy="329184"/>
           </a:xfrm>
           <a:prstGeom prst="rect">
             <a:avLst/>
@@ -5777,14 +5951,14 @@
       </p:sp>
       <p:sp>
         <p:nvSpPr>
-          <p:cNvPr id="9" name="Text 7"/>
-          <p:cNvSpPr txBox="1"/>
-          <p:nvPr/>
-        </p:nvSpPr>
-        <p:spPr>
-          <a:xfrm>
-            <a:off x="5499202" y="1399032"/>
-            <a:ext cx="1814170" cy="329184"/>
+          <p:cNvPr id="15" name="Text 13"/>
+          <p:cNvSpPr txBox="1"/>
+          <p:nvPr/>
+        </p:nvSpPr>
+        <p:spPr>
+          <a:xfrm>
+            <a:off x="5206594" y="1399032"/>
+            <a:ext cx="409651" cy="329184"/>
           </a:xfrm>
           <a:prstGeom prst="rect">
             <a:avLst/>
@@ -5800,7 +5974,7 @@
               <a:buNone/>
             </a:pPr>
             <a:r>
-              <a:rPr lang="en-US" sz="1000" b="1" dirty="0">
+              <a:rPr lang="en-US" sz="850" b="1" dirty="0">
                 <a:solidFill>
                   <a:srgbClr val="022A5B"/>
                 </a:solidFill>
@@ -5808,30 +5982,30 @@
                 <a:ea typeface="Arial" pitchFamily="34" charset="-122"/>
                 <a:cs typeface="Arial" pitchFamily="34" charset="-120"/>
               </a:rPr>
-              <a:t>Agosto</a:t>
-            </a:r>
-            <a:endParaRPr lang="en-US" sz="1000" dirty="0"/>
-          </a:p>
-        </p:txBody>
-      </p:sp>
-      <p:sp>
-        <p:nvSpPr>
-          <p:cNvPr id="10" name="Shape 8"/>
+              <a:t>S31</a:t>
+            </a:r>
+            <a:endParaRPr lang="en-US" sz="850" dirty="0"/>
+          </a:p>
+        </p:txBody>
+      </p:sp>
+      <p:sp>
+        <p:nvSpPr>
+          <p:cNvPr id="16" name="Shape 14"/>
           <p:cNvSpPr/>
           <p:nvPr/>
         </p:nvSpPr>
         <p:spPr>
           <a:xfrm>
-            <a:off x="5499202" y="1783080"/>
+            <a:off x="5206594" y="1783080"/>
             <a:ext cx="0" cy="4197096"/>
           </a:xfrm>
           <a:prstGeom prst="line">
             <a:avLst/>
           </a:prstGeom>
           <a:noFill/>
-          <a:ln w="9525">
+          <a:ln w="6350">
             <a:solidFill>
-              <a:srgbClr val="D9E0EA"/>
+              <a:srgbClr val="E3E8EF"/>
             </a:solidFill>
             <a:prstDash val="solid"/>
           </a:ln>
@@ -5839,14 +6013,101 @@
       </p:sp>
       <p:sp>
         <p:nvSpPr>
-          <p:cNvPr id="11" name="Shape 9"/>
+          <p:cNvPr id="17" name="Shape 15"/>
           <p:cNvSpPr/>
           <p:nvPr/>
         </p:nvSpPr>
         <p:spPr>
           <a:xfrm>
-            <a:off x="7313371" y="1399032"/>
-            <a:ext cx="1755648" cy="329184"/>
+            <a:off x="5616245" y="1399032"/>
+            <a:ext cx="409651" cy="329184"/>
+          </a:xfrm>
+          <a:prstGeom prst="rect">
+            <a:avLst/>
+          </a:prstGeom>
+          <a:solidFill>
+            <a:srgbClr val="E8EDF4"/>
+          </a:solidFill>
+          <a:ln w="12700">
+            <a:solidFill>
+              <a:srgbClr val="FFFFFF"/>
+            </a:solidFill>
+            <a:prstDash val="solid"/>
+          </a:ln>
+        </p:spPr>
+      </p:sp>
+      <p:sp>
+        <p:nvSpPr>
+          <p:cNvPr id="18" name="Text 16"/>
+          <p:cNvSpPr txBox="1"/>
+          <p:nvPr/>
+        </p:nvSpPr>
+        <p:spPr>
+          <a:xfrm>
+            <a:off x="5616245" y="1399032"/>
+            <a:ext cx="409651" cy="329184"/>
+          </a:xfrm>
+          <a:prstGeom prst="rect">
+            <a:avLst/>
+          </a:prstGeom>
+          <a:noFill/>
+          <a:ln/>
+        </p:spPr>
+        <p:txBody>
+          <a:bodyPr wrap="square" lIns="0" tIns="0" rIns="0" bIns="0" rtlCol="0" anchor="ctr"/>
+          <a:lstStyle/>
+          <a:p>
+            <a:pPr algn="ctr" indent="0" marL="0">
+              <a:buNone/>
+            </a:pPr>
+            <a:r>
+              <a:rPr lang="en-US" sz="850" b="1" dirty="0">
+                <a:solidFill>
+                  <a:srgbClr val="022A5B"/>
+                </a:solidFill>
+                <a:latin typeface="Arial" pitchFamily="34" charset="0"/>
+                <a:ea typeface="Arial" pitchFamily="34" charset="-122"/>
+                <a:cs typeface="Arial" pitchFamily="34" charset="-120"/>
+              </a:rPr>
+              <a:t>S32</a:t>
+            </a:r>
+            <a:endParaRPr lang="en-US" sz="850" dirty="0"/>
+          </a:p>
+        </p:txBody>
+      </p:sp>
+      <p:sp>
+        <p:nvSpPr>
+          <p:cNvPr id="19" name="Shape 17"/>
+          <p:cNvSpPr/>
+          <p:nvPr/>
+        </p:nvSpPr>
+        <p:spPr>
+          <a:xfrm>
+            <a:off x="5616245" y="1783080"/>
+            <a:ext cx="0" cy="4197096"/>
+          </a:xfrm>
+          <a:prstGeom prst="line">
+            <a:avLst/>
+          </a:prstGeom>
+          <a:noFill/>
+          <a:ln w="6350">
+            <a:solidFill>
+              <a:srgbClr val="E3E8EF"/>
+            </a:solidFill>
+            <a:prstDash val="solid"/>
+          </a:ln>
+        </p:spPr>
+      </p:sp>
+      <p:sp>
+        <p:nvSpPr>
+          <p:cNvPr id="20" name="Shape 18"/>
+          <p:cNvSpPr/>
+          <p:nvPr/>
+        </p:nvSpPr>
+        <p:spPr>
+          <a:xfrm>
+            <a:off x="6025896" y="1399032"/>
+            <a:ext cx="409651" cy="329184"/>
           </a:xfrm>
           <a:prstGeom prst="rect">
             <a:avLst/>
@@ -5864,14 +6125,14 @@
       </p:sp>
       <p:sp>
         <p:nvSpPr>
-          <p:cNvPr id="12" name="Text 10"/>
-          <p:cNvSpPr txBox="1"/>
-          <p:nvPr/>
-        </p:nvSpPr>
-        <p:spPr>
-          <a:xfrm>
-            <a:off x="7313371" y="1399032"/>
-            <a:ext cx="1755648" cy="329184"/>
+          <p:cNvPr id="21" name="Text 19"/>
+          <p:cNvSpPr txBox="1"/>
+          <p:nvPr/>
+        </p:nvSpPr>
+        <p:spPr>
+          <a:xfrm>
+            <a:off x="6025896" y="1399032"/>
+            <a:ext cx="409651" cy="329184"/>
           </a:xfrm>
           <a:prstGeom prst="rect">
             <a:avLst/>
@@ -5887,7 +6148,7 @@
               <a:buNone/>
             </a:pPr>
             <a:r>
-              <a:rPr lang="en-US" sz="1000" b="1" dirty="0">
+              <a:rPr lang="en-US" sz="850" b="1" dirty="0">
                 <a:solidFill>
                   <a:srgbClr val="022A5B"/>
                 </a:solidFill>
@@ -5895,30 +6156,30 @@
                 <a:ea typeface="Arial" pitchFamily="34" charset="-122"/>
                 <a:cs typeface="Arial" pitchFamily="34" charset="-120"/>
               </a:rPr>
-              <a:t>Septiembre</a:t>
-            </a:r>
-            <a:endParaRPr lang="en-US" sz="1000" dirty="0"/>
-          </a:p>
-        </p:txBody>
-      </p:sp>
-      <p:sp>
-        <p:nvSpPr>
-          <p:cNvPr id="13" name="Shape 11"/>
+              <a:t>S33</a:t>
+            </a:r>
+            <a:endParaRPr lang="en-US" sz="850" dirty="0"/>
+          </a:p>
+        </p:txBody>
+      </p:sp>
+      <p:sp>
+        <p:nvSpPr>
+          <p:cNvPr id="22" name="Shape 20"/>
           <p:cNvSpPr/>
           <p:nvPr/>
         </p:nvSpPr>
         <p:spPr>
           <a:xfrm>
-            <a:off x="7313371" y="1783080"/>
+            <a:off x="6025896" y="1783080"/>
             <a:ext cx="0" cy="4197096"/>
           </a:xfrm>
           <a:prstGeom prst="line">
             <a:avLst/>
           </a:prstGeom>
           <a:noFill/>
-          <a:ln w="9525">
+          <a:ln w="6350">
             <a:solidFill>
-              <a:srgbClr val="D9E0EA"/>
+              <a:srgbClr val="E3E8EF"/>
             </a:solidFill>
             <a:prstDash val="solid"/>
           </a:ln>
@@ -5926,14 +6187,101 @@
       </p:sp>
       <p:sp>
         <p:nvSpPr>
-          <p:cNvPr id="14" name="Shape 12"/>
+          <p:cNvPr id="23" name="Shape 21"/>
           <p:cNvSpPr/>
           <p:nvPr/>
         </p:nvSpPr>
         <p:spPr>
           <a:xfrm>
-            <a:off x="9069019" y="1399032"/>
-            <a:ext cx="1814170" cy="329184"/>
+            <a:off x="6435547" y="1399032"/>
+            <a:ext cx="409651" cy="329184"/>
+          </a:xfrm>
+          <a:prstGeom prst="rect">
+            <a:avLst/>
+          </a:prstGeom>
+          <a:solidFill>
+            <a:srgbClr val="E8EDF4"/>
+          </a:solidFill>
+          <a:ln w="12700">
+            <a:solidFill>
+              <a:srgbClr val="FFFFFF"/>
+            </a:solidFill>
+            <a:prstDash val="solid"/>
+          </a:ln>
+        </p:spPr>
+      </p:sp>
+      <p:sp>
+        <p:nvSpPr>
+          <p:cNvPr id="24" name="Text 22"/>
+          <p:cNvSpPr txBox="1"/>
+          <p:nvPr/>
+        </p:nvSpPr>
+        <p:spPr>
+          <a:xfrm>
+            <a:off x="6435547" y="1399032"/>
+            <a:ext cx="409651" cy="329184"/>
+          </a:xfrm>
+          <a:prstGeom prst="rect">
+            <a:avLst/>
+          </a:prstGeom>
+          <a:noFill/>
+          <a:ln/>
+        </p:spPr>
+        <p:txBody>
+          <a:bodyPr wrap="square" lIns="0" tIns="0" rIns="0" bIns="0" rtlCol="0" anchor="ctr"/>
+          <a:lstStyle/>
+          <a:p>
+            <a:pPr algn="ctr" indent="0" marL="0">
+              <a:buNone/>
+            </a:pPr>
+            <a:r>
+              <a:rPr lang="en-US" sz="850" b="1" dirty="0">
+                <a:solidFill>
+                  <a:srgbClr val="022A5B"/>
+                </a:solidFill>
+                <a:latin typeface="Arial" pitchFamily="34" charset="0"/>
+                <a:ea typeface="Arial" pitchFamily="34" charset="-122"/>
+                <a:cs typeface="Arial" pitchFamily="34" charset="-120"/>
+              </a:rPr>
+              <a:t>S34</a:t>
+            </a:r>
+            <a:endParaRPr lang="en-US" sz="850" dirty="0"/>
+          </a:p>
+        </p:txBody>
+      </p:sp>
+      <p:sp>
+        <p:nvSpPr>
+          <p:cNvPr id="25" name="Shape 23"/>
+          <p:cNvSpPr/>
+          <p:nvPr/>
+        </p:nvSpPr>
+        <p:spPr>
+          <a:xfrm>
+            <a:off x="6435547" y="1783080"/>
+            <a:ext cx="0" cy="4197096"/>
+          </a:xfrm>
+          <a:prstGeom prst="line">
+            <a:avLst/>
+          </a:prstGeom>
+          <a:noFill/>
+          <a:ln w="6350">
+            <a:solidFill>
+              <a:srgbClr val="E3E8EF"/>
+            </a:solidFill>
+            <a:prstDash val="solid"/>
+          </a:ln>
+        </p:spPr>
+      </p:sp>
+      <p:sp>
+        <p:nvSpPr>
+          <p:cNvPr id="26" name="Shape 24"/>
+          <p:cNvSpPr/>
+          <p:nvPr/>
+        </p:nvSpPr>
+        <p:spPr>
+          <a:xfrm>
+            <a:off x="6845198" y="1399032"/>
+            <a:ext cx="409651" cy="329184"/>
           </a:xfrm>
           <a:prstGeom prst="rect">
             <a:avLst/>
@@ -5951,14 +6299,14 @@
       </p:sp>
       <p:sp>
         <p:nvSpPr>
-          <p:cNvPr id="15" name="Text 13"/>
-          <p:cNvSpPr txBox="1"/>
-          <p:nvPr/>
-        </p:nvSpPr>
-        <p:spPr>
-          <a:xfrm>
-            <a:off x="9069019" y="1399032"/>
-            <a:ext cx="1814170" cy="329184"/>
+          <p:cNvPr id="27" name="Text 25"/>
+          <p:cNvSpPr txBox="1"/>
+          <p:nvPr/>
+        </p:nvSpPr>
+        <p:spPr>
+          <a:xfrm>
+            <a:off x="6845198" y="1399032"/>
+            <a:ext cx="409651" cy="329184"/>
           </a:xfrm>
           <a:prstGeom prst="rect">
             <a:avLst/>
@@ -5974,7 +6322,7 @@
               <a:buNone/>
             </a:pPr>
             <a:r>
-              <a:rPr lang="en-US" sz="1000" b="1" dirty="0">
+              <a:rPr lang="en-US" sz="850" b="1" dirty="0">
                 <a:solidFill>
                   <a:srgbClr val="022A5B"/>
                 </a:solidFill>
@@ -5982,30 +6330,30 @@
                 <a:ea typeface="Arial" pitchFamily="34" charset="-122"/>
                 <a:cs typeface="Arial" pitchFamily="34" charset="-120"/>
               </a:rPr>
-              <a:t>Octubre</a:t>
-            </a:r>
-            <a:endParaRPr lang="en-US" sz="1000" dirty="0"/>
-          </a:p>
-        </p:txBody>
-      </p:sp>
-      <p:sp>
-        <p:nvSpPr>
-          <p:cNvPr id="16" name="Shape 14"/>
+              <a:t>S35</a:t>
+            </a:r>
+            <a:endParaRPr lang="en-US" sz="850" dirty="0"/>
+          </a:p>
+        </p:txBody>
+      </p:sp>
+      <p:sp>
+        <p:nvSpPr>
+          <p:cNvPr id="28" name="Shape 26"/>
           <p:cNvSpPr/>
           <p:nvPr/>
         </p:nvSpPr>
         <p:spPr>
           <a:xfrm>
-            <a:off x="9069019" y="1783080"/>
+            <a:off x="6845198" y="1783080"/>
             <a:ext cx="0" cy="4197096"/>
           </a:xfrm>
           <a:prstGeom prst="line">
             <a:avLst/>
           </a:prstGeom>
           <a:noFill/>
-          <a:ln w="9525">
+          <a:ln w="6350">
             <a:solidFill>
-              <a:srgbClr val="D9E0EA"/>
+              <a:srgbClr val="E3E8EF"/>
             </a:solidFill>
             <a:prstDash val="solid"/>
           </a:ln>
@@ -6013,13 +6361,100 @@
       </p:sp>
       <p:sp>
         <p:nvSpPr>
-          <p:cNvPr id="17" name="Shape 15"/>
+          <p:cNvPr id="29" name="Shape 27"/>
           <p:cNvSpPr/>
           <p:nvPr/>
         </p:nvSpPr>
         <p:spPr>
           <a:xfrm>
-            <a:off x="10883189" y="1399032"/>
+            <a:off x="7254850" y="1399032"/>
+            <a:ext cx="409651" cy="329184"/>
+          </a:xfrm>
+          <a:prstGeom prst="rect">
+            <a:avLst/>
+          </a:prstGeom>
+          <a:solidFill>
+            <a:srgbClr val="E8EDF4"/>
+          </a:solidFill>
+          <a:ln w="12700">
+            <a:solidFill>
+              <a:srgbClr val="FFFFFF"/>
+            </a:solidFill>
+            <a:prstDash val="solid"/>
+          </a:ln>
+        </p:spPr>
+      </p:sp>
+      <p:sp>
+        <p:nvSpPr>
+          <p:cNvPr id="30" name="Text 28"/>
+          <p:cNvSpPr txBox="1"/>
+          <p:nvPr/>
+        </p:nvSpPr>
+        <p:spPr>
+          <a:xfrm>
+            <a:off x="7254850" y="1399032"/>
+            <a:ext cx="409651" cy="329184"/>
+          </a:xfrm>
+          <a:prstGeom prst="rect">
+            <a:avLst/>
+          </a:prstGeom>
+          <a:noFill/>
+          <a:ln/>
+        </p:spPr>
+        <p:txBody>
+          <a:bodyPr wrap="square" lIns="0" tIns="0" rIns="0" bIns="0" rtlCol="0" anchor="ctr"/>
+          <a:lstStyle/>
+          <a:p>
+            <a:pPr algn="ctr" indent="0" marL="0">
+              <a:buNone/>
+            </a:pPr>
+            <a:r>
+              <a:rPr lang="en-US" sz="850" b="1" dirty="0">
+                <a:solidFill>
+                  <a:srgbClr val="022A5B"/>
+                </a:solidFill>
+                <a:latin typeface="Arial" pitchFamily="34" charset="0"/>
+                <a:ea typeface="Arial" pitchFamily="34" charset="-122"/>
+                <a:cs typeface="Arial" pitchFamily="34" charset="-120"/>
+              </a:rPr>
+              <a:t>S36</a:t>
+            </a:r>
+            <a:endParaRPr lang="en-US" sz="850" dirty="0"/>
+          </a:p>
+        </p:txBody>
+      </p:sp>
+      <p:sp>
+        <p:nvSpPr>
+          <p:cNvPr id="31" name="Shape 29"/>
+          <p:cNvSpPr/>
+          <p:nvPr/>
+        </p:nvSpPr>
+        <p:spPr>
+          <a:xfrm>
+            <a:off x="7254850" y="1783080"/>
+            <a:ext cx="0" cy="4197096"/>
+          </a:xfrm>
+          <a:prstGeom prst="line">
+            <a:avLst/>
+          </a:prstGeom>
+          <a:noFill/>
+          <a:ln w="6350">
+            <a:solidFill>
+              <a:srgbClr val="E3E8EF"/>
+            </a:solidFill>
+            <a:prstDash val="solid"/>
+          </a:ln>
+        </p:spPr>
+      </p:sp>
+      <p:sp>
+        <p:nvSpPr>
+          <p:cNvPr id="32" name="Shape 30"/>
+          <p:cNvSpPr/>
+          <p:nvPr/>
+        </p:nvSpPr>
+        <p:spPr>
+          <a:xfrm>
+            <a:off x="7664501" y="1399032"/>
             <a:ext cx="409651" cy="329184"/>
           </a:xfrm>
           <a:prstGeom prst="rect">
@@ -6038,13 +6473,13 @@
       </p:sp>
       <p:sp>
         <p:nvSpPr>
-          <p:cNvPr id="18" name="Text 16"/>
-          <p:cNvSpPr txBox="1"/>
-          <p:nvPr/>
-        </p:nvSpPr>
-        <p:spPr>
-          <a:xfrm>
-            <a:off x="10883189" y="1399032"/>
+          <p:cNvPr id="33" name="Text 31"/>
+          <p:cNvSpPr txBox="1"/>
+          <p:nvPr/>
+        </p:nvSpPr>
+        <p:spPr>
+          <a:xfrm>
+            <a:off x="7664501" y="1399032"/>
             <a:ext cx="409651" cy="329184"/>
           </a:xfrm>
           <a:prstGeom prst="rect">
@@ -6061,7 +6496,7 @@
               <a:buNone/>
             </a:pPr>
             <a:r>
-              <a:rPr lang="en-US" sz="1000" b="1" dirty="0">
+              <a:rPr lang="en-US" sz="850" b="1" dirty="0">
                 <a:solidFill>
                   <a:srgbClr val="022A5B"/>
                 </a:solidFill>
@@ -6069,30 +6504,30 @@
                 <a:ea typeface="Arial" pitchFamily="34" charset="-122"/>
                 <a:cs typeface="Arial" pitchFamily="34" charset="-120"/>
               </a:rPr>
-              <a:t>Nov</a:t>
-            </a:r>
-            <a:endParaRPr lang="en-US" sz="1000" dirty="0"/>
-          </a:p>
-        </p:txBody>
-      </p:sp>
-      <p:sp>
-        <p:nvSpPr>
-          <p:cNvPr id="19" name="Shape 17"/>
+              <a:t>S37</a:t>
+            </a:r>
+            <a:endParaRPr lang="en-US" sz="850" dirty="0"/>
+          </a:p>
+        </p:txBody>
+      </p:sp>
+      <p:sp>
+        <p:nvSpPr>
+          <p:cNvPr id="34" name="Shape 32"/>
           <p:cNvSpPr/>
           <p:nvPr/>
         </p:nvSpPr>
         <p:spPr>
           <a:xfrm>
-            <a:off x="10883189" y="1783080"/>
+            <a:off x="7664501" y="1783080"/>
             <a:ext cx="0" cy="4197096"/>
           </a:xfrm>
           <a:prstGeom prst="line">
             <a:avLst/>
           </a:prstGeom>
           <a:noFill/>
-          <a:ln w="9525">
+          <a:ln w="6350">
             <a:solidFill>
-              <a:srgbClr val="D9E0EA"/>
+              <a:srgbClr val="E3E8EF"/>
             </a:solidFill>
             <a:prstDash val="solid"/>
           </a:ln>
@@ -6100,22 +6535,24 @@
       </p:sp>
       <p:sp>
         <p:nvSpPr>
-          <p:cNvPr id="20" name="Shape 18"/>
+          <p:cNvPr id="35" name="Shape 33"/>
           <p:cNvSpPr/>
           <p:nvPr/>
         </p:nvSpPr>
         <p:spPr>
           <a:xfrm>
-            <a:off x="3977640" y="1783080"/>
-            <a:ext cx="0" cy="4197096"/>
-          </a:xfrm>
-          <a:prstGeom prst="line">
-            <a:avLst/>
-          </a:prstGeom>
-          <a:noFill/>
-          <a:ln w="6350">
+            <a:off x="8074152" y="1399032"/>
+            <a:ext cx="409651" cy="329184"/>
+          </a:xfrm>
+          <a:prstGeom prst="rect">
+            <a:avLst/>
+          </a:prstGeom>
+          <a:solidFill>
+            <a:srgbClr val="E8EDF4"/>
+          </a:solidFill>
+          <a:ln w="12700">
             <a:solidFill>
-              <a:srgbClr val="EEF1F5"/>
+              <a:srgbClr val="FFFFFF"/>
             </a:solidFill>
             <a:prstDash val="solid"/>
           </a:ln>
@@ -6123,13 +6560,52 @@
       </p:sp>
       <p:sp>
         <p:nvSpPr>
-          <p:cNvPr id="21" name="Shape 19"/>
+          <p:cNvPr id="36" name="Text 34"/>
+          <p:cNvSpPr txBox="1"/>
+          <p:nvPr/>
+        </p:nvSpPr>
+        <p:spPr>
+          <a:xfrm>
+            <a:off x="8074152" y="1399032"/>
+            <a:ext cx="409651" cy="329184"/>
+          </a:xfrm>
+          <a:prstGeom prst="rect">
+            <a:avLst/>
+          </a:prstGeom>
+          <a:noFill/>
+          <a:ln/>
+        </p:spPr>
+        <p:txBody>
+          <a:bodyPr wrap="square" lIns="0" tIns="0" rIns="0" bIns="0" rtlCol="0" anchor="ctr"/>
+          <a:lstStyle/>
+          <a:p>
+            <a:pPr algn="ctr" indent="0" marL="0">
+              <a:buNone/>
+            </a:pPr>
+            <a:r>
+              <a:rPr lang="en-US" sz="850" b="1" dirty="0">
+                <a:solidFill>
+                  <a:srgbClr val="022A5B"/>
+                </a:solidFill>
+                <a:latin typeface="Arial" pitchFamily="34" charset="0"/>
+                <a:ea typeface="Arial" pitchFamily="34" charset="-122"/>
+                <a:cs typeface="Arial" pitchFamily="34" charset="-120"/>
+              </a:rPr>
+              <a:t>S38</a:t>
+            </a:r>
+            <a:endParaRPr lang="en-US" sz="850" dirty="0"/>
+          </a:p>
+        </p:txBody>
+      </p:sp>
+      <p:sp>
+        <p:nvSpPr>
+          <p:cNvPr id="37" name="Shape 35"/>
           <p:cNvSpPr/>
           <p:nvPr/>
         </p:nvSpPr>
         <p:spPr>
           <a:xfrm>
-            <a:off x="4387291" y="1783080"/>
+            <a:off x="8074152" y="1783080"/>
             <a:ext cx="0" cy="4197096"/>
           </a:xfrm>
           <a:prstGeom prst="line">
@@ -6138,7 +6614,7 @@
           <a:noFill/>
           <a:ln w="6350">
             <a:solidFill>
-              <a:srgbClr val="EEF1F5"/>
+              <a:srgbClr val="E3E8EF"/>
             </a:solidFill>
             <a:prstDash val="solid"/>
           </a:ln>
@@ -6146,22 +6622,24 @@
       </p:sp>
       <p:sp>
         <p:nvSpPr>
-          <p:cNvPr id="22" name="Shape 20"/>
+          <p:cNvPr id="38" name="Shape 36"/>
           <p:cNvSpPr/>
           <p:nvPr/>
         </p:nvSpPr>
         <p:spPr>
           <a:xfrm>
-            <a:off x="4796942" y="1783080"/>
-            <a:ext cx="0" cy="4197096"/>
-          </a:xfrm>
-          <a:prstGeom prst="line">
-            <a:avLst/>
-          </a:prstGeom>
-          <a:noFill/>
-          <a:ln w="6350">
+            <a:off x="8483803" y="1399032"/>
+            <a:ext cx="409651" cy="329184"/>
+          </a:xfrm>
+          <a:prstGeom prst="rect">
+            <a:avLst/>
+          </a:prstGeom>
+          <a:solidFill>
+            <a:srgbClr val="F3F5F8"/>
+          </a:solidFill>
+          <a:ln w="12700">
             <a:solidFill>
-              <a:srgbClr val="EEF1F5"/>
+              <a:srgbClr val="FFFFFF"/>
             </a:solidFill>
             <a:prstDash val="solid"/>
           </a:ln>
@@ -6169,13 +6647,52 @@
       </p:sp>
       <p:sp>
         <p:nvSpPr>
-          <p:cNvPr id="23" name="Shape 21"/>
+          <p:cNvPr id="39" name="Text 37"/>
+          <p:cNvSpPr txBox="1"/>
+          <p:nvPr/>
+        </p:nvSpPr>
+        <p:spPr>
+          <a:xfrm>
+            <a:off x="8483803" y="1399032"/>
+            <a:ext cx="409651" cy="329184"/>
+          </a:xfrm>
+          <a:prstGeom prst="rect">
+            <a:avLst/>
+          </a:prstGeom>
+          <a:noFill/>
+          <a:ln/>
+        </p:spPr>
+        <p:txBody>
+          <a:bodyPr wrap="square" lIns="0" tIns="0" rIns="0" bIns="0" rtlCol="0" anchor="ctr"/>
+          <a:lstStyle/>
+          <a:p>
+            <a:pPr algn="ctr" indent="0" marL="0">
+              <a:buNone/>
+            </a:pPr>
+            <a:r>
+              <a:rPr lang="en-US" sz="850" b="1" dirty="0">
+                <a:solidFill>
+                  <a:srgbClr val="022A5B"/>
+                </a:solidFill>
+                <a:latin typeface="Arial" pitchFamily="34" charset="0"/>
+                <a:ea typeface="Arial" pitchFamily="34" charset="-122"/>
+                <a:cs typeface="Arial" pitchFamily="34" charset="-120"/>
+              </a:rPr>
+              <a:t>S39</a:t>
+            </a:r>
+            <a:endParaRPr lang="en-US" sz="850" dirty="0"/>
+          </a:p>
+        </p:txBody>
+      </p:sp>
+      <p:sp>
+        <p:nvSpPr>
+          <p:cNvPr id="40" name="Shape 38"/>
           <p:cNvSpPr/>
           <p:nvPr/>
         </p:nvSpPr>
         <p:spPr>
           <a:xfrm>
-            <a:off x="5206594" y="1783080"/>
+            <a:off x="8483803" y="1783080"/>
             <a:ext cx="0" cy="4197096"/>
           </a:xfrm>
           <a:prstGeom prst="line">
@@ -6184,7 +6701,7 @@
           <a:noFill/>
           <a:ln w="6350">
             <a:solidFill>
-              <a:srgbClr val="EEF1F5"/>
+              <a:srgbClr val="E3E8EF"/>
             </a:solidFill>
             <a:prstDash val="solid"/>
           </a:ln>
@@ -6192,22 +6709,24 @@
       </p:sp>
       <p:sp>
         <p:nvSpPr>
-          <p:cNvPr id="24" name="Shape 22"/>
+          <p:cNvPr id="41" name="Shape 39"/>
           <p:cNvSpPr/>
           <p:nvPr/>
         </p:nvSpPr>
         <p:spPr>
           <a:xfrm>
-            <a:off x="5616245" y="1783080"/>
-            <a:ext cx="0" cy="4197096"/>
-          </a:xfrm>
-          <a:prstGeom prst="line">
-            <a:avLst/>
-          </a:prstGeom>
-          <a:noFill/>
-          <a:ln w="6350">
+            <a:off x="8893454" y="1399032"/>
+            <a:ext cx="409651" cy="329184"/>
+          </a:xfrm>
+          <a:prstGeom prst="rect">
+            <a:avLst/>
+          </a:prstGeom>
+          <a:solidFill>
+            <a:srgbClr val="E8EDF4"/>
+          </a:solidFill>
+          <a:ln w="12700">
             <a:solidFill>
-              <a:srgbClr val="EEF1F5"/>
+              <a:srgbClr val="FFFFFF"/>
             </a:solidFill>
             <a:prstDash val="solid"/>
           </a:ln>
@@ -6215,13 +6734,52 @@
       </p:sp>
       <p:sp>
         <p:nvSpPr>
-          <p:cNvPr id="25" name="Shape 23"/>
+          <p:cNvPr id="42" name="Text 40"/>
+          <p:cNvSpPr txBox="1"/>
+          <p:nvPr/>
+        </p:nvSpPr>
+        <p:spPr>
+          <a:xfrm>
+            <a:off x="8893454" y="1399032"/>
+            <a:ext cx="409651" cy="329184"/>
+          </a:xfrm>
+          <a:prstGeom prst="rect">
+            <a:avLst/>
+          </a:prstGeom>
+          <a:noFill/>
+          <a:ln/>
+        </p:spPr>
+        <p:txBody>
+          <a:bodyPr wrap="square" lIns="0" tIns="0" rIns="0" bIns="0" rtlCol="0" anchor="ctr"/>
+          <a:lstStyle/>
+          <a:p>
+            <a:pPr algn="ctr" indent="0" marL="0">
+              <a:buNone/>
+            </a:pPr>
+            <a:r>
+              <a:rPr lang="en-US" sz="850" b="1" dirty="0">
+                <a:solidFill>
+                  <a:srgbClr val="022A5B"/>
+                </a:solidFill>
+                <a:latin typeface="Arial" pitchFamily="34" charset="0"/>
+                <a:ea typeface="Arial" pitchFamily="34" charset="-122"/>
+                <a:cs typeface="Arial" pitchFamily="34" charset="-120"/>
+              </a:rPr>
+              <a:t>S40</a:t>
+            </a:r>
+            <a:endParaRPr lang="en-US" sz="850" dirty="0"/>
+          </a:p>
+        </p:txBody>
+      </p:sp>
+      <p:sp>
+        <p:nvSpPr>
+          <p:cNvPr id="43" name="Shape 41"/>
           <p:cNvSpPr/>
           <p:nvPr/>
         </p:nvSpPr>
         <p:spPr>
           <a:xfrm>
-            <a:off x="6025896" y="1783080"/>
+            <a:off x="8893454" y="1783080"/>
             <a:ext cx="0" cy="4197096"/>
           </a:xfrm>
           <a:prstGeom prst="line">
@@ -6230,7 +6788,7 @@
           <a:noFill/>
           <a:ln w="6350">
             <a:solidFill>
-              <a:srgbClr val="EEF1F5"/>
+              <a:srgbClr val="E3E8EF"/>
             </a:solidFill>
             <a:prstDash val="solid"/>
           </a:ln>
@@ -6238,22 +6796,24 @@
       </p:sp>
       <p:sp>
         <p:nvSpPr>
-          <p:cNvPr id="26" name="Shape 24"/>
+          <p:cNvPr id="44" name="Shape 42"/>
           <p:cNvSpPr/>
           <p:nvPr/>
         </p:nvSpPr>
         <p:spPr>
           <a:xfrm>
-            <a:off x="6435547" y="1783080"/>
-            <a:ext cx="0" cy="4197096"/>
-          </a:xfrm>
-          <a:prstGeom prst="line">
-            <a:avLst/>
-          </a:prstGeom>
-          <a:noFill/>
-          <a:ln w="6350">
+            <a:off x="9303106" y="1399032"/>
+            <a:ext cx="409651" cy="329184"/>
+          </a:xfrm>
+          <a:prstGeom prst="rect">
+            <a:avLst/>
+          </a:prstGeom>
+          <a:solidFill>
+            <a:srgbClr val="F3F5F8"/>
+          </a:solidFill>
+          <a:ln w="12700">
             <a:solidFill>
-              <a:srgbClr val="EEF1F5"/>
+              <a:srgbClr val="FFFFFF"/>
             </a:solidFill>
             <a:prstDash val="solid"/>
           </a:ln>
@@ -6261,13 +6821,52 @@
       </p:sp>
       <p:sp>
         <p:nvSpPr>
-          <p:cNvPr id="27" name="Shape 25"/>
+          <p:cNvPr id="45" name="Text 43"/>
+          <p:cNvSpPr txBox="1"/>
+          <p:nvPr/>
+        </p:nvSpPr>
+        <p:spPr>
+          <a:xfrm>
+            <a:off x="9303106" y="1399032"/>
+            <a:ext cx="409651" cy="329184"/>
+          </a:xfrm>
+          <a:prstGeom prst="rect">
+            <a:avLst/>
+          </a:prstGeom>
+          <a:noFill/>
+          <a:ln/>
+        </p:spPr>
+        <p:txBody>
+          <a:bodyPr wrap="square" lIns="0" tIns="0" rIns="0" bIns="0" rtlCol="0" anchor="ctr"/>
+          <a:lstStyle/>
+          <a:p>
+            <a:pPr algn="ctr" indent="0" marL="0">
+              <a:buNone/>
+            </a:pPr>
+            <a:r>
+              <a:rPr lang="en-US" sz="850" b="1" dirty="0">
+                <a:solidFill>
+                  <a:srgbClr val="022A5B"/>
+                </a:solidFill>
+                <a:latin typeface="Arial" pitchFamily="34" charset="0"/>
+                <a:ea typeface="Arial" pitchFamily="34" charset="-122"/>
+                <a:cs typeface="Arial" pitchFamily="34" charset="-120"/>
+              </a:rPr>
+              <a:t>S41</a:t>
+            </a:r>
+            <a:endParaRPr lang="en-US" sz="850" dirty="0"/>
+          </a:p>
+        </p:txBody>
+      </p:sp>
+      <p:sp>
+        <p:nvSpPr>
+          <p:cNvPr id="46" name="Shape 44"/>
           <p:cNvSpPr/>
           <p:nvPr/>
         </p:nvSpPr>
         <p:spPr>
           <a:xfrm>
-            <a:off x="6845198" y="1783080"/>
+            <a:off x="9303106" y="1783080"/>
             <a:ext cx="0" cy="4197096"/>
           </a:xfrm>
           <a:prstGeom prst="line">
@@ -6276,7 +6875,7 @@
           <a:noFill/>
           <a:ln w="6350">
             <a:solidFill>
-              <a:srgbClr val="EEF1F5"/>
+              <a:srgbClr val="E3E8EF"/>
             </a:solidFill>
             <a:prstDash val="solid"/>
           </a:ln>
@@ -6284,22 +6883,24 @@
       </p:sp>
       <p:sp>
         <p:nvSpPr>
-          <p:cNvPr id="28" name="Shape 26"/>
+          <p:cNvPr id="47" name="Shape 45"/>
           <p:cNvSpPr/>
           <p:nvPr/>
         </p:nvSpPr>
         <p:spPr>
           <a:xfrm>
-            <a:off x="7254850" y="1783080"/>
-            <a:ext cx="0" cy="4197096"/>
-          </a:xfrm>
-          <a:prstGeom prst="line">
-            <a:avLst/>
-          </a:prstGeom>
-          <a:noFill/>
-          <a:ln w="6350">
+            <a:off x="9712757" y="1399032"/>
+            <a:ext cx="409651" cy="329184"/>
+          </a:xfrm>
+          <a:prstGeom prst="rect">
+            <a:avLst/>
+          </a:prstGeom>
+          <a:solidFill>
+            <a:srgbClr val="E8EDF4"/>
+          </a:solidFill>
+          <a:ln w="12700">
             <a:solidFill>
-              <a:srgbClr val="EEF1F5"/>
+              <a:srgbClr val="FFFFFF"/>
             </a:solidFill>
             <a:prstDash val="solid"/>
           </a:ln>
@@ -6307,13 +6908,52 @@
       </p:sp>
       <p:sp>
         <p:nvSpPr>
-          <p:cNvPr id="29" name="Shape 27"/>
+          <p:cNvPr id="48" name="Text 46"/>
+          <p:cNvSpPr txBox="1"/>
+          <p:nvPr/>
+        </p:nvSpPr>
+        <p:spPr>
+          <a:xfrm>
+            <a:off x="9712757" y="1399032"/>
+            <a:ext cx="409651" cy="329184"/>
+          </a:xfrm>
+          <a:prstGeom prst="rect">
+            <a:avLst/>
+          </a:prstGeom>
+          <a:noFill/>
+          <a:ln/>
+        </p:spPr>
+        <p:txBody>
+          <a:bodyPr wrap="square" lIns="0" tIns="0" rIns="0" bIns="0" rtlCol="0" anchor="ctr"/>
+          <a:lstStyle/>
+          <a:p>
+            <a:pPr algn="ctr" indent="0" marL="0">
+              <a:buNone/>
+            </a:pPr>
+            <a:r>
+              <a:rPr lang="en-US" sz="850" b="1" dirty="0">
+                <a:solidFill>
+                  <a:srgbClr val="022A5B"/>
+                </a:solidFill>
+                <a:latin typeface="Arial" pitchFamily="34" charset="0"/>
+                <a:ea typeface="Arial" pitchFamily="34" charset="-122"/>
+                <a:cs typeface="Arial" pitchFamily="34" charset="-120"/>
+              </a:rPr>
+              <a:t>S42</a:t>
+            </a:r>
+            <a:endParaRPr lang="en-US" sz="850" dirty="0"/>
+          </a:p>
+        </p:txBody>
+      </p:sp>
+      <p:sp>
+        <p:nvSpPr>
+          <p:cNvPr id="49" name="Shape 47"/>
           <p:cNvSpPr/>
           <p:nvPr/>
         </p:nvSpPr>
         <p:spPr>
           <a:xfrm>
-            <a:off x="7664501" y="1783080"/>
+            <a:off x="9712757" y="1783080"/>
             <a:ext cx="0" cy="4197096"/>
           </a:xfrm>
           <a:prstGeom prst="line">
@@ -6322,7 +6962,7 @@
           <a:noFill/>
           <a:ln w="6350">
             <a:solidFill>
-              <a:srgbClr val="EEF1F5"/>
+              <a:srgbClr val="E3E8EF"/>
             </a:solidFill>
             <a:prstDash val="solid"/>
           </a:ln>
@@ -6330,22 +6970,24 @@
       </p:sp>
       <p:sp>
         <p:nvSpPr>
-          <p:cNvPr id="30" name="Shape 28"/>
+          <p:cNvPr id="50" name="Shape 48"/>
           <p:cNvSpPr/>
           <p:nvPr/>
         </p:nvSpPr>
         <p:spPr>
           <a:xfrm>
-            <a:off x="8074152" y="1783080"/>
-            <a:ext cx="0" cy="4197096"/>
-          </a:xfrm>
-          <a:prstGeom prst="line">
-            <a:avLst/>
-          </a:prstGeom>
-          <a:noFill/>
-          <a:ln w="6350">
+            <a:off x="10122408" y="1399032"/>
+            <a:ext cx="409651" cy="329184"/>
+          </a:xfrm>
+          <a:prstGeom prst="rect">
+            <a:avLst/>
+          </a:prstGeom>
+          <a:solidFill>
+            <a:srgbClr val="F3F5F8"/>
+          </a:solidFill>
+          <a:ln w="12700">
             <a:solidFill>
-              <a:srgbClr val="EEF1F5"/>
+              <a:srgbClr val="FFFFFF"/>
             </a:solidFill>
             <a:prstDash val="solid"/>
           </a:ln>
@@ -6353,13 +6995,52 @@
       </p:sp>
       <p:sp>
         <p:nvSpPr>
-          <p:cNvPr id="31" name="Shape 29"/>
+          <p:cNvPr id="51" name="Text 49"/>
+          <p:cNvSpPr txBox="1"/>
+          <p:nvPr/>
+        </p:nvSpPr>
+        <p:spPr>
+          <a:xfrm>
+            <a:off x="10122408" y="1399032"/>
+            <a:ext cx="409651" cy="329184"/>
+          </a:xfrm>
+          <a:prstGeom prst="rect">
+            <a:avLst/>
+          </a:prstGeom>
+          <a:noFill/>
+          <a:ln/>
+        </p:spPr>
+        <p:txBody>
+          <a:bodyPr wrap="square" lIns="0" tIns="0" rIns="0" bIns="0" rtlCol="0" anchor="ctr"/>
+          <a:lstStyle/>
+          <a:p>
+            <a:pPr algn="ctr" indent="0" marL="0">
+              <a:buNone/>
+            </a:pPr>
+            <a:r>
+              <a:rPr lang="en-US" sz="850" b="1" dirty="0">
+                <a:solidFill>
+                  <a:srgbClr val="022A5B"/>
+                </a:solidFill>
+                <a:latin typeface="Arial" pitchFamily="34" charset="0"/>
+                <a:ea typeface="Arial" pitchFamily="34" charset="-122"/>
+                <a:cs typeface="Arial" pitchFamily="34" charset="-120"/>
+              </a:rPr>
+              <a:t>S43</a:t>
+            </a:r>
+            <a:endParaRPr lang="en-US" sz="850" dirty="0"/>
+          </a:p>
+        </p:txBody>
+      </p:sp>
+      <p:sp>
+        <p:nvSpPr>
+          <p:cNvPr id="52" name="Shape 50"/>
           <p:cNvSpPr/>
           <p:nvPr/>
         </p:nvSpPr>
         <p:spPr>
           <a:xfrm>
-            <a:off x="8483803" y="1783080"/>
+            <a:off x="10122408" y="1783080"/>
             <a:ext cx="0" cy="4197096"/>
           </a:xfrm>
           <a:prstGeom prst="line">
@@ -6368,7 +7049,7 @@
           <a:noFill/>
           <a:ln w="6350">
             <a:solidFill>
-              <a:srgbClr val="EEF1F5"/>
+              <a:srgbClr val="E3E8EF"/>
             </a:solidFill>
             <a:prstDash val="solid"/>
           </a:ln>
@@ -6376,22 +7057,24 @@
       </p:sp>
       <p:sp>
         <p:nvSpPr>
-          <p:cNvPr id="32" name="Shape 30"/>
+          <p:cNvPr id="53" name="Shape 51"/>
           <p:cNvSpPr/>
           <p:nvPr/>
         </p:nvSpPr>
         <p:spPr>
           <a:xfrm>
-            <a:off x="8893454" y="1783080"/>
-            <a:ext cx="0" cy="4197096"/>
-          </a:xfrm>
-          <a:prstGeom prst="line">
-            <a:avLst/>
-          </a:prstGeom>
-          <a:noFill/>
-          <a:ln w="6350">
+            <a:off x="10532059" y="1399032"/>
+            <a:ext cx="409651" cy="329184"/>
+          </a:xfrm>
+          <a:prstGeom prst="rect">
+            <a:avLst/>
+          </a:prstGeom>
+          <a:solidFill>
+            <a:srgbClr val="E8EDF4"/>
+          </a:solidFill>
+          <a:ln w="12700">
             <a:solidFill>
-              <a:srgbClr val="EEF1F5"/>
+              <a:srgbClr val="FFFFFF"/>
             </a:solidFill>
             <a:prstDash val="solid"/>
           </a:ln>
@@ -6399,13 +7082,52 @@
       </p:sp>
       <p:sp>
         <p:nvSpPr>
-          <p:cNvPr id="33" name="Shape 31"/>
+          <p:cNvPr id="54" name="Text 52"/>
+          <p:cNvSpPr txBox="1"/>
+          <p:nvPr/>
+        </p:nvSpPr>
+        <p:spPr>
+          <a:xfrm>
+            <a:off x="10532059" y="1399032"/>
+            <a:ext cx="409651" cy="329184"/>
+          </a:xfrm>
+          <a:prstGeom prst="rect">
+            <a:avLst/>
+          </a:prstGeom>
+          <a:noFill/>
+          <a:ln/>
+        </p:spPr>
+        <p:txBody>
+          <a:bodyPr wrap="square" lIns="0" tIns="0" rIns="0" bIns="0" rtlCol="0" anchor="ctr"/>
+          <a:lstStyle/>
+          <a:p>
+            <a:pPr algn="ctr" indent="0" marL="0">
+              <a:buNone/>
+            </a:pPr>
+            <a:r>
+              <a:rPr lang="en-US" sz="850" b="1" dirty="0">
+                <a:solidFill>
+                  <a:srgbClr val="022A5B"/>
+                </a:solidFill>
+                <a:latin typeface="Arial" pitchFamily="34" charset="0"/>
+                <a:ea typeface="Arial" pitchFamily="34" charset="-122"/>
+                <a:cs typeface="Arial" pitchFamily="34" charset="-120"/>
+              </a:rPr>
+              <a:t>S44</a:t>
+            </a:r>
+            <a:endParaRPr lang="en-US" sz="850" dirty="0"/>
+          </a:p>
+        </p:txBody>
+      </p:sp>
+      <p:sp>
+        <p:nvSpPr>
+          <p:cNvPr id="55" name="Shape 53"/>
           <p:cNvSpPr/>
           <p:nvPr/>
         </p:nvSpPr>
         <p:spPr>
           <a:xfrm>
-            <a:off x="9303106" y="1783080"/>
+            <a:off x="10532059" y="1783080"/>
             <a:ext cx="0" cy="4197096"/>
           </a:xfrm>
           <a:prstGeom prst="line">
@@ -6414,7 +7136,7 @@
           <a:noFill/>
           <a:ln w="6350">
             <a:solidFill>
-              <a:srgbClr val="EEF1F5"/>
+              <a:srgbClr val="E3E8EF"/>
             </a:solidFill>
             <a:prstDash val="solid"/>
           </a:ln>
@@ -6422,22 +7144,24 @@
       </p:sp>
       <p:sp>
         <p:nvSpPr>
-          <p:cNvPr id="34" name="Shape 32"/>
+          <p:cNvPr id="56" name="Shape 54"/>
           <p:cNvSpPr/>
           <p:nvPr/>
         </p:nvSpPr>
         <p:spPr>
           <a:xfrm>
-            <a:off x="9712757" y="1783080"/>
-            <a:ext cx="0" cy="4197096"/>
-          </a:xfrm>
-          <a:prstGeom prst="line">
-            <a:avLst/>
-          </a:prstGeom>
-          <a:noFill/>
-          <a:ln w="6350">
+            <a:off x="10941710" y="1399032"/>
+            <a:ext cx="409651" cy="329184"/>
+          </a:xfrm>
+          <a:prstGeom prst="rect">
+            <a:avLst/>
+          </a:prstGeom>
+          <a:solidFill>
+            <a:srgbClr val="F3F5F8"/>
+          </a:solidFill>
+          <a:ln w="12700">
             <a:solidFill>
-              <a:srgbClr val="EEF1F5"/>
+              <a:srgbClr val="FFFFFF"/>
             </a:solidFill>
             <a:prstDash val="solid"/>
           </a:ln>
@@ -6445,13 +7169,52 @@
       </p:sp>
       <p:sp>
         <p:nvSpPr>
-          <p:cNvPr id="35" name="Shape 33"/>
+          <p:cNvPr id="57" name="Text 55"/>
+          <p:cNvSpPr txBox="1"/>
+          <p:nvPr/>
+        </p:nvSpPr>
+        <p:spPr>
+          <a:xfrm>
+            <a:off x="10941710" y="1399032"/>
+            <a:ext cx="409651" cy="329184"/>
+          </a:xfrm>
+          <a:prstGeom prst="rect">
+            <a:avLst/>
+          </a:prstGeom>
+          <a:noFill/>
+          <a:ln/>
+        </p:spPr>
+        <p:txBody>
+          <a:bodyPr wrap="square" lIns="0" tIns="0" rIns="0" bIns="0" rtlCol="0" anchor="ctr"/>
+          <a:lstStyle/>
+          <a:p>
+            <a:pPr algn="ctr" indent="0" marL="0">
+              <a:buNone/>
+            </a:pPr>
+            <a:r>
+              <a:rPr lang="en-US" sz="850" b="1" dirty="0">
+                <a:solidFill>
+                  <a:srgbClr val="022A5B"/>
+                </a:solidFill>
+                <a:latin typeface="Arial" pitchFamily="34" charset="0"/>
+                <a:ea typeface="Arial" pitchFamily="34" charset="-122"/>
+                <a:cs typeface="Arial" pitchFamily="34" charset="-120"/>
+              </a:rPr>
+              <a:t>S45</a:t>
+            </a:r>
+            <a:endParaRPr lang="en-US" sz="850" dirty="0"/>
+          </a:p>
+        </p:txBody>
+      </p:sp>
+      <p:sp>
+        <p:nvSpPr>
+          <p:cNvPr id="58" name="Shape 56"/>
           <p:cNvSpPr/>
           <p:nvPr/>
         </p:nvSpPr>
         <p:spPr>
           <a:xfrm>
-            <a:off x="10122408" y="1783080"/>
+            <a:off x="10941710" y="1783080"/>
             <a:ext cx="0" cy="4197096"/>
           </a:xfrm>
           <a:prstGeom prst="line">
@@ -6460,7 +7223,7 @@
           <a:noFill/>
           <a:ln w="6350">
             <a:solidFill>
-              <a:srgbClr val="EEF1F5"/>
+              <a:srgbClr val="E3E8EF"/>
             </a:solidFill>
             <a:prstDash val="solid"/>
           </a:ln>
@@ -6468,53 +7231,7 @@
       </p:sp>
       <p:sp>
         <p:nvSpPr>
-          <p:cNvPr id="36" name="Shape 34"/>
-          <p:cNvSpPr/>
-          <p:nvPr/>
-        </p:nvSpPr>
-        <p:spPr>
-          <a:xfrm>
-            <a:off x="10532059" y="1783080"/>
-            <a:ext cx="0" cy="4197096"/>
-          </a:xfrm>
-          <a:prstGeom prst="line">
-            <a:avLst/>
-          </a:prstGeom>
-          <a:noFill/>
-          <a:ln w="6350">
-            <a:solidFill>
-              <a:srgbClr val="EEF1F5"/>
-            </a:solidFill>
-            <a:prstDash val="solid"/>
-          </a:ln>
-        </p:spPr>
-      </p:sp>
-      <p:sp>
-        <p:nvSpPr>
-          <p:cNvPr id="37" name="Shape 35"/>
-          <p:cNvSpPr/>
-          <p:nvPr/>
-        </p:nvSpPr>
-        <p:spPr>
-          <a:xfrm>
-            <a:off x="10941710" y="1783080"/>
-            <a:ext cx="0" cy="4197096"/>
-          </a:xfrm>
-          <a:prstGeom prst="line">
-            <a:avLst/>
-          </a:prstGeom>
-          <a:noFill/>
-          <a:ln w="6350">
-            <a:solidFill>
-              <a:srgbClr val="EEF1F5"/>
-            </a:solidFill>
-            <a:prstDash val="solid"/>
-          </a:ln>
-        </p:spPr>
-      </p:sp>
-      <p:sp>
-        <p:nvSpPr>
-          <p:cNvPr id="38" name="Text 36"/>
+          <p:cNvPr id="59" name="Text 57"/>
           <p:cNvSpPr txBox="1"/>
           <p:nvPr/>
         </p:nvSpPr>
@@ -6553,7 +7270,7 @@
       </p:sp>
       <p:sp>
         <p:nvSpPr>
-          <p:cNvPr id="39" name="Shape 37"/>
+          <p:cNvPr id="60" name="Shape 58"/>
           <p:cNvSpPr/>
           <p:nvPr/>
         </p:nvSpPr>
@@ -6578,7 +7295,7 @@
       </p:sp>
       <p:sp>
         <p:nvSpPr>
-          <p:cNvPr id="40" name="Text 38"/>
+          <p:cNvPr id="61" name="Text 59"/>
           <p:cNvSpPr txBox="1"/>
           <p:nvPr/>
         </p:nvSpPr>
@@ -6617,7 +7334,7 @@
       </p:sp>
       <p:sp>
         <p:nvSpPr>
-          <p:cNvPr id="41" name="Text 39"/>
+          <p:cNvPr id="62" name="Text 60"/>
           <p:cNvSpPr txBox="1"/>
           <p:nvPr/>
         </p:nvSpPr>
@@ -6656,7 +7373,7 @@
       </p:sp>
       <p:sp>
         <p:nvSpPr>
-          <p:cNvPr id="42" name="Shape 40"/>
+          <p:cNvPr id="63" name="Shape 61"/>
           <p:cNvSpPr/>
           <p:nvPr/>
         </p:nvSpPr>
@@ -6681,7 +7398,7 @@
       </p:sp>
       <p:sp>
         <p:nvSpPr>
-          <p:cNvPr id="43" name="Text 41"/>
+          <p:cNvPr id="64" name="Text 62"/>
           <p:cNvSpPr txBox="1"/>
           <p:nvPr/>
         </p:nvSpPr>
@@ -6720,7 +7437,7 @@
       </p:sp>
       <p:sp>
         <p:nvSpPr>
-          <p:cNvPr id="44" name="Text 42"/>
+          <p:cNvPr id="65" name="Text 63"/>
           <p:cNvSpPr txBox="1"/>
           <p:nvPr/>
         </p:nvSpPr>
@@ -6759,7 +7476,7 @@
       </p:sp>
       <p:sp>
         <p:nvSpPr>
-          <p:cNvPr id="45" name="Shape 43"/>
+          <p:cNvPr id="66" name="Shape 64"/>
           <p:cNvSpPr/>
           <p:nvPr/>
         </p:nvSpPr>
@@ -6788,7 +7505,7 @@
       </p:sp>
       <p:sp>
         <p:nvSpPr>
-          <p:cNvPr id="46" name="Shape 44"/>
+          <p:cNvPr id="67" name="Shape 65"/>
           <p:cNvSpPr/>
           <p:nvPr/>
         </p:nvSpPr>
@@ -6815,7 +7532,7 @@
       </p:sp>
       <p:sp>
         <p:nvSpPr>
-          <p:cNvPr id="47" name="Text 45"/>
+          <p:cNvPr id="68" name="Text 66"/>
           <p:cNvSpPr txBox="1"/>
           <p:nvPr/>
         </p:nvSpPr>
@@ -6854,7 +7571,7 @@
       </p:sp>
       <p:sp>
         <p:nvSpPr>
-          <p:cNvPr id="48" name="Text 46"/>
+          <p:cNvPr id="69" name="Text 67"/>
           <p:cNvSpPr txBox="1"/>
           <p:nvPr/>
         </p:nvSpPr>
@@ -6893,7 +7610,7 @@
       </p:sp>
       <p:sp>
         <p:nvSpPr>
-          <p:cNvPr id="49" name="Text 47"/>
+          <p:cNvPr id="70" name="Text 68"/>
           <p:cNvSpPr txBox="1"/>
           <p:nvPr/>
         </p:nvSpPr>
@@ -6932,7 +7649,7 @@
       </p:sp>
       <p:sp>
         <p:nvSpPr>
-          <p:cNvPr id="50" name="Shape 48"/>
+          <p:cNvPr id="71" name="Shape 69"/>
           <p:cNvSpPr/>
           <p:nvPr/>
         </p:nvSpPr>
@@ -6961,7 +7678,7 @@
       </p:sp>
       <p:sp>
         <p:nvSpPr>
-          <p:cNvPr id="51" name="Shape 49"/>
+          <p:cNvPr id="72" name="Shape 70"/>
           <p:cNvSpPr/>
           <p:nvPr/>
         </p:nvSpPr>
@@ -6988,7 +7705,7 @@
       </p:sp>
       <p:sp>
         <p:nvSpPr>
-          <p:cNvPr id="52" name="Text 50"/>
+          <p:cNvPr id="73" name="Text 71"/>
           <p:cNvSpPr txBox="1"/>
           <p:nvPr/>
         </p:nvSpPr>
@@ -7027,7 +7744,7 @@
       </p:sp>
       <p:sp>
         <p:nvSpPr>
-          <p:cNvPr id="53" name="Text 51"/>
+          <p:cNvPr id="74" name="Text 72"/>
           <p:cNvSpPr txBox="1"/>
           <p:nvPr/>
         </p:nvSpPr>
@@ -7066,7 +7783,7 @@
       </p:sp>
       <p:sp>
         <p:nvSpPr>
-          <p:cNvPr id="54" name="Text 52"/>
+          <p:cNvPr id="75" name="Text 73"/>
           <p:cNvSpPr txBox="1"/>
           <p:nvPr/>
         </p:nvSpPr>
@@ -7105,7 +7822,7 @@
       </p:sp>
       <p:sp>
         <p:nvSpPr>
-          <p:cNvPr id="55" name="Shape 53"/>
+          <p:cNvPr id="76" name="Shape 74"/>
           <p:cNvSpPr/>
           <p:nvPr/>
         </p:nvSpPr>
@@ -7134,7 +7851,7 @@
       </p:sp>
       <p:sp>
         <p:nvSpPr>
-          <p:cNvPr id="56" name="Shape 54"/>
+          <p:cNvPr id="77" name="Shape 75"/>
           <p:cNvSpPr/>
           <p:nvPr/>
         </p:nvSpPr>
@@ -7161,7 +7878,7 @@
       </p:sp>
       <p:sp>
         <p:nvSpPr>
-          <p:cNvPr id="57" name="Text 55"/>
+          <p:cNvPr id="78" name="Text 76"/>
           <p:cNvSpPr txBox="1"/>
           <p:nvPr/>
         </p:nvSpPr>
@@ -7200,7 +7917,7 @@
       </p:sp>
       <p:sp>
         <p:nvSpPr>
-          <p:cNvPr id="58" name="Text 56"/>
+          <p:cNvPr id="79" name="Text 77"/>
           <p:cNvSpPr txBox="1"/>
           <p:nvPr/>
         </p:nvSpPr>
@@ -7239,7 +7956,7 @@
       </p:sp>
       <p:sp>
         <p:nvSpPr>
-          <p:cNvPr id="59" name="Text 57"/>
+          <p:cNvPr id="80" name="Text 78"/>
           <p:cNvSpPr txBox="1"/>
           <p:nvPr/>
         </p:nvSpPr>
@@ -7278,7 +7995,7 @@
       </p:sp>
       <p:sp>
         <p:nvSpPr>
-          <p:cNvPr id="60" name="Shape 58"/>
+          <p:cNvPr id="81" name="Shape 79"/>
           <p:cNvSpPr/>
           <p:nvPr/>
         </p:nvSpPr>
@@ -7307,7 +8024,7 @@
       </p:sp>
       <p:sp>
         <p:nvSpPr>
-          <p:cNvPr id="61" name="Shape 59"/>
+          <p:cNvPr id="82" name="Shape 80"/>
           <p:cNvSpPr/>
           <p:nvPr/>
         </p:nvSpPr>
@@ -7334,7 +8051,7 @@
       </p:sp>
       <p:sp>
         <p:nvSpPr>
-          <p:cNvPr id="62" name="Text 60"/>
+          <p:cNvPr id="83" name="Text 81"/>
           <p:cNvSpPr txBox="1"/>
           <p:nvPr/>
         </p:nvSpPr>
@@ -7373,7 +8090,7 @@
       </p:sp>
       <p:sp>
         <p:nvSpPr>
-          <p:cNvPr id="63" name="Text 61"/>
+          <p:cNvPr id="84" name="Text 82"/>
           <p:cNvSpPr txBox="1"/>
           <p:nvPr/>
         </p:nvSpPr>
@@ -7412,7 +8129,7 @@
       </p:sp>
       <p:sp>
         <p:nvSpPr>
-          <p:cNvPr id="64" name="Text 62"/>
+          <p:cNvPr id="85" name="Text 83"/>
           <p:cNvSpPr txBox="1"/>
           <p:nvPr/>
         </p:nvSpPr>
@@ -7451,7 +8168,7 @@
       </p:sp>
       <p:sp>
         <p:nvSpPr>
-          <p:cNvPr id="65" name="Shape 63"/>
+          <p:cNvPr id="86" name="Shape 84"/>
           <p:cNvSpPr/>
           <p:nvPr/>
         </p:nvSpPr>
@@ -7480,7 +8197,7 @@
       </p:sp>
       <p:sp>
         <p:nvSpPr>
-          <p:cNvPr id="66" name="Shape 64"/>
+          <p:cNvPr id="87" name="Shape 85"/>
           <p:cNvSpPr/>
           <p:nvPr/>
         </p:nvSpPr>
@@ -7507,7 +8224,7 @@
       </p:sp>
       <p:sp>
         <p:nvSpPr>
-          <p:cNvPr id="67" name="Text 65"/>
+          <p:cNvPr id="88" name="Text 86"/>
           <p:cNvSpPr txBox="1"/>
           <p:nvPr/>
         </p:nvSpPr>
@@ -7546,7 +8263,7 @@
       </p:sp>
       <p:sp>
         <p:nvSpPr>
-          <p:cNvPr id="68" name="Shape 66"/>
+          <p:cNvPr id="89" name="Shape 87"/>
           <p:cNvSpPr/>
           <p:nvPr/>
         </p:nvSpPr>
@@ -7571,7 +8288,7 @@
       </p:sp>
       <p:sp>
         <p:nvSpPr>
-          <p:cNvPr id="69" name="Text 67"/>
+          <p:cNvPr id="90" name="Text 88"/>
           <p:cNvSpPr txBox="1"/>
           <p:nvPr/>
         </p:nvSpPr>
@@ -7610,7 +8327,7 @@
       </p:sp>
       <p:sp>
         <p:nvSpPr>
-          <p:cNvPr id="70" name="Text 68"/>
+          <p:cNvPr id="91" name="Text 89"/>
           <p:cNvSpPr txBox="1"/>
           <p:nvPr/>
         </p:nvSpPr>
@@ -7649,7 +8366,7 @@
       </p:sp>
       <p:sp>
         <p:nvSpPr>
-          <p:cNvPr id="71" name="Shape 69"/>
+          <p:cNvPr id="92" name="Shape 90"/>
           <p:cNvSpPr/>
           <p:nvPr/>
         </p:nvSpPr>
@@ -7674,7 +8391,7 @@
       </p:sp>
       <p:sp>
         <p:nvSpPr>
-          <p:cNvPr id="72" name="Text 70"/>
+          <p:cNvPr id="93" name="Text 91"/>
           <p:cNvSpPr txBox="1"/>
           <p:nvPr/>
         </p:nvSpPr>
@@ -7713,7 +8430,7 @@
       </p:sp>
       <p:sp>
         <p:nvSpPr>
-          <p:cNvPr id="73" name="Text 71"/>
+          <p:cNvPr id="94" name="Text 92"/>
           <p:cNvSpPr txBox="1"/>
           <p:nvPr/>
         </p:nvSpPr>
@@ -7752,7 +8469,7 @@
       </p:sp>
       <p:sp>
         <p:nvSpPr>
-          <p:cNvPr id="74" name="Shape 72"/>
+          <p:cNvPr id="95" name="Shape 93"/>
           <p:cNvSpPr/>
           <p:nvPr/>
         </p:nvSpPr>
@@ -7781,7 +8498,7 @@
       </p:sp>
       <p:sp>
         <p:nvSpPr>
-          <p:cNvPr id="75" name="Shape 73"/>
+          <p:cNvPr id="96" name="Shape 94"/>
           <p:cNvSpPr/>
           <p:nvPr/>
         </p:nvSpPr>
@@ -7808,7 +8525,7 @@
       </p:sp>
       <p:sp>
         <p:nvSpPr>
-          <p:cNvPr id="76" name="Text 74"/>
+          <p:cNvPr id="97" name="Text 95"/>
           <p:cNvSpPr txBox="1"/>
           <p:nvPr/>
         </p:nvSpPr>
@@ -7847,7 +8564,7 @@
       </p:sp>
       <p:sp>
         <p:nvSpPr>
-          <p:cNvPr id="77" name="Text 75"/>
+          <p:cNvPr id="98" name="Text 96"/>
           <p:cNvSpPr txBox="1"/>
           <p:nvPr/>
         </p:nvSpPr>
@@ -7886,7 +8603,7 @@
       </p:sp>
       <p:sp>
         <p:nvSpPr>
-          <p:cNvPr id="78" name="Text 76"/>
+          <p:cNvPr id="99" name="Text 97"/>
           <p:cNvSpPr txBox="1"/>
           <p:nvPr/>
         </p:nvSpPr>
@@ -7925,7 +8642,7 @@
       </p:sp>
       <p:sp>
         <p:nvSpPr>
-          <p:cNvPr id="79" name="Shape 77"/>
+          <p:cNvPr id="100" name="Shape 98"/>
           <p:cNvSpPr/>
           <p:nvPr/>
         </p:nvSpPr>
@@ -7954,7 +8671,7 @@
       </p:sp>
       <p:sp>
         <p:nvSpPr>
-          <p:cNvPr id="80" name="Shape 78"/>
+          <p:cNvPr id="101" name="Shape 99"/>
           <p:cNvSpPr/>
           <p:nvPr/>
         </p:nvSpPr>
@@ -7981,7 +8698,7 @@
       </p:sp>
       <p:sp>
         <p:nvSpPr>
-          <p:cNvPr id="81" name="Text 79"/>
+          <p:cNvPr id="102" name="Text 100"/>
           <p:cNvSpPr txBox="1"/>
           <p:nvPr/>
         </p:nvSpPr>
@@ -8020,7 +8737,7 @@
       </p:sp>
       <p:sp>
         <p:nvSpPr>
-          <p:cNvPr id="82" name="Text 80"/>
+          <p:cNvPr id="103" name="Text 101"/>
           <p:cNvSpPr txBox="1"/>
           <p:nvPr/>
         </p:nvSpPr>
@@ -8059,7 +8776,7 @@
       </p:sp>
       <p:sp>
         <p:nvSpPr>
-          <p:cNvPr id="83" name="Text 81"/>
+          <p:cNvPr id="104" name="Text 102"/>
           <p:cNvSpPr txBox="1"/>
           <p:nvPr/>
         </p:nvSpPr>
@@ -8098,7 +8815,7 @@
       </p:sp>
       <p:sp>
         <p:nvSpPr>
-          <p:cNvPr id="84" name="Shape 82"/>
+          <p:cNvPr id="105" name="Shape 103"/>
           <p:cNvSpPr/>
           <p:nvPr/>
         </p:nvSpPr>
@@ -8127,7 +8844,7 @@
       </p:sp>
       <p:sp>
         <p:nvSpPr>
-          <p:cNvPr id="85" name="Shape 83"/>
+          <p:cNvPr id="106" name="Shape 104"/>
           <p:cNvSpPr/>
           <p:nvPr/>
         </p:nvSpPr>
@@ -8154,7 +8871,7 @@
       </p:sp>
       <p:sp>
         <p:nvSpPr>
-          <p:cNvPr id="86" name="Text 84"/>
+          <p:cNvPr id="107" name="Text 105"/>
           <p:cNvSpPr txBox="1"/>
           <p:nvPr/>
         </p:nvSpPr>
@@ -8193,7 +8910,7 @@
       </p:sp>
       <p:sp>
         <p:nvSpPr>
-          <p:cNvPr id="87" name="Text 85"/>
+          <p:cNvPr id="108" name="Text 106"/>
           <p:cNvSpPr txBox="1"/>
           <p:nvPr/>
         </p:nvSpPr>
@@ -8232,7 +8949,7 @@
       </p:sp>
       <p:sp>
         <p:nvSpPr>
-          <p:cNvPr id="88" name="Text 86"/>
+          <p:cNvPr id="109" name="Text 107"/>
           <p:cNvSpPr txBox="1"/>
           <p:nvPr/>
         </p:nvSpPr>
@@ -8271,7 +8988,7 @@
       </p:sp>
       <p:sp>
         <p:nvSpPr>
-          <p:cNvPr id="89" name="Shape 87"/>
+          <p:cNvPr id="110" name="Shape 108"/>
           <p:cNvSpPr/>
           <p:nvPr/>
         </p:nvSpPr>
@@ -8300,7 +9017,7 @@
       </p:sp>
       <p:sp>
         <p:nvSpPr>
-          <p:cNvPr id="90" name="Shape 88"/>
+          <p:cNvPr id="111" name="Shape 109"/>
           <p:cNvSpPr/>
           <p:nvPr/>
         </p:nvSpPr>
@@ -8327,7 +9044,7 @@
       </p:sp>
       <p:sp>
         <p:nvSpPr>
-          <p:cNvPr id="91" name="Text 89"/>
+          <p:cNvPr id="112" name="Text 110"/>
           <p:cNvSpPr txBox="1"/>
           <p:nvPr/>
         </p:nvSpPr>
@@ -8366,7 +9083,7 @@
       </p:sp>
       <p:sp>
         <p:nvSpPr>
-          <p:cNvPr id="92" name="Shape 90"/>
+          <p:cNvPr id="113" name="Shape 111"/>
           <p:cNvSpPr/>
           <p:nvPr/>
         </p:nvSpPr>
@@ -8391,7 +9108,7 @@
       </p:sp>
       <p:sp>
         <p:nvSpPr>
-          <p:cNvPr id="93" name="Text 91"/>
+          <p:cNvPr id="114" name="Text 112"/>
           <p:cNvSpPr txBox="1"/>
           <p:nvPr/>
         </p:nvSpPr>
@@ -8430,7 +9147,7 @@
       </p:sp>
       <p:sp>
         <p:nvSpPr>
-          <p:cNvPr id="94" name="Text 92"/>
+          <p:cNvPr id="115" name="Text 113"/>
           <p:cNvSpPr txBox="1"/>
           <p:nvPr/>
         </p:nvSpPr>
@@ -8469,7 +9186,7 @@
       </p:sp>
       <p:sp>
         <p:nvSpPr>
-          <p:cNvPr id="95" name="Shape 93"/>
+          <p:cNvPr id="116" name="Shape 114"/>
           <p:cNvSpPr/>
           <p:nvPr/>
         </p:nvSpPr>
@@ -8494,7 +9211,7 @@
       </p:sp>
       <p:sp>
         <p:nvSpPr>
-          <p:cNvPr id="96" name="Text 94"/>
+          <p:cNvPr id="117" name="Text 115"/>
           <p:cNvSpPr txBox="1"/>
           <p:nvPr/>
         </p:nvSpPr>
@@ -8533,7 +9250,7 @@
       </p:sp>
       <p:sp>
         <p:nvSpPr>
-          <p:cNvPr id="97" name="Text 95"/>
+          <p:cNvPr id="118" name="Text 116"/>
           <p:cNvSpPr txBox="1"/>
           <p:nvPr/>
         </p:nvSpPr>
@@ -8572,7 +9289,7 @@
       </p:sp>
       <p:sp>
         <p:nvSpPr>
-          <p:cNvPr id="98" name="Shape 96"/>
+          <p:cNvPr id="119" name="Shape 117"/>
           <p:cNvSpPr/>
           <p:nvPr/>
         </p:nvSpPr>
@@ -8601,7 +9318,7 @@
       </p:sp>
       <p:sp>
         <p:nvSpPr>
-          <p:cNvPr id="99" name="Text 97"/>
+          <p:cNvPr id="120" name="Text 118"/>
           <p:cNvSpPr txBox="1"/>
           <p:nvPr/>
         </p:nvSpPr>
@@ -8640,7 +9357,7 @@
       </p:sp>
       <p:sp>
         <p:nvSpPr>
-          <p:cNvPr id="100" name="Text 98"/>
+          <p:cNvPr id="121" name="Text 119"/>
           <p:cNvSpPr txBox="1"/>
           <p:nvPr/>
         </p:nvSpPr>
@@ -8679,7 +9396,7 @@
       </p:sp>
       <p:sp>
         <p:nvSpPr>
-          <p:cNvPr id="101" name="Text 99"/>
+          <p:cNvPr id="122" name="Text 120"/>
           <p:cNvSpPr txBox="1"/>
           <p:nvPr/>
         </p:nvSpPr>
@@ -8718,7 +9435,7 @@
       </p:sp>
       <p:sp>
         <p:nvSpPr>
-          <p:cNvPr id="102" name="Shape 100"/>
+          <p:cNvPr id="123" name="Shape 121"/>
           <p:cNvSpPr/>
           <p:nvPr/>
         </p:nvSpPr>
@@ -8747,7 +9464,7 @@
       </p:sp>
       <p:sp>
         <p:nvSpPr>
-          <p:cNvPr id="103" name="Text 101"/>
+          <p:cNvPr id="124" name="Text 122"/>
           <p:cNvSpPr txBox="1"/>
           <p:nvPr/>
         </p:nvSpPr>
@@ -8786,7 +9503,7 @@
       </p:sp>
       <p:sp>
         <p:nvSpPr>
-          <p:cNvPr id="104" name="Shape 102"/>
+          <p:cNvPr id="125" name="Shape 123"/>
           <p:cNvSpPr/>
           <p:nvPr/>
         </p:nvSpPr>
@@ -8811,7 +9528,7 @@
       </p:sp>
       <p:sp>
         <p:nvSpPr>
-          <p:cNvPr id="105" name="Text 103"/>
+          <p:cNvPr id="126" name="Text 124"/>
           <p:cNvSpPr txBox="1"/>
           <p:nvPr/>
         </p:nvSpPr>
@@ -8850,7 +9567,7 @@
       </p:sp>
       <p:sp>
         <p:nvSpPr>
-          <p:cNvPr id="106" name="Text 104"/>
+          <p:cNvPr id="127" name="Text 125"/>
           <p:cNvSpPr txBox="1"/>
           <p:nvPr/>
         </p:nvSpPr>
@@ -8889,7 +9606,7 @@
       </p:sp>
       <p:sp>
         <p:nvSpPr>
-          <p:cNvPr id="107" name="Shape 105"/>
+          <p:cNvPr id="128" name="Shape 126"/>
           <p:cNvSpPr/>
           <p:nvPr/>
         </p:nvSpPr>
@@ -8914,7 +9631,7 @@
       </p:sp>
       <p:sp>
         <p:nvSpPr>
-          <p:cNvPr id="108" name="Text 106"/>
+          <p:cNvPr id="129" name="Text 127"/>
           <p:cNvSpPr txBox="1"/>
           <p:nvPr/>
         </p:nvSpPr>
@@ -8953,7 +9670,7 @@
       </p:sp>
       <p:sp>
         <p:nvSpPr>
-          <p:cNvPr id="109" name="Text 107"/>
+          <p:cNvPr id="130" name="Text 128"/>
           <p:cNvSpPr txBox="1"/>
           <p:nvPr/>
         </p:nvSpPr>
@@ -8992,7 +9709,7 @@
       </p:sp>
       <p:sp>
         <p:nvSpPr>
-          <p:cNvPr id="110" name="Shape 108"/>
+          <p:cNvPr id="131" name="Shape 129"/>
           <p:cNvSpPr/>
           <p:nvPr/>
         </p:nvSpPr>
@@ -9021,7 +9738,7 @@
       </p:sp>
       <p:sp>
         <p:nvSpPr>
-          <p:cNvPr id="111" name="Text 109"/>
+          <p:cNvPr id="132" name="Text 130"/>
           <p:cNvSpPr txBox="1"/>
           <p:nvPr/>
         </p:nvSpPr>
@@ -9060,7 +9777,7 @@
       </p:sp>
       <p:sp>
         <p:nvSpPr>
-          <p:cNvPr id="112" name="Text 110"/>
+          <p:cNvPr id="133" name="Text 131"/>
           <p:cNvSpPr txBox="1"/>
           <p:nvPr/>
         </p:nvSpPr>
@@ -9099,7 +9816,7 @@
       </p:sp>
       <p:sp>
         <p:nvSpPr>
-          <p:cNvPr id="113" name="Text 111"/>
+          <p:cNvPr id="134" name="Text 132"/>
           <p:cNvSpPr txBox="1"/>
           <p:nvPr/>
         </p:nvSpPr>
@@ -9138,7 +9855,7 @@
       </p:sp>
       <p:sp>
         <p:nvSpPr>
-          <p:cNvPr id="114" name="Shape 112"/>
+          <p:cNvPr id="135" name="Shape 133"/>
           <p:cNvSpPr/>
           <p:nvPr/>
         </p:nvSpPr>
@@ -9167,7 +9884,7 @@
       </p:sp>
       <p:sp>
         <p:nvSpPr>
-          <p:cNvPr id="115" name="Text 113"/>
+          <p:cNvPr id="136" name="Text 134"/>
           <p:cNvSpPr txBox="1"/>
           <p:nvPr/>
         </p:nvSpPr>
@@ -9206,7 +9923,7 @@
       </p:sp>
       <p:sp>
         <p:nvSpPr>
-          <p:cNvPr id="116" name="Text 114"/>
+          <p:cNvPr id="137" name="Text 135"/>
           <p:cNvSpPr txBox="1"/>
           <p:nvPr/>
         </p:nvSpPr>
@@ -9245,7 +9962,7 @@
       </p:sp>
       <p:sp>
         <p:nvSpPr>
-          <p:cNvPr id="117" name="Text 115"/>
+          <p:cNvPr id="138" name="Text 136"/>
           <p:cNvSpPr txBox="1"/>
           <p:nvPr/>
         </p:nvSpPr>
@@ -9284,7 +10001,7 @@
       </p:sp>
       <p:sp>
         <p:nvSpPr>
-          <p:cNvPr id="118" name="Shape 116"/>
+          <p:cNvPr id="139" name="Shape 137"/>
           <p:cNvSpPr/>
           <p:nvPr/>
         </p:nvSpPr>
@@ -9313,7 +10030,7 @@
       </p:sp>
       <p:sp>
         <p:nvSpPr>
-          <p:cNvPr id="119" name="Text 117"/>
+          <p:cNvPr id="140" name="Text 138"/>
           <p:cNvSpPr txBox="1"/>
           <p:nvPr/>
         </p:nvSpPr>
@@ -9352,7 +10069,7 @@
       </p:sp>
       <p:sp>
         <p:nvSpPr>
-          <p:cNvPr id="120" name="Shape 118"/>
+          <p:cNvPr id="141" name="Shape 139"/>
           <p:cNvSpPr/>
           <p:nvPr/>
         </p:nvSpPr>
@@ -9375,7 +10092,7 @@
       </p:sp>
       <p:sp>
         <p:nvSpPr>
-          <p:cNvPr id="121" name="Shape 119"/>
+          <p:cNvPr id="142" name="Shape 140"/>
           <p:cNvSpPr/>
           <p:nvPr/>
         </p:nvSpPr>
@@ -9402,7 +10119,7 @@
       </p:sp>
       <p:sp>
         <p:nvSpPr>
-          <p:cNvPr id="122" name="Text 120"/>
+          <p:cNvPr id="143" name="Text 141"/>
           <p:cNvSpPr txBox="1"/>
           <p:nvPr/>
         </p:nvSpPr>
@@ -9433,7 +10150,7 @@
                 <a:ea typeface="Arial" pitchFamily="34" charset="-122"/>
                 <a:cs typeface="Arial" pitchFamily="34" charset="-120"/>
               </a:rPr>
-              <a:t>HOY 18/09</a:t>
+              <a:t>HOY · S38</a:t>
             </a:r>
             <a:endParaRPr lang="en-US" sz="700" dirty="0"/>
           </a:p>
@@ -9441,7 +10158,7 @@
       </p:sp>
       <p:sp>
         <p:nvSpPr>
-          <p:cNvPr id="123" name="Shape 121"/>
+          <p:cNvPr id="144" name="Shape 142"/>
           <p:cNvSpPr/>
           <p:nvPr/>
         </p:nvSpPr>
@@ -9466,7 +10183,7 @@
       </p:sp>
       <p:sp>
         <p:nvSpPr>
-          <p:cNvPr id="124" name="Shape 122"/>
+          <p:cNvPr id="145" name="Shape 143"/>
           <p:cNvSpPr/>
           <p:nvPr/>
         </p:nvSpPr>
@@ -9491,7 +10208,7 @@
       </p:sp>
       <p:sp>
         <p:nvSpPr>
-          <p:cNvPr id="125" name="Shape 123"/>
+          <p:cNvPr id="146" name="Shape 144"/>
           <p:cNvSpPr/>
           <p:nvPr/>
         </p:nvSpPr>
@@ -9516,7 +10233,7 @@
       </p:sp>
       <p:sp>
         <p:nvSpPr>
-          <p:cNvPr id="126" name="Shape 124"/>
+          <p:cNvPr id="147" name="Shape 145"/>
           <p:cNvSpPr/>
           <p:nvPr/>
         </p:nvSpPr>
@@ -9545,7 +10262,7 @@
       </p:sp>
       <p:sp>
         <p:nvSpPr>
-          <p:cNvPr id="127" name="Shape 125"/>
+          <p:cNvPr id="148" name="Shape 146"/>
           <p:cNvSpPr/>
           <p:nvPr/>
         </p:nvSpPr>
@@ -9572,7 +10289,7 @@
       </p:sp>
       <p:sp>
         <p:nvSpPr>
-          <p:cNvPr id="128" name="Text 126"/>
+          <p:cNvPr id="149" name="Text 147"/>
           <p:cNvSpPr txBox="1"/>
           <p:nvPr/>
         </p:nvSpPr>
@@ -9611,7 +10328,7 @@
       </p:sp>
       <p:sp>
         <p:nvSpPr>
-          <p:cNvPr id="129" name="Shape 127"/>
+          <p:cNvPr id="150" name="Shape 148"/>
           <p:cNvSpPr/>
           <p:nvPr/>
         </p:nvSpPr>
@@ -9636,7 +10353,7 @@
       </p:sp>
       <p:sp>
         <p:nvSpPr>
-          <p:cNvPr id="130" name="Text 128"/>
+          <p:cNvPr id="151" name="Text 149"/>
           <p:cNvSpPr txBox="1"/>
           <p:nvPr/>
         </p:nvSpPr>
@@ -9675,7 +10392,7 @@
       </p:sp>
       <p:sp>
         <p:nvSpPr>
-          <p:cNvPr id="131" name="Text 129"/>
+          <p:cNvPr id="152" name="Text 150"/>
           <p:cNvSpPr txBox="1"/>
           <p:nvPr/>
         </p:nvSpPr>
@@ -9714,7 +10431,7 @@
       </p:sp>
       <p:sp>
         <p:nvSpPr>
-          <p:cNvPr id="132" name="Text 130"/>
+          <p:cNvPr id="153" name="Text 151"/>
           <p:cNvSpPr txBox="1"/>
           <p:nvPr/>
         </p:nvSpPr>

</xml_diff>

<commit_message>
Agregar cronograma propuesto a diciembre con columnas por semana
Slide 14 con el plan de 15 semanas (S38 a S52 de 2026) en formato
semanal, junto al cronograma real de la slide 13.

Co-Authored-By: Claude Fable 5.1 <noreply@anthropic.com>
Claude-Session: https://claude.ai/code/session_013R5zM6jAzpk9971GWdT5eG
</commit_message>
<xml_diff>
--- a/docs/Dojo_AM_Unidad_Pintura.pptx
+++ b/docs/Dojo_AM_Unidad_Pintura.pptx
@@ -20,9 +20,10 @@
     <p:sldId id="268" r:id="rId14"/>
     <p:sldId id="269" r:id="rId15"/>
     <p:sldId id="270" r:id="rId16"/>
+    <p:sldId id="271" r:id="rId17"/>
   </p:sldIdLst>
   <p:notesMasterIdLst>
-    <p:notesMasterId r:id="rId17"/>
+    <p:notesMasterId r:id="rId18"/>
   </p:notesMasterIdLst>
   <p:sldSz cx="12192000" cy="6858000"/>
   <p:notesSz cx="6858000" cy="12192000"/>
@@ -956,7 +957,7 @@
           <a:p>
             <a:r>
               <a:rPr lang="en-US" dirty="0"/>
-              <a:t>Indicadores propuestos: operarios certificados, participación en los juegos, anomalías detectadas por operarios, intervenciones básicas resueltas por Producción y paradas por causas básicas.</a:t>
+              <a:t>Cronograma propuesto de 15 semanas, de la semana 38 a la 52 de 2026: diseño en septiembre, construcción hasta la semana 45, piloto de dos semanas y despliegue a todos los turnos hasta el 23 de diciembre.</a:t>
             </a:r>
             <a:endParaRPr lang="en-US" dirty="0"/>
           </a:p>
@@ -1044,7 +1045,7 @@
           <a:p>
             <a:r>
               <a:rPr lang="en-US" dirty="0"/>
-              <a:t>Cierre: el Dojo es un espacio para aprender, practicar y crecer juntos. El próximo paso es aprobar el espacio y arrancar la fase de diseño.</a:t>
+              <a:t>Indicadores propuestos: operarios certificados, participación en los juegos, anomalías detectadas por operarios, intervenciones básicas resueltas por Producción y paradas por causas básicas.</a:t>
             </a:r>
             <a:endParaRPr lang="en-US" dirty="0"/>
           </a:p>
@@ -1068,6 +1069,94 @@
             <a:fld id="{F7021451-1387-4CA6-816F-3879F97B5CBC}" type="slidenum">
               <a:rPr lang="en-US"/>
               <a:t>15</a:t>
+            </a:fld>
+            <a:endParaRPr lang="en-US"/>
+          </a:p>
+        </p:txBody>
+      </p:sp>
+    </p:spTree>
+    <p:extLst>
+      <p:ext uri="{BB962C8B-B14F-4D97-AF65-F5344CB8AC3E}">
+        <p14:creationId xmlns:p14="http://schemas.microsoft.com/office/powerpoint/2010/main" val="1024086991"/>
+      </p:ext>
+    </p:extLst>
+  </p:cSld>
+  <p:clrMapOvr>
+    <a:masterClrMapping/>
+  </p:clrMapOvr>
+</p:notes>
+</file>
+
+<file path=ppt/notesSlides/notesSlide16.xml><?xml version="1.0" encoding="utf-8"?>
+<p:notes xmlns:a="http://schemas.openxmlformats.org/drawingml/2006/main" xmlns:r="http://schemas.openxmlformats.org/officeDocument/2006/relationships" xmlns:p="http://schemas.openxmlformats.org/presentationml/2006/main">
+  <p:cSld>
+    <p:spTree>
+      <p:nvGrpSpPr>
+        <p:cNvPr id="1" name=""/>
+        <p:cNvGrpSpPr/>
+        <p:nvPr/>
+      </p:nvGrpSpPr>
+      <p:grpSpPr>
+        <a:xfrm>
+          <a:off x="0" y="0"/>
+          <a:ext cx="0" cy="0"/>
+          <a:chOff x="0" y="0"/>
+          <a:chExt cx="0" cy="0"/>
+        </a:xfrm>
+      </p:grpSpPr>
+      <p:sp>
+        <p:nvSpPr>
+          <p:cNvPr id="2" name="Slide Image Placeholder 1"/>
+          <p:cNvSpPr>
+            <a:spLocks noGrp="1" noRot="1" noChangeAspect="1"/>
+          </p:cNvSpPr>
+          <p:nvPr>
+            <p:ph type="sldImg"/>
+          </p:nvPr>
+        </p:nvSpPr>
+        <p:spPr/>
+      </p:sp>
+      <p:sp>
+        <p:nvSpPr>
+          <p:cNvPr id="3" name="Notes Placeholder 2"/>
+          <p:cNvSpPr>
+            <a:spLocks noGrp="1"/>
+          </p:cNvSpPr>
+          <p:nvPr>
+            <p:ph type="body" idx="1"/>
+          </p:nvPr>
+        </p:nvSpPr>
+        <p:spPr/>
+        <p:txBody>
+          <a:bodyPr/>
+          <a:lstStyle/>
+          <a:p>
+            <a:r>
+              <a:rPr lang="en-US" dirty="0"/>
+              <a:t>Cierre: el Dojo es un espacio para aprender, practicar y crecer juntos. El próximo paso es aprobar el espacio y arrancar la fase de diseño.</a:t>
+            </a:r>
+            <a:endParaRPr lang="en-US" dirty="0"/>
+          </a:p>
+        </p:txBody>
+      </p:sp>
+      <p:sp>
+        <p:nvSpPr>
+          <p:cNvPr id="4" name="Slide Number Placeholder 3"/>
+          <p:cNvSpPr>
+            <a:spLocks noGrp="1"/>
+          </p:cNvSpPr>
+          <p:nvPr>
+            <p:ph type="sldNum" sz="quarter" idx="10"/>
+          </p:nvPr>
+        </p:nvSpPr>
+        <p:spPr/>
+        <p:txBody>
+          <a:bodyPr/>
+          <a:lstStyle/>
+          <a:p>
+            <a:fld id="{F7021451-1387-4CA6-816F-3879F97B5CBC}" type="slidenum">
+              <a:rPr lang="en-US"/>
+              <a:t>16</a:t>
             </a:fld>
             <a:endParaRPr lang="en-US"/>
           </a:p>
@@ -10482,6 +10571,3605 @@
     <p:bg>
       <p:bgPr>
         <a:solidFill>
+          <a:srgbClr val="FFFFFF"/>
+        </a:solidFill>
+      </p:bgPr>
+    </p:bg>
+    <p:spTree>
+      <p:nvGrpSpPr>
+        <p:cNvPr id="1" name=""/>
+        <p:cNvGrpSpPr/>
+        <p:nvPr/>
+      </p:nvGrpSpPr>
+      <p:grpSpPr>
+        <a:xfrm>
+          <a:off x="0" y="0"/>
+          <a:ext cx="0" cy="0"/>
+          <a:chOff x="0" y="0"/>
+          <a:chExt cx="0" cy="0"/>
+        </a:xfrm>
+      </p:grpSpPr>
+      <p:sp>
+        <p:nvSpPr>
+          <p:cNvPr id="2" name="Text 0"/>
+          <p:cNvSpPr txBox="1"/>
+          <p:nvPr/>
+        </p:nvSpPr>
+        <p:spPr>
+          <a:xfrm>
+            <a:off x="548640" y="365760"/>
+            <a:ext cx="8595360" cy="777240"/>
+          </a:xfrm>
+          <a:prstGeom prst="rect">
+            <a:avLst/>
+          </a:prstGeom>
+          <a:noFill/>
+          <a:ln/>
+        </p:spPr>
+        <p:txBody>
+          <a:bodyPr wrap="square" lIns="0" tIns="0" rIns="0" bIns="0" rtlCol="0" anchor="ctr"/>
+          <a:lstStyle/>
+          <a:p>
+            <a:pPr indent="0" marL="0">
+              <a:buNone/>
+            </a:pPr>
+            <a:r>
+              <a:rPr lang="en-US" sz="2800" b="1" dirty="0">
+                <a:solidFill>
+                  <a:srgbClr val="022A5B"/>
+                </a:solidFill>
+                <a:latin typeface="Arial" pitchFamily="34" charset="0"/>
+                <a:ea typeface="Arial" pitchFamily="34" charset="-122"/>
+                <a:cs typeface="Arial" pitchFamily="34" charset="-120"/>
+              </a:rPr>
+              <a:t>Cronograma: todo listo para fines de diciembre</a:t>
+            </a:r>
+            <a:endParaRPr lang="en-US" sz="2800" dirty="0"/>
+          </a:p>
+        </p:txBody>
+      </p:sp>
+      <p:sp>
+        <p:nvSpPr>
+          <p:cNvPr id="3" name="Text 1"/>
+          <p:cNvSpPr txBox="1"/>
+          <p:nvPr/>
+        </p:nvSpPr>
+        <p:spPr>
+          <a:xfrm>
+            <a:off x="8778240" y="457200"/>
+            <a:ext cx="2862072" cy="365760"/>
+          </a:xfrm>
+          <a:prstGeom prst="rect">
+            <a:avLst/>
+          </a:prstGeom>
+          <a:noFill/>
+          <a:ln/>
+        </p:spPr>
+        <p:txBody>
+          <a:bodyPr wrap="square" lIns="0" tIns="0" rIns="0" bIns="0" rtlCol="0" anchor="ctr"/>
+          <a:lstStyle/>
+          <a:p>
+            <a:pPr algn="r" indent="0" marL="0">
+              <a:buNone/>
+            </a:pPr>
+            <a:r>
+              <a:rPr lang="en-US" sz="1000" b="1" spc="200" kern="0" dirty="0">
+                <a:solidFill>
+                  <a:srgbClr val="6B7280"/>
+                </a:solidFill>
+                <a:latin typeface="Arial" pitchFamily="34" charset="0"/>
+                <a:ea typeface="Arial" pitchFamily="34" charset="-122"/>
+                <a:cs typeface="Arial" pitchFamily="34" charset="-120"/>
+              </a:rPr>
+              <a:t>STELLANTIS  ·  UNIDAD PINTURA</a:t>
+            </a:r>
+            <a:endParaRPr lang="en-US" sz="1000" dirty="0"/>
+          </a:p>
+        </p:txBody>
+      </p:sp>
+      <p:sp>
+        <p:nvSpPr>
+          <p:cNvPr id="4" name="Text 2"/>
+          <p:cNvSpPr txBox="1"/>
+          <p:nvPr/>
+        </p:nvSpPr>
+        <p:spPr>
+          <a:xfrm>
+            <a:off x="548640" y="1024128"/>
+            <a:ext cx="7315200" cy="274320"/>
+          </a:xfrm>
+          <a:prstGeom prst="rect">
+            <a:avLst/>
+          </a:prstGeom>
+          <a:noFill/>
+          <a:ln/>
+        </p:spPr>
+        <p:txBody>
+          <a:bodyPr wrap="square" lIns="0" tIns="0" rIns="0" bIns="0" rtlCol="0" anchor="ctr"/>
+          <a:lstStyle/>
+          <a:p>
+            <a:pPr indent="0" marL="0">
+              <a:buNone/>
+            </a:pPr>
+            <a:r>
+              <a:rPr lang="en-US" sz="1100" dirty="0">
+                <a:solidFill>
+                  <a:srgbClr val="6B7280"/>
+                </a:solidFill>
+                <a:latin typeface="Arial" pitchFamily="34" charset="0"/>
+                <a:ea typeface="Arial" pitchFamily="34" charset="-122"/>
+                <a:cs typeface="Arial" pitchFamily="34" charset="-120"/>
+              </a:rPr>
+              <a:t>Plan propuesto por semana calendario, de la S38 (14/09) a la S52 (23/12/2026).</a:t>
+            </a:r>
+            <a:endParaRPr lang="en-US" sz="1100" dirty="0"/>
+          </a:p>
+        </p:txBody>
+      </p:sp>
+      <p:sp>
+        <p:nvSpPr>
+          <p:cNvPr id="5" name="Shape 3"/>
+          <p:cNvSpPr/>
+          <p:nvPr/>
+        </p:nvSpPr>
+        <p:spPr>
+          <a:xfrm>
+            <a:off x="3977640" y="1399032"/>
+            <a:ext cx="510845" cy="329184"/>
+          </a:xfrm>
+          <a:prstGeom prst="rect">
+            <a:avLst/>
+          </a:prstGeom>
+          <a:solidFill>
+            <a:srgbClr val="E8EDF4"/>
+          </a:solidFill>
+          <a:ln w="12700">
+            <a:solidFill>
+              <a:srgbClr val="FFFFFF"/>
+            </a:solidFill>
+            <a:prstDash val="solid"/>
+          </a:ln>
+        </p:spPr>
+      </p:sp>
+      <p:sp>
+        <p:nvSpPr>
+          <p:cNvPr id="6" name="Text 4"/>
+          <p:cNvSpPr txBox="1"/>
+          <p:nvPr/>
+        </p:nvSpPr>
+        <p:spPr>
+          <a:xfrm>
+            <a:off x="3977640" y="1399032"/>
+            <a:ext cx="510845" cy="329184"/>
+          </a:xfrm>
+          <a:prstGeom prst="rect">
+            <a:avLst/>
+          </a:prstGeom>
+          <a:noFill/>
+          <a:ln/>
+        </p:spPr>
+        <p:txBody>
+          <a:bodyPr wrap="square" lIns="0" tIns="0" rIns="0" bIns="0" rtlCol="0" anchor="ctr"/>
+          <a:lstStyle/>
+          <a:p>
+            <a:pPr algn="ctr" indent="0" marL="0">
+              <a:buNone/>
+            </a:pPr>
+            <a:r>
+              <a:rPr lang="en-US" sz="900" b="1" dirty="0">
+                <a:solidFill>
+                  <a:srgbClr val="022A5B"/>
+                </a:solidFill>
+                <a:latin typeface="Arial" pitchFamily="34" charset="0"/>
+                <a:ea typeface="Arial" pitchFamily="34" charset="-122"/>
+                <a:cs typeface="Arial" pitchFamily="34" charset="-120"/>
+              </a:rPr>
+              <a:t>S38</a:t>
+            </a:r>
+            <a:endParaRPr lang="en-US" sz="900" dirty="0"/>
+          </a:p>
+        </p:txBody>
+      </p:sp>
+      <p:sp>
+        <p:nvSpPr>
+          <p:cNvPr id="7" name="Shape 5"/>
+          <p:cNvSpPr/>
+          <p:nvPr/>
+        </p:nvSpPr>
+        <p:spPr>
+          <a:xfrm>
+            <a:off x="3977640" y="1783080"/>
+            <a:ext cx="0" cy="4197096"/>
+          </a:xfrm>
+          <a:prstGeom prst="line">
+            <a:avLst/>
+          </a:prstGeom>
+          <a:noFill/>
+          <a:ln w="6350">
+            <a:solidFill>
+              <a:srgbClr val="E3E8EF"/>
+            </a:solidFill>
+            <a:prstDash val="solid"/>
+          </a:ln>
+        </p:spPr>
+      </p:sp>
+      <p:sp>
+        <p:nvSpPr>
+          <p:cNvPr id="8" name="Shape 6"/>
+          <p:cNvSpPr/>
+          <p:nvPr/>
+        </p:nvSpPr>
+        <p:spPr>
+          <a:xfrm>
+            <a:off x="4488485" y="1399032"/>
+            <a:ext cx="510845" cy="329184"/>
+          </a:xfrm>
+          <a:prstGeom prst="rect">
+            <a:avLst/>
+          </a:prstGeom>
+          <a:solidFill>
+            <a:srgbClr val="F3F5F8"/>
+          </a:solidFill>
+          <a:ln w="12700">
+            <a:solidFill>
+              <a:srgbClr val="FFFFFF"/>
+            </a:solidFill>
+            <a:prstDash val="solid"/>
+          </a:ln>
+        </p:spPr>
+      </p:sp>
+      <p:sp>
+        <p:nvSpPr>
+          <p:cNvPr id="9" name="Text 7"/>
+          <p:cNvSpPr txBox="1"/>
+          <p:nvPr/>
+        </p:nvSpPr>
+        <p:spPr>
+          <a:xfrm>
+            <a:off x="4488485" y="1399032"/>
+            <a:ext cx="510845" cy="329184"/>
+          </a:xfrm>
+          <a:prstGeom prst="rect">
+            <a:avLst/>
+          </a:prstGeom>
+          <a:noFill/>
+          <a:ln/>
+        </p:spPr>
+        <p:txBody>
+          <a:bodyPr wrap="square" lIns="0" tIns="0" rIns="0" bIns="0" rtlCol="0" anchor="ctr"/>
+          <a:lstStyle/>
+          <a:p>
+            <a:pPr algn="ctr" indent="0" marL="0">
+              <a:buNone/>
+            </a:pPr>
+            <a:r>
+              <a:rPr lang="en-US" sz="900" b="1" dirty="0">
+                <a:solidFill>
+                  <a:srgbClr val="022A5B"/>
+                </a:solidFill>
+                <a:latin typeface="Arial" pitchFamily="34" charset="0"/>
+                <a:ea typeface="Arial" pitchFamily="34" charset="-122"/>
+                <a:cs typeface="Arial" pitchFamily="34" charset="-120"/>
+              </a:rPr>
+              <a:t>S39</a:t>
+            </a:r>
+            <a:endParaRPr lang="en-US" sz="900" dirty="0"/>
+          </a:p>
+        </p:txBody>
+      </p:sp>
+      <p:sp>
+        <p:nvSpPr>
+          <p:cNvPr id="10" name="Shape 8"/>
+          <p:cNvSpPr/>
+          <p:nvPr/>
+        </p:nvSpPr>
+        <p:spPr>
+          <a:xfrm>
+            <a:off x="4488485" y="1783080"/>
+            <a:ext cx="0" cy="4197096"/>
+          </a:xfrm>
+          <a:prstGeom prst="line">
+            <a:avLst/>
+          </a:prstGeom>
+          <a:noFill/>
+          <a:ln w="6350">
+            <a:solidFill>
+              <a:srgbClr val="E3E8EF"/>
+            </a:solidFill>
+            <a:prstDash val="solid"/>
+          </a:ln>
+        </p:spPr>
+      </p:sp>
+      <p:sp>
+        <p:nvSpPr>
+          <p:cNvPr id="11" name="Shape 9"/>
+          <p:cNvSpPr/>
+          <p:nvPr/>
+        </p:nvSpPr>
+        <p:spPr>
+          <a:xfrm>
+            <a:off x="4999330" y="1399032"/>
+            <a:ext cx="510845" cy="329184"/>
+          </a:xfrm>
+          <a:prstGeom prst="rect">
+            <a:avLst/>
+          </a:prstGeom>
+          <a:solidFill>
+            <a:srgbClr val="E8EDF4"/>
+          </a:solidFill>
+          <a:ln w="12700">
+            <a:solidFill>
+              <a:srgbClr val="FFFFFF"/>
+            </a:solidFill>
+            <a:prstDash val="solid"/>
+          </a:ln>
+        </p:spPr>
+      </p:sp>
+      <p:sp>
+        <p:nvSpPr>
+          <p:cNvPr id="12" name="Text 10"/>
+          <p:cNvSpPr txBox="1"/>
+          <p:nvPr/>
+        </p:nvSpPr>
+        <p:spPr>
+          <a:xfrm>
+            <a:off x="4999330" y="1399032"/>
+            <a:ext cx="510845" cy="329184"/>
+          </a:xfrm>
+          <a:prstGeom prst="rect">
+            <a:avLst/>
+          </a:prstGeom>
+          <a:noFill/>
+          <a:ln/>
+        </p:spPr>
+        <p:txBody>
+          <a:bodyPr wrap="square" lIns="0" tIns="0" rIns="0" bIns="0" rtlCol="0" anchor="ctr"/>
+          <a:lstStyle/>
+          <a:p>
+            <a:pPr algn="ctr" indent="0" marL="0">
+              <a:buNone/>
+            </a:pPr>
+            <a:r>
+              <a:rPr lang="en-US" sz="900" b="1" dirty="0">
+                <a:solidFill>
+                  <a:srgbClr val="022A5B"/>
+                </a:solidFill>
+                <a:latin typeface="Arial" pitchFamily="34" charset="0"/>
+                <a:ea typeface="Arial" pitchFamily="34" charset="-122"/>
+                <a:cs typeface="Arial" pitchFamily="34" charset="-120"/>
+              </a:rPr>
+              <a:t>S40</a:t>
+            </a:r>
+            <a:endParaRPr lang="en-US" sz="900" dirty="0"/>
+          </a:p>
+        </p:txBody>
+      </p:sp>
+      <p:sp>
+        <p:nvSpPr>
+          <p:cNvPr id="13" name="Shape 11"/>
+          <p:cNvSpPr/>
+          <p:nvPr/>
+        </p:nvSpPr>
+        <p:spPr>
+          <a:xfrm>
+            <a:off x="4999330" y="1783080"/>
+            <a:ext cx="0" cy="4197096"/>
+          </a:xfrm>
+          <a:prstGeom prst="line">
+            <a:avLst/>
+          </a:prstGeom>
+          <a:noFill/>
+          <a:ln w="6350">
+            <a:solidFill>
+              <a:srgbClr val="E3E8EF"/>
+            </a:solidFill>
+            <a:prstDash val="solid"/>
+          </a:ln>
+        </p:spPr>
+      </p:sp>
+      <p:sp>
+        <p:nvSpPr>
+          <p:cNvPr id="14" name="Shape 12"/>
+          <p:cNvSpPr/>
+          <p:nvPr/>
+        </p:nvSpPr>
+        <p:spPr>
+          <a:xfrm>
+            <a:off x="5510174" y="1399032"/>
+            <a:ext cx="510845" cy="329184"/>
+          </a:xfrm>
+          <a:prstGeom prst="rect">
+            <a:avLst/>
+          </a:prstGeom>
+          <a:solidFill>
+            <a:srgbClr val="F3F5F8"/>
+          </a:solidFill>
+          <a:ln w="12700">
+            <a:solidFill>
+              <a:srgbClr val="FFFFFF"/>
+            </a:solidFill>
+            <a:prstDash val="solid"/>
+          </a:ln>
+        </p:spPr>
+      </p:sp>
+      <p:sp>
+        <p:nvSpPr>
+          <p:cNvPr id="15" name="Text 13"/>
+          <p:cNvSpPr txBox="1"/>
+          <p:nvPr/>
+        </p:nvSpPr>
+        <p:spPr>
+          <a:xfrm>
+            <a:off x="5510174" y="1399032"/>
+            <a:ext cx="510845" cy="329184"/>
+          </a:xfrm>
+          <a:prstGeom prst="rect">
+            <a:avLst/>
+          </a:prstGeom>
+          <a:noFill/>
+          <a:ln/>
+        </p:spPr>
+        <p:txBody>
+          <a:bodyPr wrap="square" lIns="0" tIns="0" rIns="0" bIns="0" rtlCol="0" anchor="ctr"/>
+          <a:lstStyle/>
+          <a:p>
+            <a:pPr algn="ctr" indent="0" marL="0">
+              <a:buNone/>
+            </a:pPr>
+            <a:r>
+              <a:rPr lang="en-US" sz="900" b="1" dirty="0">
+                <a:solidFill>
+                  <a:srgbClr val="022A5B"/>
+                </a:solidFill>
+                <a:latin typeface="Arial" pitchFamily="34" charset="0"/>
+                <a:ea typeface="Arial" pitchFamily="34" charset="-122"/>
+                <a:cs typeface="Arial" pitchFamily="34" charset="-120"/>
+              </a:rPr>
+              <a:t>S41</a:t>
+            </a:r>
+            <a:endParaRPr lang="en-US" sz="900" dirty="0"/>
+          </a:p>
+        </p:txBody>
+      </p:sp>
+      <p:sp>
+        <p:nvSpPr>
+          <p:cNvPr id="16" name="Shape 14"/>
+          <p:cNvSpPr/>
+          <p:nvPr/>
+        </p:nvSpPr>
+        <p:spPr>
+          <a:xfrm>
+            <a:off x="5510174" y="1783080"/>
+            <a:ext cx="0" cy="4197096"/>
+          </a:xfrm>
+          <a:prstGeom prst="line">
+            <a:avLst/>
+          </a:prstGeom>
+          <a:noFill/>
+          <a:ln w="6350">
+            <a:solidFill>
+              <a:srgbClr val="E3E8EF"/>
+            </a:solidFill>
+            <a:prstDash val="solid"/>
+          </a:ln>
+        </p:spPr>
+      </p:sp>
+      <p:sp>
+        <p:nvSpPr>
+          <p:cNvPr id="17" name="Shape 15"/>
+          <p:cNvSpPr/>
+          <p:nvPr/>
+        </p:nvSpPr>
+        <p:spPr>
+          <a:xfrm>
+            <a:off x="6021019" y="1399032"/>
+            <a:ext cx="510845" cy="329184"/>
+          </a:xfrm>
+          <a:prstGeom prst="rect">
+            <a:avLst/>
+          </a:prstGeom>
+          <a:solidFill>
+            <a:srgbClr val="E8EDF4"/>
+          </a:solidFill>
+          <a:ln w="12700">
+            <a:solidFill>
+              <a:srgbClr val="FFFFFF"/>
+            </a:solidFill>
+            <a:prstDash val="solid"/>
+          </a:ln>
+        </p:spPr>
+      </p:sp>
+      <p:sp>
+        <p:nvSpPr>
+          <p:cNvPr id="18" name="Text 16"/>
+          <p:cNvSpPr txBox="1"/>
+          <p:nvPr/>
+        </p:nvSpPr>
+        <p:spPr>
+          <a:xfrm>
+            <a:off x="6021019" y="1399032"/>
+            <a:ext cx="510845" cy="329184"/>
+          </a:xfrm>
+          <a:prstGeom prst="rect">
+            <a:avLst/>
+          </a:prstGeom>
+          <a:noFill/>
+          <a:ln/>
+        </p:spPr>
+        <p:txBody>
+          <a:bodyPr wrap="square" lIns="0" tIns="0" rIns="0" bIns="0" rtlCol="0" anchor="ctr"/>
+          <a:lstStyle/>
+          <a:p>
+            <a:pPr algn="ctr" indent="0" marL="0">
+              <a:buNone/>
+            </a:pPr>
+            <a:r>
+              <a:rPr lang="en-US" sz="900" b="1" dirty="0">
+                <a:solidFill>
+                  <a:srgbClr val="022A5B"/>
+                </a:solidFill>
+                <a:latin typeface="Arial" pitchFamily="34" charset="0"/>
+                <a:ea typeface="Arial" pitchFamily="34" charset="-122"/>
+                <a:cs typeface="Arial" pitchFamily="34" charset="-120"/>
+              </a:rPr>
+              <a:t>S42</a:t>
+            </a:r>
+            <a:endParaRPr lang="en-US" sz="900" dirty="0"/>
+          </a:p>
+        </p:txBody>
+      </p:sp>
+      <p:sp>
+        <p:nvSpPr>
+          <p:cNvPr id="19" name="Shape 17"/>
+          <p:cNvSpPr/>
+          <p:nvPr/>
+        </p:nvSpPr>
+        <p:spPr>
+          <a:xfrm>
+            <a:off x="6021019" y="1783080"/>
+            <a:ext cx="0" cy="4197096"/>
+          </a:xfrm>
+          <a:prstGeom prst="line">
+            <a:avLst/>
+          </a:prstGeom>
+          <a:noFill/>
+          <a:ln w="6350">
+            <a:solidFill>
+              <a:srgbClr val="E3E8EF"/>
+            </a:solidFill>
+            <a:prstDash val="solid"/>
+          </a:ln>
+        </p:spPr>
+      </p:sp>
+      <p:sp>
+        <p:nvSpPr>
+          <p:cNvPr id="20" name="Shape 18"/>
+          <p:cNvSpPr/>
+          <p:nvPr/>
+        </p:nvSpPr>
+        <p:spPr>
+          <a:xfrm>
+            <a:off x="6531864" y="1399032"/>
+            <a:ext cx="510845" cy="329184"/>
+          </a:xfrm>
+          <a:prstGeom prst="rect">
+            <a:avLst/>
+          </a:prstGeom>
+          <a:solidFill>
+            <a:srgbClr val="F3F5F8"/>
+          </a:solidFill>
+          <a:ln w="12700">
+            <a:solidFill>
+              <a:srgbClr val="FFFFFF"/>
+            </a:solidFill>
+            <a:prstDash val="solid"/>
+          </a:ln>
+        </p:spPr>
+      </p:sp>
+      <p:sp>
+        <p:nvSpPr>
+          <p:cNvPr id="21" name="Text 19"/>
+          <p:cNvSpPr txBox="1"/>
+          <p:nvPr/>
+        </p:nvSpPr>
+        <p:spPr>
+          <a:xfrm>
+            <a:off x="6531864" y="1399032"/>
+            <a:ext cx="510845" cy="329184"/>
+          </a:xfrm>
+          <a:prstGeom prst="rect">
+            <a:avLst/>
+          </a:prstGeom>
+          <a:noFill/>
+          <a:ln/>
+        </p:spPr>
+        <p:txBody>
+          <a:bodyPr wrap="square" lIns="0" tIns="0" rIns="0" bIns="0" rtlCol="0" anchor="ctr"/>
+          <a:lstStyle/>
+          <a:p>
+            <a:pPr algn="ctr" indent="0" marL="0">
+              <a:buNone/>
+            </a:pPr>
+            <a:r>
+              <a:rPr lang="en-US" sz="900" b="1" dirty="0">
+                <a:solidFill>
+                  <a:srgbClr val="022A5B"/>
+                </a:solidFill>
+                <a:latin typeface="Arial" pitchFamily="34" charset="0"/>
+                <a:ea typeface="Arial" pitchFamily="34" charset="-122"/>
+                <a:cs typeface="Arial" pitchFamily="34" charset="-120"/>
+              </a:rPr>
+              <a:t>S43</a:t>
+            </a:r>
+            <a:endParaRPr lang="en-US" sz="900" dirty="0"/>
+          </a:p>
+        </p:txBody>
+      </p:sp>
+      <p:sp>
+        <p:nvSpPr>
+          <p:cNvPr id="22" name="Shape 20"/>
+          <p:cNvSpPr/>
+          <p:nvPr/>
+        </p:nvSpPr>
+        <p:spPr>
+          <a:xfrm>
+            <a:off x="6531864" y="1783080"/>
+            <a:ext cx="0" cy="4197096"/>
+          </a:xfrm>
+          <a:prstGeom prst="line">
+            <a:avLst/>
+          </a:prstGeom>
+          <a:noFill/>
+          <a:ln w="6350">
+            <a:solidFill>
+              <a:srgbClr val="E3E8EF"/>
+            </a:solidFill>
+            <a:prstDash val="solid"/>
+          </a:ln>
+        </p:spPr>
+      </p:sp>
+      <p:sp>
+        <p:nvSpPr>
+          <p:cNvPr id="23" name="Shape 21"/>
+          <p:cNvSpPr/>
+          <p:nvPr/>
+        </p:nvSpPr>
+        <p:spPr>
+          <a:xfrm>
+            <a:off x="7042709" y="1399032"/>
+            <a:ext cx="510845" cy="329184"/>
+          </a:xfrm>
+          <a:prstGeom prst="rect">
+            <a:avLst/>
+          </a:prstGeom>
+          <a:solidFill>
+            <a:srgbClr val="E8EDF4"/>
+          </a:solidFill>
+          <a:ln w="12700">
+            <a:solidFill>
+              <a:srgbClr val="FFFFFF"/>
+            </a:solidFill>
+            <a:prstDash val="solid"/>
+          </a:ln>
+        </p:spPr>
+      </p:sp>
+      <p:sp>
+        <p:nvSpPr>
+          <p:cNvPr id="24" name="Text 22"/>
+          <p:cNvSpPr txBox="1"/>
+          <p:nvPr/>
+        </p:nvSpPr>
+        <p:spPr>
+          <a:xfrm>
+            <a:off x="7042709" y="1399032"/>
+            <a:ext cx="510845" cy="329184"/>
+          </a:xfrm>
+          <a:prstGeom prst="rect">
+            <a:avLst/>
+          </a:prstGeom>
+          <a:noFill/>
+          <a:ln/>
+        </p:spPr>
+        <p:txBody>
+          <a:bodyPr wrap="square" lIns="0" tIns="0" rIns="0" bIns="0" rtlCol="0" anchor="ctr"/>
+          <a:lstStyle/>
+          <a:p>
+            <a:pPr algn="ctr" indent="0" marL="0">
+              <a:buNone/>
+            </a:pPr>
+            <a:r>
+              <a:rPr lang="en-US" sz="900" b="1" dirty="0">
+                <a:solidFill>
+                  <a:srgbClr val="022A5B"/>
+                </a:solidFill>
+                <a:latin typeface="Arial" pitchFamily="34" charset="0"/>
+                <a:ea typeface="Arial" pitchFamily="34" charset="-122"/>
+                <a:cs typeface="Arial" pitchFamily="34" charset="-120"/>
+              </a:rPr>
+              <a:t>S44</a:t>
+            </a:r>
+            <a:endParaRPr lang="en-US" sz="900" dirty="0"/>
+          </a:p>
+        </p:txBody>
+      </p:sp>
+      <p:sp>
+        <p:nvSpPr>
+          <p:cNvPr id="25" name="Shape 23"/>
+          <p:cNvSpPr/>
+          <p:nvPr/>
+        </p:nvSpPr>
+        <p:spPr>
+          <a:xfrm>
+            <a:off x="7042709" y="1783080"/>
+            <a:ext cx="0" cy="4197096"/>
+          </a:xfrm>
+          <a:prstGeom prst="line">
+            <a:avLst/>
+          </a:prstGeom>
+          <a:noFill/>
+          <a:ln w="6350">
+            <a:solidFill>
+              <a:srgbClr val="E3E8EF"/>
+            </a:solidFill>
+            <a:prstDash val="solid"/>
+          </a:ln>
+        </p:spPr>
+      </p:sp>
+      <p:sp>
+        <p:nvSpPr>
+          <p:cNvPr id="26" name="Shape 24"/>
+          <p:cNvSpPr/>
+          <p:nvPr/>
+        </p:nvSpPr>
+        <p:spPr>
+          <a:xfrm>
+            <a:off x="7553554" y="1399032"/>
+            <a:ext cx="510845" cy="329184"/>
+          </a:xfrm>
+          <a:prstGeom prst="rect">
+            <a:avLst/>
+          </a:prstGeom>
+          <a:solidFill>
+            <a:srgbClr val="F3F5F8"/>
+          </a:solidFill>
+          <a:ln w="12700">
+            <a:solidFill>
+              <a:srgbClr val="FFFFFF"/>
+            </a:solidFill>
+            <a:prstDash val="solid"/>
+          </a:ln>
+        </p:spPr>
+      </p:sp>
+      <p:sp>
+        <p:nvSpPr>
+          <p:cNvPr id="27" name="Text 25"/>
+          <p:cNvSpPr txBox="1"/>
+          <p:nvPr/>
+        </p:nvSpPr>
+        <p:spPr>
+          <a:xfrm>
+            <a:off x="7553554" y="1399032"/>
+            <a:ext cx="510845" cy="329184"/>
+          </a:xfrm>
+          <a:prstGeom prst="rect">
+            <a:avLst/>
+          </a:prstGeom>
+          <a:noFill/>
+          <a:ln/>
+        </p:spPr>
+        <p:txBody>
+          <a:bodyPr wrap="square" lIns="0" tIns="0" rIns="0" bIns="0" rtlCol="0" anchor="ctr"/>
+          <a:lstStyle/>
+          <a:p>
+            <a:pPr algn="ctr" indent="0" marL="0">
+              <a:buNone/>
+            </a:pPr>
+            <a:r>
+              <a:rPr lang="en-US" sz="900" b="1" dirty="0">
+                <a:solidFill>
+                  <a:srgbClr val="022A5B"/>
+                </a:solidFill>
+                <a:latin typeface="Arial" pitchFamily="34" charset="0"/>
+                <a:ea typeface="Arial" pitchFamily="34" charset="-122"/>
+                <a:cs typeface="Arial" pitchFamily="34" charset="-120"/>
+              </a:rPr>
+              <a:t>S45</a:t>
+            </a:r>
+            <a:endParaRPr lang="en-US" sz="900" dirty="0"/>
+          </a:p>
+        </p:txBody>
+      </p:sp>
+      <p:sp>
+        <p:nvSpPr>
+          <p:cNvPr id="28" name="Shape 26"/>
+          <p:cNvSpPr/>
+          <p:nvPr/>
+        </p:nvSpPr>
+        <p:spPr>
+          <a:xfrm>
+            <a:off x="7553554" y="1783080"/>
+            <a:ext cx="0" cy="4197096"/>
+          </a:xfrm>
+          <a:prstGeom prst="line">
+            <a:avLst/>
+          </a:prstGeom>
+          <a:noFill/>
+          <a:ln w="6350">
+            <a:solidFill>
+              <a:srgbClr val="E3E8EF"/>
+            </a:solidFill>
+            <a:prstDash val="solid"/>
+          </a:ln>
+        </p:spPr>
+      </p:sp>
+      <p:sp>
+        <p:nvSpPr>
+          <p:cNvPr id="29" name="Shape 27"/>
+          <p:cNvSpPr/>
+          <p:nvPr/>
+        </p:nvSpPr>
+        <p:spPr>
+          <a:xfrm>
+            <a:off x="8064398" y="1399032"/>
+            <a:ext cx="510845" cy="329184"/>
+          </a:xfrm>
+          <a:prstGeom prst="rect">
+            <a:avLst/>
+          </a:prstGeom>
+          <a:solidFill>
+            <a:srgbClr val="E8EDF4"/>
+          </a:solidFill>
+          <a:ln w="12700">
+            <a:solidFill>
+              <a:srgbClr val="FFFFFF"/>
+            </a:solidFill>
+            <a:prstDash val="solid"/>
+          </a:ln>
+        </p:spPr>
+      </p:sp>
+      <p:sp>
+        <p:nvSpPr>
+          <p:cNvPr id="30" name="Text 28"/>
+          <p:cNvSpPr txBox="1"/>
+          <p:nvPr/>
+        </p:nvSpPr>
+        <p:spPr>
+          <a:xfrm>
+            <a:off x="8064398" y="1399032"/>
+            <a:ext cx="510845" cy="329184"/>
+          </a:xfrm>
+          <a:prstGeom prst="rect">
+            <a:avLst/>
+          </a:prstGeom>
+          <a:noFill/>
+          <a:ln/>
+        </p:spPr>
+        <p:txBody>
+          <a:bodyPr wrap="square" lIns="0" tIns="0" rIns="0" bIns="0" rtlCol="0" anchor="ctr"/>
+          <a:lstStyle/>
+          <a:p>
+            <a:pPr algn="ctr" indent="0" marL="0">
+              <a:buNone/>
+            </a:pPr>
+            <a:r>
+              <a:rPr lang="en-US" sz="900" b="1" dirty="0">
+                <a:solidFill>
+                  <a:srgbClr val="022A5B"/>
+                </a:solidFill>
+                <a:latin typeface="Arial" pitchFamily="34" charset="0"/>
+                <a:ea typeface="Arial" pitchFamily="34" charset="-122"/>
+                <a:cs typeface="Arial" pitchFamily="34" charset="-120"/>
+              </a:rPr>
+              <a:t>S46</a:t>
+            </a:r>
+            <a:endParaRPr lang="en-US" sz="900" dirty="0"/>
+          </a:p>
+        </p:txBody>
+      </p:sp>
+      <p:sp>
+        <p:nvSpPr>
+          <p:cNvPr id="31" name="Shape 29"/>
+          <p:cNvSpPr/>
+          <p:nvPr/>
+        </p:nvSpPr>
+        <p:spPr>
+          <a:xfrm>
+            <a:off x="8064398" y="1783080"/>
+            <a:ext cx="0" cy="4197096"/>
+          </a:xfrm>
+          <a:prstGeom prst="line">
+            <a:avLst/>
+          </a:prstGeom>
+          <a:noFill/>
+          <a:ln w="6350">
+            <a:solidFill>
+              <a:srgbClr val="E3E8EF"/>
+            </a:solidFill>
+            <a:prstDash val="solid"/>
+          </a:ln>
+        </p:spPr>
+      </p:sp>
+      <p:sp>
+        <p:nvSpPr>
+          <p:cNvPr id="32" name="Shape 30"/>
+          <p:cNvSpPr/>
+          <p:nvPr/>
+        </p:nvSpPr>
+        <p:spPr>
+          <a:xfrm>
+            <a:off x="8575243" y="1399032"/>
+            <a:ext cx="510845" cy="329184"/>
+          </a:xfrm>
+          <a:prstGeom prst="rect">
+            <a:avLst/>
+          </a:prstGeom>
+          <a:solidFill>
+            <a:srgbClr val="F3F5F8"/>
+          </a:solidFill>
+          <a:ln w="12700">
+            <a:solidFill>
+              <a:srgbClr val="FFFFFF"/>
+            </a:solidFill>
+            <a:prstDash val="solid"/>
+          </a:ln>
+        </p:spPr>
+      </p:sp>
+      <p:sp>
+        <p:nvSpPr>
+          <p:cNvPr id="33" name="Text 31"/>
+          <p:cNvSpPr txBox="1"/>
+          <p:nvPr/>
+        </p:nvSpPr>
+        <p:spPr>
+          <a:xfrm>
+            <a:off x="8575243" y="1399032"/>
+            <a:ext cx="510845" cy="329184"/>
+          </a:xfrm>
+          <a:prstGeom prst="rect">
+            <a:avLst/>
+          </a:prstGeom>
+          <a:noFill/>
+          <a:ln/>
+        </p:spPr>
+        <p:txBody>
+          <a:bodyPr wrap="square" lIns="0" tIns="0" rIns="0" bIns="0" rtlCol="0" anchor="ctr"/>
+          <a:lstStyle/>
+          <a:p>
+            <a:pPr algn="ctr" indent="0" marL="0">
+              <a:buNone/>
+            </a:pPr>
+            <a:r>
+              <a:rPr lang="en-US" sz="900" b="1" dirty="0">
+                <a:solidFill>
+                  <a:srgbClr val="022A5B"/>
+                </a:solidFill>
+                <a:latin typeface="Arial" pitchFamily="34" charset="0"/>
+                <a:ea typeface="Arial" pitchFamily="34" charset="-122"/>
+                <a:cs typeface="Arial" pitchFamily="34" charset="-120"/>
+              </a:rPr>
+              <a:t>S47</a:t>
+            </a:r>
+            <a:endParaRPr lang="en-US" sz="900" dirty="0"/>
+          </a:p>
+        </p:txBody>
+      </p:sp>
+      <p:sp>
+        <p:nvSpPr>
+          <p:cNvPr id="34" name="Shape 32"/>
+          <p:cNvSpPr/>
+          <p:nvPr/>
+        </p:nvSpPr>
+        <p:spPr>
+          <a:xfrm>
+            <a:off x="8575243" y="1783080"/>
+            <a:ext cx="0" cy="4197096"/>
+          </a:xfrm>
+          <a:prstGeom prst="line">
+            <a:avLst/>
+          </a:prstGeom>
+          <a:noFill/>
+          <a:ln w="6350">
+            <a:solidFill>
+              <a:srgbClr val="E3E8EF"/>
+            </a:solidFill>
+            <a:prstDash val="solid"/>
+          </a:ln>
+        </p:spPr>
+      </p:sp>
+      <p:sp>
+        <p:nvSpPr>
+          <p:cNvPr id="35" name="Shape 33"/>
+          <p:cNvSpPr/>
+          <p:nvPr/>
+        </p:nvSpPr>
+        <p:spPr>
+          <a:xfrm>
+            <a:off x="9086088" y="1399032"/>
+            <a:ext cx="510845" cy="329184"/>
+          </a:xfrm>
+          <a:prstGeom prst="rect">
+            <a:avLst/>
+          </a:prstGeom>
+          <a:solidFill>
+            <a:srgbClr val="E8EDF4"/>
+          </a:solidFill>
+          <a:ln w="12700">
+            <a:solidFill>
+              <a:srgbClr val="FFFFFF"/>
+            </a:solidFill>
+            <a:prstDash val="solid"/>
+          </a:ln>
+        </p:spPr>
+      </p:sp>
+      <p:sp>
+        <p:nvSpPr>
+          <p:cNvPr id="36" name="Text 34"/>
+          <p:cNvSpPr txBox="1"/>
+          <p:nvPr/>
+        </p:nvSpPr>
+        <p:spPr>
+          <a:xfrm>
+            <a:off x="9086088" y="1399032"/>
+            <a:ext cx="510845" cy="329184"/>
+          </a:xfrm>
+          <a:prstGeom prst="rect">
+            <a:avLst/>
+          </a:prstGeom>
+          <a:noFill/>
+          <a:ln/>
+        </p:spPr>
+        <p:txBody>
+          <a:bodyPr wrap="square" lIns="0" tIns="0" rIns="0" bIns="0" rtlCol="0" anchor="ctr"/>
+          <a:lstStyle/>
+          <a:p>
+            <a:pPr algn="ctr" indent="0" marL="0">
+              <a:buNone/>
+            </a:pPr>
+            <a:r>
+              <a:rPr lang="en-US" sz="900" b="1" dirty="0">
+                <a:solidFill>
+                  <a:srgbClr val="022A5B"/>
+                </a:solidFill>
+                <a:latin typeface="Arial" pitchFamily="34" charset="0"/>
+                <a:ea typeface="Arial" pitchFamily="34" charset="-122"/>
+                <a:cs typeface="Arial" pitchFamily="34" charset="-120"/>
+              </a:rPr>
+              <a:t>S48</a:t>
+            </a:r>
+            <a:endParaRPr lang="en-US" sz="900" dirty="0"/>
+          </a:p>
+        </p:txBody>
+      </p:sp>
+      <p:sp>
+        <p:nvSpPr>
+          <p:cNvPr id="37" name="Shape 35"/>
+          <p:cNvSpPr/>
+          <p:nvPr/>
+        </p:nvSpPr>
+        <p:spPr>
+          <a:xfrm>
+            <a:off x="9086088" y="1783080"/>
+            <a:ext cx="0" cy="4197096"/>
+          </a:xfrm>
+          <a:prstGeom prst="line">
+            <a:avLst/>
+          </a:prstGeom>
+          <a:noFill/>
+          <a:ln w="6350">
+            <a:solidFill>
+              <a:srgbClr val="E3E8EF"/>
+            </a:solidFill>
+            <a:prstDash val="solid"/>
+          </a:ln>
+        </p:spPr>
+      </p:sp>
+      <p:sp>
+        <p:nvSpPr>
+          <p:cNvPr id="38" name="Shape 36"/>
+          <p:cNvSpPr/>
+          <p:nvPr/>
+        </p:nvSpPr>
+        <p:spPr>
+          <a:xfrm>
+            <a:off x="9596933" y="1399032"/>
+            <a:ext cx="510845" cy="329184"/>
+          </a:xfrm>
+          <a:prstGeom prst="rect">
+            <a:avLst/>
+          </a:prstGeom>
+          <a:solidFill>
+            <a:srgbClr val="F3F5F8"/>
+          </a:solidFill>
+          <a:ln w="12700">
+            <a:solidFill>
+              <a:srgbClr val="FFFFFF"/>
+            </a:solidFill>
+            <a:prstDash val="solid"/>
+          </a:ln>
+        </p:spPr>
+      </p:sp>
+      <p:sp>
+        <p:nvSpPr>
+          <p:cNvPr id="39" name="Text 37"/>
+          <p:cNvSpPr txBox="1"/>
+          <p:nvPr/>
+        </p:nvSpPr>
+        <p:spPr>
+          <a:xfrm>
+            <a:off x="9596933" y="1399032"/>
+            <a:ext cx="510845" cy="329184"/>
+          </a:xfrm>
+          <a:prstGeom prst="rect">
+            <a:avLst/>
+          </a:prstGeom>
+          <a:noFill/>
+          <a:ln/>
+        </p:spPr>
+        <p:txBody>
+          <a:bodyPr wrap="square" lIns="0" tIns="0" rIns="0" bIns="0" rtlCol="0" anchor="ctr"/>
+          <a:lstStyle/>
+          <a:p>
+            <a:pPr algn="ctr" indent="0" marL="0">
+              <a:buNone/>
+            </a:pPr>
+            <a:r>
+              <a:rPr lang="en-US" sz="900" b="1" dirty="0">
+                <a:solidFill>
+                  <a:srgbClr val="022A5B"/>
+                </a:solidFill>
+                <a:latin typeface="Arial" pitchFamily="34" charset="0"/>
+                <a:ea typeface="Arial" pitchFamily="34" charset="-122"/>
+                <a:cs typeface="Arial" pitchFamily="34" charset="-120"/>
+              </a:rPr>
+              <a:t>S49</a:t>
+            </a:r>
+            <a:endParaRPr lang="en-US" sz="900" dirty="0"/>
+          </a:p>
+        </p:txBody>
+      </p:sp>
+      <p:sp>
+        <p:nvSpPr>
+          <p:cNvPr id="40" name="Shape 38"/>
+          <p:cNvSpPr/>
+          <p:nvPr/>
+        </p:nvSpPr>
+        <p:spPr>
+          <a:xfrm>
+            <a:off x="9596933" y="1783080"/>
+            <a:ext cx="0" cy="4197096"/>
+          </a:xfrm>
+          <a:prstGeom prst="line">
+            <a:avLst/>
+          </a:prstGeom>
+          <a:noFill/>
+          <a:ln w="6350">
+            <a:solidFill>
+              <a:srgbClr val="E3E8EF"/>
+            </a:solidFill>
+            <a:prstDash val="solid"/>
+          </a:ln>
+        </p:spPr>
+      </p:sp>
+      <p:sp>
+        <p:nvSpPr>
+          <p:cNvPr id="41" name="Shape 39"/>
+          <p:cNvSpPr/>
+          <p:nvPr/>
+        </p:nvSpPr>
+        <p:spPr>
+          <a:xfrm>
+            <a:off x="10107778" y="1399032"/>
+            <a:ext cx="510845" cy="329184"/>
+          </a:xfrm>
+          <a:prstGeom prst="rect">
+            <a:avLst/>
+          </a:prstGeom>
+          <a:solidFill>
+            <a:srgbClr val="E8EDF4"/>
+          </a:solidFill>
+          <a:ln w="12700">
+            <a:solidFill>
+              <a:srgbClr val="FFFFFF"/>
+            </a:solidFill>
+            <a:prstDash val="solid"/>
+          </a:ln>
+        </p:spPr>
+      </p:sp>
+      <p:sp>
+        <p:nvSpPr>
+          <p:cNvPr id="42" name="Text 40"/>
+          <p:cNvSpPr txBox="1"/>
+          <p:nvPr/>
+        </p:nvSpPr>
+        <p:spPr>
+          <a:xfrm>
+            <a:off x="10107778" y="1399032"/>
+            <a:ext cx="510845" cy="329184"/>
+          </a:xfrm>
+          <a:prstGeom prst="rect">
+            <a:avLst/>
+          </a:prstGeom>
+          <a:noFill/>
+          <a:ln/>
+        </p:spPr>
+        <p:txBody>
+          <a:bodyPr wrap="square" lIns="0" tIns="0" rIns="0" bIns="0" rtlCol="0" anchor="ctr"/>
+          <a:lstStyle/>
+          <a:p>
+            <a:pPr algn="ctr" indent="0" marL="0">
+              <a:buNone/>
+            </a:pPr>
+            <a:r>
+              <a:rPr lang="en-US" sz="900" b="1" dirty="0">
+                <a:solidFill>
+                  <a:srgbClr val="022A5B"/>
+                </a:solidFill>
+                <a:latin typeface="Arial" pitchFamily="34" charset="0"/>
+                <a:ea typeface="Arial" pitchFamily="34" charset="-122"/>
+                <a:cs typeface="Arial" pitchFamily="34" charset="-120"/>
+              </a:rPr>
+              <a:t>S50</a:t>
+            </a:r>
+            <a:endParaRPr lang="en-US" sz="900" dirty="0"/>
+          </a:p>
+        </p:txBody>
+      </p:sp>
+      <p:sp>
+        <p:nvSpPr>
+          <p:cNvPr id="43" name="Shape 41"/>
+          <p:cNvSpPr/>
+          <p:nvPr/>
+        </p:nvSpPr>
+        <p:spPr>
+          <a:xfrm>
+            <a:off x="10107778" y="1783080"/>
+            <a:ext cx="0" cy="4197096"/>
+          </a:xfrm>
+          <a:prstGeom prst="line">
+            <a:avLst/>
+          </a:prstGeom>
+          <a:noFill/>
+          <a:ln w="6350">
+            <a:solidFill>
+              <a:srgbClr val="E3E8EF"/>
+            </a:solidFill>
+            <a:prstDash val="solid"/>
+          </a:ln>
+        </p:spPr>
+      </p:sp>
+      <p:sp>
+        <p:nvSpPr>
+          <p:cNvPr id="44" name="Shape 42"/>
+          <p:cNvSpPr/>
+          <p:nvPr/>
+        </p:nvSpPr>
+        <p:spPr>
+          <a:xfrm>
+            <a:off x="10618622" y="1399032"/>
+            <a:ext cx="510845" cy="329184"/>
+          </a:xfrm>
+          <a:prstGeom prst="rect">
+            <a:avLst/>
+          </a:prstGeom>
+          <a:solidFill>
+            <a:srgbClr val="F3F5F8"/>
+          </a:solidFill>
+          <a:ln w="12700">
+            <a:solidFill>
+              <a:srgbClr val="FFFFFF"/>
+            </a:solidFill>
+            <a:prstDash val="solid"/>
+          </a:ln>
+        </p:spPr>
+      </p:sp>
+      <p:sp>
+        <p:nvSpPr>
+          <p:cNvPr id="45" name="Text 43"/>
+          <p:cNvSpPr txBox="1"/>
+          <p:nvPr/>
+        </p:nvSpPr>
+        <p:spPr>
+          <a:xfrm>
+            <a:off x="10618622" y="1399032"/>
+            <a:ext cx="510845" cy="329184"/>
+          </a:xfrm>
+          <a:prstGeom prst="rect">
+            <a:avLst/>
+          </a:prstGeom>
+          <a:noFill/>
+          <a:ln/>
+        </p:spPr>
+        <p:txBody>
+          <a:bodyPr wrap="square" lIns="0" tIns="0" rIns="0" bIns="0" rtlCol="0" anchor="ctr"/>
+          <a:lstStyle/>
+          <a:p>
+            <a:pPr algn="ctr" indent="0" marL="0">
+              <a:buNone/>
+            </a:pPr>
+            <a:r>
+              <a:rPr lang="en-US" sz="900" b="1" dirty="0">
+                <a:solidFill>
+                  <a:srgbClr val="022A5B"/>
+                </a:solidFill>
+                <a:latin typeface="Arial" pitchFamily="34" charset="0"/>
+                <a:ea typeface="Arial" pitchFamily="34" charset="-122"/>
+                <a:cs typeface="Arial" pitchFamily="34" charset="-120"/>
+              </a:rPr>
+              <a:t>S51</a:t>
+            </a:r>
+            <a:endParaRPr lang="en-US" sz="900" dirty="0"/>
+          </a:p>
+        </p:txBody>
+      </p:sp>
+      <p:sp>
+        <p:nvSpPr>
+          <p:cNvPr id="46" name="Shape 44"/>
+          <p:cNvSpPr/>
+          <p:nvPr/>
+        </p:nvSpPr>
+        <p:spPr>
+          <a:xfrm>
+            <a:off x="10618622" y="1783080"/>
+            <a:ext cx="0" cy="4197096"/>
+          </a:xfrm>
+          <a:prstGeom prst="line">
+            <a:avLst/>
+          </a:prstGeom>
+          <a:noFill/>
+          <a:ln w="6350">
+            <a:solidFill>
+              <a:srgbClr val="E3E8EF"/>
+            </a:solidFill>
+            <a:prstDash val="solid"/>
+          </a:ln>
+        </p:spPr>
+      </p:sp>
+      <p:sp>
+        <p:nvSpPr>
+          <p:cNvPr id="47" name="Shape 45"/>
+          <p:cNvSpPr/>
+          <p:nvPr/>
+        </p:nvSpPr>
+        <p:spPr>
+          <a:xfrm>
+            <a:off x="11129467" y="1399032"/>
+            <a:ext cx="510845" cy="329184"/>
+          </a:xfrm>
+          <a:prstGeom prst="rect">
+            <a:avLst/>
+          </a:prstGeom>
+          <a:solidFill>
+            <a:srgbClr val="E8EDF4"/>
+          </a:solidFill>
+          <a:ln w="12700">
+            <a:solidFill>
+              <a:srgbClr val="FFFFFF"/>
+            </a:solidFill>
+            <a:prstDash val="solid"/>
+          </a:ln>
+        </p:spPr>
+      </p:sp>
+      <p:sp>
+        <p:nvSpPr>
+          <p:cNvPr id="48" name="Text 46"/>
+          <p:cNvSpPr txBox="1"/>
+          <p:nvPr/>
+        </p:nvSpPr>
+        <p:spPr>
+          <a:xfrm>
+            <a:off x="11129467" y="1399032"/>
+            <a:ext cx="510845" cy="329184"/>
+          </a:xfrm>
+          <a:prstGeom prst="rect">
+            <a:avLst/>
+          </a:prstGeom>
+          <a:noFill/>
+          <a:ln/>
+        </p:spPr>
+        <p:txBody>
+          <a:bodyPr wrap="square" lIns="0" tIns="0" rIns="0" bIns="0" rtlCol="0" anchor="ctr"/>
+          <a:lstStyle/>
+          <a:p>
+            <a:pPr algn="ctr" indent="0" marL="0">
+              <a:buNone/>
+            </a:pPr>
+            <a:r>
+              <a:rPr lang="en-US" sz="900" b="1" dirty="0">
+                <a:solidFill>
+                  <a:srgbClr val="022A5B"/>
+                </a:solidFill>
+                <a:latin typeface="Arial" pitchFamily="34" charset="0"/>
+                <a:ea typeface="Arial" pitchFamily="34" charset="-122"/>
+                <a:cs typeface="Arial" pitchFamily="34" charset="-120"/>
+              </a:rPr>
+              <a:t>S52</a:t>
+            </a:r>
+            <a:endParaRPr lang="en-US" sz="900" dirty="0"/>
+          </a:p>
+        </p:txBody>
+      </p:sp>
+      <p:sp>
+        <p:nvSpPr>
+          <p:cNvPr id="49" name="Shape 47"/>
+          <p:cNvSpPr/>
+          <p:nvPr/>
+        </p:nvSpPr>
+        <p:spPr>
+          <a:xfrm>
+            <a:off x="11129467" y="1783080"/>
+            <a:ext cx="0" cy="4197096"/>
+          </a:xfrm>
+          <a:prstGeom prst="line">
+            <a:avLst/>
+          </a:prstGeom>
+          <a:noFill/>
+          <a:ln w="6350">
+            <a:solidFill>
+              <a:srgbClr val="E3E8EF"/>
+            </a:solidFill>
+            <a:prstDash val="solid"/>
+          </a:ln>
+        </p:spPr>
+      </p:sp>
+      <p:sp>
+        <p:nvSpPr>
+          <p:cNvPr id="50" name="Shape 48"/>
+          <p:cNvSpPr/>
+          <p:nvPr/>
+        </p:nvSpPr>
+        <p:spPr>
+          <a:xfrm>
+            <a:off x="548640" y="1783080"/>
+            <a:ext cx="11091672" cy="246888"/>
+          </a:xfrm>
+          <a:prstGeom prst="rect">
+            <a:avLst/>
+          </a:prstGeom>
+          <a:solidFill>
+            <a:srgbClr val="F3F5F8"/>
+          </a:solidFill>
+          <a:ln w="12700">
+            <a:solidFill>
+              <a:srgbClr val="F3F5F8"/>
+            </a:solidFill>
+            <a:prstDash val="solid"/>
+          </a:ln>
+        </p:spPr>
+      </p:sp>
+      <p:sp>
+        <p:nvSpPr>
+          <p:cNvPr id="51" name="Text 49"/>
+          <p:cNvSpPr txBox="1"/>
+          <p:nvPr/>
+        </p:nvSpPr>
+        <p:spPr>
+          <a:xfrm>
+            <a:off x="640080" y="1783080"/>
+            <a:ext cx="2240280" cy="246888"/>
+          </a:xfrm>
+          <a:prstGeom prst="rect">
+            <a:avLst/>
+          </a:prstGeom>
+          <a:noFill/>
+          <a:ln/>
+        </p:spPr>
+        <p:txBody>
+          <a:bodyPr wrap="square" lIns="0" tIns="0" rIns="0" bIns="0" rtlCol="0" anchor="ctr"/>
+          <a:lstStyle/>
+          <a:p>
+            <a:pPr indent="0" marL="0">
+              <a:buNone/>
+            </a:pPr>
+            <a:r>
+              <a:rPr lang="en-US" sz="950" b="1" dirty="0">
+                <a:solidFill>
+                  <a:srgbClr val="022A5B"/>
+                </a:solidFill>
+                <a:latin typeface="Arial" pitchFamily="34" charset="0"/>
+                <a:ea typeface="Arial" pitchFamily="34" charset="-122"/>
+                <a:cs typeface="Arial" pitchFamily="34" charset="-120"/>
+              </a:rPr>
+              <a:t>FASE 1 · Diseño</a:t>
+            </a:r>
+            <a:endParaRPr lang="en-US" sz="950" dirty="0"/>
+          </a:p>
+        </p:txBody>
+      </p:sp>
+      <p:sp>
+        <p:nvSpPr>
+          <p:cNvPr id="52" name="Text 50"/>
+          <p:cNvSpPr txBox="1"/>
+          <p:nvPr/>
+        </p:nvSpPr>
+        <p:spPr>
+          <a:xfrm>
+            <a:off x="3017520" y="1783080"/>
+            <a:ext cx="914400" cy="246888"/>
+          </a:xfrm>
+          <a:prstGeom prst="rect">
+            <a:avLst/>
+          </a:prstGeom>
+          <a:noFill/>
+          <a:ln/>
+        </p:spPr>
+        <p:txBody>
+          <a:bodyPr wrap="square" lIns="0" tIns="0" rIns="0" bIns="0" rtlCol="0" anchor="ctr"/>
+          <a:lstStyle/>
+          <a:p>
+            <a:pPr algn="r" indent="0" marL="0">
+              <a:buNone/>
+            </a:pPr>
+            <a:r>
+              <a:rPr lang="en-US" sz="750" dirty="0">
+                <a:solidFill>
+                  <a:srgbClr val="6B7280"/>
+                </a:solidFill>
+                <a:latin typeface="Arial" pitchFamily="34" charset="0"/>
+                <a:ea typeface="Arial" pitchFamily="34" charset="-122"/>
+                <a:cs typeface="Arial" pitchFamily="34" charset="-120"/>
+              </a:rPr>
+              <a:t>14/09 – 02/10</a:t>
+            </a:r>
+            <a:endParaRPr lang="en-US" sz="750" dirty="0"/>
+          </a:p>
+        </p:txBody>
+      </p:sp>
+      <p:sp>
+        <p:nvSpPr>
+          <p:cNvPr id="53" name="Shape 51"/>
+          <p:cNvSpPr/>
+          <p:nvPr/>
+        </p:nvSpPr>
+        <p:spPr>
+          <a:xfrm>
+            <a:off x="3977640" y="1847088"/>
+            <a:ext cx="1313601" cy="118872"/>
+          </a:xfrm>
+          <a:prstGeom prst="rect">
+            <a:avLst/>
+          </a:prstGeom>
+          <a:solidFill>
+            <a:srgbClr val="022A5B"/>
+          </a:solidFill>
+          <a:ln w="12700">
+            <a:solidFill>
+              <a:srgbClr val="022A5B"/>
+            </a:solidFill>
+            <a:prstDash val="solid"/>
+          </a:ln>
+        </p:spPr>
+      </p:sp>
+      <p:sp>
+        <p:nvSpPr>
+          <p:cNvPr id="54" name="Text 52"/>
+          <p:cNvSpPr txBox="1"/>
+          <p:nvPr/>
+        </p:nvSpPr>
+        <p:spPr>
+          <a:xfrm>
+            <a:off x="868680" y="2029968"/>
+            <a:ext cx="2240280" cy="246888"/>
+          </a:xfrm>
+          <a:prstGeom prst="rect">
+            <a:avLst/>
+          </a:prstGeom>
+          <a:noFill/>
+          <a:ln/>
+        </p:spPr>
+        <p:txBody>
+          <a:bodyPr wrap="square" lIns="0" tIns="0" rIns="0" bIns="0" rtlCol="0" anchor="ctr"/>
+          <a:lstStyle/>
+          <a:p>
+            <a:pPr indent="0" marL="0">
+              <a:buNone/>
+            </a:pPr>
+            <a:r>
+              <a:rPr lang="en-US" sz="900" dirty="0">
+                <a:solidFill>
+                  <a:srgbClr val="1F2937"/>
+                </a:solidFill>
+                <a:latin typeface="Arial" pitchFamily="34" charset="0"/>
+                <a:ea typeface="Arial" pitchFamily="34" charset="-122"/>
+                <a:cs typeface="Arial" pitchFamily="34" charset="-120"/>
+              </a:rPr>
+              <a:t>Definir el espacio físico y el layout</a:t>
+            </a:r>
+            <a:endParaRPr lang="en-US" sz="900" dirty="0"/>
+          </a:p>
+        </p:txBody>
+      </p:sp>
+      <p:sp>
+        <p:nvSpPr>
+          <p:cNvPr id="55" name="Text 53"/>
+          <p:cNvSpPr txBox="1"/>
+          <p:nvPr/>
+        </p:nvSpPr>
+        <p:spPr>
+          <a:xfrm>
+            <a:off x="3017520" y="2029968"/>
+            <a:ext cx="914400" cy="246888"/>
+          </a:xfrm>
+          <a:prstGeom prst="rect">
+            <a:avLst/>
+          </a:prstGeom>
+          <a:noFill/>
+          <a:ln/>
+        </p:spPr>
+        <p:txBody>
+          <a:bodyPr wrap="square" lIns="0" tIns="0" rIns="0" bIns="0" rtlCol="0" anchor="ctr"/>
+          <a:lstStyle/>
+          <a:p>
+            <a:pPr algn="r" indent="0" marL="0">
+              <a:buNone/>
+            </a:pPr>
+            <a:r>
+              <a:rPr lang="en-US" sz="750" dirty="0">
+                <a:solidFill>
+                  <a:srgbClr val="6B7280"/>
+                </a:solidFill>
+                <a:latin typeface="Arial" pitchFamily="34" charset="0"/>
+                <a:ea typeface="Arial" pitchFamily="34" charset="-122"/>
+                <a:cs typeface="Arial" pitchFamily="34" charset="-120"/>
+              </a:rPr>
+              <a:t>14/09 – 23/09</a:t>
+            </a:r>
+            <a:endParaRPr lang="en-US" sz="750" dirty="0"/>
+          </a:p>
+        </p:txBody>
+      </p:sp>
+      <p:sp>
+        <p:nvSpPr>
+          <p:cNvPr id="56" name="Shape 54"/>
+          <p:cNvSpPr/>
+          <p:nvPr/>
+        </p:nvSpPr>
+        <p:spPr>
+          <a:xfrm>
+            <a:off x="3977640" y="2075688"/>
+            <a:ext cx="656800" cy="155448"/>
+          </a:xfrm>
+          <a:prstGeom prst="roundRect">
+            <a:avLst>
+              <a:gd name="adj" fmla="val 29412"/>
+            </a:avLst>
+          </a:prstGeom>
+          <a:solidFill>
+            <a:srgbClr val="022A5B">
+              <a:alpha val="55000"/>
+            </a:srgbClr>
+          </a:solidFill>
+          <a:ln w="9525">
+            <a:solidFill>
+              <a:srgbClr val="022A5B"/>
+            </a:solidFill>
+            <a:prstDash val="solid"/>
+          </a:ln>
+        </p:spPr>
+      </p:sp>
+      <p:sp>
+        <p:nvSpPr>
+          <p:cNvPr id="57" name="Text 55"/>
+          <p:cNvSpPr txBox="1"/>
+          <p:nvPr/>
+        </p:nvSpPr>
+        <p:spPr>
+          <a:xfrm>
+            <a:off x="868680" y="2276856"/>
+            <a:ext cx="2240280" cy="246888"/>
+          </a:xfrm>
+          <a:prstGeom prst="rect">
+            <a:avLst/>
+          </a:prstGeom>
+          <a:noFill/>
+          <a:ln/>
+        </p:spPr>
+        <p:txBody>
+          <a:bodyPr wrap="square" lIns="0" tIns="0" rIns="0" bIns="0" rtlCol="0" anchor="ctr"/>
+          <a:lstStyle/>
+          <a:p>
+            <a:pPr indent="0" marL="0">
+              <a:buNone/>
+            </a:pPr>
+            <a:r>
+              <a:rPr lang="en-US" sz="900" dirty="0">
+                <a:solidFill>
+                  <a:srgbClr val="1F2937"/>
+                </a:solidFill>
+                <a:latin typeface="Arial" pitchFamily="34" charset="0"/>
+                <a:ea typeface="Arial" pitchFamily="34" charset="-122"/>
+                <a:cs typeface="Arial" pitchFamily="34" charset="-120"/>
+              </a:rPr>
+              <a:t>Priorizar problemas con Mantenimiento</a:t>
+            </a:r>
+            <a:endParaRPr lang="en-US" sz="900" dirty="0"/>
+          </a:p>
+        </p:txBody>
+      </p:sp>
+      <p:sp>
+        <p:nvSpPr>
+          <p:cNvPr id="58" name="Text 56"/>
+          <p:cNvSpPr txBox="1"/>
+          <p:nvPr/>
+        </p:nvSpPr>
+        <p:spPr>
+          <a:xfrm>
+            <a:off x="3017520" y="2276856"/>
+            <a:ext cx="914400" cy="246888"/>
+          </a:xfrm>
+          <a:prstGeom prst="rect">
+            <a:avLst/>
+          </a:prstGeom>
+          <a:noFill/>
+          <a:ln/>
+        </p:spPr>
+        <p:txBody>
+          <a:bodyPr wrap="square" lIns="0" tIns="0" rIns="0" bIns="0" rtlCol="0" anchor="ctr"/>
+          <a:lstStyle/>
+          <a:p>
+            <a:pPr algn="r" indent="0" marL="0">
+              <a:buNone/>
+            </a:pPr>
+            <a:r>
+              <a:rPr lang="en-US" sz="750" dirty="0">
+                <a:solidFill>
+                  <a:srgbClr val="6B7280"/>
+                </a:solidFill>
+                <a:latin typeface="Arial" pitchFamily="34" charset="0"/>
+                <a:ea typeface="Arial" pitchFamily="34" charset="-122"/>
+                <a:cs typeface="Arial" pitchFamily="34" charset="-120"/>
+              </a:rPr>
+              <a:t>14/09 – 25/09</a:t>
+            </a:r>
+            <a:endParaRPr lang="en-US" sz="750" dirty="0"/>
+          </a:p>
+        </p:txBody>
+      </p:sp>
+      <p:sp>
+        <p:nvSpPr>
+          <p:cNvPr id="59" name="Shape 57"/>
+          <p:cNvSpPr/>
+          <p:nvPr/>
+        </p:nvSpPr>
+        <p:spPr>
+          <a:xfrm>
+            <a:off x="3977640" y="2322576"/>
+            <a:ext cx="802756" cy="155448"/>
+          </a:xfrm>
+          <a:prstGeom prst="roundRect">
+            <a:avLst>
+              <a:gd name="adj" fmla="val 29412"/>
+            </a:avLst>
+          </a:prstGeom>
+          <a:solidFill>
+            <a:srgbClr val="022A5B">
+              <a:alpha val="55000"/>
+            </a:srgbClr>
+          </a:solidFill>
+          <a:ln w="9525">
+            <a:solidFill>
+              <a:srgbClr val="022A5B"/>
+            </a:solidFill>
+            <a:prstDash val="solid"/>
+          </a:ln>
+        </p:spPr>
+      </p:sp>
+      <p:sp>
+        <p:nvSpPr>
+          <p:cNvPr id="60" name="Text 58"/>
+          <p:cNvSpPr txBox="1"/>
+          <p:nvPr/>
+        </p:nvSpPr>
+        <p:spPr>
+          <a:xfrm>
+            <a:off x="868680" y="2523744"/>
+            <a:ext cx="2240280" cy="246888"/>
+          </a:xfrm>
+          <a:prstGeom prst="rect">
+            <a:avLst/>
+          </a:prstGeom>
+          <a:noFill/>
+          <a:ln/>
+        </p:spPr>
+        <p:txBody>
+          <a:bodyPr wrap="square" lIns="0" tIns="0" rIns="0" bIns="0" rtlCol="0" anchor="ctr"/>
+          <a:lstStyle/>
+          <a:p>
+            <a:pPr indent="0" marL="0">
+              <a:buNone/>
+            </a:pPr>
+            <a:r>
+              <a:rPr lang="en-US" sz="900" dirty="0">
+                <a:solidFill>
+                  <a:srgbClr val="1F2937"/>
+                </a:solidFill>
+                <a:latin typeface="Arial" pitchFamily="34" charset="0"/>
+                <a:ea typeface="Arial" pitchFamily="34" charset="-122"/>
+                <a:cs typeface="Arial" pitchFamily="34" charset="-120"/>
+              </a:rPr>
+              <a:t>Formar a los multiplicadores</a:t>
+            </a:r>
+            <a:endParaRPr lang="en-US" sz="900" dirty="0"/>
+          </a:p>
+        </p:txBody>
+      </p:sp>
+      <p:sp>
+        <p:nvSpPr>
+          <p:cNvPr id="61" name="Text 59"/>
+          <p:cNvSpPr txBox="1"/>
+          <p:nvPr/>
+        </p:nvSpPr>
+        <p:spPr>
+          <a:xfrm>
+            <a:off x="3017520" y="2523744"/>
+            <a:ext cx="914400" cy="246888"/>
+          </a:xfrm>
+          <a:prstGeom prst="rect">
+            <a:avLst/>
+          </a:prstGeom>
+          <a:noFill/>
+          <a:ln/>
+        </p:spPr>
+        <p:txBody>
+          <a:bodyPr wrap="square" lIns="0" tIns="0" rIns="0" bIns="0" rtlCol="0" anchor="ctr"/>
+          <a:lstStyle/>
+          <a:p>
+            <a:pPr algn="r" indent="0" marL="0">
+              <a:buNone/>
+            </a:pPr>
+            <a:r>
+              <a:rPr lang="en-US" sz="750" dirty="0">
+                <a:solidFill>
+                  <a:srgbClr val="6B7280"/>
+                </a:solidFill>
+                <a:latin typeface="Arial" pitchFamily="34" charset="0"/>
+                <a:ea typeface="Arial" pitchFamily="34" charset="-122"/>
+                <a:cs typeface="Arial" pitchFamily="34" charset="-120"/>
+              </a:rPr>
+              <a:t>21/09 – 09/10</a:t>
+            </a:r>
+            <a:endParaRPr lang="en-US" sz="750" dirty="0"/>
+          </a:p>
+        </p:txBody>
+      </p:sp>
+      <p:sp>
+        <p:nvSpPr>
+          <p:cNvPr id="62" name="Shape 60"/>
+          <p:cNvSpPr/>
+          <p:nvPr/>
+        </p:nvSpPr>
+        <p:spPr>
+          <a:xfrm>
+            <a:off x="4488485" y="2569464"/>
+            <a:ext cx="1313601" cy="155448"/>
+          </a:xfrm>
+          <a:prstGeom prst="roundRect">
+            <a:avLst>
+              <a:gd name="adj" fmla="val 29412"/>
+            </a:avLst>
+          </a:prstGeom>
+          <a:solidFill>
+            <a:srgbClr val="022A5B">
+              <a:alpha val="55000"/>
+            </a:srgbClr>
+          </a:solidFill>
+          <a:ln w="9525">
+            <a:solidFill>
+              <a:srgbClr val="022A5B"/>
+            </a:solidFill>
+            <a:prstDash val="solid"/>
+          </a:ln>
+        </p:spPr>
+      </p:sp>
+      <p:sp>
+        <p:nvSpPr>
+          <p:cNvPr id="63" name="Shape 61"/>
+          <p:cNvSpPr/>
+          <p:nvPr/>
+        </p:nvSpPr>
+        <p:spPr>
+          <a:xfrm>
+            <a:off x="548640" y="2770632"/>
+            <a:ext cx="11091672" cy="246888"/>
+          </a:xfrm>
+          <a:prstGeom prst="rect">
+            <a:avLst/>
+          </a:prstGeom>
+          <a:solidFill>
+            <a:srgbClr val="F3F5F8"/>
+          </a:solidFill>
+          <a:ln w="12700">
+            <a:solidFill>
+              <a:srgbClr val="F3F5F8"/>
+            </a:solidFill>
+            <a:prstDash val="solid"/>
+          </a:ln>
+        </p:spPr>
+      </p:sp>
+      <p:sp>
+        <p:nvSpPr>
+          <p:cNvPr id="64" name="Text 62"/>
+          <p:cNvSpPr txBox="1"/>
+          <p:nvPr/>
+        </p:nvSpPr>
+        <p:spPr>
+          <a:xfrm>
+            <a:off x="640080" y="2770632"/>
+            <a:ext cx="2240280" cy="246888"/>
+          </a:xfrm>
+          <a:prstGeom prst="rect">
+            <a:avLst/>
+          </a:prstGeom>
+          <a:noFill/>
+          <a:ln/>
+        </p:spPr>
+        <p:txBody>
+          <a:bodyPr wrap="square" lIns="0" tIns="0" rIns="0" bIns="0" rtlCol="0" anchor="ctr"/>
+          <a:lstStyle/>
+          <a:p>
+            <a:pPr indent="0" marL="0">
+              <a:buNone/>
+            </a:pPr>
+            <a:r>
+              <a:rPr lang="en-US" sz="950" b="1" dirty="0">
+                <a:solidFill>
+                  <a:srgbClr val="022A5B"/>
+                </a:solidFill>
+                <a:latin typeface="Arial" pitchFamily="34" charset="0"/>
+                <a:ea typeface="Arial" pitchFamily="34" charset="-122"/>
+                <a:cs typeface="Arial" pitchFamily="34" charset="-120"/>
+              </a:rPr>
+              <a:t>FASE 2 · Construcción</a:t>
+            </a:r>
+            <a:endParaRPr lang="en-US" sz="950" dirty="0"/>
+          </a:p>
+        </p:txBody>
+      </p:sp>
+      <p:sp>
+        <p:nvSpPr>
+          <p:cNvPr id="65" name="Text 63"/>
+          <p:cNvSpPr txBox="1"/>
+          <p:nvPr/>
+        </p:nvSpPr>
+        <p:spPr>
+          <a:xfrm>
+            <a:off x="3017520" y="2770632"/>
+            <a:ext cx="914400" cy="246888"/>
+          </a:xfrm>
+          <a:prstGeom prst="rect">
+            <a:avLst/>
+          </a:prstGeom>
+          <a:noFill/>
+          <a:ln/>
+        </p:spPr>
+        <p:txBody>
+          <a:bodyPr wrap="square" lIns="0" tIns="0" rIns="0" bIns="0" rtlCol="0" anchor="ctr"/>
+          <a:lstStyle/>
+          <a:p>
+            <a:pPr algn="r" indent="0" marL="0">
+              <a:buNone/>
+            </a:pPr>
+            <a:r>
+              <a:rPr lang="en-US" sz="750" dirty="0">
+                <a:solidFill>
+                  <a:srgbClr val="6B7280"/>
+                </a:solidFill>
+                <a:latin typeface="Arial" pitchFamily="34" charset="0"/>
+                <a:ea typeface="Arial" pitchFamily="34" charset="-122"/>
+                <a:cs typeface="Arial" pitchFamily="34" charset="-120"/>
+              </a:rPr>
+              <a:t>28/09 – 06/11</a:t>
+            </a:r>
+            <a:endParaRPr lang="en-US" sz="750" dirty="0"/>
+          </a:p>
+        </p:txBody>
+      </p:sp>
+      <p:sp>
+        <p:nvSpPr>
+          <p:cNvPr id="66" name="Shape 64"/>
+          <p:cNvSpPr/>
+          <p:nvPr/>
+        </p:nvSpPr>
+        <p:spPr>
+          <a:xfrm>
+            <a:off x="4999330" y="2834640"/>
+            <a:ext cx="2846135" cy="118872"/>
+          </a:xfrm>
+          <a:prstGeom prst="rect">
+            <a:avLst/>
+          </a:prstGeom>
+          <a:solidFill>
+            <a:srgbClr val="0B3A73"/>
+          </a:solidFill>
+          <a:ln w="12700">
+            <a:solidFill>
+              <a:srgbClr val="0B3A73"/>
+            </a:solidFill>
+            <a:prstDash val="solid"/>
+          </a:ln>
+        </p:spPr>
+      </p:sp>
+      <p:sp>
+        <p:nvSpPr>
+          <p:cNvPr id="67" name="Text 65"/>
+          <p:cNvSpPr txBox="1"/>
+          <p:nvPr/>
+        </p:nvSpPr>
+        <p:spPr>
+          <a:xfrm>
+            <a:off x="868680" y="3017520"/>
+            <a:ext cx="2240280" cy="246888"/>
+          </a:xfrm>
+          <a:prstGeom prst="rect">
+            <a:avLst/>
+          </a:prstGeom>
+          <a:noFill/>
+          <a:ln/>
+        </p:spPr>
+        <p:txBody>
+          <a:bodyPr wrap="square" lIns="0" tIns="0" rIns="0" bIns="0" rtlCol="0" anchor="ctr"/>
+          <a:lstStyle/>
+          <a:p>
+            <a:pPr indent="0" marL="0">
+              <a:buNone/>
+            </a:pPr>
+            <a:r>
+              <a:rPr lang="en-US" sz="900" dirty="0">
+                <a:solidFill>
+                  <a:srgbClr val="1F2937"/>
+                </a:solidFill>
+                <a:latin typeface="Arial" pitchFamily="34" charset="0"/>
+                <a:ea typeface="Arial" pitchFamily="34" charset="-122"/>
+                <a:cs typeface="Arial" pitchFamily="34" charset="-120"/>
+              </a:rPr>
+              <a:t>Fabricar las 4 maquetas</a:t>
+            </a:r>
+            <a:endParaRPr lang="en-US" sz="900" dirty="0"/>
+          </a:p>
+        </p:txBody>
+      </p:sp>
+      <p:sp>
+        <p:nvSpPr>
+          <p:cNvPr id="68" name="Text 66"/>
+          <p:cNvSpPr txBox="1"/>
+          <p:nvPr/>
+        </p:nvSpPr>
+        <p:spPr>
+          <a:xfrm>
+            <a:off x="3017520" y="3017520"/>
+            <a:ext cx="914400" cy="246888"/>
+          </a:xfrm>
+          <a:prstGeom prst="rect">
+            <a:avLst/>
+          </a:prstGeom>
+          <a:noFill/>
+          <a:ln/>
+        </p:spPr>
+        <p:txBody>
+          <a:bodyPr wrap="square" lIns="0" tIns="0" rIns="0" bIns="0" rtlCol="0" anchor="ctr"/>
+          <a:lstStyle/>
+          <a:p>
+            <a:pPr algn="r" indent="0" marL="0">
+              <a:buNone/>
+            </a:pPr>
+            <a:r>
+              <a:rPr lang="en-US" sz="750" dirty="0">
+                <a:solidFill>
+                  <a:srgbClr val="6B7280"/>
+                </a:solidFill>
+                <a:latin typeface="Arial" pitchFamily="34" charset="0"/>
+                <a:ea typeface="Arial" pitchFamily="34" charset="-122"/>
+                <a:cs typeface="Arial" pitchFamily="34" charset="-120"/>
+              </a:rPr>
+              <a:t>28/09 – 30/10</a:t>
+            </a:r>
+            <a:endParaRPr lang="en-US" sz="750" dirty="0"/>
+          </a:p>
+        </p:txBody>
+      </p:sp>
+      <p:sp>
+        <p:nvSpPr>
+          <p:cNvPr id="69" name="Shape 67"/>
+          <p:cNvSpPr/>
+          <p:nvPr/>
+        </p:nvSpPr>
+        <p:spPr>
+          <a:xfrm>
+            <a:off x="4999330" y="3063240"/>
+            <a:ext cx="2335291" cy="155448"/>
+          </a:xfrm>
+          <a:prstGeom prst="roundRect">
+            <a:avLst>
+              <a:gd name="adj" fmla="val 29412"/>
+            </a:avLst>
+          </a:prstGeom>
+          <a:solidFill>
+            <a:srgbClr val="0B3A73">
+              <a:alpha val="55000"/>
+            </a:srgbClr>
+          </a:solidFill>
+          <a:ln w="9525">
+            <a:solidFill>
+              <a:srgbClr val="0B3A73"/>
+            </a:solidFill>
+            <a:prstDash val="solid"/>
+          </a:ln>
+        </p:spPr>
+      </p:sp>
+      <p:sp>
+        <p:nvSpPr>
+          <p:cNvPr id="70" name="Text 68"/>
+          <p:cNvSpPr txBox="1"/>
+          <p:nvPr/>
+        </p:nvSpPr>
+        <p:spPr>
+          <a:xfrm>
+            <a:off x="868680" y="3264408"/>
+            <a:ext cx="2240280" cy="246888"/>
+          </a:xfrm>
+          <a:prstGeom prst="rect">
+            <a:avLst/>
+          </a:prstGeom>
+          <a:noFill/>
+          <a:ln/>
+        </p:spPr>
+        <p:txBody>
+          <a:bodyPr wrap="square" lIns="0" tIns="0" rIns="0" bIns="0" rtlCol="0" anchor="ctr"/>
+          <a:lstStyle/>
+          <a:p>
+            <a:pPr indent="0" marL="0">
+              <a:buNone/>
+            </a:pPr>
+            <a:r>
+              <a:rPr lang="en-US" sz="900" dirty="0">
+                <a:solidFill>
+                  <a:srgbClr val="1F2937"/>
+                </a:solidFill>
+                <a:latin typeface="Arial" pitchFamily="34" charset="0"/>
+                <a:ea typeface="Arial" pitchFamily="34" charset="-122"/>
+                <a:cs typeface="Arial" pitchFamily="34" charset="-120"/>
+              </a:rPr>
+              <a:t>Imprimir tótems y señalización del sector</a:t>
+            </a:r>
+            <a:endParaRPr lang="en-US" sz="900" dirty="0"/>
+          </a:p>
+        </p:txBody>
+      </p:sp>
+      <p:sp>
+        <p:nvSpPr>
+          <p:cNvPr id="71" name="Text 69"/>
+          <p:cNvSpPr txBox="1"/>
+          <p:nvPr/>
+        </p:nvSpPr>
+        <p:spPr>
+          <a:xfrm>
+            <a:off x="3017520" y="3264408"/>
+            <a:ext cx="914400" cy="246888"/>
+          </a:xfrm>
+          <a:prstGeom prst="rect">
+            <a:avLst/>
+          </a:prstGeom>
+          <a:noFill/>
+          <a:ln/>
+        </p:spPr>
+        <p:txBody>
+          <a:bodyPr wrap="square" lIns="0" tIns="0" rIns="0" bIns="0" rtlCol="0" anchor="ctr"/>
+          <a:lstStyle/>
+          <a:p>
+            <a:pPr algn="r" indent="0" marL="0">
+              <a:buNone/>
+            </a:pPr>
+            <a:r>
+              <a:rPr lang="en-US" sz="750" dirty="0">
+                <a:solidFill>
+                  <a:srgbClr val="6B7280"/>
+                </a:solidFill>
+                <a:latin typeface="Arial" pitchFamily="34" charset="0"/>
+                <a:ea typeface="Arial" pitchFamily="34" charset="-122"/>
+                <a:cs typeface="Arial" pitchFamily="34" charset="-120"/>
+              </a:rPr>
+              <a:t>05/10 – 23/10</a:t>
+            </a:r>
+            <a:endParaRPr lang="en-US" sz="750" dirty="0"/>
+          </a:p>
+        </p:txBody>
+      </p:sp>
+      <p:sp>
+        <p:nvSpPr>
+          <p:cNvPr id="72" name="Shape 70"/>
+          <p:cNvSpPr/>
+          <p:nvPr/>
+        </p:nvSpPr>
+        <p:spPr>
+          <a:xfrm>
+            <a:off x="5510174" y="3310128"/>
+            <a:ext cx="1313601" cy="155448"/>
+          </a:xfrm>
+          <a:prstGeom prst="roundRect">
+            <a:avLst>
+              <a:gd name="adj" fmla="val 29412"/>
+            </a:avLst>
+          </a:prstGeom>
+          <a:solidFill>
+            <a:srgbClr val="0B3A73">
+              <a:alpha val="55000"/>
+            </a:srgbClr>
+          </a:solidFill>
+          <a:ln w="9525">
+            <a:solidFill>
+              <a:srgbClr val="0B3A73"/>
+            </a:solidFill>
+            <a:prstDash val="solid"/>
+          </a:ln>
+        </p:spPr>
+      </p:sp>
+      <p:sp>
+        <p:nvSpPr>
+          <p:cNvPr id="73" name="Text 71"/>
+          <p:cNvSpPr txBox="1"/>
+          <p:nvPr/>
+        </p:nvSpPr>
+        <p:spPr>
+          <a:xfrm>
+            <a:off x="868680" y="3511296"/>
+            <a:ext cx="2240280" cy="246888"/>
+          </a:xfrm>
+          <a:prstGeom prst="rect">
+            <a:avLst/>
+          </a:prstGeom>
+          <a:noFill/>
+          <a:ln/>
+        </p:spPr>
+        <p:txBody>
+          <a:bodyPr wrap="square" lIns="0" tIns="0" rIns="0" bIns="0" rtlCol="0" anchor="ctr"/>
+          <a:lstStyle/>
+          <a:p>
+            <a:pPr indent="0" marL="0">
+              <a:buNone/>
+            </a:pPr>
+            <a:r>
+              <a:rPr lang="en-US" sz="900" dirty="0">
+                <a:solidFill>
+                  <a:srgbClr val="1F2937"/>
+                </a:solidFill>
+                <a:latin typeface="Arial" pitchFamily="34" charset="0"/>
+                <a:ea typeface="Arial" pitchFamily="34" charset="-122"/>
+                <a:cs typeface="Arial" pitchFamily="34" charset="-120"/>
+              </a:rPr>
+              <a:t>Crear contenido y estándares LLA</a:t>
+            </a:r>
+            <a:endParaRPr lang="en-US" sz="900" dirty="0"/>
+          </a:p>
+        </p:txBody>
+      </p:sp>
+      <p:sp>
+        <p:nvSpPr>
+          <p:cNvPr id="74" name="Text 72"/>
+          <p:cNvSpPr txBox="1"/>
+          <p:nvPr/>
+        </p:nvSpPr>
+        <p:spPr>
+          <a:xfrm>
+            <a:off x="3017520" y="3511296"/>
+            <a:ext cx="914400" cy="246888"/>
+          </a:xfrm>
+          <a:prstGeom prst="rect">
+            <a:avLst/>
+          </a:prstGeom>
+          <a:noFill/>
+          <a:ln/>
+        </p:spPr>
+        <p:txBody>
+          <a:bodyPr wrap="square" lIns="0" tIns="0" rIns="0" bIns="0" rtlCol="0" anchor="ctr"/>
+          <a:lstStyle/>
+          <a:p>
+            <a:pPr algn="r" indent="0" marL="0">
+              <a:buNone/>
+            </a:pPr>
+            <a:r>
+              <a:rPr lang="en-US" sz="750" dirty="0">
+                <a:solidFill>
+                  <a:srgbClr val="6B7280"/>
+                </a:solidFill>
+                <a:latin typeface="Arial" pitchFamily="34" charset="0"/>
+                <a:ea typeface="Arial" pitchFamily="34" charset="-122"/>
+                <a:cs typeface="Arial" pitchFamily="34" charset="-120"/>
+              </a:rPr>
+              <a:t>05/10 – 30/10</a:t>
+            </a:r>
+            <a:endParaRPr lang="en-US" sz="750" dirty="0"/>
+          </a:p>
+        </p:txBody>
+      </p:sp>
+      <p:sp>
+        <p:nvSpPr>
+          <p:cNvPr id="75" name="Shape 73"/>
+          <p:cNvSpPr/>
+          <p:nvPr/>
+        </p:nvSpPr>
+        <p:spPr>
+          <a:xfrm>
+            <a:off x="5510174" y="3557016"/>
+            <a:ext cx="1824446" cy="155448"/>
+          </a:xfrm>
+          <a:prstGeom prst="roundRect">
+            <a:avLst>
+              <a:gd name="adj" fmla="val 29412"/>
+            </a:avLst>
+          </a:prstGeom>
+          <a:solidFill>
+            <a:srgbClr val="0B3A73">
+              <a:alpha val="55000"/>
+            </a:srgbClr>
+          </a:solidFill>
+          <a:ln w="9525">
+            <a:solidFill>
+              <a:srgbClr val="0B3A73"/>
+            </a:solidFill>
+            <a:prstDash val="solid"/>
+          </a:ln>
+        </p:spPr>
+      </p:sp>
+      <p:sp>
+        <p:nvSpPr>
+          <p:cNvPr id="76" name="Text 74"/>
+          <p:cNvSpPr txBox="1"/>
+          <p:nvPr/>
+        </p:nvSpPr>
+        <p:spPr>
+          <a:xfrm>
+            <a:off x="868680" y="3758184"/>
+            <a:ext cx="2240280" cy="246888"/>
+          </a:xfrm>
+          <a:prstGeom prst="rect">
+            <a:avLst/>
+          </a:prstGeom>
+          <a:noFill/>
+          <a:ln/>
+        </p:spPr>
+        <p:txBody>
+          <a:bodyPr wrap="square" lIns="0" tIns="0" rIns="0" bIns="0" rtlCol="0" anchor="ctr"/>
+          <a:lstStyle/>
+          <a:p>
+            <a:pPr indent="0" marL="0">
+              <a:buNone/>
+            </a:pPr>
+            <a:r>
+              <a:rPr lang="en-US" sz="900" dirty="0">
+                <a:solidFill>
+                  <a:srgbClr val="1F2937"/>
+                </a:solidFill>
+                <a:latin typeface="Arial" pitchFamily="34" charset="0"/>
+                <a:ea typeface="Arial" pitchFamily="34" charset="-122"/>
+                <a:cs typeface="Arial" pitchFamily="34" charset="-120"/>
+              </a:rPr>
+              <a:t>Adaptar el AM Game a Pintura</a:t>
+            </a:r>
+            <a:endParaRPr lang="en-US" sz="900" dirty="0"/>
+          </a:p>
+        </p:txBody>
+      </p:sp>
+      <p:sp>
+        <p:nvSpPr>
+          <p:cNvPr id="77" name="Text 75"/>
+          <p:cNvSpPr txBox="1"/>
+          <p:nvPr/>
+        </p:nvSpPr>
+        <p:spPr>
+          <a:xfrm>
+            <a:off x="3017520" y="3758184"/>
+            <a:ext cx="914400" cy="246888"/>
+          </a:xfrm>
+          <a:prstGeom prst="rect">
+            <a:avLst/>
+          </a:prstGeom>
+          <a:noFill/>
+          <a:ln/>
+        </p:spPr>
+        <p:txBody>
+          <a:bodyPr wrap="square" lIns="0" tIns="0" rIns="0" bIns="0" rtlCol="0" anchor="ctr"/>
+          <a:lstStyle/>
+          <a:p>
+            <a:pPr algn="r" indent="0" marL="0">
+              <a:buNone/>
+            </a:pPr>
+            <a:r>
+              <a:rPr lang="en-US" sz="750" dirty="0">
+                <a:solidFill>
+                  <a:srgbClr val="6B7280"/>
+                </a:solidFill>
+                <a:latin typeface="Arial" pitchFamily="34" charset="0"/>
+                <a:ea typeface="Arial" pitchFamily="34" charset="-122"/>
+                <a:cs typeface="Arial" pitchFamily="34" charset="-120"/>
+              </a:rPr>
+              <a:t>12/10 – 06/11</a:t>
+            </a:r>
+            <a:endParaRPr lang="en-US" sz="750" dirty="0"/>
+          </a:p>
+        </p:txBody>
+      </p:sp>
+      <p:sp>
+        <p:nvSpPr>
+          <p:cNvPr id="78" name="Shape 76"/>
+          <p:cNvSpPr/>
+          <p:nvPr/>
+        </p:nvSpPr>
+        <p:spPr>
+          <a:xfrm>
+            <a:off x="6021019" y="3803904"/>
+            <a:ext cx="1824446" cy="155448"/>
+          </a:xfrm>
+          <a:prstGeom prst="roundRect">
+            <a:avLst>
+              <a:gd name="adj" fmla="val 29412"/>
+            </a:avLst>
+          </a:prstGeom>
+          <a:solidFill>
+            <a:srgbClr val="0B3A73">
+              <a:alpha val="55000"/>
+            </a:srgbClr>
+          </a:solidFill>
+          <a:ln w="9525">
+            <a:solidFill>
+              <a:srgbClr val="0B3A73"/>
+            </a:solidFill>
+            <a:prstDash val="solid"/>
+          </a:ln>
+        </p:spPr>
+      </p:sp>
+      <p:sp>
+        <p:nvSpPr>
+          <p:cNvPr id="79" name="Shape 77"/>
+          <p:cNvSpPr/>
+          <p:nvPr/>
+        </p:nvSpPr>
+        <p:spPr>
+          <a:xfrm>
+            <a:off x="548640" y="4005072"/>
+            <a:ext cx="11091672" cy="246888"/>
+          </a:xfrm>
+          <a:prstGeom prst="rect">
+            <a:avLst/>
+          </a:prstGeom>
+          <a:solidFill>
+            <a:srgbClr val="F3F5F8"/>
+          </a:solidFill>
+          <a:ln w="12700">
+            <a:solidFill>
+              <a:srgbClr val="F3F5F8"/>
+            </a:solidFill>
+            <a:prstDash val="solid"/>
+          </a:ln>
+        </p:spPr>
+      </p:sp>
+      <p:sp>
+        <p:nvSpPr>
+          <p:cNvPr id="80" name="Text 78"/>
+          <p:cNvSpPr txBox="1"/>
+          <p:nvPr/>
+        </p:nvSpPr>
+        <p:spPr>
+          <a:xfrm>
+            <a:off x="640080" y="4005072"/>
+            <a:ext cx="2240280" cy="246888"/>
+          </a:xfrm>
+          <a:prstGeom prst="rect">
+            <a:avLst/>
+          </a:prstGeom>
+          <a:noFill/>
+          <a:ln/>
+        </p:spPr>
+        <p:txBody>
+          <a:bodyPr wrap="square" lIns="0" tIns="0" rIns="0" bIns="0" rtlCol="0" anchor="ctr"/>
+          <a:lstStyle/>
+          <a:p>
+            <a:pPr indent="0" marL="0">
+              <a:buNone/>
+            </a:pPr>
+            <a:r>
+              <a:rPr lang="en-US" sz="950" b="1" dirty="0">
+                <a:solidFill>
+                  <a:srgbClr val="022A5B"/>
+                </a:solidFill>
+                <a:latin typeface="Arial" pitchFamily="34" charset="0"/>
+                <a:ea typeface="Arial" pitchFamily="34" charset="-122"/>
+                <a:cs typeface="Arial" pitchFamily="34" charset="-120"/>
+              </a:rPr>
+              <a:t>FASE 3 · Piloto</a:t>
+            </a:r>
+            <a:endParaRPr lang="en-US" sz="950" dirty="0"/>
+          </a:p>
+        </p:txBody>
+      </p:sp>
+      <p:sp>
+        <p:nvSpPr>
+          <p:cNvPr id="81" name="Text 79"/>
+          <p:cNvSpPr txBox="1"/>
+          <p:nvPr/>
+        </p:nvSpPr>
+        <p:spPr>
+          <a:xfrm>
+            <a:off x="3017520" y="4005072"/>
+            <a:ext cx="914400" cy="246888"/>
+          </a:xfrm>
+          <a:prstGeom prst="rect">
+            <a:avLst/>
+          </a:prstGeom>
+          <a:noFill/>
+          <a:ln/>
+        </p:spPr>
+        <p:txBody>
+          <a:bodyPr wrap="square" lIns="0" tIns="0" rIns="0" bIns="0" rtlCol="0" anchor="ctr"/>
+          <a:lstStyle/>
+          <a:p>
+            <a:pPr algn="r" indent="0" marL="0">
+              <a:buNone/>
+            </a:pPr>
+            <a:r>
+              <a:rPr lang="en-US" sz="750" dirty="0">
+                <a:solidFill>
+                  <a:srgbClr val="6B7280"/>
+                </a:solidFill>
+                <a:latin typeface="Arial" pitchFamily="34" charset="0"/>
+                <a:ea typeface="Arial" pitchFamily="34" charset="-122"/>
+                <a:cs typeface="Arial" pitchFamily="34" charset="-120"/>
+              </a:rPr>
+              <a:t>09/11 – 20/11</a:t>
+            </a:r>
+            <a:endParaRPr lang="en-US" sz="750" dirty="0"/>
+          </a:p>
+        </p:txBody>
+      </p:sp>
+      <p:sp>
+        <p:nvSpPr>
+          <p:cNvPr id="82" name="Shape 80"/>
+          <p:cNvSpPr/>
+          <p:nvPr/>
+        </p:nvSpPr>
+        <p:spPr>
+          <a:xfrm>
+            <a:off x="8064398" y="4069080"/>
+            <a:ext cx="802756" cy="118872"/>
+          </a:xfrm>
+          <a:prstGeom prst="rect">
+            <a:avLst/>
+          </a:prstGeom>
+          <a:solidFill>
+            <a:srgbClr val="079CCE"/>
+          </a:solidFill>
+          <a:ln w="12700">
+            <a:solidFill>
+              <a:srgbClr val="079CCE"/>
+            </a:solidFill>
+            <a:prstDash val="solid"/>
+          </a:ln>
+        </p:spPr>
+      </p:sp>
+      <p:sp>
+        <p:nvSpPr>
+          <p:cNvPr id="83" name="Text 81"/>
+          <p:cNvSpPr txBox="1"/>
+          <p:nvPr/>
+        </p:nvSpPr>
+        <p:spPr>
+          <a:xfrm>
+            <a:off x="868680" y="4251960"/>
+            <a:ext cx="2240280" cy="246888"/>
+          </a:xfrm>
+          <a:prstGeom prst="rect">
+            <a:avLst/>
+          </a:prstGeom>
+          <a:noFill/>
+          <a:ln/>
+        </p:spPr>
+        <p:txBody>
+          <a:bodyPr wrap="square" lIns="0" tIns="0" rIns="0" bIns="0" rtlCol="0" anchor="ctr"/>
+          <a:lstStyle/>
+          <a:p>
+            <a:pPr indent="0" marL="0">
+              <a:buNone/>
+            </a:pPr>
+            <a:r>
+              <a:rPr lang="en-US" sz="900" dirty="0">
+                <a:solidFill>
+                  <a:srgbClr val="1F2937"/>
+                </a:solidFill>
+                <a:latin typeface="Arial" pitchFamily="34" charset="0"/>
+                <a:ea typeface="Arial" pitchFamily="34" charset="-122"/>
+                <a:cs typeface="Arial" pitchFamily="34" charset="-120"/>
+              </a:rPr>
+              <a:t>Sesiones piloto con el primer grupo</a:t>
+            </a:r>
+            <a:endParaRPr lang="en-US" sz="900" dirty="0"/>
+          </a:p>
+        </p:txBody>
+      </p:sp>
+      <p:sp>
+        <p:nvSpPr>
+          <p:cNvPr id="84" name="Text 82"/>
+          <p:cNvSpPr txBox="1"/>
+          <p:nvPr/>
+        </p:nvSpPr>
+        <p:spPr>
+          <a:xfrm>
+            <a:off x="3017520" y="4251960"/>
+            <a:ext cx="914400" cy="246888"/>
+          </a:xfrm>
+          <a:prstGeom prst="rect">
+            <a:avLst/>
+          </a:prstGeom>
+          <a:noFill/>
+          <a:ln/>
+        </p:spPr>
+        <p:txBody>
+          <a:bodyPr wrap="square" lIns="0" tIns="0" rIns="0" bIns="0" rtlCol="0" anchor="ctr"/>
+          <a:lstStyle/>
+          <a:p>
+            <a:pPr algn="r" indent="0" marL="0">
+              <a:buNone/>
+            </a:pPr>
+            <a:r>
+              <a:rPr lang="en-US" sz="750" dirty="0">
+                <a:solidFill>
+                  <a:srgbClr val="6B7280"/>
+                </a:solidFill>
+                <a:latin typeface="Arial" pitchFamily="34" charset="0"/>
+                <a:ea typeface="Arial" pitchFamily="34" charset="-122"/>
+                <a:cs typeface="Arial" pitchFamily="34" charset="-120"/>
+              </a:rPr>
+              <a:t>09/11 – 13/11</a:t>
+            </a:r>
+            <a:endParaRPr lang="en-US" sz="750" dirty="0"/>
+          </a:p>
+        </p:txBody>
+      </p:sp>
+      <p:sp>
+        <p:nvSpPr>
+          <p:cNvPr id="85" name="Shape 83"/>
+          <p:cNvSpPr/>
+          <p:nvPr/>
+        </p:nvSpPr>
+        <p:spPr>
+          <a:xfrm>
+            <a:off x="8064398" y="4297680"/>
+            <a:ext cx="291911" cy="155448"/>
+          </a:xfrm>
+          <a:prstGeom prst="roundRect">
+            <a:avLst>
+              <a:gd name="adj" fmla="val 29412"/>
+            </a:avLst>
+          </a:prstGeom>
+          <a:solidFill>
+            <a:srgbClr val="079CCE">
+              <a:alpha val="55000"/>
+            </a:srgbClr>
+          </a:solidFill>
+          <a:ln w="9525">
+            <a:solidFill>
+              <a:srgbClr val="079CCE"/>
+            </a:solidFill>
+            <a:prstDash val="solid"/>
+          </a:ln>
+        </p:spPr>
+      </p:sp>
+      <p:sp>
+        <p:nvSpPr>
+          <p:cNvPr id="86" name="Text 84"/>
+          <p:cNvSpPr txBox="1"/>
+          <p:nvPr/>
+        </p:nvSpPr>
+        <p:spPr>
+          <a:xfrm>
+            <a:off x="868680" y="4498848"/>
+            <a:ext cx="2240280" cy="246888"/>
+          </a:xfrm>
+          <a:prstGeom prst="rect">
+            <a:avLst/>
+          </a:prstGeom>
+          <a:noFill/>
+          <a:ln/>
+        </p:spPr>
+        <p:txBody>
+          <a:bodyPr wrap="square" lIns="0" tIns="0" rIns="0" bIns="0" rtlCol="0" anchor="ctr"/>
+          <a:lstStyle/>
+          <a:p>
+            <a:pPr indent="0" marL="0">
+              <a:buNone/>
+            </a:pPr>
+            <a:r>
+              <a:rPr lang="en-US" sz="900" dirty="0">
+                <a:solidFill>
+                  <a:srgbClr val="1F2937"/>
+                </a:solidFill>
+                <a:latin typeface="Arial" pitchFamily="34" charset="0"/>
+                <a:ea typeface="Arial" pitchFamily="34" charset="-122"/>
+                <a:cs typeface="Arial" pitchFamily="34" charset="-120"/>
+              </a:rPr>
+              <a:t>Ajustar tiempos y dificultad de los juegos</a:t>
+            </a:r>
+            <a:endParaRPr lang="en-US" sz="900" dirty="0"/>
+          </a:p>
+        </p:txBody>
+      </p:sp>
+      <p:sp>
+        <p:nvSpPr>
+          <p:cNvPr id="87" name="Text 85"/>
+          <p:cNvSpPr txBox="1"/>
+          <p:nvPr/>
+        </p:nvSpPr>
+        <p:spPr>
+          <a:xfrm>
+            <a:off x="3017520" y="4498848"/>
+            <a:ext cx="914400" cy="246888"/>
+          </a:xfrm>
+          <a:prstGeom prst="rect">
+            <a:avLst/>
+          </a:prstGeom>
+          <a:noFill/>
+          <a:ln/>
+        </p:spPr>
+        <p:txBody>
+          <a:bodyPr wrap="square" lIns="0" tIns="0" rIns="0" bIns="0" rtlCol="0" anchor="ctr"/>
+          <a:lstStyle/>
+          <a:p>
+            <a:pPr algn="r" indent="0" marL="0">
+              <a:buNone/>
+            </a:pPr>
+            <a:r>
+              <a:rPr lang="en-US" sz="750" dirty="0">
+                <a:solidFill>
+                  <a:srgbClr val="6B7280"/>
+                </a:solidFill>
+                <a:latin typeface="Arial" pitchFamily="34" charset="0"/>
+                <a:ea typeface="Arial" pitchFamily="34" charset="-122"/>
+                <a:cs typeface="Arial" pitchFamily="34" charset="-120"/>
+              </a:rPr>
+              <a:t>12/11 – 18/11</a:t>
+            </a:r>
+            <a:endParaRPr lang="en-US" sz="750" dirty="0"/>
+          </a:p>
+        </p:txBody>
+      </p:sp>
+      <p:sp>
+        <p:nvSpPr>
+          <p:cNvPr id="88" name="Shape 86"/>
+          <p:cNvSpPr/>
+          <p:nvPr/>
+        </p:nvSpPr>
+        <p:spPr>
+          <a:xfrm>
+            <a:off x="8283332" y="4544568"/>
+            <a:ext cx="437867" cy="155448"/>
+          </a:xfrm>
+          <a:prstGeom prst="roundRect">
+            <a:avLst>
+              <a:gd name="adj" fmla="val 29412"/>
+            </a:avLst>
+          </a:prstGeom>
+          <a:solidFill>
+            <a:srgbClr val="079CCE">
+              <a:alpha val="55000"/>
+            </a:srgbClr>
+          </a:solidFill>
+          <a:ln w="9525">
+            <a:solidFill>
+              <a:srgbClr val="079CCE"/>
+            </a:solidFill>
+            <a:prstDash val="solid"/>
+          </a:ln>
+        </p:spPr>
+      </p:sp>
+      <p:sp>
+        <p:nvSpPr>
+          <p:cNvPr id="89" name="Text 87"/>
+          <p:cNvSpPr txBox="1"/>
+          <p:nvPr/>
+        </p:nvSpPr>
+        <p:spPr>
+          <a:xfrm>
+            <a:off x="868680" y="4745736"/>
+            <a:ext cx="2240280" cy="246888"/>
+          </a:xfrm>
+          <a:prstGeom prst="rect">
+            <a:avLst/>
+          </a:prstGeom>
+          <a:noFill/>
+          <a:ln/>
+        </p:spPr>
+        <p:txBody>
+          <a:bodyPr wrap="square" lIns="0" tIns="0" rIns="0" bIns="0" rtlCol="0" anchor="ctr"/>
+          <a:lstStyle/>
+          <a:p>
+            <a:pPr indent="0" marL="0">
+              <a:buNone/>
+            </a:pPr>
+            <a:r>
+              <a:rPr lang="en-US" sz="900" dirty="0">
+                <a:solidFill>
+                  <a:srgbClr val="1F2937"/>
+                </a:solidFill>
+                <a:latin typeface="Arial" pitchFamily="34" charset="0"/>
+                <a:ea typeface="Arial" pitchFamily="34" charset="-122"/>
+                <a:cs typeface="Arial" pitchFamily="34" charset="-120"/>
+              </a:rPr>
+              <a:t>Medir resultados iniciales (línea base)</a:t>
+            </a:r>
+            <a:endParaRPr lang="en-US" sz="900" dirty="0"/>
+          </a:p>
+        </p:txBody>
+      </p:sp>
+      <p:sp>
+        <p:nvSpPr>
+          <p:cNvPr id="90" name="Text 88"/>
+          <p:cNvSpPr txBox="1"/>
+          <p:nvPr/>
+        </p:nvSpPr>
+        <p:spPr>
+          <a:xfrm>
+            <a:off x="3017520" y="4745736"/>
+            <a:ext cx="914400" cy="246888"/>
+          </a:xfrm>
+          <a:prstGeom prst="rect">
+            <a:avLst/>
+          </a:prstGeom>
+          <a:noFill/>
+          <a:ln/>
+        </p:spPr>
+        <p:txBody>
+          <a:bodyPr wrap="square" lIns="0" tIns="0" rIns="0" bIns="0" rtlCol="0" anchor="ctr"/>
+          <a:lstStyle/>
+          <a:p>
+            <a:pPr algn="r" indent="0" marL="0">
+              <a:buNone/>
+            </a:pPr>
+            <a:r>
+              <a:rPr lang="en-US" sz="750" dirty="0">
+                <a:solidFill>
+                  <a:srgbClr val="6B7280"/>
+                </a:solidFill>
+                <a:latin typeface="Arial" pitchFamily="34" charset="0"/>
+                <a:ea typeface="Arial" pitchFamily="34" charset="-122"/>
+                <a:cs typeface="Arial" pitchFamily="34" charset="-120"/>
+              </a:rPr>
+              <a:t>16/11 – 20/11</a:t>
+            </a:r>
+            <a:endParaRPr lang="en-US" sz="750" dirty="0"/>
+          </a:p>
+        </p:txBody>
+      </p:sp>
+      <p:sp>
+        <p:nvSpPr>
+          <p:cNvPr id="91" name="Shape 89"/>
+          <p:cNvSpPr/>
+          <p:nvPr/>
+        </p:nvSpPr>
+        <p:spPr>
+          <a:xfrm>
+            <a:off x="8575243" y="4791456"/>
+            <a:ext cx="291911" cy="155448"/>
+          </a:xfrm>
+          <a:prstGeom prst="roundRect">
+            <a:avLst>
+              <a:gd name="adj" fmla="val 29412"/>
+            </a:avLst>
+          </a:prstGeom>
+          <a:solidFill>
+            <a:srgbClr val="079CCE">
+              <a:alpha val="55000"/>
+            </a:srgbClr>
+          </a:solidFill>
+          <a:ln w="9525">
+            <a:solidFill>
+              <a:srgbClr val="079CCE"/>
+            </a:solidFill>
+            <a:prstDash val="solid"/>
+          </a:ln>
+        </p:spPr>
+      </p:sp>
+      <p:sp>
+        <p:nvSpPr>
+          <p:cNvPr id="92" name="Shape 90"/>
+          <p:cNvSpPr/>
+          <p:nvPr/>
+        </p:nvSpPr>
+        <p:spPr>
+          <a:xfrm>
+            <a:off x="548640" y="4992624"/>
+            <a:ext cx="11091672" cy="246888"/>
+          </a:xfrm>
+          <a:prstGeom prst="rect">
+            <a:avLst/>
+          </a:prstGeom>
+          <a:solidFill>
+            <a:srgbClr val="F3F5F8"/>
+          </a:solidFill>
+          <a:ln w="12700">
+            <a:solidFill>
+              <a:srgbClr val="F3F5F8"/>
+            </a:solidFill>
+            <a:prstDash val="solid"/>
+          </a:ln>
+        </p:spPr>
+      </p:sp>
+      <p:sp>
+        <p:nvSpPr>
+          <p:cNvPr id="93" name="Text 91"/>
+          <p:cNvSpPr txBox="1"/>
+          <p:nvPr/>
+        </p:nvSpPr>
+        <p:spPr>
+          <a:xfrm>
+            <a:off x="640080" y="4992624"/>
+            <a:ext cx="2240280" cy="246888"/>
+          </a:xfrm>
+          <a:prstGeom prst="rect">
+            <a:avLst/>
+          </a:prstGeom>
+          <a:noFill/>
+          <a:ln/>
+        </p:spPr>
+        <p:txBody>
+          <a:bodyPr wrap="square" lIns="0" tIns="0" rIns="0" bIns="0" rtlCol="0" anchor="ctr"/>
+          <a:lstStyle/>
+          <a:p>
+            <a:pPr indent="0" marL="0">
+              <a:buNone/>
+            </a:pPr>
+            <a:r>
+              <a:rPr lang="en-US" sz="950" b="1" dirty="0">
+                <a:solidFill>
+                  <a:srgbClr val="022A5B"/>
+                </a:solidFill>
+                <a:latin typeface="Arial" pitchFamily="34" charset="0"/>
+                <a:ea typeface="Arial" pitchFamily="34" charset="-122"/>
+                <a:cs typeface="Arial" pitchFamily="34" charset="-120"/>
+              </a:rPr>
+              <a:t>FASE 4 · Despliegue</a:t>
+            </a:r>
+            <a:endParaRPr lang="en-US" sz="950" dirty="0"/>
+          </a:p>
+        </p:txBody>
+      </p:sp>
+      <p:sp>
+        <p:nvSpPr>
+          <p:cNvPr id="94" name="Text 92"/>
+          <p:cNvSpPr txBox="1"/>
+          <p:nvPr/>
+        </p:nvSpPr>
+        <p:spPr>
+          <a:xfrm>
+            <a:off x="3017520" y="4992624"/>
+            <a:ext cx="914400" cy="246888"/>
+          </a:xfrm>
+          <a:prstGeom prst="rect">
+            <a:avLst/>
+          </a:prstGeom>
+          <a:noFill/>
+          <a:ln/>
+        </p:spPr>
+        <p:txBody>
+          <a:bodyPr wrap="square" lIns="0" tIns="0" rIns="0" bIns="0" rtlCol="0" anchor="ctr"/>
+          <a:lstStyle/>
+          <a:p>
+            <a:pPr algn="r" indent="0" marL="0">
+              <a:buNone/>
+            </a:pPr>
+            <a:r>
+              <a:rPr lang="en-US" sz="750" dirty="0">
+                <a:solidFill>
+                  <a:srgbClr val="6B7280"/>
+                </a:solidFill>
+                <a:latin typeface="Arial" pitchFamily="34" charset="0"/>
+                <a:ea typeface="Arial" pitchFamily="34" charset="-122"/>
+                <a:cs typeface="Arial" pitchFamily="34" charset="-120"/>
+              </a:rPr>
+              <a:t>23/11 – 23/12</a:t>
+            </a:r>
+            <a:endParaRPr lang="en-US" sz="750" dirty="0"/>
+          </a:p>
+        </p:txBody>
+      </p:sp>
+      <p:sp>
+        <p:nvSpPr>
+          <p:cNvPr id="95" name="Shape 93"/>
+          <p:cNvSpPr/>
+          <p:nvPr/>
+        </p:nvSpPr>
+        <p:spPr>
+          <a:xfrm>
+            <a:off x="9086088" y="5056632"/>
+            <a:ext cx="2189335" cy="118872"/>
+          </a:xfrm>
+          <a:prstGeom prst="rect">
+            <a:avLst/>
+          </a:prstGeom>
+          <a:solidFill>
+            <a:srgbClr val="FFA403"/>
+          </a:solidFill>
+          <a:ln w="12700">
+            <a:solidFill>
+              <a:srgbClr val="FFA403"/>
+            </a:solidFill>
+            <a:prstDash val="solid"/>
+          </a:ln>
+        </p:spPr>
+      </p:sp>
+      <p:sp>
+        <p:nvSpPr>
+          <p:cNvPr id="96" name="Text 94"/>
+          <p:cNvSpPr txBox="1"/>
+          <p:nvPr/>
+        </p:nvSpPr>
+        <p:spPr>
+          <a:xfrm>
+            <a:off x="868680" y="5239512"/>
+            <a:ext cx="2240280" cy="246888"/>
+          </a:xfrm>
+          <a:prstGeom prst="rect">
+            <a:avLst/>
+          </a:prstGeom>
+          <a:noFill/>
+          <a:ln/>
+        </p:spPr>
+        <p:txBody>
+          <a:bodyPr wrap="square" lIns="0" tIns="0" rIns="0" bIns="0" rtlCol="0" anchor="ctr"/>
+          <a:lstStyle/>
+          <a:p>
+            <a:pPr indent="0" marL="0">
+              <a:buNone/>
+            </a:pPr>
+            <a:r>
+              <a:rPr lang="en-US" sz="900" dirty="0">
+                <a:solidFill>
+                  <a:srgbClr val="1F2937"/>
+                </a:solidFill>
+                <a:latin typeface="Arial" pitchFamily="34" charset="0"/>
+                <a:ea typeface="Arial" pitchFamily="34" charset="-122"/>
+                <a:cs typeface="Arial" pitchFamily="34" charset="-120"/>
+              </a:rPr>
+              <a:t>Sesiones para todos los turnos y líneas</a:t>
+            </a:r>
+            <a:endParaRPr lang="en-US" sz="900" dirty="0"/>
+          </a:p>
+        </p:txBody>
+      </p:sp>
+      <p:sp>
+        <p:nvSpPr>
+          <p:cNvPr id="97" name="Text 95"/>
+          <p:cNvSpPr txBox="1"/>
+          <p:nvPr/>
+        </p:nvSpPr>
+        <p:spPr>
+          <a:xfrm>
+            <a:off x="3017520" y="5239512"/>
+            <a:ext cx="914400" cy="246888"/>
+          </a:xfrm>
+          <a:prstGeom prst="rect">
+            <a:avLst/>
+          </a:prstGeom>
+          <a:noFill/>
+          <a:ln/>
+        </p:spPr>
+        <p:txBody>
+          <a:bodyPr wrap="square" lIns="0" tIns="0" rIns="0" bIns="0" rtlCol="0" anchor="ctr"/>
+          <a:lstStyle/>
+          <a:p>
+            <a:pPr algn="r" indent="0" marL="0">
+              <a:buNone/>
+            </a:pPr>
+            <a:r>
+              <a:rPr lang="en-US" sz="750" dirty="0">
+                <a:solidFill>
+                  <a:srgbClr val="6B7280"/>
+                </a:solidFill>
+                <a:latin typeface="Arial" pitchFamily="34" charset="0"/>
+                <a:ea typeface="Arial" pitchFamily="34" charset="-122"/>
+                <a:cs typeface="Arial" pitchFamily="34" charset="-120"/>
+              </a:rPr>
+              <a:t>23/11 – 18/12</a:t>
+            </a:r>
+            <a:endParaRPr lang="en-US" sz="750" dirty="0"/>
+          </a:p>
+        </p:txBody>
+      </p:sp>
+      <p:sp>
+        <p:nvSpPr>
+          <p:cNvPr id="98" name="Shape 96"/>
+          <p:cNvSpPr/>
+          <p:nvPr/>
+        </p:nvSpPr>
+        <p:spPr>
+          <a:xfrm>
+            <a:off x="9086088" y="5285232"/>
+            <a:ext cx="1824446" cy="155448"/>
+          </a:xfrm>
+          <a:prstGeom prst="roundRect">
+            <a:avLst>
+              <a:gd name="adj" fmla="val 29412"/>
+            </a:avLst>
+          </a:prstGeom>
+          <a:solidFill>
+            <a:srgbClr val="FFA403">
+              <a:alpha val="55000"/>
+            </a:srgbClr>
+          </a:solidFill>
+          <a:ln w="9525">
+            <a:solidFill>
+              <a:srgbClr val="FFA403"/>
+            </a:solidFill>
+            <a:prstDash val="solid"/>
+          </a:ln>
+        </p:spPr>
+      </p:sp>
+      <p:sp>
+        <p:nvSpPr>
+          <p:cNvPr id="99" name="Text 97"/>
+          <p:cNvSpPr txBox="1"/>
+          <p:nvPr/>
+        </p:nvSpPr>
+        <p:spPr>
+          <a:xfrm>
+            <a:off x="868680" y="5486400"/>
+            <a:ext cx="2240280" cy="246888"/>
+          </a:xfrm>
+          <a:prstGeom prst="rect">
+            <a:avLst/>
+          </a:prstGeom>
+          <a:noFill/>
+          <a:ln/>
+        </p:spPr>
+        <p:txBody>
+          <a:bodyPr wrap="square" lIns="0" tIns="0" rIns="0" bIns="0" rtlCol="0" anchor="ctr"/>
+          <a:lstStyle/>
+          <a:p>
+            <a:pPr indent="0" marL="0">
+              <a:buNone/>
+            </a:pPr>
+            <a:r>
+              <a:rPr lang="en-US" sz="900" dirty="0">
+                <a:solidFill>
+                  <a:srgbClr val="1F2937"/>
+                </a:solidFill>
+                <a:latin typeface="Arial" pitchFamily="34" charset="0"/>
+                <a:ea typeface="Arial" pitchFamily="34" charset="-122"/>
+                <a:cs typeface="Arial" pitchFamily="34" charset="-120"/>
+              </a:rPr>
+              <a:t>Ranking y reconocimiento</a:t>
+            </a:r>
+            <a:endParaRPr lang="en-US" sz="900" dirty="0"/>
+          </a:p>
+        </p:txBody>
+      </p:sp>
+      <p:sp>
+        <p:nvSpPr>
+          <p:cNvPr id="100" name="Text 98"/>
+          <p:cNvSpPr txBox="1"/>
+          <p:nvPr/>
+        </p:nvSpPr>
+        <p:spPr>
+          <a:xfrm>
+            <a:off x="3017520" y="5486400"/>
+            <a:ext cx="914400" cy="246888"/>
+          </a:xfrm>
+          <a:prstGeom prst="rect">
+            <a:avLst/>
+          </a:prstGeom>
+          <a:noFill/>
+          <a:ln/>
+        </p:spPr>
+        <p:txBody>
+          <a:bodyPr wrap="square" lIns="0" tIns="0" rIns="0" bIns="0" rtlCol="0" anchor="ctr"/>
+          <a:lstStyle/>
+          <a:p>
+            <a:pPr algn="r" indent="0" marL="0">
+              <a:buNone/>
+            </a:pPr>
+            <a:r>
+              <a:rPr lang="en-US" sz="750" dirty="0">
+                <a:solidFill>
+                  <a:srgbClr val="6B7280"/>
+                </a:solidFill>
+                <a:latin typeface="Arial" pitchFamily="34" charset="0"/>
+                <a:ea typeface="Arial" pitchFamily="34" charset="-122"/>
+                <a:cs typeface="Arial" pitchFamily="34" charset="-120"/>
+              </a:rPr>
+              <a:t>07/12 – 23/12</a:t>
+            </a:r>
+            <a:endParaRPr lang="en-US" sz="750" dirty="0"/>
+          </a:p>
+        </p:txBody>
+      </p:sp>
+      <p:sp>
+        <p:nvSpPr>
+          <p:cNvPr id="101" name="Shape 99"/>
+          <p:cNvSpPr/>
+          <p:nvPr/>
+        </p:nvSpPr>
+        <p:spPr>
+          <a:xfrm>
+            <a:off x="10107778" y="5532120"/>
+            <a:ext cx="1167645" cy="155448"/>
+          </a:xfrm>
+          <a:prstGeom prst="roundRect">
+            <a:avLst>
+              <a:gd name="adj" fmla="val 29412"/>
+            </a:avLst>
+          </a:prstGeom>
+          <a:solidFill>
+            <a:srgbClr val="FFA403">
+              <a:alpha val="55000"/>
+            </a:srgbClr>
+          </a:solidFill>
+          <a:ln w="9525">
+            <a:solidFill>
+              <a:srgbClr val="FFA403"/>
+            </a:solidFill>
+            <a:prstDash val="solid"/>
+          </a:ln>
+        </p:spPr>
+      </p:sp>
+      <p:sp>
+        <p:nvSpPr>
+          <p:cNvPr id="102" name="Text 100"/>
+          <p:cNvSpPr txBox="1"/>
+          <p:nvPr/>
+        </p:nvSpPr>
+        <p:spPr>
+          <a:xfrm>
+            <a:off x="868680" y="5733288"/>
+            <a:ext cx="2240280" cy="246888"/>
+          </a:xfrm>
+          <a:prstGeom prst="rect">
+            <a:avLst/>
+          </a:prstGeom>
+          <a:noFill/>
+          <a:ln/>
+        </p:spPr>
+        <p:txBody>
+          <a:bodyPr wrap="square" lIns="0" tIns="0" rIns="0" bIns="0" rtlCol="0" anchor="ctr"/>
+          <a:lstStyle/>
+          <a:p>
+            <a:pPr indent="0" marL="0">
+              <a:buNone/>
+            </a:pPr>
+            <a:r>
+              <a:rPr lang="en-US" sz="900" dirty="0">
+                <a:solidFill>
+                  <a:srgbClr val="1F2937"/>
+                </a:solidFill>
+                <a:latin typeface="Arial" pitchFamily="34" charset="0"/>
+                <a:ea typeface="Arial" pitchFamily="34" charset="-122"/>
+                <a:cs typeface="Arial" pitchFamily="34" charset="-120"/>
+              </a:rPr>
+              <a:t>Cierre y primera medición de indicadores</a:t>
+            </a:r>
+            <a:endParaRPr lang="en-US" sz="900" dirty="0"/>
+          </a:p>
+        </p:txBody>
+      </p:sp>
+      <p:sp>
+        <p:nvSpPr>
+          <p:cNvPr id="103" name="Text 101"/>
+          <p:cNvSpPr txBox="1"/>
+          <p:nvPr/>
+        </p:nvSpPr>
+        <p:spPr>
+          <a:xfrm>
+            <a:off x="3017520" y="5733288"/>
+            <a:ext cx="914400" cy="246888"/>
+          </a:xfrm>
+          <a:prstGeom prst="rect">
+            <a:avLst/>
+          </a:prstGeom>
+          <a:noFill/>
+          <a:ln/>
+        </p:spPr>
+        <p:txBody>
+          <a:bodyPr wrap="square" lIns="0" tIns="0" rIns="0" bIns="0" rtlCol="0" anchor="ctr"/>
+          <a:lstStyle/>
+          <a:p>
+            <a:pPr algn="r" indent="0" marL="0">
+              <a:buNone/>
+            </a:pPr>
+            <a:r>
+              <a:rPr lang="en-US" sz="750" dirty="0">
+                <a:solidFill>
+                  <a:srgbClr val="6B7280"/>
+                </a:solidFill>
+                <a:latin typeface="Arial" pitchFamily="34" charset="0"/>
+                <a:ea typeface="Arial" pitchFamily="34" charset="-122"/>
+                <a:cs typeface="Arial" pitchFamily="34" charset="-120"/>
+              </a:rPr>
+              <a:t>14/12 – 23/12</a:t>
+            </a:r>
+            <a:endParaRPr lang="en-US" sz="750" dirty="0"/>
+          </a:p>
+        </p:txBody>
+      </p:sp>
+      <p:sp>
+        <p:nvSpPr>
+          <p:cNvPr id="104" name="Shape 102"/>
+          <p:cNvSpPr/>
+          <p:nvPr/>
+        </p:nvSpPr>
+        <p:spPr>
+          <a:xfrm>
+            <a:off x="10618622" y="5779008"/>
+            <a:ext cx="656800" cy="155448"/>
+          </a:xfrm>
+          <a:prstGeom prst="roundRect">
+            <a:avLst>
+              <a:gd name="adj" fmla="val 29412"/>
+            </a:avLst>
+          </a:prstGeom>
+          <a:solidFill>
+            <a:srgbClr val="FFA403">
+              <a:alpha val="55000"/>
+            </a:srgbClr>
+          </a:solidFill>
+          <a:ln w="9525">
+            <a:solidFill>
+              <a:srgbClr val="FFA403"/>
+            </a:solidFill>
+            <a:prstDash val="solid"/>
+          </a:ln>
+        </p:spPr>
+      </p:sp>
+      <p:sp>
+        <p:nvSpPr>
+          <p:cNvPr id="105" name="Shape 103"/>
+          <p:cNvSpPr/>
+          <p:nvPr/>
+        </p:nvSpPr>
+        <p:spPr>
+          <a:xfrm>
+            <a:off x="5190657" y="1805940"/>
+            <a:ext cx="201168" cy="201168"/>
+          </a:xfrm>
+          <a:prstGeom prst="diamond">
+            <a:avLst/>
+          </a:prstGeom>
+          <a:solidFill>
+            <a:srgbClr val="E42312"/>
+          </a:solidFill>
+          <a:ln w="12700">
+            <a:solidFill>
+              <a:srgbClr val="FFFFFF"/>
+            </a:solidFill>
+            <a:prstDash val="solid"/>
+          </a:ln>
+        </p:spPr>
+      </p:sp>
+      <p:sp>
+        <p:nvSpPr>
+          <p:cNvPr id="106" name="Shape 104"/>
+          <p:cNvSpPr/>
+          <p:nvPr/>
+        </p:nvSpPr>
+        <p:spPr>
+          <a:xfrm>
+            <a:off x="7744881" y="2793492"/>
+            <a:ext cx="201168" cy="201168"/>
+          </a:xfrm>
+          <a:prstGeom prst="diamond">
+            <a:avLst/>
+          </a:prstGeom>
+          <a:solidFill>
+            <a:srgbClr val="E42312"/>
+          </a:solidFill>
+          <a:ln w="12700">
+            <a:solidFill>
+              <a:srgbClr val="FFFFFF"/>
+            </a:solidFill>
+            <a:prstDash val="solid"/>
+          </a:ln>
+        </p:spPr>
+      </p:sp>
+      <p:sp>
+        <p:nvSpPr>
+          <p:cNvPr id="107" name="Shape 105"/>
+          <p:cNvSpPr/>
+          <p:nvPr/>
+        </p:nvSpPr>
+        <p:spPr>
+          <a:xfrm>
+            <a:off x="8766571" y="4027932"/>
+            <a:ext cx="201168" cy="201168"/>
+          </a:xfrm>
+          <a:prstGeom prst="diamond">
+            <a:avLst/>
+          </a:prstGeom>
+          <a:solidFill>
+            <a:srgbClr val="E42312"/>
+          </a:solidFill>
+          <a:ln w="12700">
+            <a:solidFill>
+              <a:srgbClr val="FFFFFF"/>
+            </a:solidFill>
+            <a:prstDash val="solid"/>
+          </a:ln>
+        </p:spPr>
+      </p:sp>
+      <p:sp>
+        <p:nvSpPr>
+          <p:cNvPr id="108" name="Shape 106"/>
+          <p:cNvSpPr/>
+          <p:nvPr/>
+        </p:nvSpPr>
+        <p:spPr>
+          <a:xfrm>
+            <a:off x="11174839" y="5015484"/>
+            <a:ext cx="201168" cy="201168"/>
+          </a:xfrm>
+          <a:prstGeom prst="diamond">
+            <a:avLst/>
+          </a:prstGeom>
+          <a:solidFill>
+            <a:srgbClr val="E42312"/>
+          </a:solidFill>
+          <a:ln w="12700">
+            <a:solidFill>
+              <a:srgbClr val="FFFFFF"/>
+            </a:solidFill>
+            <a:prstDash val="solid"/>
+          </a:ln>
+        </p:spPr>
+      </p:sp>
+      <p:sp>
+        <p:nvSpPr>
+          <p:cNvPr id="109" name="Shape 107"/>
+          <p:cNvSpPr/>
+          <p:nvPr/>
+        </p:nvSpPr>
+        <p:spPr>
+          <a:xfrm>
+            <a:off x="640080" y="6199632"/>
+            <a:ext cx="164592" cy="164592"/>
+          </a:xfrm>
+          <a:prstGeom prst="diamond">
+            <a:avLst/>
+          </a:prstGeom>
+          <a:solidFill>
+            <a:srgbClr val="E42312"/>
+          </a:solidFill>
+          <a:ln w="12700">
+            <a:solidFill>
+              <a:srgbClr val="FFFFFF"/>
+            </a:solidFill>
+            <a:prstDash val="solid"/>
+          </a:ln>
+        </p:spPr>
+      </p:sp>
+      <p:sp>
+        <p:nvSpPr>
+          <p:cNvPr id="110" name="Text 108"/>
+          <p:cNvSpPr txBox="1"/>
+          <p:nvPr/>
+        </p:nvSpPr>
+        <p:spPr>
+          <a:xfrm>
+            <a:off x="914400" y="6163056"/>
+            <a:ext cx="10698480" cy="237744"/>
+          </a:xfrm>
+          <a:prstGeom prst="rect">
+            <a:avLst/>
+          </a:prstGeom>
+          <a:noFill/>
+          <a:ln/>
+        </p:spPr>
+        <p:txBody>
+          <a:bodyPr wrap="square" lIns="0" tIns="0" rIns="0" bIns="0" rtlCol="0" anchor="ctr"/>
+          <a:lstStyle/>
+          <a:p>
+            <a:pPr indent="0" marL="0">
+              <a:buNone/>
+            </a:pPr>
+            <a:r>
+              <a:rPr lang="en-US" sz="900" dirty="0">
+                <a:solidFill>
+                  <a:srgbClr val="1F2937"/>
+                </a:solidFill>
+                <a:latin typeface="Arial" pitchFamily="34" charset="0"/>
+                <a:ea typeface="Arial" pitchFamily="34" charset="-122"/>
+                <a:cs typeface="Arial" pitchFamily="34" charset="-120"/>
+              </a:rPr>
+              <a:t>Hitos: S40 (02/10) layout y presupuesto aprobados · S45 (06/11) maquetas y tótems listos · S47 (20/11) go/no-go del despliegue · S52 (23/12) 100% de los turnos certificados</a:t>
+            </a:r>
+            <a:endParaRPr lang="en-US" sz="900" dirty="0"/>
+          </a:p>
+        </p:txBody>
+      </p:sp>
+      <p:sp>
+        <p:nvSpPr>
+          <p:cNvPr id="111" name="Text 109"/>
+          <p:cNvSpPr txBox="1"/>
+          <p:nvPr/>
+        </p:nvSpPr>
+        <p:spPr>
+          <a:xfrm>
+            <a:off x="640080" y="6437376"/>
+            <a:ext cx="10972800" cy="237744"/>
+          </a:xfrm>
+          <a:prstGeom prst="rect">
+            <a:avLst/>
+          </a:prstGeom>
+          <a:noFill/>
+          <a:ln/>
+        </p:spPr>
+        <p:txBody>
+          <a:bodyPr wrap="square" lIns="0" tIns="0" rIns="0" bIns="0" rtlCol="0" anchor="ctr"/>
+          <a:lstStyle/>
+          <a:p>
+            <a:pPr indent="0" marL="0">
+              <a:buNone/>
+            </a:pPr>
+            <a:r>
+              <a:rPr lang="en-US" sz="900" i="1" dirty="0">
+                <a:solidFill>
+                  <a:srgbClr val="6B7280"/>
+                </a:solidFill>
+                <a:latin typeface="Arial" pitchFamily="34" charset="0"/>
+                <a:ea typeface="Arial" pitchFamily="34" charset="-122"/>
+                <a:cs typeface="Arial" pitchFamily="34" charset="-120"/>
+              </a:rPr>
+              <a:t>Duración total: 15 semanas (S38 a S52 de 2026). Para llegar a diciembre las fases se solapan: la construcción arranca antes de cerrar el diseño y el despliegue sigue al piloto sin pausa.</a:t>
+            </a:r>
+            <a:endParaRPr lang="en-US" sz="900" dirty="0"/>
+          </a:p>
+        </p:txBody>
+      </p:sp>
+      <p:sp>
+        <p:nvSpPr>
+          <p:cNvPr id="112" name="Text 110"/>
+          <p:cNvSpPr txBox="1"/>
+          <p:nvPr/>
+        </p:nvSpPr>
+        <p:spPr>
+          <a:xfrm>
+            <a:off x="11155680" y="6355080"/>
+            <a:ext cx="484632" cy="274320"/>
+          </a:xfrm>
+          <a:prstGeom prst="rect">
+            <a:avLst/>
+          </a:prstGeom>
+          <a:noFill/>
+          <a:ln/>
+        </p:spPr>
+        <p:txBody>
+          <a:bodyPr wrap="square" lIns="0" tIns="0" rIns="0" bIns="0" rtlCol="0" anchor="ctr"/>
+          <a:lstStyle/>
+          <a:p>
+            <a:pPr algn="r" indent="0" marL="0">
+              <a:buNone/>
+            </a:pPr>
+            <a:r>
+              <a:rPr lang="en-US" sz="1000" dirty="0">
+                <a:solidFill>
+                  <a:srgbClr val="6B7280"/>
+                </a:solidFill>
+                <a:latin typeface="Arial" pitchFamily="34" charset="0"/>
+                <a:ea typeface="Arial" pitchFamily="34" charset="-122"/>
+                <a:cs typeface="Arial" pitchFamily="34" charset="-120"/>
+              </a:rPr>
+              <a:t>14</a:t>
+            </a:r>
+            <a:endParaRPr lang="en-US" sz="1000" dirty="0"/>
+          </a:p>
+        </p:txBody>
+      </p:sp>
+    </p:spTree>
+  </p:cSld>
+  <p:clrMapOvr>
+    <a:masterClrMapping/>
+  </p:clrMapOvr>
+</p:sld>
+</file>
+
+<file path=ppt/slides/slide15.xml><?xml version="1.0" encoding="utf-8"?>
+<p:sld xmlns:a="http://schemas.openxmlformats.org/drawingml/2006/main" xmlns:r="http://schemas.openxmlformats.org/officeDocument/2006/relationships" xmlns:p="http://schemas.openxmlformats.org/presentationml/2006/main">
+  <p:cSld name="Slide 15">
+    <p:bg>
+      <p:bgPr>
+        <a:solidFill>
           <a:srgbClr val="F3F5F8"/>
         </a:solidFill>
       </p:bgPr>
@@ -11616,7 +15304,7 @@
                 <a:ea typeface="Arial" pitchFamily="34" charset="-122"/>
                 <a:cs typeface="Arial" pitchFamily="34" charset="-120"/>
               </a:rPr>
-              <a:t>14</a:t>
+              <a:t>15</a:t>
             </a:r>
             <a:endParaRPr lang="en-US" sz="1000" dirty="0"/>
           </a:p>
@@ -11630,9 +15318,9 @@
 </p:sld>
 </file>
 
-<file path=ppt/slides/slide15.xml><?xml version="1.0" encoding="utf-8"?>
+<file path=ppt/slides/slide16.xml><?xml version="1.0" encoding="utf-8"?>
 <p:sld xmlns:a="http://schemas.openxmlformats.org/drawingml/2006/main" xmlns:r="http://schemas.openxmlformats.org/officeDocument/2006/relationships" xmlns:p="http://schemas.openxmlformats.org/presentationml/2006/main">
-  <p:cSld name="Slide 15">
+  <p:cSld name="Slide 16">
     <p:bg>
       <p:bgPr>
         <a:blipFill dpi="0" rotWithShape="1">

</xml_diff>